<commit_message>
fix section dividers (slides 11, 19, 30) to SUTD white theme
</commit_message>
<xml_diff>
--- a/slides/swat_sutd.pptx
+++ b/slides/swat_sutd.pptx
@@ -5273,34 +5273,57 @@
       </p:grpSpPr>
       <p:sp>
         <p:nvSpPr>
-          <p:cNvPr id="2" name="Shape 0"/>
+          <p:cNvPr id="2" name="Rectangle 1"/>
           <p:cNvSpPr/>
           <p:nvPr/>
         </p:nvSpPr>
         <p:spPr>
           <a:xfrm>
             <a:off x="0" y="0"/>
-            <a:ext cx="12188952" cy="6858000"/>
-          </a:xfrm>
-          <a:prstGeom prst="rect">
-            <a:avLst/>
-          </a:prstGeom>
-          <a:solidFill>
-            <a:srgbClr val="1A1A1A"/>
-          </a:solidFill>
-          <a:ln/>
-        </p:spPr>
-      </p:sp>
-      <p:sp>
-        <p:nvSpPr>
-          <p:cNvPr id="3" name="Shape 1"/>
+            <a:ext cx="12192000" cy="6858000"/>
+          </a:xfrm>
+          <a:prstGeom prst="rect">
+            <a:avLst/>
+          </a:prstGeom>
+          <a:solidFill>
+            <a:srgbClr val="FFFFFF"/>
+          </a:solidFill>
+          <a:ln>
+            <a:noFill/>
+          </a:ln>
+        </p:spPr>
+        <p:style>
+          <a:lnRef idx="1">
+            <a:schemeClr val="accent1"/>
+          </a:lnRef>
+          <a:fillRef idx="3">
+            <a:schemeClr val="accent1"/>
+          </a:fillRef>
+          <a:effectRef idx="2">
+            <a:schemeClr val="accent1"/>
+          </a:effectRef>
+          <a:fontRef idx="minor">
+            <a:schemeClr val="lt1"/>
+          </a:fontRef>
+        </p:style>
+        <p:txBody>
+          <a:bodyPr rtlCol="0" anchor="ctr"/>
+          <a:lstStyle/>
+          <a:p>
+            <a:pPr algn="ctr"/>
+          </a:p>
+        </p:txBody>
+      </p:sp>
+      <p:sp>
+        <p:nvSpPr>
+          <p:cNvPr id="3" name="Rectangle 2"/>
           <p:cNvSpPr/>
           <p:nvPr/>
         </p:nvSpPr>
         <p:spPr>
           <a:xfrm>
             <a:off x="0" y="0"/>
-            <a:ext cx="109728" cy="6858000"/>
+            <a:ext cx="12192000" cy="64008"/>
           </a:xfrm>
           <a:prstGeom prst="rect">
             <a:avLst/>
@@ -5308,183 +5331,389 @@
           <a:solidFill>
             <a:srgbClr val="E8243C"/>
           </a:solidFill>
-          <a:ln/>
-        </p:spPr>
-      </p:sp>
-      <p:sp>
-        <p:nvSpPr>
-          <p:cNvPr id="4" name="Text 2"/>
-          <p:cNvSpPr/>
-          <p:nvPr/>
-        </p:nvSpPr>
-        <p:spPr>
-          <a:xfrm>
-            <a:off x="457200" y="1371600"/>
-            <a:ext cx="7315200" cy="914400"/>
-          </a:xfrm>
-          <a:prstGeom prst="rect">
-            <a:avLst/>
-          </a:prstGeom>
-          <a:noFill/>
-          <a:ln/>
-        </p:spPr>
-        <p:txBody>
-          <a:bodyPr wrap="square" rtlCol="0" anchor="ctr"/>
-          <a:lstStyle/>
-          <a:p>
-            <a:pPr indent="0" marL="0">
-              <a:buNone/>
-            </a:pPr>
-            <a:r>
-              <a:rPr lang="en-US" sz="4400" b="1" dirty="0">
+          <a:ln>
+            <a:noFill/>
+          </a:ln>
+        </p:spPr>
+        <p:style>
+          <a:lnRef idx="1">
+            <a:schemeClr val="accent1"/>
+          </a:lnRef>
+          <a:fillRef idx="3">
+            <a:schemeClr val="accent1"/>
+          </a:fillRef>
+          <a:effectRef idx="2">
+            <a:schemeClr val="accent1"/>
+          </a:effectRef>
+          <a:fontRef idx="minor">
+            <a:schemeClr val="lt1"/>
+          </a:fontRef>
+        </p:style>
+        <p:txBody>
+          <a:bodyPr rtlCol="0" anchor="ctr"/>
+          <a:lstStyle/>
+          <a:p>
+            <a:pPr algn="ctr"/>
+          </a:p>
+        </p:txBody>
+      </p:sp>
+      <p:sp>
+        <p:nvSpPr>
+          <p:cNvPr id="4" name="Rectangle 3"/>
+          <p:cNvSpPr/>
+          <p:nvPr/>
+        </p:nvSpPr>
+        <p:spPr>
+          <a:xfrm>
+            <a:off x="0" y="0"/>
+            <a:ext cx="320040" cy="6858000"/>
+          </a:xfrm>
+          <a:prstGeom prst="rect">
+            <a:avLst/>
+          </a:prstGeom>
+          <a:solidFill>
+            <a:srgbClr val="E8243C"/>
+          </a:solidFill>
+          <a:ln>
+            <a:noFill/>
+          </a:ln>
+        </p:spPr>
+        <p:style>
+          <a:lnRef idx="1">
+            <a:schemeClr val="accent1"/>
+          </a:lnRef>
+          <a:fillRef idx="3">
+            <a:schemeClr val="accent1"/>
+          </a:fillRef>
+          <a:effectRef idx="2">
+            <a:schemeClr val="accent1"/>
+          </a:effectRef>
+          <a:fontRef idx="minor">
+            <a:schemeClr val="lt1"/>
+          </a:fontRef>
+        </p:style>
+        <p:txBody>
+          <a:bodyPr rtlCol="0" anchor="ctr"/>
+          <a:lstStyle/>
+          <a:p>
+            <a:pPr algn="ctr"/>
+          </a:p>
+        </p:txBody>
+      </p:sp>
+      <p:sp>
+        <p:nvSpPr>
+          <p:cNvPr id="5" name="Rectangle 4"/>
+          <p:cNvSpPr/>
+          <p:nvPr/>
+        </p:nvSpPr>
+        <p:spPr>
+          <a:xfrm>
+            <a:off x="0" y="6510528"/>
+            <a:ext cx="12192000" cy="347472"/>
+          </a:xfrm>
+          <a:prstGeom prst="rect">
+            <a:avLst/>
+          </a:prstGeom>
+          <a:solidFill>
+            <a:srgbClr val="F5F5F5"/>
+          </a:solidFill>
+          <a:ln>
+            <a:noFill/>
+          </a:ln>
+        </p:spPr>
+        <p:style>
+          <a:lnRef idx="1">
+            <a:schemeClr val="accent1"/>
+          </a:lnRef>
+          <a:fillRef idx="3">
+            <a:schemeClr val="accent1"/>
+          </a:fillRef>
+          <a:effectRef idx="2">
+            <a:schemeClr val="accent1"/>
+          </a:effectRef>
+          <a:fontRef idx="minor">
+            <a:schemeClr val="lt1"/>
+          </a:fontRef>
+        </p:style>
+        <p:txBody>
+          <a:bodyPr rtlCol="0" anchor="ctr"/>
+          <a:lstStyle/>
+          <a:p>
+            <a:pPr algn="ctr"/>
+          </a:p>
+        </p:txBody>
+      </p:sp>
+      <p:sp>
+        <p:nvSpPr>
+          <p:cNvPr id="6" name="TextBox 5"/>
+          <p:cNvSpPr txBox="1"/>
+          <p:nvPr/>
+        </p:nvSpPr>
+        <p:spPr>
+          <a:xfrm>
+            <a:off x="502920" y="6565392"/>
+            <a:ext cx="11460480" cy="219456"/>
+          </a:xfrm>
+          <a:prstGeom prst="rect">
+            <a:avLst/>
+          </a:prstGeom>
+          <a:noFill/>
+        </p:spPr>
+        <p:txBody>
+          <a:bodyPr wrap="square">
+            <a:spAutoFit/>
+          </a:bodyPr>
+          <a:lstStyle/>
+          <a:p>
+            <a:pPr algn="l"/>
+            <a:r>
+              <a:rPr sz="800" b="0" i="0">
+                <a:solidFill>
+                  <a:srgbClr val="6B6B6B"/>
+                </a:solidFill>
+                <a:latin typeface="Calibri"/>
+              </a:rPr>
+              <a:t>51.508 Secure Cyber Physical Systems  ·  SWaT Project  ·  iTrust Lab, SUTD</a:t>
+            </a:r>
+          </a:p>
+        </p:txBody>
+      </p:sp>
+      <p:sp>
+        <p:nvSpPr>
+          <p:cNvPr id="7" name="Rectangle 6"/>
+          <p:cNvSpPr/>
+          <p:nvPr/>
+        </p:nvSpPr>
+        <p:spPr>
+          <a:xfrm>
+            <a:off x="502920" y="548640"/>
+            <a:ext cx="1828800" cy="384048"/>
+          </a:xfrm>
+          <a:prstGeom prst="rect">
+            <a:avLst/>
+          </a:prstGeom>
+          <a:solidFill>
+            <a:srgbClr val="E8243C"/>
+          </a:solidFill>
+          <a:ln>
+            <a:noFill/>
+          </a:ln>
+        </p:spPr>
+        <p:style>
+          <a:lnRef idx="1">
+            <a:schemeClr val="accent1"/>
+          </a:lnRef>
+          <a:fillRef idx="3">
+            <a:schemeClr val="accent1"/>
+          </a:fillRef>
+          <a:effectRef idx="2">
+            <a:schemeClr val="accent1"/>
+          </a:effectRef>
+          <a:fontRef idx="minor">
+            <a:schemeClr val="lt1"/>
+          </a:fontRef>
+        </p:style>
+        <p:txBody>
+          <a:bodyPr rtlCol="0" anchor="ctr"/>
+          <a:lstStyle/>
+          <a:p>
+            <a:pPr algn="ctr"/>
+          </a:p>
+        </p:txBody>
+      </p:sp>
+      <p:sp>
+        <p:nvSpPr>
+          <p:cNvPr id="8" name="TextBox 7"/>
+          <p:cNvSpPr txBox="1"/>
+          <p:nvPr/>
+        </p:nvSpPr>
+        <p:spPr>
+          <a:xfrm>
+            <a:off x="502920" y="548640"/>
+            <a:ext cx="1828800" cy="384048"/>
+          </a:xfrm>
+          <a:prstGeom prst="rect">
+            <a:avLst/>
+          </a:prstGeom>
+          <a:noFill/>
+        </p:spPr>
+        <p:txBody>
+          <a:bodyPr wrap="square">
+            <a:spAutoFit/>
+          </a:bodyPr>
+          <a:lstStyle/>
+          <a:p>
+            <a:pPr algn="ctr"/>
+            <a:r>
+              <a:rPr sz="1100" b="1" i="0">
                 <a:solidFill>
                   <a:srgbClr val="FFFFFF"/>
                 </a:solidFill>
-                <a:latin typeface="Calibri Light" pitchFamily="34" charset="0"/>
-                <a:ea typeface="Calibri Light" pitchFamily="34" charset="-122"/>
-                <a:cs typeface="Calibri Light" pitchFamily="34" charset="-120"/>
+                <a:latin typeface="Calibri"/>
+              </a:rPr>
+              <a:t>SECTION 2</a:t>
+            </a:r>
+          </a:p>
+        </p:txBody>
+      </p:sp>
+      <p:sp>
+        <p:nvSpPr>
+          <p:cNvPr id="9" name="TextBox 8"/>
+          <p:cNvSpPr txBox="1"/>
+          <p:nvPr/>
+        </p:nvSpPr>
+        <p:spPr>
+          <a:xfrm>
+            <a:off x="502920" y="1097280"/>
+            <a:ext cx="7315200" cy="1005840"/>
+          </a:xfrm>
+          <a:prstGeom prst="rect">
+            <a:avLst/>
+          </a:prstGeom>
+          <a:noFill/>
+        </p:spPr>
+        <p:txBody>
+          <a:bodyPr wrap="square">
+            <a:spAutoFit/>
+          </a:bodyPr>
+          <a:lstStyle/>
+          <a:p>
+            <a:pPr algn="l"/>
+            <a:r>
+              <a:rPr sz="4200" b="1" i="0">
+                <a:solidFill>
+                  <a:srgbClr val="1A1A1A"/>
+                </a:solidFill>
+                <a:latin typeface="Calibri Light"/>
               </a:rPr>
               <a:t>SWaT P1 Attack</a:t>
             </a:r>
-            <a:endParaRPr lang="en-US" sz="4400" dirty="0"/>
-          </a:p>
-        </p:txBody>
-      </p:sp>
-      <p:sp>
-        <p:nvSpPr>
-          <p:cNvPr id="5" name="Text 3"/>
-          <p:cNvSpPr/>
-          <p:nvPr/>
-        </p:nvSpPr>
-        <p:spPr>
-          <a:xfrm>
-            <a:off x="457200" y="2286000"/>
-            <a:ext cx="8229600" cy="457200"/>
-          </a:xfrm>
-          <a:prstGeom prst="rect">
-            <a:avLst/>
-          </a:prstGeom>
-          <a:noFill/>
-          <a:ln/>
-        </p:spPr>
-        <p:txBody>
-          <a:bodyPr wrap="square" rtlCol="0" anchor="ctr"/>
-          <a:lstStyle/>
-          <a:p>
-            <a:pPr indent="0" marL="0">
-              <a:buNone/>
-            </a:pPr>
-            <a:r>
-              <a:rPr lang="en-US" sz="2000" dirty="0">
+          </a:p>
+        </p:txBody>
+      </p:sp>
+      <p:sp>
+        <p:nvSpPr>
+          <p:cNvPr id="10" name="TextBox 9"/>
+          <p:cNvSpPr txBox="1"/>
+          <p:nvPr/>
+        </p:nvSpPr>
+        <p:spPr>
+          <a:xfrm>
+            <a:off x="502920" y="2084831"/>
+            <a:ext cx="7315200" cy="502920"/>
+          </a:xfrm>
+          <a:prstGeom prst="rect">
+            <a:avLst/>
+          </a:prstGeom>
+          <a:noFill/>
+        </p:spPr>
+        <p:txBody>
+          <a:bodyPr wrap="square">
+            <a:spAutoFit/>
+          </a:bodyPr>
+          <a:lstStyle/>
+          <a:p>
+            <a:pPr algn="l"/>
+            <a:r>
+              <a:rPr sz="2000" b="0" i="0">
                 <a:solidFill>
                   <a:srgbClr val="E8243C"/>
                 </a:solidFill>
-                <a:latin typeface="Calibri Light" pitchFamily="34" charset="0"/>
-                <a:ea typeface="Calibri Light" pitchFamily="34" charset="-122"/>
-                <a:cs typeface="Calibri Light" pitchFamily="34" charset="-120"/>
+                <a:latin typeface="Calibri Light"/>
               </a:rPr>
               <a:t>False CIP Tag Injection via Compromised HMI</a:t>
             </a:r>
-            <a:endParaRPr lang="en-US" sz="2000" dirty="0"/>
-          </a:p>
-        </p:txBody>
-      </p:sp>
-      <p:sp>
-        <p:nvSpPr>
-          <p:cNvPr id="6" name="Text 4"/>
-          <p:cNvSpPr/>
-          <p:nvPr/>
-        </p:nvSpPr>
-        <p:spPr>
-          <a:xfrm>
-            <a:off x="457200" y="2926080"/>
-            <a:ext cx="8229600" cy="365760"/>
-          </a:xfrm>
-          <a:prstGeom prst="rect">
-            <a:avLst/>
-          </a:prstGeom>
-          <a:noFill/>
-          <a:ln/>
-        </p:spPr>
-        <p:txBody>
-          <a:bodyPr wrap="square" rtlCol="0" anchor="ctr"/>
-          <a:lstStyle/>
-          <a:p>
-            <a:pPr indent="0" marL="0">
-              <a:buNone/>
-            </a:pPr>
-            <a:r>
-              <a:rPr lang="en-US" sz="1400" dirty="0">
-                <a:solidFill>
-                  <a:srgbClr val="888888"/>
-                </a:solidFill>
-                <a:latin typeface="Courier New" pitchFamily="34" charset="0"/>
-                <a:ea typeface="Courier New" pitchFamily="34" charset="-122"/>
-                <a:cs typeface="Courier New" pitchFamily="34" charset="-120"/>
+          </a:p>
+        </p:txBody>
+      </p:sp>
+      <p:sp>
+        <p:nvSpPr>
+          <p:cNvPr id="11" name="TextBox 10"/>
+          <p:cNvSpPr txBox="1"/>
+          <p:nvPr/>
+        </p:nvSpPr>
+        <p:spPr>
+          <a:xfrm>
+            <a:off x="502920" y="2743200"/>
+            <a:ext cx="7315200" cy="347472"/>
+          </a:xfrm>
+          <a:prstGeom prst="rect">
+            <a:avLst/>
+          </a:prstGeom>
+          <a:noFill/>
+        </p:spPr>
+        <p:txBody>
+          <a:bodyPr wrap="square">
+            <a:spAutoFit/>
+          </a:bodyPr>
+          <a:lstStyle/>
+          <a:p>
+            <a:pPr algn="l"/>
+            <a:r>
+              <a:rPr sz="1300" b="0" i="0">
+                <a:solidFill>
+                  <a:srgbClr val="6B6B6B"/>
+                </a:solidFill>
+                <a:latin typeface="Courier New"/>
               </a:rPr>
               <a:t>phase0_recon.py  ·  phase1_inject.py  ·  phase2_spoof.py</a:t>
             </a:r>
-            <a:endParaRPr lang="en-US" sz="1400" dirty="0"/>
-          </a:p>
-        </p:txBody>
-      </p:sp>
-      <p:sp>
-        <p:nvSpPr>
-          <p:cNvPr id="7" name="Text 5"/>
-          <p:cNvSpPr/>
-          <p:nvPr/>
-        </p:nvSpPr>
-        <p:spPr>
-          <a:xfrm>
-            <a:off x="457200" y="3337560"/>
-            <a:ext cx="8229600" cy="320040"/>
-          </a:xfrm>
-          <a:prstGeom prst="rect">
-            <a:avLst/>
-          </a:prstGeom>
-          <a:noFill/>
-          <a:ln/>
-        </p:spPr>
-        <p:txBody>
-          <a:bodyPr wrap="square" rtlCol="0" anchor="ctr"/>
-          <a:lstStyle/>
-          <a:p>
-            <a:pPr indent="0" marL="0">
-              <a:buNone/>
-            </a:pPr>
-            <a:r>
-              <a:rPr lang="en-US" sz="1200" dirty="0">
-                <a:solidFill>
-                  <a:srgbClr val="666666"/>
-                </a:solidFill>
-                <a:latin typeface="Courier New" pitchFamily="34" charset="0"/>
-                <a:ea typeface="Courier New" pitchFamily="34" charset="-122"/>
-                <a:cs typeface="Courier New" pitchFamily="34" charset="-120"/>
-              </a:rPr>
-              <a:t>pylogix / PyTorch  ·  192.168.1.10 (PLC1)</a:t>
-            </a:r>
-            <a:endParaRPr lang="en-US" sz="1200" dirty="0"/>
+          </a:p>
+        </p:txBody>
+      </p:sp>
+      <p:sp>
+        <p:nvSpPr>
+          <p:cNvPr id="12" name="TextBox 11"/>
+          <p:cNvSpPr txBox="1"/>
+          <p:nvPr/>
+        </p:nvSpPr>
+        <p:spPr>
+          <a:xfrm>
+            <a:off x="502920" y="3127248"/>
+            <a:ext cx="7315200" cy="320040"/>
+          </a:xfrm>
+          <a:prstGeom prst="rect">
+            <a:avLst/>
+          </a:prstGeom>
+          <a:noFill/>
+        </p:spPr>
+        <p:txBody>
+          <a:bodyPr wrap="square">
+            <a:spAutoFit/>
+          </a:bodyPr>
+          <a:lstStyle/>
+          <a:p>
+            <a:pPr algn="l"/>
+            <a:r>
+              <a:rPr sz="1200" b="0" i="0">
+                <a:solidFill>
+                  <a:srgbClr val="AAAAAA"/>
+                </a:solidFill>
+                <a:latin typeface="Courier New"/>
+              </a:rPr>
+              <a:t>pylogix  ·  PyTorch  ·  192.168.1.10 (PLC1)</a:t>
+            </a:r>
           </a:p>
         </p:txBody>
       </p:sp>
       <p:pic>
         <p:nvPicPr>
-          <p:cNvPr id="8" name="Image 0" descr="/home/claude/swat-cps-project/assets/images/swat_testbed_photo.jpg">    </p:cNvPr>
+          <p:cNvPr id="13" name="Picture 12" descr="image.jpg"/>
           <p:cNvPicPr>
             <a:picLocks noChangeAspect="1"/>
           </p:cNvPicPr>
           <p:nvPr/>
         </p:nvPicPr>
         <p:blipFill>
-          <a:blip r:embed="rId1"/>
+          <a:blip r:embed="rId4"/>
           <a:stretch>
             <a:fillRect/>
           </a:stretch>
         </p:blipFill>
         <p:spPr>
           <a:xfrm>
-            <a:off x="7132320" y="1097280"/>
-            <a:ext cx="4736592" cy="2377440"/>
+            <a:off x="7772400" y="1005840"/>
+            <a:ext cx="4096512" cy="3474720"/>
           </a:xfrm>
           <a:prstGeom prst="rect">
             <a:avLst/>
@@ -13339,34 +13568,369 @@
       </p:grpSpPr>
       <p:sp>
         <p:nvSpPr>
-          <p:cNvPr id="2" name="Shape 0"/>
+          <p:cNvPr id="2" name="Rectangle 1"/>
           <p:cNvSpPr/>
           <p:nvPr/>
         </p:nvSpPr>
         <p:spPr>
           <a:xfrm>
             <a:off x="0" y="0"/>
-            <a:ext cx="12188952" cy="6858000"/>
-          </a:xfrm>
-          <a:prstGeom prst="rect">
-            <a:avLst/>
-          </a:prstGeom>
-          <a:solidFill>
-            <a:srgbClr val="1A1A1A"/>
-          </a:solidFill>
-          <a:ln/>
-        </p:spPr>
-      </p:sp>
-      <p:sp>
-        <p:nvSpPr>
-          <p:cNvPr id="3" name="Shape 1"/>
+            <a:ext cx="12192000" cy="6858000"/>
+          </a:xfrm>
+          <a:prstGeom prst="rect">
+            <a:avLst/>
+          </a:prstGeom>
+          <a:solidFill>
+            <a:srgbClr val="FFFFFF"/>
+          </a:solidFill>
+          <a:ln>
+            <a:noFill/>
+          </a:ln>
+        </p:spPr>
+        <p:style>
+          <a:lnRef idx="1">
+            <a:schemeClr val="accent1"/>
+          </a:lnRef>
+          <a:fillRef idx="3">
+            <a:schemeClr val="accent1"/>
+          </a:fillRef>
+          <a:effectRef idx="2">
+            <a:schemeClr val="accent1"/>
+          </a:effectRef>
+          <a:fontRef idx="minor">
+            <a:schemeClr val="lt1"/>
+          </a:fontRef>
+        </p:style>
+        <p:txBody>
+          <a:bodyPr rtlCol="0" anchor="ctr"/>
+          <a:lstStyle/>
+          <a:p>
+            <a:pPr algn="ctr"/>
+          </a:p>
+        </p:txBody>
+      </p:sp>
+      <p:sp>
+        <p:nvSpPr>
+          <p:cNvPr id="3" name="Rectangle 2"/>
           <p:cNvSpPr/>
           <p:nvPr/>
         </p:nvSpPr>
         <p:spPr>
           <a:xfrm>
             <a:off x="0" y="0"/>
-            <a:ext cx="109728" cy="6858000"/>
+            <a:ext cx="12192000" cy="64008"/>
+          </a:xfrm>
+          <a:prstGeom prst="rect">
+            <a:avLst/>
+          </a:prstGeom>
+          <a:solidFill>
+            <a:srgbClr val="E8243C"/>
+          </a:solidFill>
+          <a:ln>
+            <a:noFill/>
+          </a:ln>
+        </p:spPr>
+        <p:style>
+          <a:lnRef idx="1">
+            <a:schemeClr val="accent1"/>
+          </a:lnRef>
+          <a:fillRef idx="3">
+            <a:schemeClr val="accent1"/>
+          </a:fillRef>
+          <a:effectRef idx="2">
+            <a:schemeClr val="accent1"/>
+          </a:effectRef>
+          <a:fontRef idx="minor">
+            <a:schemeClr val="lt1"/>
+          </a:fontRef>
+        </p:style>
+        <p:txBody>
+          <a:bodyPr rtlCol="0" anchor="ctr"/>
+          <a:lstStyle/>
+          <a:p>
+            <a:pPr algn="ctr"/>
+          </a:p>
+        </p:txBody>
+      </p:sp>
+      <p:sp>
+        <p:nvSpPr>
+          <p:cNvPr id="4" name="Rectangle 3"/>
+          <p:cNvSpPr/>
+          <p:nvPr/>
+        </p:nvSpPr>
+        <p:spPr>
+          <a:xfrm>
+            <a:off x="0" y="0"/>
+            <a:ext cx="320040" cy="6858000"/>
+          </a:xfrm>
+          <a:prstGeom prst="rect">
+            <a:avLst/>
+          </a:prstGeom>
+          <a:solidFill>
+            <a:srgbClr val="E8243C"/>
+          </a:solidFill>
+          <a:ln>
+            <a:noFill/>
+          </a:ln>
+        </p:spPr>
+        <p:style>
+          <a:lnRef idx="1">
+            <a:schemeClr val="accent1"/>
+          </a:lnRef>
+          <a:fillRef idx="3">
+            <a:schemeClr val="accent1"/>
+          </a:fillRef>
+          <a:effectRef idx="2">
+            <a:schemeClr val="accent1"/>
+          </a:effectRef>
+          <a:fontRef idx="minor">
+            <a:schemeClr val="lt1"/>
+          </a:fontRef>
+        </p:style>
+        <p:txBody>
+          <a:bodyPr rtlCol="0" anchor="ctr"/>
+          <a:lstStyle/>
+          <a:p>
+            <a:pPr algn="ctr"/>
+          </a:p>
+        </p:txBody>
+      </p:sp>
+      <p:sp>
+        <p:nvSpPr>
+          <p:cNvPr id="5" name="Rectangle 4"/>
+          <p:cNvSpPr/>
+          <p:nvPr/>
+        </p:nvSpPr>
+        <p:spPr>
+          <a:xfrm>
+            <a:off x="0" y="6510528"/>
+            <a:ext cx="12192000" cy="347472"/>
+          </a:xfrm>
+          <a:prstGeom prst="rect">
+            <a:avLst/>
+          </a:prstGeom>
+          <a:solidFill>
+            <a:srgbClr val="F5F5F5"/>
+          </a:solidFill>
+          <a:ln>
+            <a:noFill/>
+          </a:ln>
+        </p:spPr>
+        <p:style>
+          <a:lnRef idx="1">
+            <a:schemeClr val="accent1"/>
+          </a:lnRef>
+          <a:fillRef idx="3">
+            <a:schemeClr val="accent1"/>
+          </a:fillRef>
+          <a:effectRef idx="2">
+            <a:schemeClr val="accent1"/>
+          </a:effectRef>
+          <a:fontRef idx="minor">
+            <a:schemeClr val="lt1"/>
+          </a:fontRef>
+        </p:style>
+        <p:txBody>
+          <a:bodyPr rtlCol="0" anchor="ctr"/>
+          <a:lstStyle/>
+          <a:p>
+            <a:pPr algn="ctr"/>
+          </a:p>
+        </p:txBody>
+      </p:sp>
+      <p:sp>
+        <p:nvSpPr>
+          <p:cNvPr id="6" name="TextBox 5"/>
+          <p:cNvSpPr txBox="1"/>
+          <p:nvPr/>
+        </p:nvSpPr>
+        <p:spPr>
+          <a:xfrm>
+            <a:off x="502920" y="6565392"/>
+            <a:ext cx="11460480" cy="219456"/>
+          </a:xfrm>
+          <a:prstGeom prst="rect">
+            <a:avLst/>
+          </a:prstGeom>
+          <a:noFill/>
+        </p:spPr>
+        <p:txBody>
+          <a:bodyPr wrap="square">
+            <a:spAutoFit/>
+          </a:bodyPr>
+          <a:lstStyle/>
+          <a:p>
+            <a:pPr algn="l"/>
+            <a:r>
+              <a:rPr sz="800" b="0" i="0">
+                <a:solidFill>
+                  <a:srgbClr val="6B6B6B"/>
+                </a:solidFill>
+                <a:latin typeface="Calibri"/>
+              </a:rPr>
+              <a:t>51.508 Secure Cyber Physical Systems  ·  SWaT Project  ·  iTrust Lab, SUTD</a:t>
+            </a:r>
+          </a:p>
+        </p:txBody>
+      </p:sp>
+      <p:sp>
+        <p:nvSpPr>
+          <p:cNvPr id="7" name="Rectangle 6"/>
+          <p:cNvSpPr/>
+          <p:nvPr/>
+        </p:nvSpPr>
+        <p:spPr>
+          <a:xfrm>
+            <a:off x="502920" y="548640"/>
+            <a:ext cx="1828800" cy="384048"/>
+          </a:xfrm>
+          <a:prstGeom prst="rect">
+            <a:avLst/>
+          </a:prstGeom>
+          <a:solidFill>
+            <a:srgbClr val="E8243C"/>
+          </a:solidFill>
+          <a:ln>
+            <a:noFill/>
+          </a:ln>
+        </p:spPr>
+        <p:style>
+          <a:lnRef idx="1">
+            <a:schemeClr val="accent1"/>
+          </a:lnRef>
+          <a:fillRef idx="3">
+            <a:schemeClr val="accent1"/>
+          </a:fillRef>
+          <a:effectRef idx="2">
+            <a:schemeClr val="accent1"/>
+          </a:effectRef>
+          <a:fontRef idx="minor">
+            <a:schemeClr val="lt1"/>
+          </a:fontRef>
+        </p:style>
+        <p:txBody>
+          <a:bodyPr rtlCol="0" anchor="ctr"/>
+          <a:lstStyle/>
+          <a:p>
+            <a:pPr algn="ctr"/>
+          </a:p>
+        </p:txBody>
+      </p:sp>
+      <p:sp>
+        <p:nvSpPr>
+          <p:cNvPr id="8" name="TextBox 7"/>
+          <p:cNvSpPr txBox="1"/>
+          <p:nvPr/>
+        </p:nvSpPr>
+        <p:spPr>
+          <a:xfrm>
+            <a:off x="502920" y="548640"/>
+            <a:ext cx="1828800" cy="384048"/>
+          </a:xfrm>
+          <a:prstGeom prst="rect">
+            <a:avLst/>
+          </a:prstGeom>
+          <a:noFill/>
+        </p:spPr>
+        <p:txBody>
+          <a:bodyPr wrap="square">
+            <a:spAutoFit/>
+          </a:bodyPr>
+          <a:lstStyle/>
+          <a:p>
+            <a:pPr algn="ctr"/>
+            <a:r>
+              <a:rPr sz="1100" b="1" i="0">
+                <a:solidFill>
+                  <a:srgbClr val="FFFFFF"/>
+                </a:solidFill>
+                <a:latin typeface="Calibri"/>
+              </a:rPr>
+              <a:t>SECTION 3</a:t>
+            </a:r>
+          </a:p>
+        </p:txBody>
+      </p:sp>
+      <p:sp>
+        <p:nvSpPr>
+          <p:cNvPr id="9" name="TextBox 8"/>
+          <p:cNvSpPr txBox="1"/>
+          <p:nvPr/>
+        </p:nvSpPr>
+        <p:spPr>
+          <a:xfrm>
+            <a:off x="502920" y="1097280"/>
+            <a:ext cx="8229600" cy="914400"/>
+          </a:xfrm>
+          <a:prstGeom prst="rect">
+            <a:avLst/>
+          </a:prstGeom>
+          <a:noFill/>
+        </p:spPr>
+        <p:txBody>
+          <a:bodyPr wrap="square">
+            <a:spAutoFit/>
+          </a:bodyPr>
+          <a:lstStyle/>
+          <a:p>
+            <a:pPr algn="l"/>
+            <a:r>
+              <a:rPr sz="4200" b="1" i="0">
+                <a:solidFill>
+                  <a:srgbClr val="1A1A1A"/>
+                </a:solidFill>
+                <a:latin typeface="Calibri Light"/>
+              </a:rPr>
+              <a:t>Defending SWaT</a:t>
+            </a:r>
+          </a:p>
+        </p:txBody>
+      </p:sp>
+      <p:sp>
+        <p:nvSpPr>
+          <p:cNvPr id="10" name="TextBox 9"/>
+          <p:cNvSpPr txBox="1"/>
+          <p:nvPr/>
+        </p:nvSpPr>
+        <p:spPr>
+          <a:xfrm>
+            <a:off x="502920" y="2029968"/>
+            <a:ext cx="8229600" cy="475488"/>
+          </a:xfrm>
+          <a:prstGeom prst="rect">
+            <a:avLst/>
+          </a:prstGeom>
+          <a:noFill/>
+        </p:spPr>
+        <p:txBody>
+          <a:bodyPr wrap="square">
+            <a:spAutoFit/>
+          </a:bodyPr>
+          <a:lstStyle/>
+          <a:p>
+            <a:pPr algn="l"/>
+            <a:r>
+              <a:rPr sz="2000" b="0" i="0">
+                <a:solidFill>
+                  <a:srgbClr val="E8243C"/>
+                </a:solidFill>
+                <a:latin typeface="Calibri Light"/>
+              </a:rPr>
+              <a:t>Against False CIP Tag Injection from Compromised HMI</a:t>
+            </a:r>
+          </a:p>
+        </p:txBody>
+      </p:sp>
+      <p:sp>
+        <p:nvSpPr>
+          <p:cNvPr id="11" name="Rectangle 10"/>
+          <p:cNvSpPr/>
+          <p:nvPr/>
+        </p:nvSpPr>
+        <p:spPr>
+          <a:xfrm>
+            <a:off x="502920" y="2697480"/>
+            <a:ext cx="2560320" cy="868680"/>
           </a:xfrm>
           <a:prstGeom prst="rect">
             <a:avLst/>
@@ -13374,372 +13938,279 @@
           <a:solidFill>
             <a:srgbClr val="1565C0"/>
           </a:solidFill>
-          <a:ln/>
-        </p:spPr>
-      </p:sp>
-      <p:sp>
-        <p:nvSpPr>
-          <p:cNvPr id="4" name="Text 2"/>
-          <p:cNvSpPr/>
-          <p:nvPr/>
-        </p:nvSpPr>
-        <p:spPr>
-          <a:xfrm>
-            <a:off x="457200" y="1371600"/>
-            <a:ext cx="8229600" cy="914400"/>
-          </a:xfrm>
-          <a:prstGeom prst="rect">
-            <a:avLst/>
-          </a:prstGeom>
-          <a:noFill/>
-          <a:ln/>
-        </p:spPr>
-        <p:txBody>
-          <a:bodyPr wrap="square" rtlCol="0" anchor="ctr"/>
-          <a:lstStyle/>
-          <a:p>
-            <a:pPr indent="0" marL="0">
-              <a:buNone/>
-            </a:pPr>
-            <a:r>
-              <a:rPr lang="en-US" sz="4400" b="1" dirty="0">
+          <a:ln>
+            <a:noFill/>
+          </a:ln>
+        </p:spPr>
+        <p:style>
+          <a:lnRef idx="1">
+            <a:schemeClr val="accent1"/>
+          </a:lnRef>
+          <a:fillRef idx="3">
+            <a:schemeClr val="accent1"/>
+          </a:fillRef>
+          <a:effectRef idx="2">
+            <a:schemeClr val="accent1"/>
+          </a:effectRef>
+          <a:fontRef idx="minor">
+            <a:schemeClr val="lt1"/>
+          </a:fontRef>
+        </p:style>
+        <p:txBody>
+          <a:bodyPr rtlCol="0" anchor="ctr"/>
+          <a:lstStyle/>
+          <a:p>
+            <a:pPr algn="ctr"/>
+          </a:p>
+        </p:txBody>
+      </p:sp>
+      <p:sp>
+        <p:nvSpPr>
+          <p:cNvPr id="12" name="TextBox 11"/>
+          <p:cNvSpPr txBox="1"/>
+          <p:nvPr/>
+        </p:nvSpPr>
+        <p:spPr>
+          <a:xfrm>
+            <a:off x="502920" y="2697480"/>
+            <a:ext cx="2560320" cy="868680"/>
+          </a:xfrm>
+          <a:prstGeom prst="rect">
+            <a:avLst/>
+          </a:prstGeom>
+          <a:noFill/>
+        </p:spPr>
+        <p:txBody>
+          <a:bodyPr wrap="square">
+            <a:spAutoFit/>
+          </a:bodyPr>
+          <a:lstStyle/>
+          <a:p>
+            <a:pPr algn="ctr"/>
+            <a:r>
+              <a:rPr sz="1200" b="1" i="0">
                 <a:solidFill>
                   <a:srgbClr val="FFFFFF"/>
                 </a:solidFill>
-                <a:latin typeface="Calibri Light" pitchFamily="34" charset="0"/>
-                <a:ea typeface="Calibri Light" pitchFamily="34" charset="-122"/>
-                <a:cs typeface="Calibri Light" pitchFamily="34" charset="-120"/>
-              </a:rPr>
-              <a:t>Defending SWaT</a:t>
-            </a:r>
-            <a:endParaRPr lang="en-US" sz="4400" dirty="0"/>
-          </a:p>
-        </p:txBody>
-      </p:sp>
-      <p:sp>
-        <p:nvSpPr>
-          <p:cNvPr id="5" name="Text 3"/>
-          <p:cNvSpPr/>
-          <p:nvPr/>
-        </p:nvSpPr>
-        <p:spPr>
-          <a:xfrm>
-            <a:off x="457200" y="2286000"/>
-            <a:ext cx="8229600" cy="457200"/>
-          </a:xfrm>
-          <a:prstGeom prst="rect">
-            <a:avLst/>
-          </a:prstGeom>
-          <a:noFill/>
-          <a:ln/>
-        </p:spPr>
-        <p:txBody>
-          <a:bodyPr wrap="square" rtlCol="0" anchor="ctr"/>
-          <a:lstStyle/>
-          <a:p>
-            <a:pPr indent="0" marL="0">
-              <a:buNone/>
-            </a:pPr>
-            <a:r>
-              <a:rPr lang="en-US" sz="2000" dirty="0">
-                <a:solidFill>
-                  <a:srgbClr val="4FC3F7"/>
-                </a:solidFill>
-                <a:latin typeface="Calibri Light" pitchFamily="34" charset="0"/>
-                <a:ea typeface="Calibri Light" pitchFamily="34" charset="-122"/>
-                <a:cs typeface="Calibri Light" pitchFamily="34" charset="-120"/>
-              </a:rPr>
-              <a:t>Against False CIP Tag Injection from Compromised HMI</a:t>
-            </a:r>
-            <a:endParaRPr lang="en-US" sz="2000" dirty="0"/>
-          </a:p>
-        </p:txBody>
-      </p:sp>
-      <p:sp>
-        <p:nvSpPr>
-          <p:cNvPr id="6" name="Shape 4"/>
-          <p:cNvSpPr/>
-          <p:nvPr/>
-        </p:nvSpPr>
-        <p:spPr>
-          <a:xfrm>
-            <a:off x="457200" y="3017520"/>
-            <a:ext cx="2743200" cy="822960"/>
-          </a:xfrm>
-          <a:prstGeom prst="rect">
-            <a:avLst/>
-          </a:prstGeom>
-          <a:solidFill>
-            <a:srgbClr val="1565C0"/>
-          </a:solidFill>
-          <a:ln/>
-        </p:spPr>
-      </p:sp>
-      <p:sp>
-        <p:nvSpPr>
-          <p:cNvPr id="7" name="Text 5"/>
-          <p:cNvSpPr/>
-          <p:nvPr/>
-        </p:nvSpPr>
-        <p:spPr>
-          <a:xfrm>
-            <a:off x="457200" y="3017520"/>
-            <a:ext cx="2743200" cy="822960"/>
-          </a:xfrm>
-          <a:prstGeom prst="rect">
-            <a:avLst/>
-          </a:prstGeom>
-          <a:noFill/>
-          <a:ln/>
-        </p:spPr>
-        <p:txBody>
-          <a:bodyPr wrap="square" rtlCol="0" anchor="ctr"/>
-          <a:lstStyle/>
-          <a:p>
-            <a:pPr algn="ctr" indent="0" marL="0">
-              <a:buNone/>
-            </a:pPr>
-            <a:r>
-              <a:rPr lang="en-US" sz="1200" b="1" dirty="0">
+                <a:latin typeface="Calibri"/>
+              </a:rPr>
+              <a:t>Layer 1
+Process Invariant Checker</a:t>
+            </a:r>
+          </a:p>
+        </p:txBody>
+      </p:sp>
+      <p:sp>
+        <p:nvSpPr>
+          <p:cNvPr id="13" name="Rectangle 12"/>
+          <p:cNvSpPr/>
+          <p:nvPr/>
+        </p:nvSpPr>
+        <p:spPr>
+          <a:xfrm>
+            <a:off x="3246120" y="2697480"/>
+            <a:ext cx="2560320" cy="868680"/>
+          </a:xfrm>
+          <a:prstGeom prst="rect">
+            <a:avLst/>
+          </a:prstGeom>
+          <a:solidFill>
+            <a:srgbClr val="1976D2"/>
+          </a:solidFill>
+          <a:ln>
+            <a:noFill/>
+          </a:ln>
+        </p:spPr>
+        <p:style>
+          <a:lnRef idx="1">
+            <a:schemeClr val="accent1"/>
+          </a:lnRef>
+          <a:fillRef idx="3">
+            <a:schemeClr val="accent1"/>
+          </a:fillRef>
+          <a:effectRef idx="2">
+            <a:schemeClr val="accent1"/>
+          </a:effectRef>
+          <a:fontRef idx="minor">
+            <a:schemeClr val="lt1"/>
+          </a:fontRef>
+        </p:style>
+        <p:txBody>
+          <a:bodyPr rtlCol="0" anchor="ctr"/>
+          <a:lstStyle/>
+          <a:p>
+            <a:pPr algn="ctr"/>
+          </a:p>
+        </p:txBody>
+      </p:sp>
+      <p:sp>
+        <p:nvSpPr>
+          <p:cNvPr id="14" name="TextBox 13"/>
+          <p:cNvSpPr txBox="1"/>
+          <p:nvPr/>
+        </p:nvSpPr>
+        <p:spPr>
+          <a:xfrm>
+            <a:off x="3246120" y="2697480"/>
+            <a:ext cx="2560320" cy="868680"/>
+          </a:xfrm>
+          <a:prstGeom prst="rect">
+            <a:avLst/>
+          </a:prstGeom>
+          <a:noFill/>
+        </p:spPr>
+        <p:txBody>
+          <a:bodyPr wrap="square">
+            <a:spAutoFit/>
+          </a:bodyPr>
+          <a:lstStyle/>
+          <a:p>
+            <a:pPr algn="ctr"/>
+            <a:r>
+              <a:rPr sz="1200" b="1" i="0">
                 <a:solidFill>
                   <a:srgbClr val="FFFFFF"/>
                 </a:solidFill>
-                <a:latin typeface="Calibri" pitchFamily="34" charset="0"/>
-                <a:ea typeface="Calibri" pitchFamily="34" charset="-122"/>
-                <a:cs typeface="Calibri" pitchFamily="34" charset="-120"/>
-              </a:rPr>
-              <a:t>Layer 1</a:t>
-            </a:r>
-            <a:endParaRPr lang="en-US" sz="1200" dirty="0"/>
-          </a:p>
-          <a:p>
-            <a:pPr algn="ctr" indent="0" marL="0">
-              <a:buNone/>
-            </a:pPr>
-            <a:r>
-              <a:rPr lang="en-US" sz="1200" b="1" dirty="0">
+                <a:latin typeface="Calibri"/>
+              </a:rPr>
+              <a:t>Layer 2
+Reconstruction Autoencoder</a:t>
+            </a:r>
+          </a:p>
+        </p:txBody>
+      </p:sp>
+      <p:sp>
+        <p:nvSpPr>
+          <p:cNvPr id="15" name="Rectangle 14"/>
+          <p:cNvSpPr/>
+          <p:nvPr/>
+        </p:nvSpPr>
+        <p:spPr>
+          <a:xfrm>
+            <a:off x="5989320" y="2697480"/>
+            <a:ext cx="2560320" cy="868680"/>
+          </a:xfrm>
+          <a:prstGeom prst="rect">
+            <a:avLst/>
+          </a:prstGeom>
+          <a:solidFill>
+            <a:srgbClr val="E65100"/>
+          </a:solidFill>
+          <a:ln>
+            <a:noFill/>
+          </a:ln>
+        </p:spPr>
+        <p:style>
+          <a:lnRef idx="1">
+            <a:schemeClr val="accent1"/>
+          </a:lnRef>
+          <a:fillRef idx="3">
+            <a:schemeClr val="accent1"/>
+          </a:fillRef>
+          <a:effectRef idx="2">
+            <a:schemeClr val="accent1"/>
+          </a:effectRef>
+          <a:fontRef idx="minor">
+            <a:schemeClr val="lt1"/>
+          </a:fontRef>
+        </p:style>
+        <p:txBody>
+          <a:bodyPr rtlCol="0" anchor="ctr"/>
+          <a:lstStyle/>
+          <a:p>
+            <a:pPr algn="ctr"/>
+          </a:p>
+        </p:txBody>
+      </p:sp>
+      <p:sp>
+        <p:nvSpPr>
+          <p:cNvPr id="16" name="TextBox 15"/>
+          <p:cNvSpPr txBox="1"/>
+          <p:nvPr/>
+        </p:nvSpPr>
+        <p:spPr>
+          <a:xfrm>
+            <a:off x="5989320" y="2697480"/>
+            <a:ext cx="2560320" cy="868680"/>
+          </a:xfrm>
+          <a:prstGeom prst="rect">
+            <a:avLst/>
+          </a:prstGeom>
+          <a:noFill/>
+        </p:spPr>
+        <p:txBody>
+          <a:bodyPr wrap="square">
+            <a:spAutoFit/>
+          </a:bodyPr>
+          <a:lstStyle/>
+          <a:p>
+            <a:pPr algn="ctr"/>
+            <a:r>
+              <a:rPr sz="1200" b="1" i="0">
                 <a:solidFill>
                   <a:srgbClr val="FFFFFF"/>
                 </a:solidFill>
-                <a:latin typeface="Calibri" pitchFamily="34" charset="0"/>
-                <a:ea typeface="Calibri" pitchFamily="34" charset="-122"/>
-                <a:cs typeface="Calibri" pitchFamily="34" charset="-120"/>
-              </a:rPr>
-              <a:t>Process Invariant Checker</a:t>
-            </a:r>
-            <a:endParaRPr lang="en-US" sz="1200" dirty="0"/>
-          </a:p>
-        </p:txBody>
-      </p:sp>
-      <p:sp>
-        <p:nvSpPr>
-          <p:cNvPr id="8" name="Shape 6"/>
-          <p:cNvSpPr/>
-          <p:nvPr/>
-        </p:nvSpPr>
-        <p:spPr>
-          <a:xfrm>
-            <a:off x="3383280" y="3017520"/>
-            <a:ext cx="2743200" cy="822960"/>
-          </a:xfrm>
-          <a:prstGeom prst="rect">
-            <a:avLst/>
-          </a:prstGeom>
-          <a:solidFill>
-            <a:srgbClr val="1976D2"/>
-          </a:solidFill>
-          <a:ln/>
-        </p:spPr>
-      </p:sp>
-      <p:sp>
-        <p:nvSpPr>
-          <p:cNvPr id="9" name="Text 7"/>
-          <p:cNvSpPr/>
-          <p:nvPr/>
-        </p:nvSpPr>
-        <p:spPr>
-          <a:xfrm>
-            <a:off x="3383280" y="3017520"/>
-            <a:ext cx="2743200" cy="822960"/>
-          </a:xfrm>
-          <a:prstGeom prst="rect">
-            <a:avLst/>
-          </a:prstGeom>
-          <a:noFill/>
-          <a:ln/>
-        </p:spPr>
-        <p:txBody>
-          <a:bodyPr wrap="square" rtlCol="0" anchor="ctr"/>
-          <a:lstStyle/>
-          <a:p>
-            <a:pPr algn="ctr" indent="0" marL="0">
-              <a:buNone/>
-            </a:pPr>
-            <a:r>
-              <a:rPr lang="en-US" sz="1200" b="1" dirty="0">
-                <a:solidFill>
-                  <a:srgbClr val="FFFFFF"/>
-                </a:solidFill>
-                <a:latin typeface="Calibri" pitchFamily="34" charset="0"/>
-                <a:ea typeface="Calibri" pitchFamily="34" charset="-122"/>
-                <a:cs typeface="Calibri" pitchFamily="34" charset="-120"/>
-              </a:rPr>
-              <a:t>Layer 2</a:t>
-            </a:r>
-            <a:endParaRPr lang="en-US" sz="1200" dirty="0"/>
-          </a:p>
-          <a:p>
-            <a:pPr algn="ctr" indent="0" marL="0">
-              <a:buNone/>
-            </a:pPr>
-            <a:r>
-              <a:rPr lang="en-US" sz="1200" b="1" dirty="0">
-                <a:solidFill>
-                  <a:srgbClr val="FFFFFF"/>
-                </a:solidFill>
-                <a:latin typeface="Calibri" pitchFamily="34" charset="0"/>
-                <a:ea typeface="Calibri" pitchFamily="34" charset="-122"/>
-                <a:cs typeface="Calibri" pitchFamily="34" charset="-120"/>
-              </a:rPr>
-              <a:t>Reconstruction Autoencoder</a:t>
-            </a:r>
-            <a:endParaRPr lang="en-US" sz="1200" dirty="0"/>
-          </a:p>
-        </p:txBody>
-      </p:sp>
-      <p:sp>
-        <p:nvSpPr>
-          <p:cNvPr id="10" name="Shape 8"/>
-          <p:cNvSpPr/>
-          <p:nvPr/>
-        </p:nvSpPr>
-        <p:spPr>
-          <a:xfrm>
-            <a:off x="6309360" y="3017520"/>
-            <a:ext cx="2743200" cy="822960"/>
-          </a:xfrm>
-          <a:prstGeom prst="rect">
-            <a:avLst/>
-          </a:prstGeom>
-          <a:solidFill>
-            <a:srgbClr val="E65100"/>
-          </a:solidFill>
-          <a:ln/>
-        </p:spPr>
-      </p:sp>
-      <p:sp>
-        <p:nvSpPr>
-          <p:cNvPr id="11" name="Text 9"/>
-          <p:cNvSpPr/>
-          <p:nvPr/>
-        </p:nvSpPr>
-        <p:spPr>
-          <a:xfrm>
-            <a:off x="6309360" y="3017520"/>
-            <a:ext cx="2743200" cy="822960"/>
-          </a:xfrm>
-          <a:prstGeom prst="rect">
-            <a:avLst/>
-          </a:prstGeom>
-          <a:noFill/>
-          <a:ln/>
-        </p:spPr>
-        <p:txBody>
-          <a:bodyPr wrap="square" rtlCol="0" anchor="ctr"/>
-          <a:lstStyle/>
-          <a:p>
-            <a:pPr algn="ctr" indent="0" marL="0">
-              <a:buNone/>
-            </a:pPr>
-            <a:r>
-              <a:rPr lang="en-US" sz="1200" b="1" dirty="0">
-                <a:solidFill>
-                  <a:srgbClr val="FFFFFF"/>
-                </a:solidFill>
-                <a:latin typeface="Calibri" pitchFamily="34" charset="0"/>
-                <a:ea typeface="Calibri" pitchFamily="34" charset="-122"/>
-                <a:cs typeface="Calibri" pitchFamily="34" charset="-120"/>
-              </a:rPr>
-              <a:t>Layer 3</a:t>
-            </a:r>
-            <a:endParaRPr lang="en-US" sz="1200" dirty="0"/>
-          </a:p>
-          <a:p>
-            <a:pPr algn="ctr" indent="0" marL="0">
-              <a:buNone/>
-            </a:pPr>
-            <a:r>
-              <a:rPr lang="en-US" sz="1200" b="1" dirty="0">
-                <a:solidFill>
-                  <a:srgbClr val="FFFFFF"/>
-                </a:solidFill>
-                <a:latin typeface="Calibri" pitchFamily="34" charset="0"/>
-                <a:ea typeface="Calibri" pitchFamily="34" charset="-122"/>
-                <a:cs typeface="Calibri" pitchFamily="34" charset="-120"/>
-              </a:rPr>
-              <a:t>Decision Fusion + Alert</a:t>
-            </a:r>
-            <a:endParaRPr lang="en-US" sz="1200" dirty="0"/>
-          </a:p>
-        </p:txBody>
-      </p:sp>
-      <p:sp>
-        <p:nvSpPr>
-          <p:cNvPr id="12" name="Text 10"/>
-          <p:cNvSpPr/>
-          <p:nvPr/>
-        </p:nvSpPr>
-        <p:spPr>
-          <a:xfrm>
-            <a:off x="457200" y="4023360"/>
-            <a:ext cx="9144000" cy="365760"/>
-          </a:xfrm>
-          <a:prstGeom prst="rect">
-            <a:avLst/>
-          </a:prstGeom>
-          <a:noFill/>
-          <a:ln/>
-        </p:spPr>
-        <p:txBody>
-          <a:bodyPr wrap="square" rtlCol="0" anchor="ctr"/>
-          <a:lstStyle/>
-          <a:p>
-            <a:pPr indent="0" marL="0">
-              <a:buNone/>
-            </a:pPr>
-            <a:r>
-              <a:rPr lang="en-US" sz="1300" dirty="0">
-                <a:solidFill>
-                  <a:srgbClr val="AAAAAA"/>
-                </a:solidFill>
-                <a:latin typeface="Calibri" pitchFamily="34" charset="0"/>
-                <a:ea typeface="Calibri" pitchFamily="34" charset="-122"/>
-                <a:cs typeface="Calibri" pitchFamily="34" charset="-120"/>
+                <a:latin typeface="Calibri"/>
+              </a:rPr>
+              <a:t>Layer 3
+Decision Fusion + Alert</a:t>
+            </a:r>
+          </a:p>
+        </p:txBody>
+      </p:sp>
+      <p:sp>
+        <p:nvSpPr>
+          <p:cNvPr id="17" name="TextBox 16"/>
+          <p:cNvSpPr txBox="1"/>
+          <p:nvPr/>
+        </p:nvSpPr>
+        <p:spPr>
+          <a:xfrm>
+            <a:off x="502920" y="3730752"/>
+            <a:ext cx="9144000" cy="347472"/>
+          </a:xfrm>
+          <a:prstGeom prst="rect">
+            <a:avLst/>
+          </a:prstGeom>
+          <a:noFill/>
+        </p:spPr>
+        <p:txBody>
+          <a:bodyPr wrap="square">
+            <a:spAutoFit/>
+          </a:bodyPr>
+          <a:lstStyle/>
+          <a:p>
+            <a:pPr algn="l"/>
+            <a:r>
+              <a:rPr sz="1200" b="0" i="0">
+                <a:solidFill>
+                  <a:srgbClr val="6B6B6B"/>
+                </a:solidFill>
+                <a:latin typeface="Calibri"/>
               </a:rPr>
               <a:t>Recovery:  Detect → Contain → Safe State → PLC Failover → Invariant-Verified Resume</a:t>
             </a:r>
-            <a:endParaRPr lang="en-US" sz="1300" dirty="0"/>
           </a:p>
         </p:txBody>
       </p:sp>
       <p:pic>
         <p:nvPicPr>
-          <p:cNvPr id="13" name="Image 0" descr="/home/claude/swat-cps-project/assets/images/swat_testbed_photo.jpg">    </p:cNvPr>
+          <p:cNvPr id="18" name="Picture 17" descr="image.jpg"/>
           <p:cNvPicPr>
             <a:picLocks noChangeAspect="1"/>
           </p:cNvPicPr>
           <p:nvPr/>
         </p:nvPicPr>
         <p:blipFill>
-          <a:blip r:embed="rId1"/>
+          <a:blip r:embed="rId4"/>
           <a:stretch>
             <a:fillRect/>
           </a:stretch>
         </p:blipFill>
         <p:spPr>
           <a:xfrm>
-            <a:off x="457200" y="4526280"/>
-            <a:ext cx="11548872" cy="1828800"/>
+            <a:off x="502920" y="4160520"/>
+            <a:ext cx="11369040" cy="1828800"/>
           </a:xfrm>
           <a:prstGeom prst="rect">
             <a:avLst/>
@@ -27474,34 +27945,369 @@
       </p:grpSpPr>
       <p:sp>
         <p:nvSpPr>
-          <p:cNvPr id="2" name="Shape 0"/>
+          <p:cNvPr id="2" name="Rectangle 1"/>
           <p:cNvSpPr/>
           <p:nvPr/>
         </p:nvSpPr>
         <p:spPr>
           <a:xfrm>
             <a:off x="0" y="0"/>
-            <a:ext cx="12188952" cy="6858000"/>
-          </a:xfrm>
-          <a:prstGeom prst="rect">
-            <a:avLst/>
-          </a:prstGeom>
-          <a:solidFill>
-            <a:srgbClr val="1A1A1A"/>
-          </a:solidFill>
-          <a:ln/>
-        </p:spPr>
-      </p:sp>
-      <p:sp>
-        <p:nvSpPr>
-          <p:cNvPr id="3" name="Shape 1"/>
+            <a:ext cx="12192000" cy="6858000"/>
+          </a:xfrm>
+          <a:prstGeom prst="rect">
+            <a:avLst/>
+          </a:prstGeom>
+          <a:solidFill>
+            <a:srgbClr val="FFFFFF"/>
+          </a:solidFill>
+          <a:ln>
+            <a:noFill/>
+          </a:ln>
+        </p:spPr>
+        <p:style>
+          <a:lnRef idx="1">
+            <a:schemeClr val="accent1"/>
+          </a:lnRef>
+          <a:fillRef idx="3">
+            <a:schemeClr val="accent1"/>
+          </a:fillRef>
+          <a:effectRef idx="2">
+            <a:schemeClr val="accent1"/>
+          </a:effectRef>
+          <a:fontRef idx="minor">
+            <a:schemeClr val="lt1"/>
+          </a:fontRef>
+        </p:style>
+        <p:txBody>
+          <a:bodyPr rtlCol="0" anchor="ctr"/>
+          <a:lstStyle/>
+          <a:p>
+            <a:pPr algn="ctr"/>
+          </a:p>
+        </p:txBody>
+      </p:sp>
+      <p:sp>
+        <p:nvSpPr>
+          <p:cNvPr id="3" name="Rectangle 2"/>
           <p:cNvSpPr/>
           <p:nvPr/>
         </p:nvSpPr>
         <p:spPr>
           <a:xfrm>
             <a:off x="0" y="0"/>
-            <a:ext cx="109728" cy="6858000"/>
+            <a:ext cx="12192000" cy="64008"/>
+          </a:xfrm>
+          <a:prstGeom prst="rect">
+            <a:avLst/>
+          </a:prstGeom>
+          <a:solidFill>
+            <a:srgbClr val="E8243C"/>
+          </a:solidFill>
+          <a:ln>
+            <a:noFill/>
+          </a:ln>
+        </p:spPr>
+        <p:style>
+          <a:lnRef idx="1">
+            <a:schemeClr val="accent1"/>
+          </a:lnRef>
+          <a:fillRef idx="3">
+            <a:schemeClr val="accent1"/>
+          </a:fillRef>
+          <a:effectRef idx="2">
+            <a:schemeClr val="accent1"/>
+          </a:effectRef>
+          <a:fontRef idx="minor">
+            <a:schemeClr val="lt1"/>
+          </a:fontRef>
+        </p:style>
+        <p:txBody>
+          <a:bodyPr rtlCol="0" anchor="ctr"/>
+          <a:lstStyle/>
+          <a:p>
+            <a:pPr algn="ctr"/>
+          </a:p>
+        </p:txBody>
+      </p:sp>
+      <p:sp>
+        <p:nvSpPr>
+          <p:cNvPr id="4" name="Rectangle 3"/>
+          <p:cNvSpPr/>
+          <p:nvPr/>
+        </p:nvSpPr>
+        <p:spPr>
+          <a:xfrm>
+            <a:off x="0" y="0"/>
+            <a:ext cx="320040" cy="6858000"/>
+          </a:xfrm>
+          <a:prstGeom prst="rect">
+            <a:avLst/>
+          </a:prstGeom>
+          <a:solidFill>
+            <a:srgbClr val="E8243C"/>
+          </a:solidFill>
+          <a:ln>
+            <a:noFill/>
+          </a:ln>
+        </p:spPr>
+        <p:style>
+          <a:lnRef idx="1">
+            <a:schemeClr val="accent1"/>
+          </a:lnRef>
+          <a:fillRef idx="3">
+            <a:schemeClr val="accent1"/>
+          </a:fillRef>
+          <a:effectRef idx="2">
+            <a:schemeClr val="accent1"/>
+          </a:effectRef>
+          <a:fontRef idx="minor">
+            <a:schemeClr val="lt1"/>
+          </a:fontRef>
+        </p:style>
+        <p:txBody>
+          <a:bodyPr rtlCol="0" anchor="ctr"/>
+          <a:lstStyle/>
+          <a:p>
+            <a:pPr algn="ctr"/>
+          </a:p>
+        </p:txBody>
+      </p:sp>
+      <p:sp>
+        <p:nvSpPr>
+          <p:cNvPr id="5" name="Rectangle 4"/>
+          <p:cNvSpPr/>
+          <p:nvPr/>
+        </p:nvSpPr>
+        <p:spPr>
+          <a:xfrm>
+            <a:off x="0" y="6510528"/>
+            <a:ext cx="12192000" cy="347472"/>
+          </a:xfrm>
+          <a:prstGeom prst="rect">
+            <a:avLst/>
+          </a:prstGeom>
+          <a:solidFill>
+            <a:srgbClr val="F5F5F5"/>
+          </a:solidFill>
+          <a:ln>
+            <a:noFill/>
+          </a:ln>
+        </p:spPr>
+        <p:style>
+          <a:lnRef idx="1">
+            <a:schemeClr val="accent1"/>
+          </a:lnRef>
+          <a:fillRef idx="3">
+            <a:schemeClr val="accent1"/>
+          </a:fillRef>
+          <a:effectRef idx="2">
+            <a:schemeClr val="accent1"/>
+          </a:effectRef>
+          <a:fontRef idx="minor">
+            <a:schemeClr val="lt1"/>
+          </a:fontRef>
+        </p:style>
+        <p:txBody>
+          <a:bodyPr rtlCol="0" anchor="ctr"/>
+          <a:lstStyle/>
+          <a:p>
+            <a:pPr algn="ctr"/>
+          </a:p>
+        </p:txBody>
+      </p:sp>
+      <p:sp>
+        <p:nvSpPr>
+          <p:cNvPr id="6" name="TextBox 5"/>
+          <p:cNvSpPr txBox="1"/>
+          <p:nvPr/>
+        </p:nvSpPr>
+        <p:spPr>
+          <a:xfrm>
+            <a:off x="502920" y="6565392"/>
+            <a:ext cx="11460480" cy="219456"/>
+          </a:xfrm>
+          <a:prstGeom prst="rect">
+            <a:avLst/>
+          </a:prstGeom>
+          <a:noFill/>
+        </p:spPr>
+        <p:txBody>
+          <a:bodyPr wrap="square">
+            <a:spAutoFit/>
+          </a:bodyPr>
+          <a:lstStyle/>
+          <a:p>
+            <a:pPr algn="l"/>
+            <a:r>
+              <a:rPr sz="800" b="0" i="0">
+                <a:solidFill>
+                  <a:srgbClr val="6B6B6B"/>
+                </a:solidFill>
+                <a:latin typeface="Calibri"/>
+              </a:rPr>
+              <a:t>51.508 Secure Cyber Physical Systems  ·  SWaT Project  ·  iTrust Lab, SUTD</a:t>
+            </a:r>
+          </a:p>
+        </p:txBody>
+      </p:sp>
+      <p:sp>
+        <p:nvSpPr>
+          <p:cNvPr id="7" name="Rectangle 6"/>
+          <p:cNvSpPr/>
+          <p:nvPr/>
+        </p:nvSpPr>
+        <p:spPr>
+          <a:xfrm>
+            <a:off x="502920" y="548640"/>
+            <a:ext cx="1828800" cy="384048"/>
+          </a:xfrm>
+          <a:prstGeom prst="rect">
+            <a:avLst/>
+          </a:prstGeom>
+          <a:solidFill>
+            <a:srgbClr val="E8243C"/>
+          </a:solidFill>
+          <a:ln>
+            <a:noFill/>
+          </a:ln>
+        </p:spPr>
+        <p:style>
+          <a:lnRef idx="1">
+            <a:schemeClr val="accent1"/>
+          </a:lnRef>
+          <a:fillRef idx="3">
+            <a:schemeClr val="accent1"/>
+          </a:fillRef>
+          <a:effectRef idx="2">
+            <a:schemeClr val="accent1"/>
+          </a:effectRef>
+          <a:fontRef idx="minor">
+            <a:schemeClr val="lt1"/>
+          </a:fontRef>
+        </p:style>
+        <p:txBody>
+          <a:bodyPr rtlCol="0" anchor="ctr"/>
+          <a:lstStyle/>
+          <a:p>
+            <a:pPr algn="ctr"/>
+          </a:p>
+        </p:txBody>
+      </p:sp>
+      <p:sp>
+        <p:nvSpPr>
+          <p:cNvPr id="8" name="TextBox 7"/>
+          <p:cNvSpPr txBox="1"/>
+          <p:nvPr/>
+        </p:nvSpPr>
+        <p:spPr>
+          <a:xfrm>
+            <a:off x="502920" y="548640"/>
+            <a:ext cx="1828800" cy="384048"/>
+          </a:xfrm>
+          <a:prstGeom prst="rect">
+            <a:avLst/>
+          </a:prstGeom>
+          <a:noFill/>
+        </p:spPr>
+        <p:txBody>
+          <a:bodyPr wrap="square">
+            <a:spAutoFit/>
+          </a:bodyPr>
+          <a:lstStyle/>
+          <a:p>
+            <a:pPr algn="ctr"/>
+            <a:r>
+              <a:rPr sz="1100" b="1" i="0">
+                <a:solidFill>
+                  <a:srgbClr val="FFFFFF"/>
+                </a:solidFill>
+                <a:latin typeface="Calibri"/>
+              </a:rPr>
+              <a:t>SECTION 4</a:t>
+            </a:r>
+          </a:p>
+        </p:txBody>
+      </p:sp>
+      <p:sp>
+        <p:nvSpPr>
+          <p:cNvPr id="9" name="TextBox 8"/>
+          <p:cNvSpPr txBox="1"/>
+          <p:nvPr/>
+        </p:nvSpPr>
+        <p:spPr>
+          <a:xfrm>
+            <a:off x="502920" y="1097280"/>
+            <a:ext cx="9144000" cy="914400"/>
+          </a:xfrm>
+          <a:prstGeom prst="rect">
+            <a:avLst/>
+          </a:prstGeom>
+          <a:noFill/>
+        </p:spPr>
+        <p:txBody>
+          <a:bodyPr wrap="square">
+            <a:spAutoFit/>
+          </a:bodyPr>
+          <a:lstStyle/>
+          <a:p>
+            <a:pPr algn="l"/>
+            <a:r>
+              <a:rPr sz="3800" b="1" i="0">
+                <a:solidFill>
+                  <a:srgbClr val="1A1A1A"/>
+                </a:solidFill>
+                <a:latin typeface="Calibri Light"/>
+              </a:rPr>
+              <a:t>CPS Cyber Attack Recovery</a:t>
+            </a:r>
+          </a:p>
+        </p:txBody>
+      </p:sp>
+      <p:sp>
+        <p:nvSpPr>
+          <p:cNvPr id="10" name="TextBox 9"/>
+          <p:cNvSpPr txBox="1"/>
+          <p:nvPr/>
+        </p:nvSpPr>
+        <p:spPr>
+          <a:xfrm>
+            <a:off x="502920" y="2029968"/>
+            <a:ext cx="9144000" cy="475488"/>
+          </a:xfrm>
+          <a:prstGeom prst="rect">
+            <a:avLst/>
+          </a:prstGeom>
+          <a:noFill/>
+        </p:spPr>
+        <p:txBody>
+          <a:bodyPr wrap="square">
+            <a:spAutoFit/>
+          </a:bodyPr>
+          <a:lstStyle/>
+          <a:p>
+            <a:pPr algn="l"/>
+            <a:r>
+              <a:rPr sz="2000" b="0" i="0">
+                <a:solidFill>
+                  <a:srgbClr val="E8243C"/>
+                </a:solidFill>
+                <a:latin typeface="Calibri Light"/>
+              </a:rPr>
+              <a:t>Methods, Taxonomy &amp; Application to SWaT</a:t>
+            </a:r>
+          </a:p>
+        </p:txBody>
+      </p:sp>
+      <p:sp>
+        <p:nvSpPr>
+          <p:cNvPr id="11" name="Rectangle 10"/>
+          <p:cNvSpPr/>
+          <p:nvPr/>
+        </p:nvSpPr>
+        <p:spPr>
+          <a:xfrm>
+            <a:off x="502920" y="2697480"/>
+            <a:ext cx="2560320" cy="868680"/>
           </a:xfrm>
           <a:prstGeom prst="rect">
             <a:avLst/>
@@ -27509,448 +28315,358 @@
           <a:solidFill>
             <a:srgbClr val="2E7D32"/>
           </a:solidFill>
-          <a:ln/>
-        </p:spPr>
-      </p:sp>
-      <p:sp>
-        <p:nvSpPr>
-          <p:cNvPr id="4" name="Text 2"/>
-          <p:cNvSpPr/>
-          <p:nvPr/>
-        </p:nvSpPr>
-        <p:spPr>
-          <a:xfrm>
-            <a:off x="457200" y="1097280"/>
-            <a:ext cx="9144000" cy="914400"/>
-          </a:xfrm>
-          <a:prstGeom prst="rect">
-            <a:avLst/>
-          </a:prstGeom>
-          <a:noFill/>
-          <a:ln/>
-        </p:spPr>
-        <p:txBody>
-          <a:bodyPr wrap="square" rtlCol="0" anchor="ctr"/>
-          <a:lstStyle/>
-          <a:p>
-            <a:pPr indent="0" marL="0">
-              <a:buNone/>
-            </a:pPr>
-            <a:r>
-              <a:rPr lang="en-US" sz="4000" b="1" dirty="0">
+          <a:ln>
+            <a:noFill/>
+          </a:ln>
+        </p:spPr>
+        <p:style>
+          <a:lnRef idx="1">
+            <a:schemeClr val="accent1"/>
+          </a:lnRef>
+          <a:fillRef idx="3">
+            <a:schemeClr val="accent1"/>
+          </a:fillRef>
+          <a:effectRef idx="2">
+            <a:schemeClr val="accent1"/>
+          </a:effectRef>
+          <a:fontRef idx="minor">
+            <a:schemeClr val="lt1"/>
+          </a:fontRef>
+        </p:style>
+        <p:txBody>
+          <a:bodyPr rtlCol="0" anchor="ctr"/>
+          <a:lstStyle/>
+          <a:p>
+            <a:pPr algn="ctr"/>
+          </a:p>
+        </p:txBody>
+      </p:sp>
+      <p:sp>
+        <p:nvSpPr>
+          <p:cNvPr id="12" name="TextBox 11"/>
+          <p:cNvSpPr txBox="1"/>
+          <p:nvPr/>
+        </p:nvSpPr>
+        <p:spPr>
+          <a:xfrm>
+            <a:off x="502920" y="2697480"/>
+            <a:ext cx="2560320" cy="868680"/>
+          </a:xfrm>
+          <a:prstGeom prst="rect">
+            <a:avLst/>
+          </a:prstGeom>
+          <a:noFill/>
+        </p:spPr>
+        <p:txBody>
+          <a:bodyPr wrap="square">
+            <a:spAutoFit/>
+          </a:bodyPr>
+          <a:lstStyle/>
+          <a:p>
+            <a:pPr algn="ctr"/>
+            <a:r>
+              <a:rPr sz="1100" b="1" i="0">
                 <a:solidFill>
                   <a:srgbClr val="FFFFFF"/>
                 </a:solidFill>
-                <a:latin typeface="Calibri Light" pitchFamily="34" charset="0"/>
-                <a:ea typeface="Calibri Light" pitchFamily="34" charset="-122"/>
-                <a:cs typeface="Calibri Light" pitchFamily="34" charset="-120"/>
-              </a:rPr>
-              <a:t>CPS Cyber Attack Recovery</a:t>
-            </a:r>
-            <a:endParaRPr lang="en-US" sz="4000" dirty="0"/>
-          </a:p>
-        </p:txBody>
-      </p:sp>
-      <p:sp>
-        <p:nvSpPr>
-          <p:cNvPr id="5" name="Text 3"/>
-          <p:cNvSpPr/>
-          <p:nvPr/>
-        </p:nvSpPr>
-        <p:spPr>
-          <a:xfrm>
-            <a:off x="457200" y="2011680"/>
-            <a:ext cx="9144000" cy="457200"/>
-          </a:xfrm>
-          <a:prstGeom prst="rect">
-            <a:avLst/>
-          </a:prstGeom>
-          <a:noFill/>
-          <a:ln/>
-        </p:spPr>
-        <p:txBody>
-          <a:bodyPr wrap="square" rtlCol="0" anchor="ctr"/>
-          <a:lstStyle/>
-          <a:p>
-            <a:pPr indent="0" marL="0">
-              <a:buNone/>
-            </a:pPr>
-            <a:r>
-              <a:rPr lang="en-US" sz="2000" dirty="0">
-                <a:solidFill>
-                  <a:srgbClr val="81C784"/>
-                </a:solidFill>
-                <a:latin typeface="Calibri Light" pitchFamily="34" charset="0"/>
-                <a:ea typeface="Calibri Light" pitchFamily="34" charset="-122"/>
-                <a:cs typeface="Calibri Light" pitchFamily="34" charset="-120"/>
-              </a:rPr>
-              <a:t>Methods, Taxonomy &amp; Application to SWaT</a:t>
-            </a:r>
-            <a:endParaRPr lang="en-US" sz="2000" dirty="0"/>
-          </a:p>
-        </p:txBody>
-      </p:sp>
-      <p:sp>
-        <p:nvSpPr>
-          <p:cNvPr id="6" name="Shape 4"/>
-          <p:cNvSpPr/>
-          <p:nvPr/>
-        </p:nvSpPr>
-        <p:spPr>
-          <a:xfrm>
-            <a:off x="457200" y="2743200"/>
+                <a:latin typeface="Calibri"/>
+              </a:rPr>
+              <a:t>Shallow Recovery
+Safe-state + failover</a:t>
+            </a:r>
+          </a:p>
+        </p:txBody>
+      </p:sp>
+      <p:sp>
+        <p:nvSpPr>
+          <p:cNvPr id="13" name="Rectangle 12"/>
+          <p:cNvSpPr/>
+          <p:nvPr/>
+        </p:nvSpPr>
+        <p:spPr>
+          <a:xfrm>
+            <a:off x="3246120" y="2697480"/>
             <a:ext cx="2560320" cy="868680"/>
           </a:xfrm>
           <a:prstGeom prst="rect">
             <a:avLst/>
           </a:prstGeom>
           <a:solidFill>
-            <a:srgbClr val="2E7D32"/>
-          </a:solidFill>
-          <a:ln/>
-        </p:spPr>
-      </p:sp>
-      <p:sp>
-        <p:nvSpPr>
-          <p:cNvPr id="7" name="Text 5"/>
-          <p:cNvSpPr/>
-          <p:nvPr/>
-        </p:nvSpPr>
-        <p:spPr>
-          <a:xfrm>
-            <a:off x="457200" y="2743200"/>
+            <a:srgbClr val="388E3C"/>
+          </a:solidFill>
+          <a:ln>
+            <a:noFill/>
+          </a:ln>
+        </p:spPr>
+        <p:style>
+          <a:lnRef idx="1">
+            <a:schemeClr val="accent1"/>
+          </a:lnRef>
+          <a:fillRef idx="3">
+            <a:schemeClr val="accent1"/>
+          </a:fillRef>
+          <a:effectRef idx="2">
+            <a:schemeClr val="accent1"/>
+          </a:effectRef>
+          <a:fontRef idx="minor">
+            <a:schemeClr val="lt1"/>
+          </a:fontRef>
+        </p:style>
+        <p:txBody>
+          <a:bodyPr rtlCol="0" anchor="ctr"/>
+          <a:lstStyle/>
+          <a:p>
+            <a:pPr algn="ctr"/>
+          </a:p>
+        </p:txBody>
+      </p:sp>
+      <p:sp>
+        <p:nvSpPr>
+          <p:cNvPr id="14" name="TextBox 13"/>
+          <p:cNvSpPr txBox="1"/>
+          <p:nvPr/>
+        </p:nvSpPr>
+        <p:spPr>
+          <a:xfrm>
+            <a:off x="3246120" y="2697480"/>
             <a:ext cx="2560320" cy="868680"/>
           </a:xfrm>
           <a:prstGeom prst="rect">
             <a:avLst/>
           </a:prstGeom>
           <a:noFill/>
-          <a:ln/>
-        </p:spPr>
-        <p:txBody>
-          <a:bodyPr wrap="square" rtlCol="0" anchor="ctr"/>
-          <a:lstStyle/>
-          <a:p>
-            <a:pPr algn="ctr" indent="0" marL="0">
-              <a:buNone/>
-            </a:pPr>
-            <a:r>
-              <a:rPr lang="en-US" sz="1100" b="1" dirty="0">
+        </p:spPr>
+        <p:txBody>
+          <a:bodyPr wrap="square">
+            <a:spAutoFit/>
+          </a:bodyPr>
+          <a:lstStyle/>
+          <a:p>
+            <a:pPr algn="ctr"/>
+            <a:r>
+              <a:rPr sz="1100" b="1" i="0">
                 <a:solidFill>
                   <a:srgbClr val="FFFFFF"/>
                 </a:solidFill>
-                <a:latin typeface="Calibri" pitchFamily="34" charset="0"/>
-                <a:ea typeface="Calibri" pitchFamily="34" charset="-122"/>
-                <a:cs typeface="Calibri" pitchFamily="34" charset="-120"/>
-              </a:rPr>
-              <a:t>Shallow Recovery</a:t>
-            </a:r>
-            <a:endParaRPr lang="en-US" sz="1100" dirty="0"/>
-          </a:p>
-          <a:p>
-            <a:pPr algn="ctr" indent="0" marL="0">
-              <a:buNone/>
-            </a:pPr>
-            <a:r>
-              <a:rPr lang="en-US" sz="1100" b="1" dirty="0">
+                <a:latin typeface="Calibri"/>
+              </a:rPr>
+              <a:t>Deep Recovery
+Dedicated controller</a:t>
+            </a:r>
+          </a:p>
+        </p:txBody>
+      </p:sp>
+      <p:sp>
+        <p:nvSpPr>
+          <p:cNvPr id="15" name="Rectangle 14"/>
+          <p:cNvSpPr/>
+          <p:nvPr/>
+        </p:nvSpPr>
+        <p:spPr>
+          <a:xfrm>
+            <a:off x="5989320" y="2697480"/>
+            <a:ext cx="2560320" cy="868680"/>
+          </a:xfrm>
+          <a:prstGeom prst="rect">
+            <a:avLst/>
+          </a:prstGeom>
+          <a:solidFill>
+            <a:srgbClr val="1565C0"/>
+          </a:solidFill>
+          <a:ln>
+            <a:noFill/>
+          </a:ln>
+        </p:spPr>
+        <p:style>
+          <a:lnRef idx="1">
+            <a:schemeClr val="accent1"/>
+          </a:lnRef>
+          <a:fillRef idx="3">
+            <a:schemeClr val="accent1"/>
+          </a:fillRef>
+          <a:effectRef idx="2">
+            <a:schemeClr val="accent1"/>
+          </a:effectRef>
+          <a:fontRef idx="minor">
+            <a:schemeClr val="lt1"/>
+          </a:fontRef>
+        </p:style>
+        <p:txBody>
+          <a:bodyPr rtlCol="0" anchor="ctr"/>
+          <a:lstStyle/>
+          <a:p>
+            <a:pPr algn="ctr"/>
+          </a:p>
+        </p:txBody>
+      </p:sp>
+      <p:sp>
+        <p:nvSpPr>
+          <p:cNvPr id="16" name="TextBox 15"/>
+          <p:cNvSpPr txBox="1"/>
+          <p:nvPr/>
+        </p:nvSpPr>
+        <p:spPr>
+          <a:xfrm>
+            <a:off x="5989320" y="2697480"/>
+            <a:ext cx="2560320" cy="868680"/>
+          </a:xfrm>
+          <a:prstGeom prst="rect">
+            <a:avLst/>
+          </a:prstGeom>
+          <a:noFill/>
+        </p:spPr>
+        <p:txBody>
+          <a:bodyPr wrap="square">
+            <a:spAutoFit/>
+          </a:bodyPr>
+          <a:lstStyle/>
+          <a:p>
+            <a:pPr algn="ctr"/>
+            <a:r>
+              <a:rPr sz="1100" b="1" i="0">
                 <a:solidFill>
                   <a:srgbClr val="FFFFFF"/>
                 </a:solidFill>
-                <a:latin typeface="Calibri" pitchFamily="34" charset="0"/>
-                <a:ea typeface="Calibri" pitchFamily="34" charset="-122"/>
-                <a:cs typeface="Calibri" pitchFamily="34" charset="-120"/>
-              </a:rPr>
-              <a:t>Safe-state + failover</a:t>
-            </a:r>
-            <a:endParaRPr lang="en-US" sz="1100" dirty="0"/>
-          </a:p>
-        </p:txBody>
-      </p:sp>
-      <p:sp>
-        <p:nvSpPr>
-          <p:cNvPr id="8" name="Shape 6"/>
-          <p:cNvSpPr/>
-          <p:nvPr/>
-        </p:nvSpPr>
-        <p:spPr>
-          <a:xfrm>
-            <a:off x="3200400" y="2743200"/>
+                <a:latin typeface="Calibri"/>
+              </a:rPr>
+              <a:t>State Estimation
+Kalman / Luenberger</a:t>
+            </a:r>
+          </a:p>
+        </p:txBody>
+      </p:sp>
+      <p:sp>
+        <p:nvSpPr>
+          <p:cNvPr id="17" name="Rectangle 16"/>
+          <p:cNvSpPr/>
+          <p:nvPr/>
+        </p:nvSpPr>
+        <p:spPr>
+          <a:xfrm>
+            <a:off x="8732520" y="2697480"/>
             <a:ext cx="2560320" cy="868680"/>
           </a:xfrm>
           <a:prstGeom prst="rect">
             <a:avLst/>
           </a:prstGeom>
           <a:solidFill>
-            <a:srgbClr val="388E3C"/>
-          </a:solidFill>
-          <a:ln/>
-        </p:spPr>
-      </p:sp>
-      <p:sp>
-        <p:nvSpPr>
-          <p:cNvPr id="9" name="Text 7"/>
-          <p:cNvSpPr/>
-          <p:nvPr/>
-        </p:nvSpPr>
-        <p:spPr>
-          <a:xfrm>
-            <a:off x="3200400" y="2743200"/>
+            <a:srgbClr val="E65100"/>
+          </a:solidFill>
+          <a:ln>
+            <a:noFill/>
+          </a:ln>
+        </p:spPr>
+        <p:style>
+          <a:lnRef idx="1">
+            <a:schemeClr val="accent1"/>
+          </a:lnRef>
+          <a:fillRef idx="3">
+            <a:schemeClr val="accent1"/>
+          </a:fillRef>
+          <a:effectRef idx="2">
+            <a:schemeClr val="accent1"/>
+          </a:effectRef>
+          <a:fontRef idx="minor">
+            <a:schemeClr val="lt1"/>
+          </a:fontRef>
+        </p:style>
+        <p:txBody>
+          <a:bodyPr rtlCol="0" anchor="ctr"/>
+          <a:lstStyle/>
+          <a:p>
+            <a:pPr algn="ctr"/>
+          </a:p>
+        </p:txBody>
+      </p:sp>
+      <p:sp>
+        <p:nvSpPr>
+          <p:cNvPr id="18" name="TextBox 17"/>
+          <p:cNvSpPr txBox="1"/>
+          <p:nvPr/>
+        </p:nvSpPr>
+        <p:spPr>
+          <a:xfrm>
+            <a:off x="8732520" y="2697480"/>
             <a:ext cx="2560320" cy="868680"/>
           </a:xfrm>
           <a:prstGeom prst="rect">
             <a:avLst/>
           </a:prstGeom>
           <a:noFill/>
-          <a:ln/>
-        </p:spPr>
-        <p:txBody>
-          <a:bodyPr wrap="square" rtlCol="0" anchor="ctr"/>
-          <a:lstStyle/>
-          <a:p>
-            <a:pPr algn="ctr" indent="0" marL="0">
-              <a:buNone/>
-            </a:pPr>
-            <a:r>
-              <a:rPr lang="en-US" sz="1100" b="1" dirty="0">
+        </p:spPr>
+        <p:txBody>
+          <a:bodyPr wrap="square">
+            <a:spAutoFit/>
+          </a:bodyPr>
+          <a:lstStyle/>
+          <a:p>
+            <a:pPr algn="ctr"/>
+            <a:r>
+              <a:rPr sz="1100" b="1" i="0">
                 <a:solidFill>
                   <a:srgbClr val="FFFFFF"/>
                 </a:solidFill>
-                <a:latin typeface="Calibri" pitchFamily="34" charset="0"/>
-                <a:ea typeface="Calibri" pitchFamily="34" charset="-122"/>
-                <a:cs typeface="Calibri" pitchFamily="34" charset="-120"/>
-              </a:rPr>
-              <a:t>Deep Recovery</a:t>
-            </a:r>
-            <a:endParaRPr lang="en-US" sz="1100" dirty="0"/>
-          </a:p>
-          <a:p>
-            <a:pPr algn="ctr" indent="0" marL="0">
-              <a:buNone/>
-            </a:pPr>
-            <a:r>
-              <a:rPr lang="en-US" sz="1100" b="1" dirty="0">
-                <a:solidFill>
-                  <a:srgbClr val="FFFFFF"/>
-                </a:solidFill>
-                <a:latin typeface="Calibri" pitchFamily="34" charset="0"/>
-                <a:ea typeface="Calibri" pitchFamily="34" charset="-122"/>
-                <a:cs typeface="Calibri" pitchFamily="34" charset="-120"/>
-              </a:rPr>
-              <a:t>Dedicated controller</a:t>
-            </a:r>
-            <a:endParaRPr lang="en-US" sz="1100" dirty="0"/>
-          </a:p>
-        </p:txBody>
-      </p:sp>
-      <p:sp>
-        <p:nvSpPr>
-          <p:cNvPr id="10" name="Shape 8"/>
-          <p:cNvSpPr/>
-          <p:nvPr/>
-        </p:nvSpPr>
-        <p:spPr>
-          <a:xfrm>
-            <a:off x="5943600" y="2743200"/>
-            <a:ext cx="2560320" cy="868680"/>
-          </a:xfrm>
-          <a:prstGeom prst="rect">
-            <a:avLst/>
-          </a:prstGeom>
-          <a:solidFill>
-            <a:srgbClr val="1565C0"/>
-          </a:solidFill>
-          <a:ln/>
-        </p:spPr>
-      </p:sp>
-      <p:sp>
-        <p:nvSpPr>
-          <p:cNvPr id="11" name="Text 9"/>
-          <p:cNvSpPr/>
-          <p:nvPr/>
-        </p:nvSpPr>
-        <p:spPr>
-          <a:xfrm>
-            <a:off x="5943600" y="2743200"/>
-            <a:ext cx="2560320" cy="868680"/>
-          </a:xfrm>
-          <a:prstGeom prst="rect">
-            <a:avLst/>
-          </a:prstGeom>
-          <a:noFill/>
-          <a:ln/>
-        </p:spPr>
-        <p:txBody>
-          <a:bodyPr wrap="square" rtlCol="0" anchor="ctr"/>
-          <a:lstStyle/>
-          <a:p>
-            <a:pPr algn="ctr" indent="0" marL="0">
-              <a:buNone/>
-            </a:pPr>
-            <a:r>
-              <a:rPr lang="en-US" sz="1100" b="1" dirty="0">
-                <a:solidFill>
-                  <a:srgbClr val="FFFFFF"/>
-                </a:solidFill>
-                <a:latin typeface="Calibri" pitchFamily="34" charset="0"/>
-                <a:ea typeface="Calibri" pitchFamily="34" charset="-122"/>
-                <a:cs typeface="Calibri" pitchFamily="34" charset="-120"/>
-              </a:rPr>
-              <a:t>State Estimation</a:t>
-            </a:r>
-            <a:endParaRPr lang="en-US" sz="1100" dirty="0"/>
-          </a:p>
-          <a:p>
-            <a:pPr algn="ctr" indent="0" marL="0">
-              <a:buNone/>
-            </a:pPr>
-            <a:r>
-              <a:rPr lang="en-US" sz="1100" b="1" dirty="0">
-                <a:solidFill>
-                  <a:srgbClr val="FFFFFF"/>
-                </a:solidFill>
-                <a:latin typeface="Calibri" pitchFamily="34" charset="0"/>
-                <a:ea typeface="Calibri" pitchFamily="34" charset="-122"/>
-                <a:cs typeface="Calibri" pitchFamily="34" charset="-120"/>
-              </a:rPr>
-              <a:t>Kalman / Luenberger</a:t>
-            </a:r>
-            <a:endParaRPr lang="en-US" sz="1100" dirty="0"/>
-          </a:p>
-        </p:txBody>
-      </p:sp>
-      <p:sp>
-        <p:nvSpPr>
-          <p:cNvPr id="12" name="Shape 10"/>
-          <p:cNvSpPr/>
-          <p:nvPr/>
-        </p:nvSpPr>
-        <p:spPr>
-          <a:xfrm>
-            <a:off x="8686800" y="2743200"/>
-            <a:ext cx="2560320" cy="868680"/>
-          </a:xfrm>
-          <a:prstGeom prst="rect">
-            <a:avLst/>
-          </a:prstGeom>
-          <a:solidFill>
-            <a:srgbClr val="E65100"/>
-          </a:solidFill>
-          <a:ln/>
-        </p:spPr>
-      </p:sp>
-      <p:sp>
-        <p:nvSpPr>
-          <p:cNvPr id="13" name="Text 11"/>
-          <p:cNvSpPr/>
-          <p:nvPr/>
-        </p:nvSpPr>
-        <p:spPr>
-          <a:xfrm>
-            <a:off x="8686800" y="2743200"/>
-            <a:ext cx="2560320" cy="868680"/>
-          </a:xfrm>
-          <a:prstGeom prst="rect">
-            <a:avLst/>
-          </a:prstGeom>
-          <a:noFill/>
-          <a:ln/>
-        </p:spPr>
-        <p:txBody>
-          <a:bodyPr wrap="square" rtlCol="0" anchor="ctr"/>
-          <a:lstStyle/>
-          <a:p>
-            <a:pPr algn="ctr" indent="0" marL="0">
-              <a:buNone/>
-            </a:pPr>
-            <a:r>
-              <a:rPr lang="en-US" sz="1100" b="1" dirty="0">
-                <a:solidFill>
-                  <a:srgbClr val="FFFFFF"/>
-                </a:solidFill>
-                <a:latin typeface="Calibri" pitchFamily="34" charset="0"/>
-                <a:ea typeface="Calibri" pitchFamily="34" charset="-122"/>
-                <a:cs typeface="Calibri" pitchFamily="34" charset="-120"/>
-              </a:rPr>
-              <a:t>NIST SP 800-82r3</a:t>
-            </a:r>
-            <a:endParaRPr lang="en-US" sz="1100" dirty="0"/>
-          </a:p>
-          <a:p>
-            <a:pPr algn="ctr" indent="0" marL="0">
-              <a:buNone/>
-            </a:pPr>
-            <a:r>
-              <a:rPr lang="en-US" sz="1100" b="1" dirty="0">
-                <a:solidFill>
-                  <a:srgbClr val="FFFFFF"/>
-                </a:solidFill>
-                <a:latin typeface="Calibri" pitchFamily="34" charset="0"/>
-                <a:ea typeface="Calibri" pitchFamily="34" charset="-122"/>
-                <a:cs typeface="Calibri" pitchFamily="34" charset="-120"/>
-              </a:rPr>
-              <a:t>OT incident response</a:t>
-            </a:r>
-            <a:endParaRPr lang="en-US" sz="1100" dirty="0"/>
-          </a:p>
-        </p:txBody>
-      </p:sp>
-      <p:sp>
-        <p:nvSpPr>
-          <p:cNvPr id="14" name="Text 12"/>
-          <p:cNvSpPr/>
-          <p:nvPr/>
-        </p:nvSpPr>
-        <p:spPr>
-          <a:xfrm>
-            <a:off x="457200" y="3794760"/>
-            <a:ext cx="11548872" cy="548640"/>
-          </a:xfrm>
-          <a:prstGeom prst="rect">
-            <a:avLst/>
-          </a:prstGeom>
-          <a:noFill/>
-          <a:ln/>
-        </p:spPr>
-        <p:txBody>
-          <a:bodyPr wrap="square" rtlCol="0" anchor="ctr"/>
-          <a:lstStyle/>
-          <a:p>
-            <a:pPr indent="0" marL="0">
-              <a:buNone/>
-            </a:pPr>
-            <a:r>
-              <a:rPr lang="en-US" sz="1100" dirty="0">
-                <a:solidFill>
-                  <a:srgbClr val="CCCCCC"/>
-                </a:solidFill>
-                <a:latin typeface="Calibri" pitchFamily="34" charset="0"/>
-                <a:ea typeface="Calibri" pitchFamily="34" charset="-122"/>
-                <a:cs typeface="Calibri" pitchFamily="34" charset="-120"/>
-              </a:rPr>
-              <a:t>Key finding (ACM Survey 2024): Most CPS security research focuses on detection — recovery is the least studied phase. Shallow recovery is deployable in SWaT immediately; deep recovery via secure state estimation is the research frontier.</a:t>
-            </a:r>
-            <a:endParaRPr lang="en-US" sz="1100" dirty="0"/>
+                <a:latin typeface="Calibri"/>
+              </a:rPr>
+              <a:t>NIST SP 800-82r3
+OT incident response</a:t>
+            </a:r>
+          </a:p>
+        </p:txBody>
+      </p:sp>
+      <p:sp>
+        <p:nvSpPr>
+          <p:cNvPr id="19" name="TextBox 18"/>
+          <p:cNvSpPr txBox="1"/>
+          <p:nvPr/>
+        </p:nvSpPr>
+        <p:spPr>
+          <a:xfrm>
+            <a:off x="502920" y="3749039"/>
+            <a:ext cx="11369040" cy="347472"/>
+          </a:xfrm>
+          <a:prstGeom prst="rect">
+            <a:avLst/>
+          </a:prstGeom>
+          <a:noFill/>
+        </p:spPr>
+        <p:txBody>
+          <a:bodyPr wrap="square">
+            <a:spAutoFit/>
+          </a:bodyPr>
+          <a:lstStyle/>
+          <a:p>
+            <a:pPr algn="l"/>
+            <a:r>
+              <a:rPr sz="1100" b="0" i="1">
+                <a:solidFill>
+                  <a:srgbClr val="6B6B6B"/>
+                </a:solidFill>
+                <a:latin typeface="Calibri"/>
+              </a:rPr>
+              <a:t>Key finding (ACM Survey 2024): Most CPS research focuses on detection — recovery is the least studied phase.</a:t>
+            </a:r>
           </a:p>
         </p:txBody>
       </p:sp>
       <p:pic>
         <p:nvPicPr>
-          <p:cNvPr id="15" name="Image 0" descr="/home/claude/swat-cps-project/assets/images/swat_testbed_photo.jpg">    </p:cNvPr>
+          <p:cNvPr id="20" name="Picture 19" descr="image.jpg"/>
           <p:cNvPicPr>
             <a:picLocks noChangeAspect="1"/>
           </p:cNvPicPr>
           <p:nvPr/>
         </p:nvPicPr>
         <p:blipFill>
-          <a:blip r:embed="rId1"/>
+          <a:blip r:embed="rId4"/>
           <a:stretch>
             <a:fillRect/>
           </a:stretch>
         </p:blipFill>
         <p:spPr>
           <a:xfrm>
-            <a:off x="457200" y="4480560"/>
-            <a:ext cx="11548872" cy="1874520"/>
+            <a:off x="502920" y="4187952"/>
+            <a:ext cx="11369040" cy="1828800"/>
           </a:xfrm>
           <a:prstGeom prst="rect">
             <a:avLst/>

</xml_diff>

<commit_message>
add I-9 invariant to slides (table + green badge) and report (table row + insight paragraph)
</commit_message>
<xml_diff>
--- a/slides/swat_sutd.pptx
+++ b/slides/swat_sutd.pptx
@@ -16616,6 +16616,10 @@
           </a:solidFill>
           <a:ln/>
         </p:spPr>
+        <p:txBody>
+          <a:bodyPr/>
+          <a:p/>
+        </p:txBody>
       </p:sp>
       <p:sp>
         <p:nvSpPr>
@@ -16636,6 +16640,10 @@
           </a:solidFill>
           <a:ln/>
         </p:spPr>
+        <p:txBody>
+          <a:bodyPr/>
+          <a:p/>
+        </p:txBody>
       </p:sp>
       <p:sp>
         <p:nvSpPr>
@@ -16656,6 +16664,10 @@
           </a:solidFill>
           <a:ln/>
         </p:spPr>
+        <p:txBody>
+          <a:bodyPr/>
+          <a:p/>
+        </p:txBody>
       </p:sp>
       <p:sp>
         <p:nvSpPr>
@@ -16715,6 +16727,10 @@
           </a:solidFill>
           <a:ln/>
         </p:spPr>
+        <p:txBody>
+          <a:bodyPr/>
+          <a:p/>
+        </p:txBody>
       </p:sp>
       <p:sp>
         <p:nvSpPr>
@@ -16857,6 +16873,10 @@
             <a:prstDash val="solid"/>
           </a:ln>
         </p:spPr>
+        <p:txBody>
+          <a:bodyPr/>
+          <a:p/>
+        </p:txBody>
       </p:sp>
       <p:sp>
         <p:nvSpPr>
@@ -16921,6 +16941,10 @@
             <a:prstDash val="solid"/>
           </a:ln>
         </p:spPr>
+        <p:txBody>
+          <a:bodyPr/>
+          <a:p/>
+        </p:txBody>
       </p:sp>
       <p:sp>
         <p:nvSpPr>
@@ -16985,6 +17009,10 @@
             <a:prstDash val="solid"/>
           </a:ln>
         </p:spPr>
+        <p:txBody>
+          <a:bodyPr/>
+          <a:p/>
+        </p:txBody>
       </p:sp>
       <p:sp>
         <p:nvSpPr>
@@ -17049,6 +17077,10 @@
             <a:prstDash val="solid"/>
           </a:ln>
         </p:spPr>
+        <p:txBody>
+          <a:bodyPr/>
+          <a:p/>
+        </p:txBody>
       </p:sp>
       <p:sp>
         <p:nvSpPr>
@@ -17097,8 +17129,8 @@
         </p:nvSpPr>
         <p:spPr>
           <a:xfrm>
-            <a:off x="320040" y="1737360"/>
-            <a:ext cx="457200" cy="320040"/>
+            <a:off x="320040" y="1837943"/>
+            <a:ext cx="457200" cy="402336"/>
           </a:xfrm>
           <a:prstGeom prst="rect">
             <a:avLst/>
@@ -17113,6 +17145,10 @@
             <a:prstDash val="solid"/>
           </a:ln>
         </p:spPr>
+        <p:txBody>
+          <a:bodyPr/>
+          <a:p/>
+        </p:txBody>
       </p:sp>
       <p:sp>
         <p:nvSpPr>
@@ -17122,8 +17158,8 @@
         </p:nvSpPr>
         <p:spPr>
           <a:xfrm>
-            <a:off x="393192" y="1737360"/>
-            <a:ext cx="310896" cy="320040"/>
+            <a:off x="393192" y="1837943"/>
+            <a:ext cx="310896" cy="402336"/>
           </a:xfrm>
           <a:prstGeom prst="rect">
             <a:avLst/>
@@ -17161,8 +17197,8 @@
         </p:nvSpPr>
         <p:spPr>
           <a:xfrm>
-            <a:off x="777240" y="1737360"/>
-            <a:ext cx="2011680" cy="320040"/>
+            <a:off x="777240" y="1837943"/>
+            <a:ext cx="2011680" cy="402336"/>
           </a:xfrm>
           <a:prstGeom prst="rect">
             <a:avLst/>
@@ -17177,6 +17213,10 @@
             <a:prstDash val="solid"/>
           </a:ln>
         </p:spPr>
+        <p:txBody>
+          <a:bodyPr/>
+          <a:p/>
+        </p:txBody>
       </p:sp>
       <p:sp>
         <p:nvSpPr>
@@ -17186,8 +17226,8 @@
         </p:nvSpPr>
         <p:spPr>
           <a:xfrm>
-            <a:off x="850392" y="1737360"/>
-            <a:ext cx="1865376" cy="320040"/>
+            <a:off x="850392" y="1837943"/>
+            <a:ext cx="1865376" cy="402336"/>
           </a:xfrm>
           <a:prstGeom prst="rect">
             <a:avLst/>
@@ -17225,8 +17265,8 @@
         </p:nvSpPr>
         <p:spPr>
           <a:xfrm>
-            <a:off x="2788920" y="1737360"/>
-            <a:ext cx="2103120" cy="320040"/>
+            <a:off x="2788920" y="1837943"/>
+            <a:ext cx="2103120" cy="402336"/>
           </a:xfrm>
           <a:prstGeom prst="rect">
             <a:avLst/>
@@ -17241,6 +17281,10 @@
             <a:prstDash val="solid"/>
           </a:ln>
         </p:spPr>
+        <p:txBody>
+          <a:bodyPr/>
+          <a:p/>
+        </p:txBody>
       </p:sp>
       <p:sp>
         <p:nvSpPr>
@@ -17250,8 +17294,8 @@
         </p:nvSpPr>
         <p:spPr>
           <a:xfrm>
-            <a:off x="2862072" y="1737360"/>
-            <a:ext cx="1956816" cy="320040"/>
+            <a:off x="2862072" y="1837943"/>
+            <a:ext cx="1956816" cy="402336"/>
           </a:xfrm>
           <a:prstGeom prst="rect">
             <a:avLst/>
@@ -17289,8 +17333,8 @@
         </p:nvSpPr>
         <p:spPr>
           <a:xfrm>
-            <a:off x="4892040" y="1737360"/>
-            <a:ext cx="3081528" cy="320040"/>
+            <a:off x="4892040" y="1837943"/>
+            <a:ext cx="3081528" cy="402336"/>
           </a:xfrm>
           <a:prstGeom prst="rect">
             <a:avLst/>
@@ -17305,6 +17349,10 @@
             <a:prstDash val="solid"/>
           </a:ln>
         </p:spPr>
+        <p:txBody>
+          <a:bodyPr/>
+          <a:p/>
+        </p:txBody>
       </p:sp>
       <p:sp>
         <p:nvSpPr>
@@ -17314,8 +17362,8 @@
         </p:nvSpPr>
         <p:spPr>
           <a:xfrm>
-            <a:off x="4965192" y="1737360"/>
-            <a:ext cx="2935224" cy="320040"/>
+            <a:off x="4965192" y="1837943"/>
+            <a:ext cx="2935224" cy="402336"/>
           </a:xfrm>
           <a:prstGeom prst="rect">
             <a:avLst/>
@@ -17353,8 +17401,8 @@
         </p:nvSpPr>
         <p:spPr>
           <a:xfrm>
-            <a:off x="320040" y="2231136"/>
-            <a:ext cx="457200" cy="320040"/>
+            <a:off x="320040" y="2258568"/>
+            <a:ext cx="457200" cy="402336"/>
           </a:xfrm>
           <a:prstGeom prst="rect">
             <a:avLst/>
@@ -17369,6 +17417,10 @@
             <a:prstDash val="solid"/>
           </a:ln>
         </p:spPr>
+        <p:txBody>
+          <a:bodyPr/>
+          <a:p/>
+        </p:txBody>
       </p:sp>
       <p:sp>
         <p:nvSpPr>
@@ -17378,8 +17430,8 @@
         </p:nvSpPr>
         <p:spPr>
           <a:xfrm>
-            <a:off x="393192" y="2231136"/>
-            <a:ext cx="310896" cy="320040"/>
+            <a:off x="393192" y="2258568"/>
+            <a:ext cx="310896" cy="402336"/>
           </a:xfrm>
           <a:prstGeom prst="rect">
             <a:avLst/>
@@ -17417,8 +17469,8 @@
         </p:nvSpPr>
         <p:spPr>
           <a:xfrm>
-            <a:off x="777240" y="2231136"/>
-            <a:ext cx="2011680" cy="320040"/>
+            <a:off x="777240" y="2258568"/>
+            <a:ext cx="2011680" cy="402336"/>
           </a:xfrm>
           <a:prstGeom prst="rect">
             <a:avLst/>
@@ -17433,6 +17485,10 @@
             <a:prstDash val="solid"/>
           </a:ln>
         </p:spPr>
+        <p:txBody>
+          <a:bodyPr/>
+          <a:p/>
+        </p:txBody>
       </p:sp>
       <p:sp>
         <p:nvSpPr>
@@ -17442,8 +17498,8 @@
         </p:nvSpPr>
         <p:spPr>
           <a:xfrm>
-            <a:off x="850392" y="2231136"/>
-            <a:ext cx="1865376" cy="320040"/>
+            <a:off x="850392" y="2258568"/>
+            <a:ext cx="1865376" cy="402336"/>
           </a:xfrm>
           <a:prstGeom prst="rect">
             <a:avLst/>
@@ -17481,8 +17537,8 @@
         </p:nvSpPr>
         <p:spPr>
           <a:xfrm>
-            <a:off x="2788920" y="2231136"/>
-            <a:ext cx="2103120" cy="320040"/>
+            <a:off x="2788920" y="2258568"/>
+            <a:ext cx="2103120" cy="402336"/>
           </a:xfrm>
           <a:prstGeom prst="rect">
             <a:avLst/>
@@ -17497,6 +17553,10 @@
             <a:prstDash val="solid"/>
           </a:ln>
         </p:spPr>
+        <p:txBody>
+          <a:bodyPr/>
+          <a:p/>
+        </p:txBody>
       </p:sp>
       <p:sp>
         <p:nvSpPr>
@@ -17506,8 +17566,8 @@
         </p:nvSpPr>
         <p:spPr>
           <a:xfrm>
-            <a:off x="2862072" y="2231136"/>
-            <a:ext cx="1956816" cy="320040"/>
+            <a:off x="2862072" y="2258568"/>
+            <a:ext cx="1956816" cy="402336"/>
           </a:xfrm>
           <a:prstGeom prst="rect">
             <a:avLst/>
@@ -17545,8 +17605,8 @@
         </p:nvSpPr>
         <p:spPr>
           <a:xfrm>
-            <a:off x="4892040" y="2231136"/>
-            <a:ext cx="3081528" cy="320040"/>
+            <a:off x="4892040" y="2258568"/>
+            <a:ext cx="3081528" cy="402336"/>
           </a:xfrm>
           <a:prstGeom prst="rect">
             <a:avLst/>
@@ -17561,6 +17621,10 @@
             <a:prstDash val="solid"/>
           </a:ln>
         </p:spPr>
+        <p:txBody>
+          <a:bodyPr/>
+          <a:p/>
+        </p:txBody>
       </p:sp>
       <p:sp>
         <p:nvSpPr>
@@ -17570,8 +17634,8 @@
         </p:nvSpPr>
         <p:spPr>
           <a:xfrm>
-            <a:off x="4965192" y="2231136"/>
-            <a:ext cx="2935224" cy="320040"/>
+            <a:off x="4965192" y="2258568"/>
+            <a:ext cx="2935224" cy="402336"/>
           </a:xfrm>
           <a:prstGeom prst="rect">
             <a:avLst/>
@@ -17609,8 +17673,8 @@
         </p:nvSpPr>
         <p:spPr>
           <a:xfrm>
-            <a:off x="320040" y="2724912"/>
-            <a:ext cx="457200" cy="320040"/>
+            <a:off x="320040" y="2679191"/>
+            <a:ext cx="457200" cy="402336"/>
           </a:xfrm>
           <a:prstGeom prst="rect">
             <a:avLst/>
@@ -17625,6 +17689,10 @@
             <a:prstDash val="solid"/>
           </a:ln>
         </p:spPr>
+        <p:txBody>
+          <a:bodyPr/>
+          <a:p/>
+        </p:txBody>
       </p:sp>
       <p:sp>
         <p:nvSpPr>
@@ -17634,8 +17702,8 @@
         </p:nvSpPr>
         <p:spPr>
           <a:xfrm>
-            <a:off x="393192" y="2724912"/>
-            <a:ext cx="310896" cy="320040"/>
+            <a:off x="393192" y="2679191"/>
+            <a:ext cx="310896" cy="402336"/>
           </a:xfrm>
           <a:prstGeom prst="rect">
             <a:avLst/>
@@ -17673,8 +17741,8 @@
         </p:nvSpPr>
         <p:spPr>
           <a:xfrm>
-            <a:off x="777240" y="2724912"/>
-            <a:ext cx="2011680" cy="320040"/>
+            <a:off x="777240" y="2679191"/>
+            <a:ext cx="2011680" cy="402336"/>
           </a:xfrm>
           <a:prstGeom prst="rect">
             <a:avLst/>
@@ -17689,6 +17757,10 @@
             <a:prstDash val="solid"/>
           </a:ln>
         </p:spPr>
+        <p:txBody>
+          <a:bodyPr/>
+          <a:p/>
+        </p:txBody>
       </p:sp>
       <p:sp>
         <p:nvSpPr>
@@ -17698,8 +17770,8 @@
         </p:nvSpPr>
         <p:spPr>
           <a:xfrm>
-            <a:off x="850392" y="2724912"/>
-            <a:ext cx="1865376" cy="320040"/>
+            <a:off x="850392" y="2679191"/>
+            <a:ext cx="1865376" cy="402336"/>
           </a:xfrm>
           <a:prstGeom prst="rect">
             <a:avLst/>
@@ -17737,8 +17809,8 @@
         </p:nvSpPr>
         <p:spPr>
           <a:xfrm>
-            <a:off x="2788920" y="2724912"/>
-            <a:ext cx="2103120" cy="320040"/>
+            <a:off x="2788920" y="2679191"/>
+            <a:ext cx="2103120" cy="402336"/>
           </a:xfrm>
           <a:prstGeom prst="rect">
             <a:avLst/>
@@ -17753,6 +17825,10 @@
             <a:prstDash val="solid"/>
           </a:ln>
         </p:spPr>
+        <p:txBody>
+          <a:bodyPr/>
+          <a:p/>
+        </p:txBody>
       </p:sp>
       <p:sp>
         <p:nvSpPr>
@@ -17762,8 +17838,8 @@
         </p:nvSpPr>
         <p:spPr>
           <a:xfrm>
-            <a:off x="2862072" y="2724912"/>
-            <a:ext cx="1956816" cy="320040"/>
+            <a:off x="2862072" y="2679191"/>
+            <a:ext cx="1956816" cy="402336"/>
           </a:xfrm>
           <a:prstGeom prst="rect">
             <a:avLst/>
@@ -17801,8 +17877,8 @@
         </p:nvSpPr>
         <p:spPr>
           <a:xfrm>
-            <a:off x="4892040" y="2724912"/>
-            <a:ext cx="3081528" cy="320040"/>
+            <a:off x="4892040" y="2679191"/>
+            <a:ext cx="3081528" cy="402336"/>
           </a:xfrm>
           <a:prstGeom prst="rect">
             <a:avLst/>
@@ -17817,6 +17893,10 @@
             <a:prstDash val="solid"/>
           </a:ln>
         </p:spPr>
+        <p:txBody>
+          <a:bodyPr/>
+          <a:p/>
+        </p:txBody>
       </p:sp>
       <p:sp>
         <p:nvSpPr>
@@ -17826,8 +17906,8 @@
         </p:nvSpPr>
         <p:spPr>
           <a:xfrm>
-            <a:off x="4965192" y="2724912"/>
-            <a:ext cx="2935224" cy="320040"/>
+            <a:off x="4965192" y="2679191"/>
+            <a:ext cx="2935224" cy="402336"/>
           </a:xfrm>
           <a:prstGeom prst="rect">
             <a:avLst/>
@@ -17865,8 +17945,8 @@
         </p:nvSpPr>
         <p:spPr>
           <a:xfrm>
-            <a:off x="320040" y="3218688"/>
-            <a:ext cx="457200" cy="320040"/>
+            <a:off x="320040" y="3099815"/>
+            <a:ext cx="457200" cy="402336"/>
           </a:xfrm>
           <a:prstGeom prst="rect">
             <a:avLst/>
@@ -17881,6 +17961,10 @@
             <a:prstDash val="solid"/>
           </a:ln>
         </p:spPr>
+        <p:txBody>
+          <a:bodyPr/>
+          <a:p/>
+        </p:txBody>
       </p:sp>
       <p:sp>
         <p:nvSpPr>
@@ -17890,8 +17974,8 @@
         </p:nvSpPr>
         <p:spPr>
           <a:xfrm>
-            <a:off x="393192" y="3218688"/>
-            <a:ext cx="310896" cy="320040"/>
+            <a:off x="393192" y="3099815"/>
+            <a:ext cx="310896" cy="402336"/>
           </a:xfrm>
           <a:prstGeom prst="rect">
             <a:avLst/>
@@ -17929,8 +18013,8 @@
         </p:nvSpPr>
         <p:spPr>
           <a:xfrm>
-            <a:off x="777240" y="3218688"/>
-            <a:ext cx="2011680" cy="320040"/>
+            <a:off x="777240" y="3099815"/>
+            <a:ext cx="2011680" cy="402336"/>
           </a:xfrm>
           <a:prstGeom prst="rect">
             <a:avLst/>
@@ -17945,6 +18029,10 @@
             <a:prstDash val="solid"/>
           </a:ln>
         </p:spPr>
+        <p:txBody>
+          <a:bodyPr/>
+          <a:p/>
+        </p:txBody>
       </p:sp>
       <p:sp>
         <p:nvSpPr>
@@ -17954,8 +18042,8 @@
         </p:nvSpPr>
         <p:spPr>
           <a:xfrm>
-            <a:off x="850392" y="3218688"/>
-            <a:ext cx="1865376" cy="320040"/>
+            <a:off x="850392" y="3099815"/>
+            <a:ext cx="1865376" cy="402336"/>
           </a:xfrm>
           <a:prstGeom prst="rect">
             <a:avLst/>
@@ -17993,8 +18081,8 @@
         </p:nvSpPr>
         <p:spPr>
           <a:xfrm>
-            <a:off x="2788920" y="3218688"/>
-            <a:ext cx="2103120" cy="320040"/>
+            <a:off x="2788920" y="3099815"/>
+            <a:ext cx="2103120" cy="402336"/>
           </a:xfrm>
           <a:prstGeom prst="rect">
             <a:avLst/>
@@ -18009,6 +18097,10 @@
             <a:prstDash val="solid"/>
           </a:ln>
         </p:spPr>
+        <p:txBody>
+          <a:bodyPr/>
+          <a:p/>
+        </p:txBody>
       </p:sp>
       <p:sp>
         <p:nvSpPr>
@@ -18018,8 +18110,8 @@
         </p:nvSpPr>
         <p:spPr>
           <a:xfrm>
-            <a:off x="2862072" y="3218688"/>
-            <a:ext cx="1956816" cy="320040"/>
+            <a:off x="2862072" y="3099815"/>
+            <a:ext cx="1956816" cy="402336"/>
           </a:xfrm>
           <a:prstGeom prst="rect">
             <a:avLst/>
@@ -18057,8 +18149,8 @@
         </p:nvSpPr>
         <p:spPr>
           <a:xfrm>
-            <a:off x="4892040" y="3218688"/>
-            <a:ext cx="3081528" cy="320040"/>
+            <a:off x="4892040" y="3099815"/>
+            <a:ext cx="3081528" cy="402336"/>
           </a:xfrm>
           <a:prstGeom prst="rect">
             <a:avLst/>
@@ -18073,6 +18165,10 @@
             <a:prstDash val="solid"/>
           </a:ln>
         </p:spPr>
+        <p:txBody>
+          <a:bodyPr/>
+          <a:p/>
+        </p:txBody>
       </p:sp>
       <p:sp>
         <p:nvSpPr>
@@ -18082,8 +18178,8 @@
         </p:nvSpPr>
         <p:spPr>
           <a:xfrm>
-            <a:off x="4965192" y="3218688"/>
-            <a:ext cx="2935224" cy="320040"/>
+            <a:off x="4965192" y="3099815"/>
+            <a:ext cx="2935224" cy="402336"/>
           </a:xfrm>
           <a:prstGeom prst="rect">
             <a:avLst/>
@@ -18121,8 +18217,8 @@
         </p:nvSpPr>
         <p:spPr>
           <a:xfrm>
-            <a:off x="320040" y="3712464"/>
-            <a:ext cx="457200" cy="320040"/>
+            <a:off x="320040" y="3520439"/>
+            <a:ext cx="457200" cy="402336"/>
           </a:xfrm>
           <a:prstGeom prst="rect">
             <a:avLst/>
@@ -18137,6 +18233,10 @@
             <a:prstDash val="solid"/>
           </a:ln>
         </p:spPr>
+        <p:txBody>
+          <a:bodyPr/>
+          <a:p/>
+        </p:txBody>
       </p:sp>
       <p:sp>
         <p:nvSpPr>
@@ -18146,8 +18246,8 @@
         </p:nvSpPr>
         <p:spPr>
           <a:xfrm>
-            <a:off x="393192" y="3712464"/>
-            <a:ext cx="310896" cy="320040"/>
+            <a:off x="393192" y="3520439"/>
+            <a:ext cx="310896" cy="402336"/>
           </a:xfrm>
           <a:prstGeom prst="rect">
             <a:avLst/>
@@ -18185,8 +18285,8 @@
         </p:nvSpPr>
         <p:spPr>
           <a:xfrm>
-            <a:off x="777240" y="3712464"/>
-            <a:ext cx="2011680" cy="320040"/>
+            <a:off x="777240" y="3520439"/>
+            <a:ext cx="2011680" cy="402336"/>
           </a:xfrm>
           <a:prstGeom prst="rect">
             <a:avLst/>
@@ -18201,6 +18301,10 @@
             <a:prstDash val="solid"/>
           </a:ln>
         </p:spPr>
+        <p:txBody>
+          <a:bodyPr/>
+          <a:p/>
+        </p:txBody>
       </p:sp>
       <p:sp>
         <p:nvSpPr>
@@ -18210,8 +18314,8 @@
         </p:nvSpPr>
         <p:spPr>
           <a:xfrm>
-            <a:off x="850392" y="3712464"/>
-            <a:ext cx="1865376" cy="320040"/>
+            <a:off x="850392" y="3520439"/>
+            <a:ext cx="1865376" cy="402336"/>
           </a:xfrm>
           <a:prstGeom prst="rect">
             <a:avLst/>
@@ -18249,8 +18353,8 @@
         </p:nvSpPr>
         <p:spPr>
           <a:xfrm>
-            <a:off x="2788920" y="3712464"/>
-            <a:ext cx="2103120" cy="320040"/>
+            <a:off x="2788920" y="3520439"/>
+            <a:ext cx="2103120" cy="402336"/>
           </a:xfrm>
           <a:prstGeom prst="rect">
             <a:avLst/>
@@ -18265,6 +18369,10 @@
             <a:prstDash val="solid"/>
           </a:ln>
         </p:spPr>
+        <p:txBody>
+          <a:bodyPr/>
+          <a:p/>
+        </p:txBody>
       </p:sp>
       <p:sp>
         <p:nvSpPr>
@@ -18274,8 +18382,8 @@
         </p:nvSpPr>
         <p:spPr>
           <a:xfrm>
-            <a:off x="2862072" y="3712464"/>
-            <a:ext cx="1956816" cy="320040"/>
+            <a:off x="2862072" y="3520439"/>
+            <a:ext cx="1956816" cy="402336"/>
           </a:xfrm>
           <a:prstGeom prst="rect">
             <a:avLst/>
@@ -18313,8 +18421,8 @@
         </p:nvSpPr>
         <p:spPr>
           <a:xfrm>
-            <a:off x="4892040" y="3712464"/>
-            <a:ext cx="3081528" cy="320040"/>
+            <a:off x="4892040" y="3520439"/>
+            <a:ext cx="3081528" cy="402336"/>
           </a:xfrm>
           <a:prstGeom prst="rect">
             <a:avLst/>
@@ -18329,6 +18437,10 @@
             <a:prstDash val="solid"/>
           </a:ln>
         </p:spPr>
+        <p:txBody>
+          <a:bodyPr/>
+          <a:p/>
+        </p:txBody>
       </p:sp>
       <p:sp>
         <p:nvSpPr>
@@ -18338,8 +18450,8 @@
         </p:nvSpPr>
         <p:spPr>
           <a:xfrm>
-            <a:off x="4965192" y="3712464"/>
-            <a:ext cx="2935224" cy="320040"/>
+            <a:off x="4965192" y="3520439"/>
+            <a:ext cx="2935224" cy="402336"/>
           </a:xfrm>
           <a:prstGeom prst="rect">
             <a:avLst/>
@@ -18377,8 +18489,8 @@
         </p:nvSpPr>
         <p:spPr>
           <a:xfrm>
-            <a:off x="320040" y="4206240"/>
-            <a:ext cx="457200" cy="320040"/>
+            <a:off x="320040" y="3941064"/>
+            <a:ext cx="457200" cy="402336"/>
           </a:xfrm>
           <a:prstGeom prst="rect">
             <a:avLst/>
@@ -18393,6 +18505,10 @@
             <a:prstDash val="solid"/>
           </a:ln>
         </p:spPr>
+        <p:txBody>
+          <a:bodyPr/>
+          <a:p/>
+        </p:txBody>
       </p:sp>
       <p:sp>
         <p:nvSpPr>
@@ -18402,8 +18518,8 @@
         </p:nvSpPr>
         <p:spPr>
           <a:xfrm>
-            <a:off x="393192" y="4206240"/>
-            <a:ext cx="310896" cy="320040"/>
+            <a:off x="393192" y="3941064"/>
+            <a:ext cx="310896" cy="402336"/>
           </a:xfrm>
           <a:prstGeom prst="rect">
             <a:avLst/>
@@ -18441,8 +18557,8 @@
         </p:nvSpPr>
         <p:spPr>
           <a:xfrm>
-            <a:off x="777240" y="4206240"/>
-            <a:ext cx="2011680" cy="320040"/>
+            <a:off x="777240" y="3941064"/>
+            <a:ext cx="2011680" cy="402336"/>
           </a:xfrm>
           <a:prstGeom prst="rect">
             <a:avLst/>
@@ -18457,6 +18573,10 @@
             <a:prstDash val="solid"/>
           </a:ln>
         </p:spPr>
+        <p:txBody>
+          <a:bodyPr/>
+          <a:p/>
+        </p:txBody>
       </p:sp>
       <p:sp>
         <p:nvSpPr>
@@ -18466,8 +18586,8 @@
         </p:nvSpPr>
         <p:spPr>
           <a:xfrm>
-            <a:off x="850392" y="4206240"/>
-            <a:ext cx="1865376" cy="320040"/>
+            <a:off x="850392" y="3941064"/>
+            <a:ext cx="1865376" cy="402336"/>
           </a:xfrm>
           <a:prstGeom prst="rect">
             <a:avLst/>
@@ -18505,8 +18625,8 @@
         </p:nvSpPr>
         <p:spPr>
           <a:xfrm>
-            <a:off x="2788920" y="4206240"/>
-            <a:ext cx="2103120" cy="320040"/>
+            <a:off x="2788920" y="3941064"/>
+            <a:ext cx="2103120" cy="402336"/>
           </a:xfrm>
           <a:prstGeom prst="rect">
             <a:avLst/>
@@ -18521,6 +18641,10 @@
             <a:prstDash val="solid"/>
           </a:ln>
         </p:spPr>
+        <p:txBody>
+          <a:bodyPr/>
+          <a:p/>
+        </p:txBody>
       </p:sp>
       <p:sp>
         <p:nvSpPr>
@@ -18530,8 +18654,8 @@
         </p:nvSpPr>
         <p:spPr>
           <a:xfrm>
-            <a:off x="2862072" y="4206240"/>
-            <a:ext cx="1956816" cy="320040"/>
+            <a:off x="2862072" y="3941064"/>
+            <a:ext cx="1956816" cy="402336"/>
           </a:xfrm>
           <a:prstGeom prst="rect">
             <a:avLst/>
@@ -18569,8 +18693,8 @@
         </p:nvSpPr>
         <p:spPr>
           <a:xfrm>
-            <a:off x="4892040" y="4206240"/>
-            <a:ext cx="3081528" cy="320040"/>
+            <a:off x="4892040" y="3941064"/>
+            <a:ext cx="3081528" cy="402336"/>
           </a:xfrm>
           <a:prstGeom prst="rect">
             <a:avLst/>
@@ -18585,6 +18709,10 @@
             <a:prstDash val="solid"/>
           </a:ln>
         </p:spPr>
+        <p:txBody>
+          <a:bodyPr/>
+          <a:p/>
+        </p:txBody>
       </p:sp>
       <p:sp>
         <p:nvSpPr>
@@ -18594,8 +18722,8 @@
         </p:nvSpPr>
         <p:spPr>
           <a:xfrm>
-            <a:off x="4965192" y="4206240"/>
-            <a:ext cx="2935224" cy="320040"/>
+            <a:off x="4965192" y="3941064"/>
+            <a:ext cx="2935224" cy="402336"/>
           </a:xfrm>
           <a:prstGeom prst="rect">
             <a:avLst/>
@@ -18633,8 +18761,8 @@
         </p:nvSpPr>
         <p:spPr>
           <a:xfrm>
-            <a:off x="320040" y="4700016"/>
-            <a:ext cx="457200" cy="320040"/>
+            <a:off x="320040" y="4361688"/>
+            <a:ext cx="457200" cy="402336"/>
           </a:xfrm>
           <a:prstGeom prst="rect">
             <a:avLst/>
@@ -18649,6 +18777,10 @@
             <a:prstDash val="solid"/>
           </a:ln>
         </p:spPr>
+        <p:txBody>
+          <a:bodyPr/>
+          <a:p/>
+        </p:txBody>
       </p:sp>
       <p:sp>
         <p:nvSpPr>
@@ -18658,8 +18790,8 @@
         </p:nvSpPr>
         <p:spPr>
           <a:xfrm>
-            <a:off x="393192" y="4700016"/>
-            <a:ext cx="310896" cy="320040"/>
+            <a:off x="393192" y="4361688"/>
+            <a:ext cx="310896" cy="402336"/>
           </a:xfrm>
           <a:prstGeom prst="rect">
             <a:avLst/>
@@ -18697,8 +18829,8 @@
         </p:nvSpPr>
         <p:spPr>
           <a:xfrm>
-            <a:off x="777240" y="4700016"/>
-            <a:ext cx="2011680" cy="320040"/>
+            <a:off x="777240" y="4361688"/>
+            <a:ext cx="2011680" cy="402336"/>
           </a:xfrm>
           <a:prstGeom prst="rect">
             <a:avLst/>
@@ -18713,6 +18845,10 @@
             <a:prstDash val="solid"/>
           </a:ln>
         </p:spPr>
+        <p:txBody>
+          <a:bodyPr/>
+          <a:p/>
+        </p:txBody>
       </p:sp>
       <p:sp>
         <p:nvSpPr>
@@ -18722,8 +18858,8 @@
         </p:nvSpPr>
         <p:spPr>
           <a:xfrm>
-            <a:off x="850392" y="4700016"/>
-            <a:ext cx="1865376" cy="320040"/>
+            <a:off x="850392" y="4361688"/>
+            <a:ext cx="1865376" cy="402336"/>
           </a:xfrm>
           <a:prstGeom prst="rect">
             <a:avLst/>
@@ -18761,8 +18897,8 @@
         </p:nvSpPr>
         <p:spPr>
           <a:xfrm>
-            <a:off x="2788920" y="4700016"/>
-            <a:ext cx="2103120" cy="320040"/>
+            <a:off x="2788920" y="4361688"/>
+            <a:ext cx="2103120" cy="402336"/>
           </a:xfrm>
           <a:prstGeom prst="rect">
             <a:avLst/>
@@ -18777,6 +18913,10 @@
             <a:prstDash val="solid"/>
           </a:ln>
         </p:spPr>
+        <p:txBody>
+          <a:bodyPr/>
+          <a:p/>
+        </p:txBody>
       </p:sp>
       <p:sp>
         <p:nvSpPr>
@@ -18786,8 +18926,8 @@
         </p:nvSpPr>
         <p:spPr>
           <a:xfrm>
-            <a:off x="2862072" y="4700016"/>
-            <a:ext cx="1956816" cy="320040"/>
+            <a:off x="2862072" y="4361688"/>
+            <a:ext cx="1956816" cy="402336"/>
           </a:xfrm>
           <a:prstGeom prst="rect">
             <a:avLst/>
@@ -18825,8 +18965,8 @@
         </p:nvSpPr>
         <p:spPr>
           <a:xfrm>
-            <a:off x="4892040" y="4700016"/>
-            <a:ext cx="3081528" cy="320040"/>
+            <a:off x="4892040" y="4361688"/>
+            <a:ext cx="3081528" cy="402336"/>
           </a:xfrm>
           <a:prstGeom prst="rect">
             <a:avLst/>
@@ -18841,6 +18981,10 @@
             <a:prstDash val="solid"/>
           </a:ln>
         </p:spPr>
+        <p:txBody>
+          <a:bodyPr/>
+          <a:p/>
+        </p:txBody>
       </p:sp>
       <p:sp>
         <p:nvSpPr>
@@ -18850,8 +18994,8 @@
         </p:nvSpPr>
         <p:spPr>
           <a:xfrm>
-            <a:off x="4965192" y="4700016"/>
-            <a:ext cx="2935224" cy="320040"/>
+            <a:off x="4965192" y="4361688"/>
+            <a:ext cx="2935224" cy="402336"/>
           </a:xfrm>
           <a:prstGeom prst="rect">
             <a:avLst/>
@@ -18889,8 +19033,8 @@
         </p:nvSpPr>
         <p:spPr>
           <a:xfrm>
-            <a:off x="320040" y="5193792"/>
-            <a:ext cx="457200" cy="320040"/>
+            <a:off x="320040" y="4782312"/>
+            <a:ext cx="457200" cy="402336"/>
           </a:xfrm>
           <a:prstGeom prst="rect">
             <a:avLst/>
@@ -18905,6 +19049,10 @@
             <a:prstDash val="solid"/>
           </a:ln>
         </p:spPr>
+        <p:txBody>
+          <a:bodyPr/>
+          <a:p/>
+        </p:txBody>
       </p:sp>
       <p:sp>
         <p:nvSpPr>
@@ -18914,8 +19062,8 @@
         </p:nvSpPr>
         <p:spPr>
           <a:xfrm>
-            <a:off x="393192" y="5193792"/>
-            <a:ext cx="310896" cy="320040"/>
+            <a:off x="393192" y="4782312"/>
+            <a:ext cx="310896" cy="402336"/>
           </a:xfrm>
           <a:prstGeom prst="rect">
             <a:avLst/>
@@ -18953,8 +19101,8 @@
         </p:nvSpPr>
         <p:spPr>
           <a:xfrm>
-            <a:off x="777240" y="5193792"/>
-            <a:ext cx="2011680" cy="320040"/>
+            <a:off x="777240" y="4782312"/>
+            <a:ext cx="2011680" cy="402336"/>
           </a:xfrm>
           <a:prstGeom prst="rect">
             <a:avLst/>
@@ -18969,6 +19117,10 @@
             <a:prstDash val="solid"/>
           </a:ln>
         </p:spPr>
+        <p:txBody>
+          <a:bodyPr/>
+          <a:p/>
+        </p:txBody>
       </p:sp>
       <p:sp>
         <p:nvSpPr>
@@ -18978,8 +19130,8 @@
         </p:nvSpPr>
         <p:spPr>
           <a:xfrm>
-            <a:off x="850392" y="5193792"/>
-            <a:ext cx="1865376" cy="320040"/>
+            <a:off x="850392" y="4782312"/>
+            <a:ext cx="1865376" cy="402336"/>
           </a:xfrm>
           <a:prstGeom prst="rect">
             <a:avLst/>
@@ -19017,8 +19169,8 @@
         </p:nvSpPr>
         <p:spPr>
           <a:xfrm>
-            <a:off x="2788920" y="5193792"/>
-            <a:ext cx="2103120" cy="320040"/>
+            <a:off x="2788920" y="4782312"/>
+            <a:ext cx="2103120" cy="402336"/>
           </a:xfrm>
           <a:prstGeom prst="rect">
             <a:avLst/>
@@ -19033,6 +19185,10 @@
             <a:prstDash val="solid"/>
           </a:ln>
         </p:spPr>
+        <p:txBody>
+          <a:bodyPr/>
+          <a:p/>
+        </p:txBody>
       </p:sp>
       <p:sp>
         <p:nvSpPr>
@@ -19042,8 +19198,8 @@
         </p:nvSpPr>
         <p:spPr>
           <a:xfrm>
-            <a:off x="2862072" y="5193792"/>
-            <a:ext cx="1956816" cy="320040"/>
+            <a:off x="2862072" y="4782312"/>
+            <a:ext cx="1956816" cy="402336"/>
           </a:xfrm>
           <a:prstGeom prst="rect">
             <a:avLst/>
@@ -19081,8 +19237,8 @@
         </p:nvSpPr>
         <p:spPr>
           <a:xfrm>
-            <a:off x="4892040" y="5193792"/>
-            <a:ext cx="3081528" cy="320040"/>
+            <a:off x="4892040" y="4782312"/>
+            <a:ext cx="3081528" cy="402336"/>
           </a:xfrm>
           <a:prstGeom prst="rect">
             <a:avLst/>
@@ -19097,6 +19253,10 @@
             <a:prstDash val="solid"/>
           </a:ln>
         </p:spPr>
+        <p:txBody>
+          <a:bodyPr/>
+          <a:p/>
+        </p:txBody>
       </p:sp>
       <p:sp>
         <p:nvSpPr>
@@ -19106,8 +19266,8 @@
         </p:nvSpPr>
         <p:spPr>
           <a:xfrm>
-            <a:off x="4965192" y="5193792"/>
-            <a:ext cx="2935224" cy="320040"/>
+            <a:off x="4965192" y="4782312"/>
+            <a:ext cx="2935224" cy="402336"/>
           </a:xfrm>
           <a:prstGeom prst="rect">
             <a:avLst/>
@@ -19139,40 +19299,344 @@
       </p:sp>
       <p:sp>
         <p:nvSpPr>
-          <p:cNvPr id="82" name="Text 80"/>
-          <p:cNvSpPr/>
-          <p:nvPr/>
-        </p:nvSpPr>
-        <p:spPr>
-          <a:xfrm>
-            <a:off x="320040" y="5760720"/>
-            <a:ext cx="11548872" cy="256032"/>
-          </a:xfrm>
-          <a:prstGeom prst="rect">
-            <a:avLst/>
-          </a:prstGeom>
-          <a:noFill/>
-          <a:ln/>
-        </p:spPr>
-        <p:txBody>
-          <a:bodyPr wrap="square" rtlCol="0" anchor="ctr"/>
-          <a:lstStyle/>
-          <a:p>
-            <a:pPr indent="0" marL="0">
-              <a:buNone/>
-            </a:pPr>
-            <a:r>
-              <a:rPr lang="en-US" sz="1000" b="1" dirty="0">
-                <a:solidFill>
-                  <a:srgbClr val="1565C0"/>
-                </a:solidFill>
-                <a:latin typeface="Calibri" pitchFamily="34" charset="0"/>
-                <a:ea typeface="Calibri" pitchFamily="34" charset="-122"/>
-                <a:cs typeface="Calibri" pitchFamily="34" charset="-120"/>
-              </a:rPr>
-              <a:t>I-7 fires immediately when Phase 1 forces P101=ON + MV101=CLOSED — invariant detects attack before any physical damage.</a:t>
-            </a:r>
-            <a:endParaRPr lang="en-US" sz="1000" dirty="0"/>
+          <p:cNvPr id="82" name="Rectangle 81"/>
+          <p:cNvSpPr/>
+          <p:nvPr/>
+        </p:nvSpPr>
+        <p:spPr>
+          <a:xfrm>
+            <a:off x="320040" y="5202936"/>
+            <a:ext cx="7653528" cy="420624"/>
+          </a:xfrm>
+          <a:prstGeom prst="rect">
+            <a:avLst/>
+          </a:prstGeom>
+          <a:solidFill>
+            <a:srgbClr val="E8F5E9"/>
+          </a:solidFill>
+          <a:ln w="6350">
+            <a:solidFill>
+              <a:srgbClr val="E0E0E0"/>
+            </a:solidFill>
+          </a:ln>
+        </p:spPr>
+        <p:style>
+          <a:lnRef idx="1">
+            <a:schemeClr val="accent1"/>
+          </a:lnRef>
+          <a:fillRef idx="3">
+            <a:schemeClr val="accent1"/>
+          </a:fillRef>
+          <a:effectRef idx="2">
+            <a:schemeClr val="accent1"/>
+          </a:effectRef>
+          <a:fontRef idx="minor">
+            <a:schemeClr val="lt1"/>
+          </a:fontRef>
+        </p:style>
+        <p:txBody>
+          <a:bodyPr rtlCol="0" anchor="ctr"/>
+          <a:lstStyle/>
+          <a:p>
+            <a:pPr algn="ctr"/>
+          </a:p>
+        </p:txBody>
+      </p:sp>
+      <p:sp>
+        <p:nvSpPr>
+          <p:cNvPr id="83" name="Rectangle 82"/>
+          <p:cNvSpPr/>
+          <p:nvPr/>
+        </p:nvSpPr>
+        <p:spPr>
+          <a:xfrm>
+            <a:off x="320040" y="5202936"/>
+            <a:ext cx="54864" cy="420624"/>
+          </a:xfrm>
+          <a:prstGeom prst="rect">
+            <a:avLst/>
+          </a:prstGeom>
+          <a:solidFill>
+            <a:srgbClr val="2E7D32"/>
+          </a:solidFill>
+          <a:ln>
+            <a:noFill/>
+          </a:ln>
+        </p:spPr>
+        <p:style>
+          <a:lnRef idx="1">
+            <a:schemeClr val="accent1"/>
+          </a:lnRef>
+          <a:fillRef idx="3">
+            <a:schemeClr val="accent1"/>
+          </a:fillRef>
+          <a:effectRef idx="2">
+            <a:schemeClr val="accent1"/>
+          </a:effectRef>
+          <a:fontRef idx="minor">
+            <a:schemeClr val="lt1"/>
+          </a:fontRef>
+        </p:style>
+        <p:txBody>
+          <a:bodyPr rtlCol="0" anchor="ctr"/>
+          <a:lstStyle/>
+          <a:p>
+            <a:pPr algn="ctr"/>
+          </a:p>
+        </p:txBody>
+      </p:sp>
+      <p:sp>
+        <p:nvSpPr>
+          <p:cNvPr id="84" name="TextBox 83"/>
+          <p:cNvSpPr txBox="1"/>
+          <p:nvPr/>
+        </p:nvSpPr>
+        <p:spPr>
+          <a:xfrm>
+            <a:off x="393192" y="5294375"/>
+            <a:ext cx="347472" cy="384048"/>
+          </a:xfrm>
+          <a:prstGeom prst="rect">
+            <a:avLst/>
+          </a:prstGeom>
+          <a:noFill/>
+        </p:spPr>
+        <p:txBody>
+          <a:bodyPr wrap="square">
+            <a:spAutoFit/>
+          </a:bodyPr>
+          <a:lstStyle/>
+          <a:p>
+            <a:pPr algn="ctr"/>
+            <a:r>
+              <a:rPr sz="800" b="1" i="0">
+                <a:solidFill>
+                  <a:srgbClr val="2E7D32"/>
+                </a:solidFill>
+                <a:latin typeface="Calibri"/>
+              </a:rPr>
+              <a:t>I-9</a:t>
+            </a:r>
+          </a:p>
+        </p:txBody>
+      </p:sp>
+      <p:sp>
+        <p:nvSpPr>
+          <p:cNvPr id="85" name="TextBox 84"/>
+          <p:cNvSpPr txBox="1"/>
+          <p:nvPr/>
+        </p:nvSpPr>
+        <p:spPr>
+          <a:xfrm>
+            <a:off x="850392" y="5221223"/>
+            <a:ext cx="1901952" cy="384048"/>
+          </a:xfrm>
+          <a:prstGeom prst="rect">
+            <a:avLst/>
+          </a:prstGeom>
+          <a:noFill/>
+        </p:spPr>
+        <p:txBody>
+          <a:bodyPr wrap="square">
+            <a:spAutoFit/>
+          </a:bodyPr>
+          <a:lstStyle/>
+          <a:p>
+            <a:pPr algn="l"/>
+            <a:r>
+              <a:rPr sz="800" b="1" i="0">
+                <a:solidFill>
+                  <a:srgbClr val="2E7D32"/>
+                </a:solidFill>
+                <a:latin typeface="Calibri"/>
+              </a:rPr>
+              <a:t>MV101=CLOSED AND P101=OFF
+(300mm &lt; LIT101 &lt; 850mm)</a:t>
+            </a:r>
+          </a:p>
+        </p:txBody>
+      </p:sp>
+      <p:sp>
+        <p:nvSpPr>
+          <p:cNvPr id="86" name="TextBox 85"/>
+          <p:cNvSpPr txBox="1"/>
+          <p:nvPr/>
+        </p:nvSpPr>
+        <p:spPr>
+          <a:xfrm>
+            <a:off x="2862072" y="5221223"/>
+            <a:ext cx="1993391" cy="384048"/>
+          </a:xfrm>
+          <a:prstGeom prst="rect">
+            <a:avLst/>
+          </a:prstGeom>
+          <a:noFill/>
+        </p:spPr>
+        <p:txBody>
+          <a:bodyPr wrap="square">
+            <a:spAutoFit/>
+          </a:bodyPr>
+          <a:lstStyle/>
+          <a:p>
+            <a:pPr algn="l"/>
+            <a:r>
+              <a:rPr sz="800" b="1" i="0">
+                <a:solidFill>
+                  <a:srgbClr val="2E7D32"/>
+                </a:solidFill>
+                <a:latin typeface="Calibri"/>
+              </a:rPr>
+              <a:t>VIOLATION — Phase 1 attack
+detected in &lt;1 second</a:t>
+            </a:r>
+          </a:p>
+        </p:txBody>
+      </p:sp>
+      <p:sp>
+        <p:nvSpPr>
+          <p:cNvPr id="87" name="TextBox 86"/>
+          <p:cNvSpPr txBox="1"/>
+          <p:nvPr/>
+        </p:nvSpPr>
+        <p:spPr>
+          <a:xfrm>
+            <a:off x="4965192" y="5221223"/>
+            <a:ext cx="2971800" cy="384048"/>
+          </a:xfrm>
+          <a:prstGeom prst="rect">
+            <a:avLst/>
+          </a:prstGeom>
+          <a:noFill/>
+        </p:spPr>
+        <p:txBody>
+          <a:bodyPr wrap="square">
+            <a:spAutoFit/>
+          </a:bodyPr>
+          <a:lstStyle/>
+          <a:p>
+            <a:pPr algn="l"/>
+            <a:r>
+              <a:rPr sz="800" b="0" i="0">
+                <a:solidFill>
+                  <a:srgbClr val="1A1A1A"/>
+                </a:solidFill>
+                <a:latin typeface="Calibri"/>
+              </a:rPr>
+              <a:t>Both off simultaneously in normal operating range is impossible in SWaT. Direct signature of compromised HMI attack.</a:t>
+            </a:r>
+          </a:p>
+        </p:txBody>
+      </p:sp>
+      <p:sp>
+        <p:nvSpPr>
+          <p:cNvPr id="88" name="Rectangle 87"/>
+          <p:cNvSpPr/>
+          <p:nvPr/>
+        </p:nvSpPr>
+        <p:spPr>
+          <a:xfrm>
+            <a:off x="320040" y="4983479"/>
+            <a:ext cx="2377440" cy="201168"/>
+          </a:xfrm>
+          <a:prstGeom prst="rect">
+            <a:avLst/>
+          </a:prstGeom>
+          <a:solidFill>
+            <a:srgbClr val="2E7D32"/>
+          </a:solidFill>
+          <a:ln>
+            <a:noFill/>
+          </a:ln>
+        </p:spPr>
+        <p:style>
+          <a:lnRef idx="1">
+            <a:schemeClr val="accent1"/>
+          </a:lnRef>
+          <a:fillRef idx="3">
+            <a:schemeClr val="accent1"/>
+          </a:fillRef>
+          <a:effectRef idx="2">
+            <a:schemeClr val="accent1"/>
+          </a:effectRef>
+          <a:fontRef idx="minor">
+            <a:schemeClr val="lt1"/>
+          </a:fontRef>
+        </p:style>
+        <p:txBody>
+          <a:bodyPr rtlCol="0" anchor="ctr"/>
+          <a:lstStyle/>
+          <a:p>
+            <a:pPr algn="ctr"/>
+          </a:p>
+        </p:txBody>
+      </p:sp>
+      <p:sp>
+        <p:nvSpPr>
+          <p:cNvPr id="89" name="TextBox 88"/>
+          <p:cNvSpPr txBox="1"/>
+          <p:nvPr/>
+        </p:nvSpPr>
+        <p:spPr>
+          <a:xfrm>
+            <a:off x="338328" y="5084064"/>
+            <a:ext cx="2340864" cy="182880"/>
+          </a:xfrm>
+          <a:prstGeom prst="rect">
+            <a:avLst/>
+          </a:prstGeom>
+          <a:noFill/>
+        </p:spPr>
+        <p:txBody>
+          <a:bodyPr wrap="square">
+            <a:spAutoFit/>
+          </a:bodyPr>
+          <a:lstStyle/>
+          <a:p>
+            <a:pPr algn="l"/>
+            <a:r>
+              <a:rPr sz="750" b="1" i="0">
+                <a:solidFill>
+                  <a:srgbClr val="FFFFFF"/>
+                </a:solidFill>
+                <a:latin typeface="Calibri"/>
+              </a:rPr>
+              <a:t>★  NEW — Discovered via simulator testing</a:t>
+            </a:r>
+          </a:p>
+        </p:txBody>
+      </p:sp>
+      <p:sp>
+        <p:nvSpPr>
+          <p:cNvPr id="90" name="TextBox 89"/>
+          <p:cNvSpPr txBox="1"/>
+          <p:nvPr/>
+        </p:nvSpPr>
+        <p:spPr>
+          <a:xfrm>
+            <a:off x="320040" y="5733288"/>
+            <a:ext cx="11521440" cy="320040"/>
+          </a:xfrm>
+          <a:prstGeom prst="rect">
+            <a:avLst/>
+          </a:prstGeom>
+          <a:noFill/>
+        </p:spPr>
+        <p:txBody>
+          <a:bodyPr wrap="square">
+            <a:spAutoFit/>
+          </a:bodyPr>
+          <a:lstStyle/>
+          <a:p>
+            <a:pPr algn="l"/>
+            <a:r>
+              <a:rPr sz="900" b="0" i="1">
+                <a:solidFill>
+                  <a:srgbClr val="2E7D32"/>
+                </a:solidFill>
+                <a:latin typeface="Calibri"/>
+              </a:rPr>
+              <a:t>I-9 catches the Phase 1 attack immediately (&lt;1s) — without it, detection requires LIT101 to drop below 250mm (hours). Discovered empirically via PLC simulator testing.</a:t>
+            </a:r>
           </a:p>
         </p:txBody>
       </p:sp>

</xml_diff>

<commit_message>
add broader impact section: cascade effect, 6-stage generalisation, real-world precedent (slides 41-45 + report epilogue)
</commit_message>
<xml_diff>
--- a/slides/swat_sutd.pptx
+++ b/slides/swat_sutd.pptx
@@ -45,6 +45,11 @@
     <p:sldId id="293" r:id="rId39"/>
     <p:sldId id="294" r:id="rId40"/>
     <p:sldId id="295" r:id="rId41"/>
+    <p:sldId id="296" r:id="rId47"/>
+    <p:sldId id="297" r:id="rId48"/>
+    <p:sldId id="298" r:id="rId49"/>
+    <p:sldId id="299" r:id="rId50"/>
+    <p:sldId id="300" r:id="rId51"/>
   </p:sldIdLst>
   <p:notesMasterIdLst>
     <p:notesMasterId r:id="rId42"/>
@@ -39138,6 +39143,4950 @@
               <a:t>[R6] F. Kong et al. "Cyber-Physical System Checkpointing and Recovery." ICCPS 2018.</a:t>
             </a:r>
             <a:endParaRPr lang="en-US" sz="1050" dirty="0"/>
+          </a:p>
+        </p:txBody>
+      </p:sp>
+    </p:spTree>
+  </p:cSld>
+  <p:clrMapOvr>
+    <a:masterClrMapping/>
+  </p:clrMapOvr>
+</p:sld>
+</file>
+
+<file path=ppt/slides/slide41.xml><?xml version="1.0" encoding="utf-8"?>
+<p:sld xmlns:a="http://schemas.openxmlformats.org/drawingml/2006/main" xmlns:p="http://schemas.openxmlformats.org/presentationml/2006/main" xmlns:r="http://schemas.openxmlformats.org/officeDocument/2006/relationships">
+  <p:cSld>
+    <p:spTree>
+      <p:nvGrpSpPr>
+        <p:cNvPr id="1" name=""/>
+        <p:cNvGrpSpPr/>
+        <p:nvPr/>
+      </p:nvGrpSpPr>
+      <p:grpSpPr/>
+      <p:sp>
+        <p:nvSpPr>
+          <p:cNvPr id="2" name="Rectangle 1"/>
+          <p:cNvSpPr/>
+          <p:nvPr/>
+        </p:nvSpPr>
+        <p:spPr>
+          <a:xfrm>
+            <a:off x="0" y="0"/>
+            <a:ext cx="12188952" cy="6858000"/>
+          </a:xfrm>
+          <a:prstGeom prst="rect">
+            <a:avLst/>
+          </a:prstGeom>
+          <a:solidFill>
+            <a:srgbClr val="FFFFFF"/>
+          </a:solidFill>
+          <a:ln>
+            <a:noFill/>
+          </a:ln>
+        </p:spPr>
+        <p:style>
+          <a:lnRef idx="1">
+            <a:schemeClr val="accent1"/>
+          </a:lnRef>
+          <a:fillRef idx="3">
+            <a:schemeClr val="accent1"/>
+          </a:fillRef>
+          <a:effectRef idx="2">
+            <a:schemeClr val="accent1"/>
+          </a:effectRef>
+          <a:fontRef idx="minor">
+            <a:schemeClr val="lt1"/>
+          </a:fontRef>
+        </p:style>
+        <p:txBody>
+          <a:bodyPr rtlCol="0" anchor="ctr"/>
+          <a:lstStyle/>
+          <a:p>
+            <a:pPr algn="ctr"/>
+          </a:p>
+        </p:txBody>
+      </p:sp>
+      <p:sp>
+        <p:nvSpPr>
+          <p:cNvPr id="3" name="Rectangle 2"/>
+          <p:cNvSpPr/>
+          <p:nvPr/>
+        </p:nvSpPr>
+        <p:spPr>
+          <a:xfrm>
+            <a:off x="0" y="0"/>
+            <a:ext cx="12188952" cy="64008"/>
+          </a:xfrm>
+          <a:prstGeom prst="rect">
+            <a:avLst/>
+          </a:prstGeom>
+          <a:solidFill>
+            <a:srgbClr val="E8243C"/>
+          </a:solidFill>
+          <a:ln>
+            <a:noFill/>
+          </a:ln>
+        </p:spPr>
+        <p:style>
+          <a:lnRef idx="1">
+            <a:schemeClr val="accent1"/>
+          </a:lnRef>
+          <a:fillRef idx="3">
+            <a:schemeClr val="accent1"/>
+          </a:fillRef>
+          <a:effectRef idx="2">
+            <a:schemeClr val="accent1"/>
+          </a:effectRef>
+          <a:fontRef idx="minor">
+            <a:schemeClr val="lt1"/>
+          </a:fontRef>
+        </p:style>
+        <p:txBody>
+          <a:bodyPr rtlCol="0" anchor="ctr"/>
+          <a:lstStyle/>
+          <a:p>
+            <a:pPr algn="ctr"/>
+          </a:p>
+        </p:txBody>
+      </p:sp>
+      <p:sp>
+        <p:nvSpPr>
+          <p:cNvPr id="4" name="Rectangle 3"/>
+          <p:cNvSpPr/>
+          <p:nvPr/>
+        </p:nvSpPr>
+        <p:spPr>
+          <a:xfrm>
+            <a:off x="0" y="0"/>
+            <a:ext cx="320040" cy="6858000"/>
+          </a:xfrm>
+          <a:prstGeom prst="rect">
+            <a:avLst/>
+          </a:prstGeom>
+          <a:solidFill>
+            <a:srgbClr val="E8243C"/>
+          </a:solidFill>
+          <a:ln>
+            <a:noFill/>
+          </a:ln>
+        </p:spPr>
+        <p:style>
+          <a:lnRef idx="1">
+            <a:schemeClr val="accent1"/>
+          </a:lnRef>
+          <a:fillRef idx="3">
+            <a:schemeClr val="accent1"/>
+          </a:fillRef>
+          <a:effectRef idx="2">
+            <a:schemeClr val="accent1"/>
+          </a:effectRef>
+          <a:fontRef idx="minor">
+            <a:schemeClr val="lt1"/>
+          </a:fontRef>
+        </p:style>
+        <p:txBody>
+          <a:bodyPr rtlCol="0" anchor="ctr"/>
+          <a:lstStyle/>
+          <a:p>
+            <a:pPr algn="ctr"/>
+          </a:p>
+        </p:txBody>
+      </p:sp>
+      <p:sp>
+        <p:nvSpPr>
+          <p:cNvPr id="5" name="Rectangle 4"/>
+          <p:cNvSpPr/>
+          <p:nvPr/>
+        </p:nvSpPr>
+        <p:spPr>
+          <a:xfrm>
+            <a:off x="0" y="6510528"/>
+            <a:ext cx="12188952" cy="347472"/>
+          </a:xfrm>
+          <a:prstGeom prst="rect">
+            <a:avLst/>
+          </a:prstGeom>
+          <a:solidFill>
+            <a:srgbClr val="F5F5F5"/>
+          </a:solidFill>
+          <a:ln>
+            <a:noFill/>
+          </a:ln>
+        </p:spPr>
+        <p:style>
+          <a:lnRef idx="1">
+            <a:schemeClr val="accent1"/>
+          </a:lnRef>
+          <a:fillRef idx="3">
+            <a:schemeClr val="accent1"/>
+          </a:fillRef>
+          <a:effectRef idx="2">
+            <a:schemeClr val="accent1"/>
+          </a:effectRef>
+          <a:fontRef idx="minor">
+            <a:schemeClr val="lt1"/>
+          </a:fontRef>
+        </p:style>
+        <p:txBody>
+          <a:bodyPr rtlCol="0" anchor="ctr"/>
+          <a:lstStyle/>
+          <a:p>
+            <a:pPr algn="ctr"/>
+          </a:p>
+        </p:txBody>
+      </p:sp>
+      <p:sp>
+        <p:nvSpPr>
+          <p:cNvPr id="6" name="TextBox 5"/>
+          <p:cNvSpPr txBox="1"/>
+          <p:nvPr/>
+        </p:nvSpPr>
+        <p:spPr>
+          <a:xfrm>
+            <a:off x="502920" y="6565392"/>
+            <a:ext cx="11457432" cy="219456"/>
+          </a:xfrm>
+          <a:prstGeom prst="rect">
+            <a:avLst/>
+          </a:prstGeom>
+          <a:noFill/>
+        </p:spPr>
+        <p:txBody>
+          <a:bodyPr wrap="square">
+            <a:spAutoFit/>
+          </a:bodyPr>
+          <a:lstStyle/>
+          <a:p>
+            <a:pPr algn="l"/>
+            <a:r>
+              <a:rPr sz="800" b="0" i="0">
+                <a:solidFill>
+                  <a:srgbClr val="6B6B6B"/>
+                </a:solidFill>
+                <a:latin typeface="Calibri"/>
+              </a:rPr>
+              <a:t>51.508 Secure CPS  ·  SWaT Project  ·  iTrust Lab, SUTD</a:t>
+            </a:r>
+          </a:p>
+        </p:txBody>
+      </p:sp>
+      <p:sp>
+        <p:nvSpPr>
+          <p:cNvPr id="7" name="Rectangle 6"/>
+          <p:cNvSpPr/>
+          <p:nvPr/>
+        </p:nvSpPr>
+        <p:spPr>
+          <a:xfrm>
+            <a:off x="502920" y="548640"/>
+            <a:ext cx="2103120" cy="384048"/>
+          </a:xfrm>
+          <a:prstGeom prst="rect">
+            <a:avLst/>
+          </a:prstGeom>
+          <a:solidFill>
+            <a:srgbClr val="E8243C"/>
+          </a:solidFill>
+          <a:ln>
+            <a:noFill/>
+          </a:ln>
+        </p:spPr>
+        <p:style>
+          <a:lnRef idx="1">
+            <a:schemeClr val="accent1"/>
+          </a:lnRef>
+          <a:fillRef idx="3">
+            <a:schemeClr val="accent1"/>
+          </a:fillRef>
+          <a:effectRef idx="2">
+            <a:schemeClr val="accent1"/>
+          </a:effectRef>
+          <a:fontRef idx="minor">
+            <a:schemeClr val="lt1"/>
+          </a:fontRef>
+        </p:style>
+        <p:txBody>
+          <a:bodyPr rtlCol="0" anchor="ctr"/>
+          <a:lstStyle/>
+          <a:p>
+            <a:pPr algn="ctr"/>
+          </a:p>
+        </p:txBody>
+      </p:sp>
+      <p:sp>
+        <p:nvSpPr>
+          <p:cNvPr id="8" name="TextBox 7"/>
+          <p:cNvSpPr txBox="1"/>
+          <p:nvPr/>
+        </p:nvSpPr>
+        <p:spPr>
+          <a:xfrm>
+            <a:off x="502920" y="548640"/>
+            <a:ext cx="2103120" cy="384048"/>
+          </a:xfrm>
+          <a:prstGeom prst="rect">
+            <a:avLst/>
+          </a:prstGeom>
+          <a:noFill/>
+        </p:spPr>
+        <p:txBody>
+          <a:bodyPr wrap="square">
+            <a:spAutoFit/>
+          </a:bodyPr>
+          <a:lstStyle/>
+          <a:p>
+            <a:pPr algn="ctr"/>
+            <a:r>
+              <a:rPr sz="1100" b="1" i="0">
+                <a:solidFill>
+                  <a:srgbClr val="FFFFFF"/>
+                </a:solidFill>
+                <a:latin typeface="Calibri"/>
+              </a:rPr>
+              <a:t>BROADER IMPACT</a:t>
+            </a:r>
+          </a:p>
+        </p:txBody>
+      </p:sp>
+      <p:sp>
+        <p:nvSpPr>
+          <p:cNvPr id="9" name="TextBox 8"/>
+          <p:cNvSpPr txBox="1"/>
+          <p:nvPr/>
+        </p:nvSpPr>
+        <p:spPr>
+          <a:xfrm>
+            <a:off x="502920" y="1188720"/>
+            <a:ext cx="9601200" cy="777240"/>
+          </a:xfrm>
+          <a:prstGeom prst="rect">
+            <a:avLst/>
+          </a:prstGeom>
+          <a:noFill/>
+        </p:spPr>
+        <p:txBody>
+          <a:bodyPr wrap="square">
+            <a:spAutoFit/>
+          </a:bodyPr>
+          <a:lstStyle/>
+          <a:p>
+            <a:pPr algn="l"/>
+            <a:r>
+              <a:rPr sz="4200" b="1" i="0">
+                <a:solidFill>
+                  <a:srgbClr val="1A1A1A"/>
+                </a:solidFill>
+                <a:latin typeface="Calibri Light"/>
+              </a:rPr>
+              <a:t>Beyond Stage 1:</a:t>
+            </a:r>
+          </a:p>
+        </p:txBody>
+      </p:sp>
+      <p:sp>
+        <p:nvSpPr>
+          <p:cNvPr id="10" name="TextBox 9"/>
+          <p:cNvSpPr txBox="1"/>
+          <p:nvPr/>
+        </p:nvSpPr>
+        <p:spPr>
+          <a:xfrm>
+            <a:off x="502920" y="1938528"/>
+            <a:ext cx="9601200" cy="502920"/>
+          </a:xfrm>
+          <a:prstGeom prst="rect">
+            <a:avLst/>
+          </a:prstGeom>
+          <a:noFill/>
+        </p:spPr>
+        <p:txBody>
+          <a:bodyPr wrap="square">
+            <a:spAutoFit/>
+          </a:bodyPr>
+          <a:lstStyle/>
+          <a:p>
+            <a:pPr algn="l"/>
+            <a:r>
+              <a:rPr sz="2200" b="0" i="0">
+                <a:solidFill>
+                  <a:srgbClr val="E8243C"/>
+                </a:solidFill>
+                <a:latin typeface="Calibri Light"/>
+              </a:rPr>
+              <a:t>What Happens When the Water Stops</a:t>
+            </a:r>
+          </a:p>
+        </p:txBody>
+      </p:sp>
+      <p:sp>
+        <p:nvSpPr>
+          <p:cNvPr id="11" name="TextBox 10"/>
+          <p:cNvSpPr txBox="1"/>
+          <p:nvPr/>
+        </p:nvSpPr>
+        <p:spPr>
+          <a:xfrm>
+            <a:off x="502920" y="2606040"/>
+            <a:ext cx="8686800" cy="594360"/>
+          </a:xfrm>
+          <a:prstGeom prst="rect">
+            <a:avLst/>
+          </a:prstGeom>
+          <a:noFill/>
+        </p:spPr>
+        <p:txBody>
+          <a:bodyPr wrap="square">
+            <a:spAutoFit/>
+          </a:bodyPr>
+          <a:lstStyle/>
+          <a:p>
+            <a:pPr algn="l"/>
+            <a:r>
+              <a:rPr sz="1300" b="0" i="1">
+                <a:solidFill>
+                  <a:srgbClr val="6B6B6B"/>
+                </a:solidFill>
+                <a:latin typeface="Calibri"/>
+              </a:rPr>
+              <a:t>Our demo is a proof-of-concept on P1. The same attack pattern
+scales across all 6 stages and can cripple the entire plant from one compromised HMI.</a:t>
+            </a:r>
+          </a:p>
+        </p:txBody>
+      </p:sp>
+      <p:pic>
+        <p:nvPicPr>
+          <p:cNvPr id="12" name="Picture 11" descr="image.jpg"/>
+          <p:cNvPicPr>
+            <a:picLocks noChangeAspect="1"/>
+          </p:cNvPicPr>
+          <p:nvPr/>
+        </p:nvPicPr>
+        <p:blipFill>
+          <a:blip r:embed="rId2"/>
+          <a:stretch>
+            <a:fillRect/>
+          </a:stretch>
+        </p:blipFill>
+        <p:spPr>
+          <a:xfrm>
+            <a:off x="502920" y="3337560"/>
+            <a:ext cx="11365992" cy="2743200"/>
+          </a:xfrm>
+          <a:prstGeom prst="rect">
+            <a:avLst/>
+          </a:prstGeom>
+        </p:spPr>
+      </p:pic>
+      <p:sp>
+        <p:nvSpPr>
+          <p:cNvPr id="13" name="TextBox 12"/>
+          <p:cNvSpPr txBox="1"/>
+          <p:nvPr/>
+        </p:nvSpPr>
+        <p:spPr>
+          <a:xfrm>
+            <a:off x="502920" y="6062472"/>
+            <a:ext cx="11365992" cy="182880"/>
+          </a:xfrm>
+          <a:prstGeom prst="rect">
+            <a:avLst/>
+          </a:prstGeom>
+          <a:noFill/>
+        </p:spPr>
+        <p:txBody>
+          <a:bodyPr wrap="square">
+            <a:spAutoFit/>
+          </a:bodyPr>
+          <a:lstStyle/>
+          <a:p>
+            <a:pPr algn="ctr"/>
+            <a:r>
+              <a:rPr sz="750" b="0" i="1">
+                <a:solidFill>
+                  <a:srgbClr val="6B6B6B"/>
+                </a:solidFill>
+                <a:latin typeface="Calibri"/>
+              </a:rPr>
+              <a:t>SWaT 6-stage water treatment testbed — iTrust Lab, SUTD</a:t>
+            </a:r>
+          </a:p>
+        </p:txBody>
+      </p:sp>
+    </p:spTree>
+  </p:cSld>
+  <p:clrMapOvr>
+    <a:masterClrMapping/>
+  </p:clrMapOvr>
+</p:sld>
+</file>
+
+<file path=ppt/slides/slide42.xml><?xml version="1.0" encoding="utf-8"?>
+<p:sld xmlns:a="http://schemas.openxmlformats.org/drawingml/2006/main" xmlns:p="http://schemas.openxmlformats.org/presentationml/2006/main" xmlns:r="http://schemas.openxmlformats.org/officeDocument/2006/relationships">
+  <p:cSld>
+    <p:spTree>
+      <p:nvGrpSpPr>
+        <p:cNvPr id="1" name=""/>
+        <p:cNvGrpSpPr/>
+        <p:nvPr/>
+      </p:nvGrpSpPr>
+      <p:grpSpPr/>
+      <p:sp>
+        <p:nvSpPr>
+          <p:cNvPr id="2" name="Rectangle 1"/>
+          <p:cNvSpPr/>
+          <p:nvPr/>
+        </p:nvSpPr>
+        <p:spPr>
+          <a:xfrm>
+            <a:off x="0" y="0"/>
+            <a:ext cx="12188952" cy="6858000"/>
+          </a:xfrm>
+          <a:prstGeom prst="rect">
+            <a:avLst/>
+          </a:prstGeom>
+          <a:solidFill>
+            <a:srgbClr val="FFFFFF"/>
+          </a:solidFill>
+          <a:ln>
+            <a:noFill/>
+          </a:ln>
+        </p:spPr>
+        <p:style>
+          <a:lnRef idx="1">
+            <a:schemeClr val="accent1"/>
+          </a:lnRef>
+          <a:fillRef idx="3">
+            <a:schemeClr val="accent1"/>
+          </a:fillRef>
+          <a:effectRef idx="2">
+            <a:schemeClr val="accent1"/>
+          </a:effectRef>
+          <a:fontRef idx="minor">
+            <a:schemeClr val="lt1"/>
+          </a:fontRef>
+        </p:style>
+        <p:txBody>
+          <a:bodyPr rtlCol="0" anchor="ctr"/>
+          <a:lstStyle/>
+          <a:p>
+            <a:pPr algn="ctr"/>
+          </a:p>
+        </p:txBody>
+      </p:sp>
+      <p:sp>
+        <p:nvSpPr>
+          <p:cNvPr id="3" name="Rectangle 2"/>
+          <p:cNvSpPr/>
+          <p:nvPr/>
+        </p:nvSpPr>
+        <p:spPr>
+          <a:xfrm>
+            <a:off x="0" y="0"/>
+            <a:ext cx="12188952" cy="64008"/>
+          </a:xfrm>
+          <a:prstGeom prst="rect">
+            <a:avLst/>
+          </a:prstGeom>
+          <a:solidFill>
+            <a:srgbClr val="E8243C"/>
+          </a:solidFill>
+          <a:ln>
+            <a:noFill/>
+          </a:ln>
+        </p:spPr>
+        <p:style>
+          <a:lnRef idx="1">
+            <a:schemeClr val="accent1"/>
+          </a:lnRef>
+          <a:fillRef idx="3">
+            <a:schemeClr val="accent1"/>
+          </a:fillRef>
+          <a:effectRef idx="2">
+            <a:schemeClr val="accent1"/>
+          </a:effectRef>
+          <a:fontRef idx="minor">
+            <a:schemeClr val="lt1"/>
+          </a:fontRef>
+        </p:style>
+        <p:txBody>
+          <a:bodyPr rtlCol="0" anchor="ctr"/>
+          <a:lstStyle/>
+          <a:p>
+            <a:pPr algn="ctr"/>
+          </a:p>
+        </p:txBody>
+      </p:sp>
+      <p:sp>
+        <p:nvSpPr>
+          <p:cNvPr id="4" name="Rectangle 3"/>
+          <p:cNvSpPr/>
+          <p:nvPr/>
+        </p:nvSpPr>
+        <p:spPr>
+          <a:xfrm>
+            <a:off x="0" y="6510528"/>
+            <a:ext cx="12188952" cy="347472"/>
+          </a:xfrm>
+          <a:prstGeom prst="rect">
+            <a:avLst/>
+          </a:prstGeom>
+          <a:solidFill>
+            <a:srgbClr val="F5F5F5"/>
+          </a:solidFill>
+          <a:ln>
+            <a:noFill/>
+          </a:ln>
+        </p:spPr>
+        <p:style>
+          <a:lnRef idx="1">
+            <a:schemeClr val="accent1"/>
+          </a:lnRef>
+          <a:fillRef idx="3">
+            <a:schemeClr val="accent1"/>
+          </a:fillRef>
+          <a:effectRef idx="2">
+            <a:schemeClr val="accent1"/>
+          </a:effectRef>
+          <a:fontRef idx="minor">
+            <a:schemeClr val="lt1"/>
+          </a:fontRef>
+        </p:style>
+        <p:txBody>
+          <a:bodyPr rtlCol="0" anchor="ctr"/>
+          <a:lstStyle/>
+          <a:p>
+            <a:pPr algn="ctr"/>
+          </a:p>
+        </p:txBody>
+      </p:sp>
+      <p:sp>
+        <p:nvSpPr>
+          <p:cNvPr id="5" name="TextBox 4"/>
+          <p:cNvSpPr txBox="1"/>
+          <p:nvPr/>
+        </p:nvSpPr>
+        <p:spPr>
+          <a:xfrm>
+            <a:off x="274320" y="6565392"/>
+            <a:ext cx="11640312" cy="219456"/>
+          </a:xfrm>
+          <a:prstGeom prst="rect">
+            <a:avLst/>
+          </a:prstGeom>
+          <a:noFill/>
+        </p:spPr>
+        <p:txBody>
+          <a:bodyPr wrap="square">
+            <a:spAutoFit/>
+          </a:bodyPr>
+          <a:lstStyle/>
+          <a:p>
+            <a:pPr algn="l"/>
+            <a:r>
+              <a:rPr sz="800" b="0" i="0">
+                <a:solidFill>
+                  <a:srgbClr val="6B6B6B"/>
+                </a:solidFill>
+                <a:latin typeface="Calibri"/>
+              </a:rPr>
+              <a:t>51.508 Secure CPS  ·  SWaT Project  ·  iTrust Lab, SUTD</a:t>
+            </a:r>
+          </a:p>
+        </p:txBody>
+      </p:sp>
+      <p:sp>
+        <p:nvSpPr>
+          <p:cNvPr id="6" name="Rectangle 5"/>
+          <p:cNvSpPr/>
+          <p:nvPr/>
+        </p:nvSpPr>
+        <p:spPr>
+          <a:xfrm>
+            <a:off x="320040" y="109728"/>
+            <a:ext cx="1737360" cy="292608"/>
+          </a:xfrm>
+          <a:prstGeom prst="rect">
+            <a:avLst/>
+          </a:prstGeom>
+          <a:solidFill>
+            <a:srgbClr val="E8243C"/>
+          </a:solidFill>
+          <a:ln>
+            <a:noFill/>
+          </a:ln>
+        </p:spPr>
+        <p:style>
+          <a:lnRef idx="1">
+            <a:schemeClr val="accent1"/>
+          </a:lnRef>
+          <a:fillRef idx="3">
+            <a:schemeClr val="accent1"/>
+          </a:fillRef>
+          <a:effectRef idx="2">
+            <a:schemeClr val="accent1"/>
+          </a:effectRef>
+          <a:fontRef idx="minor">
+            <a:schemeClr val="lt1"/>
+          </a:fontRef>
+        </p:style>
+        <p:txBody>
+          <a:bodyPr rtlCol="0" anchor="ctr"/>
+          <a:lstStyle/>
+          <a:p>
+            <a:pPr algn="ctr"/>
+          </a:p>
+        </p:txBody>
+      </p:sp>
+      <p:sp>
+        <p:nvSpPr>
+          <p:cNvPr id="7" name="TextBox 6"/>
+          <p:cNvSpPr txBox="1"/>
+          <p:nvPr/>
+        </p:nvSpPr>
+        <p:spPr>
+          <a:xfrm>
+            <a:off x="320040" y="109728"/>
+            <a:ext cx="1737360" cy="292608"/>
+          </a:xfrm>
+          <a:prstGeom prst="rect">
+            <a:avLst/>
+          </a:prstGeom>
+          <a:noFill/>
+        </p:spPr>
+        <p:txBody>
+          <a:bodyPr wrap="square">
+            <a:spAutoFit/>
+          </a:bodyPr>
+          <a:lstStyle/>
+          <a:p>
+            <a:pPr algn="ctr"/>
+            <a:r>
+              <a:rPr sz="1000" b="1" i="0">
+                <a:solidFill>
+                  <a:srgbClr val="FFFFFF"/>
+                </a:solidFill>
+                <a:latin typeface="Calibri"/>
+              </a:rPr>
+              <a:t>BROADER IMPACT</a:t>
+            </a:r>
+          </a:p>
+        </p:txBody>
+      </p:sp>
+      <p:sp>
+        <p:nvSpPr>
+          <p:cNvPr id="8" name="TextBox 7"/>
+          <p:cNvSpPr txBox="1"/>
+          <p:nvPr/>
+        </p:nvSpPr>
+        <p:spPr>
+          <a:xfrm>
+            <a:off x="320040" y="457200"/>
+            <a:ext cx="11548872" cy="566928"/>
+          </a:xfrm>
+          <a:prstGeom prst="rect">
+            <a:avLst/>
+          </a:prstGeom>
+          <a:noFill/>
+        </p:spPr>
+        <p:txBody>
+          <a:bodyPr wrap="square">
+            <a:spAutoFit/>
+          </a:bodyPr>
+          <a:lstStyle/>
+          <a:p>
+            <a:pPr algn="l"/>
+            <a:r>
+              <a:rPr sz="3000" b="1" i="0">
+                <a:solidFill>
+                  <a:srgbClr val="1A1A1A"/>
+                </a:solidFill>
+                <a:latin typeface="Calibri Light"/>
+              </a:rPr>
+              <a:t>The Cascade Effect</a:t>
+            </a:r>
+          </a:p>
+        </p:txBody>
+      </p:sp>
+      <p:sp>
+        <p:nvSpPr>
+          <p:cNvPr id="9" name="TextBox 8"/>
+          <p:cNvSpPr txBox="1"/>
+          <p:nvPr/>
+        </p:nvSpPr>
+        <p:spPr>
+          <a:xfrm>
+            <a:off x="320040" y="1005840"/>
+            <a:ext cx="11548872" cy="237744"/>
+          </a:xfrm>
+          <a:prstGeom prst="rect">
+            <a:avLst/>
+          </a:prstGeom>
+          <a:noFill/>
+        </p:spPr>
+        <p:txBody>
+          <a:bodyPr wrap="square">
+            <a:spAutoFit/>
+          </a:bodyPr>
+          <a:lstStyle/>
+          <a:p>
+            <a:pPr algn="l"/>
+            <a:r>
+              <a:rPr sz="1150" b="0" i="1">
+                <a:solidFill>
+                  <a:srgbClr val="6B6B6B"/>
+                </a:solidFill>
+                <a:latin typeface="Calibri"/>
+              </a:rPr>
+              <a:t>Starve Stage 1 — every downstream stage fails in sequence</a:t>
+            </a:r>
+          </a:p>
+        </p:txBody>
+      </p:sp>
+      <p:pic>
+        <p:nvPicPr>
+          <p:cNvPr id="10" name="Picture 9" descr="image.png"/>
+          <p:cNvPicPr>
+            <a:picLocks noChangeAspect="1"/>
+          </p:cNvPicPr>
+          <p:nvPr/>
+        </p:nvPicPr>
+        <p:blipFill>
+          <a:blip r:embed="rId2"/>
+          <a:stretch>
+            <a:fillRect/>
+          </a:stretch>
+        </p:blipFill>
+        <p:spPr>
+          <a:xfrm>
+            <a:off x="320040" y="1353312"/>
+            <a:ext cx="4937760" cy="4251960"/>
+          </a:xfrm>
+          <a:prstGeom prst="rect">
+            <a:avLst/>
+          </a:prstGeom>
+        </p:spPr>
+      </p:pic>
+      <p:sp>
+        <p:nvSpPr>
+          <p:cNvPr id="11" name="TextBox 10"/>
+          <p:cNvSpPr txBox="1"/>
+          <p:nvPr/>
+        </p:nvSpPr>
+        <p:spPr>
+          <a:xfrm>
+            <a:off x="320040" y="5577840"/>
+            <a:ext cx="4937760" cy="182880"/>
+          </a:xfrm>
+          <a:prstGeom prst="rect">
+            <a:avLst/>
+          </a:prstGeom>
+          <a:noFill/>
+        </p:spPr>
+        <p:txBody>
+          <a:bodyPr wrap="square">
+            <a:spAutoFit/>
+          </a:bodyPr>
+          <a:lstStyle/>
+          <a:p>
+            <a:pPr algn="ctr"/>
+            <a:r>
+              <a:rPr sz="750" b="0" i="1">
+                <a:solidFill>
+                  <a:srgbClr val="6B6B6B"/>
+                </a:solidFill>
+                <a:latin typeface="Calibri"/>
+              </a:rPr>
+              <a:t>SWaT network — 6 stages, each with independent PLC</a:t>
+            </a:r>
+          </a:p>
+        </p:txBody>
+      </p:sp>
+      <p:sp>
+        <p:nvSpPr>
+          <p:cNvPr id="12" name="Rectangle 11"/>
+          <p:cNvSpPr/>
+          <p:nvPr/>
+        </p:nvSpPr>
+        <p:spPr>
+          <a:xfrm>
+            <a:off x="5468112" y="1353312"/>
+            <a:ext cx="6400800" cy="749808"/>
+          </a:xfrm>
+          <a:prstGeom prst="rect">
+            <a:avLst/>
+          </a:prstGeom>
+          <a:solidFill>
+            <a:srgbClr val="E8243C"/>
+          </a:solidFill>
+          <a:ln>
+            <a:noFill/>
+          </a:ln>
+        </p:spPr>
+        <p:style>
+          <a:lnRef idx="1">
+            <a:schemeClr val="accent1"/>
+          </a:lnRef>
+          <a:fillRef idx="3">
+            <a:schemeClr val="accent1"/>
+          </a:fillRef>
+          <a:effectRef idx="2">
+            <a:schemeClr val="accent1"/>
+          </a:effectRef>
+          <a:fontRef idx="minor">
+            <a:schemeClr val="lt1"/>
+          </a:fontRef>
+        </p:style>
+        <p:txBody>
+          <a:bodyPr rtlCol="0" anchor="ctr"/>
+          <a:lstStyle/>
+          <a:p>
+            <a:pPr algn="ctr"/>
+          </a:p>
+        </p:txBody>
+      </p:sp>
+      <p:sp>
+        <p:nvSpPr>
+          <p:cNvPr id="13" name="TextBox 12"/>
+          <p:cNvSpPr txBox="1"/>
+          <p:nvPr/>
+        </p:nvSpPr>
+        <p:spPr>
+          <a:xfrm>
+            <a:off x="5577840" y="1408176"/>
+            <a:ext cx="6217920" cy="274320"/>
+          </a:xfrm>
+          <a:prstGeom prst="rect">
+            <a:avLst/>
+          </a:prstGeom>
+          <a:noFill/>
+        </p:spPr>
+        <p:txBody>
+          <a:bodyPr wrap="square">
+            <a:spAutoFit/>
+          </a:bodyPr>
+          <a:lstStyle/>
+          <a:p>
+            <a:pPr algn="l"/>
+            <a:r>
+              <a:rPr sz="1100" b="1" i="0">
+                <a:solidFill>
+                  <a:srgbClr val="FFFFFF"/>
+                </a:solidFill>
+                <a:latin typeface="Calibri"/>
+              </a:rPr>
+              <a:t>P1 — Raw Water</a:t>
+            </a:r>
+          </a:p>
+        </p:txBody>
+      </p:sp>
+      <p:sp>
+        <p:nvSpPr>
+          <p:cNvPr id="14" name="TextBox 13"/>
+          <p:cNvSpPr txBox="1"/>
+          <p:nvPr/>
+        </p:nvSpPr>
+        <p:spPr>
+          <a:xfrm>
+            <a:off x="5577840" y="1700784"/>
+            <a:ext cx="6217920" cy="365760"/>
+          </a:xfrm>
+          <a:prstGeom prst="rect">
+            <a:avLst/>
+          </a:prstGeom>
+          <a:noFill/>
+        </p:spPr>
+        <p:txBody>
+          <a:bodyPr wrap="square">
+            <a:spAutoFit/>
+          </a:bodyPr>
+          <a:lstStyle/>
+          <a:p>
+            <a:pPr algn="l"/>
+            <a:r>
+              <a:rPr sz="950" b="0" i="0">
+                <a:solidFill>
+                  <a:srgbClr val="FFFFFF"/>
+                </a:solidFill>
+                <a:latin typeface="Calibri"/>
+              </a:rPr>
+              <a:t>MV101 CLOSED, P101 OFF → T101 drains → zero feed to P2</a:t>
+            </a:r>
+          </a:p>
+        </p:txBody>
+      </p:sp>
+      <p:sp>
+        <p:nvSpPr>
+          <p:cNvPr id="15" name="Rectangle 14"/>
+          <p:cNvSpPr/>
+          <p:nvPr/>
+        </p:nvSpPr>
+        <p:spPr>
+          <a:xfrm>
+            <a:off x="5468112" y="2212848"/>
+            <a:ext cx="6400800" cy="749808"/>
+          </a:xfrm>
+          <a:prstGeom prst="rect">
+            <a:avLst/>
+          </a:prstGeom>
+          <a:solidFill>
+            <a:srgbClr val="C62828"/>
+          </a:solidFill>
+          <a:ln>
+            <a:noFill/>
+          </a:ln>
+        </p:spPr>
+        <p:style>
+          <a:lnRef idx="1">
+            <a:schemeClr val="accent1"/>
+          </a:lnRef>
+          <a:fillRef idx="3">
+            <a:schemeClr val="accent1"/>
+          </a:fillRef>
+          <a:effectRef idx="2">
+            <a:schemeClr val="accent1"/>
+          </a:effectRef>
+          <a:fontRef idx="minor">
+            <a:schemeClr val="lt1"/>
+          </a:fontRef>
+        </p:style>
+        <p:txBody>
+          <a:bodyPr rtlCol="0" anchor="ctr"/>
+          <a:lstStyle/>
+          <a:p>
+            <a:pPr algn="ctr"/>
+          </a:p>
+        </p:txBody>
+      </p:sp>
+      <p:sp>
+        <p:nvSpPr>
+          <p:cNvPr id="16" name="TextBox 15"/>
+          <p:cNvSpPr txBox="1"/>
+          <p:nvPr/>
+        </p:nvSpPr>
+        <p:spPr>
+          <a:xfrm>
+            <a:off x="5577840" y="2267712"/>
+            <a:ext cx="6217920" cy="274320"/>
+          </a:xfrm>
+          <a:prstGeom prst="rect">
+            <a:avLst/>
+          </a:prstGeom>
+          <a:noFill/>
+        </p:spPr>
+        <p:txBody>
+          <a:bodyPr wrap="square">
+            <a:spAutoFit/>
+          </a:bodyPr>
+          <a:lstStyle/>
+          <a:p>
+            <a:pPr algn="l"/>
+            <a:r>
+              <a:rPr sz="1100" b="1" i="0">
+                <a:solidFill>
+                  <a:srgbClr val="FFFFFF"/>
+                </a:solidFill>
+                <a:latin typeface="Calibri"/>
+              </a:rPr>
+              <a:t>P2 — Pre-Treatment</a:t>
+            </a:r>
+          </a:p>
+        </p:txBody>
+      </p:sp>
+      <p:sp>
+        <p:nvSpPr>
+          <p:cNvPr id="17" name="TextBox 16"/>
+          <p:cNvSpPr txBox="1"/>
+          <p:nvPr/>
+        </p:nvSpPr>
+        <p:spPr>
+          <a:xfrm>
+            <a:off x="5577840" y="2560320"/>
+            <a:ext cx="6217920" cy="365760"/>
+          </a:xfrm>
+          <a:prstGeom prst="rect">
+            <a:avLst/>
+          </a:prstGeom>
+          <a:noFill/>
+        </p:spPr>
+        <p:txBody>
+          <a:bodyPr wrap="square">
+            <a:spAutoFit/>
+          </a:bodyPr>
+          <a:lstStyle/>
+          <a:p>
+            <a:pPr algn="l"/>
+            <a:r>
+              <a:rPr sz="950" b="0" i="0">
+                <a:solidFill>
+                  <a:srgbClr val="FFFFFF"/>
+                </a:solidFill>
+                <a:latin typeface="Calibri"/>
+              </a:rPr>
+              <a:t>Dosing pumps inject chemicals into empty pipe → concentration spike</a:t>
+            </a:r>
+          </a:p>
+        </p:txBody>
+      </p:sp>
+      <p:sp>
+        <p:nvSpPr>
+          <p:cNvPr id="18" name="Rectangle 17"/>
+          <p:cNvSpPr/>
+          <p:nvPr/>
+        </p:nvSpPr>
+        <p:spPr>
+          <a:xfrm>
+            <a:off x="5468112" y="3072384"/>
+            <a:ext cx="6400800" cy="749808"/>
+          </a:xfrm>
+          <a:prstGeom prst="rect">
+            <a:avLst/>
+          </a:prstGeom>
+          <a:solidFill>
+            <a:srgbClr val="AD1A57"/>
+          </a:solidFill>
+          <a:ln>
+            <a:noFill/>
+          </a:ln>
+        </p:spPr>
+        <p:style>
+          <a:lnRef idx="1">
+            <a:schemeClr val="accent1"/>
+          </a:lnRef>
+          <a:fillRef idx="3">
+            <a:schemeClr val="accent1"/>
+          </a:fillRef>
+          <a:effectRef idx="2">
+            <a:schemeClr val="accent1"/>
+          </a:effectRef>
+          <a:fontRef idx="minor">
+            <a:schemeClr val="lt1"/>
+          </a:fontRef>
+        </p:style>
+        <p:txBody>
+          <a:bodyPr rtlCol="0" anchor="ctr"/>
+          <a:lstStyle/>
+          <a:p>
+            <a:pPr algn="ctr"/>
+          </a:p>
+        </p:txBody>
+      </p:sp>
+      <p:sp>
+        <p:nvSpPr>
+          <p:cNvPr id="19" name="TextBox 18"/>
+          <p:cNvSpPr txBox="1"/>
+          <p:nvPr/>
+        </p:nvSpPr>
+        <p:spPr>
+          <a:xfrm>
+            <a:off x="5577840" y="3127248"/>
+            <a:ext cx="6217920" cy="274320"/>
+          </a:xfrm>
+          <a:prstGeom prst="rect">
+            <a:avLst/>
+          </a:prstGeom>
+          <a:noFill/>
+        </p:spPr>
+        <p:txBody>
+          <a:bodyPr wrap="square">
+            <a:spAutoFit/>
+          </a:bodyPr>
+          <a:lstStyle/>
+          <a:p>
+            <a:pPr algn="l"/>
+            <a:r>
+              <a:rPr sz="1100" b="1" i="0">
+                <a:solidFill>
+                  <a:srgbClr val="FFFFFF"/>
+                </a:solidFill>
+                <a:latin typeface="Calibri"/>
+              </a:rPr>
+              <a:t>P3 — Ultrafiltration</a:t>
+            </a:r>
+          </a:p>
+        </p:txBody>
+      </p:sp>
+      <p:sp>
+        <p:nvSpPr>
+          <p:cNvPr id="20" name="TextBox 19"/>
+          <p:cNvSpPr txBox="1"/>
+          <p:nvPr/>
+        </p:nvSpPr>
+        <p:spPr>
+          <a:xfrm>
+            <a:off x="5577840" y="3419856"/>
+            <a:ext cx="6217920" cy="365760"/>
+          </a:xfrm>
+          <a:prstGeom prst="rect">
+            <a:avLst/>
+          </a:prstGeom>
+          <a:noFill/>
+        </p:spPr>
+        <p:txBody>
+          <a:bodyPr wrap="square">
+            <a:spAutoFit/>
+          </a:bodyPr>
+          <a:lstStyle/>
+          <a:p>
+            <a:pPr algn="l"/>
+            <a:r>
+              <a:rPr sz="950" b="0" i="0">
+                <a:solidFill>
+                  <a:srgbClr val="FFFFFF"/>
+                </a:solidFill>
+                <a:latin typeface="Calibri"/>
+              </a:rPr>
+              <a:t>P301 runs dry → cavitation → UF pump destroyed in minutes</a:t>
+            </a:r>
+          </a:p>
+        </p:txBody>
+      </p:sp>
+      <p:sp>
+        <p:nvSpPr>
+          <p:cNvPr id="21" name="Rectangle 20"/>
+          <p:cNvSpPr/>
+          <p:nvPr/>
+        </p:nvSpPr>
+        <p:spPr>
+          <a:xfrm>
+            <a:off x="5468112" y="3931920"/>
+            <a:ext cx="6400800" cy="749808"/>
+          </a:xfrm>
+          <a:prstGeom prst="rect">
+            <a:avLst/>
+          </a:prstGeom>
+          <a:solidFill>
+            <a:srgbClr val="6A1B9A"/>
+          </a:solidFill>
+          <a:ln>
+            <a:noFill/>
+          </a:ln>
+        </p:spPr>
+        <p:style>
+          <a:lnRef idx="1">
+            <a:schemeClr val="accent1"/>
+          </a:lnRef>
+          <a:fillRef idx="3">
+            <a:schemeClr val="accent1"/>
+          </a:fillRef>
+          <a:effectRef idx="2">
+            <a:schemeClr val="accent1"/>
+          </a:effectRef>
+          <a:fontRef idx="minor">
+            <a:schemeClr val="lt1"/>
+          </a:fontRef>
+        </p:style>
+        <p:txBody>
+          <a:bodyPr rtlCol="0" anchor="ctr"/>
+          <a:lstStyle/>
+          <a:p>
+            <a:pPr algn="ctr"/>
+          </a:p>
+        </p:txBody>
+      </p:sp>
+      <p:sp>
+        <p:nvSpPr>
+          <p:cNvPr id="22" name="TextBox 21"/>
+          <p:cNvSpPr txBox="1"/>
+          <p:nvPr/>
+        </p:nvSpPr>
+        <p:spPr>
+          <a:xfrm>
+            <a:off x="5577840" y="3986783"/>
+            <a:ext cx="6217920" cy="274320"/>
+          </a:xfrm>
+          <a:prstGeom prst="rect">
+            <a:avLst/>
+          </a:prstGeom>
+          <a:noFill/>
+        </p:spPr>
+        <p:txBody>
+          <a:bodyPr wrap="square">
+            <a:spAutoFit/>
+          </a:bodyPr>
+          <a:lstStyle/>
+          <a:p>
+            <a:pPr algn="l"/>
+            <a:r>
+              <a:rPr sz="1100" b="1" i="0">
+                <a:solidFill>
+                  <a:srgbClr val="FFFFFF"/>
+                </a:solidFill>
+                <a:latin typeface="Calibri"/>
+              </a:rPr>
+              <a:t>P4/P5 — RO System</a:t>
+            </a:r>
+          </a:p>
+        </p:txBody>
+      </p:sp>
+      <p:sp>
+        <p:nvSpPr>
+          <p:cNvPr id="23" name="TextBox 22"/>
+          <p:cNvSpPr txBox="1"/>
+          <p:nvPr/>
+        </p:nvSpPr>
+        <p:spPr>
+          <a:xfrm>
+            <a:off x="5577840" y="4279392"/>
+            <a:ext cx="6217920" cy="365760"/>
+          </a:xfrm>
+          <a:prstGeom prst="rect">
+            <a:avLst/>
+          </a:prstGeom>
+          <a:noFill/>
+        </p:spPr>
+        <p:txBody>
+          <a:bodyPr wrap="square">
+            <a:spAutoFit/>
+          </a:bodyPr>
+          <a:lstStyle/>
+          <a:p>
+            <a:pPr algn="l"/>
+            <a:r>
+              <a:rPr sz="950" b="0" i="0">
+                <a:solidFill>
+                  <a:srgbClr val="FFFFFF"/>
+                </a:solidFill>
+                <a:latin typeface="Calibri"/>
+              </a:rPr>
+              <a:t>High-pressure membranes lose flow → pressure swings → seal damage</a:t>
+            </a:r>
+          </a:p>
+        </p:txBody>
+      </p:sp>
+      <p:sp>
+        <p:nvSpPr>
+          <p:cNvPr id="24" name="Rectangle 23"/>
+          <p:cNvSpPr/>
+          <p:nvPr/>
+        </p:nvSpPr>
+        <p:spPr>
+          <a:xfrm>
+            <a:off x="5468112" y="4791456"/>
+            <a:ext cx="6400800" cy="749808"/>
+          </a:xfrm>
+          <a:prstGeom prst="rect">
+            <a:avLst/>
+          </a:prstGeom>
+          <a:solidFill>
+            <a:srgbClr val="1A237E"/>
+          </a:solidFill>
+          <a:ln>
+            <a:noFill/>
+          </a:ln>
+        </p:spPr>
+        <p:style>
+          <a:lnRef idx="1">
+            <a:schemeClr val="accent1"/>
+          </a:lnRef>
+          <a:fillRef idx="3">
+            <a:schemeClr val="accent1"/>
+          </a:fillRef>
+          <a:effectRef idx="2">
+            <a:schemeClr val="accent1"/>
+          </a:effectRef>
+          <a:fontRef idx="minor">
+            <a:schemeClr val="lt1"/>
+          </a:fontRef>
+        </p:style>
+        <p:txBody>
+          <a:bodyPr rtlCol="0" anchor="ctr"/>
+          <a:lstStyle/>
+          <a:p>
+            <a:pPr algn="ctr"/>
+          </a:p>
+        </p:txBody>
+      </p:sp>
+      <p:sp>
+        <p:nvSpPr>
+          <p:cNvPr id="25" name="TextBox 24"/>
+          <p:cNvSpPr txBox="1"/>
+          <p:nvPr/>
+        </p:nvSpPr>
+        <p:spPr>
+          <a:xfrm>
+            <a:off x="5577840" y="4846320"/>
+            <a:ext cx="6217920" cy="274320"/>
+          </a:xfrm>
+          <a:prstGeom prst="rect">
+            <a:avLst/>
+          </a:prstGeom>
+          <a:noFill/>
+        </p:spPr>
+        <p:txBody>
+          <a:bodyPr wrap="square">
+            <a:spAutoFit/>
+          </a:bodyPr>
+          <a:lstStyle/>
+          <a:p>
+            <a:pPr algn="l"/>
+            <a:r>
+              <a:rPr sz="1100" b="1" i="0">
+                <a:solidFill>
+                  <a:srgbClr val="FFFFFF"/>
+                </a:solidFill>
+                <a:latin typeface="Calibri"/>
+              </a:rPr>
+              <a:t>P6 — Product Water</a:t>
+            </a:r>
+          </a:p>
+        </p:txBody>
+      </p:sp>
+      <p:sp>
+        <p:nvSpPr>
+          <p:cNvPr id="26" name="TextBox 25"/>
+          <p:cNvSpPr txBox="1"/>
+          <p:nvPr/>
+        </p:nvSpPr>
+        <p:spPr>
+          <a:xfrm>
+            <a:off x="5577840" y="5138928"/>
+            <a:ext cx="6217920" cy="365760"/>
+          </a:xfrm>
+          <a:prstGeom prst="rect">
+            <a:avLst/>
+          </a:prstGeom>
+          <a:noFill/>
+        </p:spPr>
+        <p:txBody>
+          <a:bodyPr wrap="square">
+            <a:spAutoFit/>
+          </a:bodyPr>
+          <a:lstStyle/>
+          <a:p>
+            <a:pPr algn="l"/>
+            <a:r>
+              <a:rPr sz="950" b="0" i="0">
+                <a:solidFill>
+                  <a:srgbClr val="FFFFFF"/>
+                </a:solidFill>
+                <a:latin typeface="Calibri"/>
+              </a:rPr>
+              <a:t>LIT601 drops → LIT602 drops → plant-wide emergency shutdown</a:t>
+            </a:r>
+          </a:p>
+        </p:txBody>
+      </p:sp>
+      <p:sp>
+        <p:nvSpPr>
+          <p:cNvPr id="27" name="TextBox 26"/>
+          <p:cNvSpPr txBox="1"/>
+          <p:nvPr/>
+        </p:nvSpPr>
+        <p:spPr>
+          <a:xfrm>
+            <a:off x="320040" y="5806440"/>
+            <a:ext cx="11548872" cy="237744"/>
+          </a:xfrm>
+          <a:prstGeom prst="rect">
+            <a:avLst/>
+          </a:prstGeom>
+          <a:noFill/>
+        </p:spPr>
+        <p:txBody>
+          <a:bodyPr wrap="square">
+            <a:spAutoFit/>
+          </a:bodyPr>
+          <a:lstStyle/>
+          <a:p>
+            <a:pPr algn="ctr"/>
+            <a:r>
+              <a:rPr sz="1000" b="1" i="0">
+                <a:solidFill>
+                  <a:srgbClr val="E8243C"/>
+                </a:solidFill>
+                <a:latin typeface="Calibri"/>
+              </a:rPr>
+              <a:t>One compromised HMI. One valve closed. The cascade does the rest.</a:t>
+            </a:r>
+          </a:p>
+        </p:txBody>
+      </p:sp>
+    </p:spTree>
+  </p:cSld>
+  <p:clrMapOvr>
+    <a:masterClrMapping/>
+  </p:clrMapOvr>
+</p:sld>
+</file>
+
+<file path=ppt/slides/slide43.xml><?xml version="1.0" encoding="utf-8"?>
+<p:sld xmlns:a="http://schemas.openxmlformats.org/drawingml/2006/main" xmlns:p="http://schemas.openxmlformats.org/presentationml/2006/main" xmlns:r="http://schemas.openxmlformats.org/officeDocument/2006/relationships">
+  <p:cSld>
+    <p:spTree>
+      <p:nvGrpSpPr>
+        <p:cNvPr id="1" name=""/>
+        <p:cNvGrpSpPr/>
+        <p:nvPr/>
+      </p:nvGrpSpPr>
+      <p:grpSpPr/>
+      <p:sp>
+        <p:nvSpPr>
+          <p:cNvPr id="2" name="Rectangle 1"/>
+          <p:cNvSpPr/>
+          <p:nvPr/>
+        </p:nvSpPr>
+        <p:spPr>
+          <a:xfrm>
+            <a:off x="0" y="0"/>
+            <a:ext cx="12188952" cy="6858000"/>
+          </a:xfrm>
+          <a:prstGeom prst="rect">
+            <a:avLst/>
+          </a:prstGeom>
+          <a:solidFill>
+            <a:srgbClr val="FFFFFF"/>
+          </a:solidFill>
+          <a:ln>
+            <a:noFill/>
+          </a:ln>
+        </p:spPr>
+        <p:style>
+          <a:lnRef idx="1">
+            <a:schemeClr val="accent1"/>
+          </a:lnRef>
+          <a:fillRef idx="3">
+            <a:schemeClr val="accent1"/>
+          </a:fillRef>
+          <a:effectRef idx="2">
+            <a:schemeClr val="accent1"/>
+          </a:effectRef>
+          <a:fontRef idx="minor">
+            <a:schemeClr val="lt1"/>
+          </a:fontRef>
+        </p:style>
+        <p:txBody>
+          <a:bodyPr rtlCol="0" anchor="ctr"/>
+          <a:lstStyle/>
+          <a:p>
+            <a:pPr algn="ctr"/>
+          </a:p>
+        </p:txBody>
+      </p:sp>
+      <p:sp>
+        <p:nvSpPr>
+          <p:cNvPr id="3" name="Rectangle 2"/>
+          <p:cNvSpPr/>
+          <p:nvPr/>
+        </p:nvSpPr>
+        <p:spPr>
+          <a:xfrm>
+            <a:off x="0" y="0"/>
+            <a:ext cx="12188952" cy="64008"/>
+          </a:xfrm>
+          <a:prstGeom prst="rect">
+            <a:avLst/>
+          </a:prstGeom>
+          <a:solidFill>
+            <a:srgbClr val="E8243C"/>
+          </a:solidFill>
+          <a:ln>
+            <a:noFill/>
+          </a:ln>
+        </p:spPr>
+        <p:style>
+          <a:lnRef idx="1">
+            <a:schemeClr val="accent1"/>
+          </a:lnRef>
+          <a:fillRef idx="3">
+            <a:schemeClr val="accent1"/>
+          </a:fillRef>
+          <a:effectRef idx="2">
+            <a:schemeClr val="accent1"/>
+          </a:effectRef>
+          <a:fontRef idx="minor">
+            <a:schemeClr val="lt1"/>
+          </a:fontRef>
+        </p:style>
+        <p:txBody>
+          <a:bodyPr rtlCol="0" anchor="ctr"/>
+          <a:lstStyle/>
+          <a:p>
+            <a:pPr algn="ctr"/>
+          </a:p>
+        </p:txBody>
+      </p:sp>
+      <p:sp>
+        <p:nvSpPr>
+          <p:cNvPr id="4" name="Rectangle 3"/>
+          <p:cNvSpPr/>
+          <p:nvPr/>
+        </p:nvSpPr>
+        <p:spPr>
+          <a:xfrm>
+            <a:off x="0" y="6510528"/>
+            <a:ext cx="12188952" cy="347472"/>
+          </a:xfrm>
+          <a:prstGeom prst="rect">
+            <a:avLst/>
+          </a:prstGeom>
+          <a:solidFill>
+            <a:srgbClr val="F5F5F5"/>
+          </a:solidFill>
+          <a:ln>
+            <a:noFill/>
+          </a:ln>
+        </p:spPr>
+        <p:style>
+          <a:lnRef idx="1">
+            <a:schemeClr val="accent1"/>
+          </a:lnRef>
+          <a:fillRef idx="3">
+            <a:schemeClr val="accent1"/>
+          </a:fillRef>
+          <a:effectRef idx="2">
+            <a:schemeClr val="accent1"/>
+          </a:effectRef>
+          <a:fontRef idx="minor">
+            <a:schemeClr val="lt1"/>
+          </a:fontRef>
+        </p:style>
+        <p:txBody>
+          <a:bodyPr rtlCol="0" anchor="ctr"/>
+          <a:lstStyle/>
+          <a:p>
+            <a:pPr algn="ctr"/>
+          </a:p>
+        </p:txBody>
+      </p:sp>
+      <p:sp>
+        <p:nvSpPr>
+          <p:cNvPr id="5" name="TextBox 4"/>
+          <p:cNvSpPr txBox="1"/>
+          <p:nvPr/>
+        </p:nvSpPr>
+        <p:spPr>
+          <a:xfrm>
+            <a:off x="274320" y="6565392"/>
+            <a:ext cx="11640312" cy="219456"/>
+          </a:xfrm>
+          <a:prstGeom prst="rect">
+            <a:avLst/>
+          </a:prstGeom>
+          <a:noFill/>
+        </p:spPr>
+        <p:txBody>
+          <a:bodyPr wrap="square">
+            <a:spAutoFit/>
+          </a:bodyPr>
+          <a:lstStyle/>
+          <a:p>
+            <a:pPr algn="l"/>
+            <a:r>
+              <a:rPr sz="800" b="0" i="0">
+                <a:solidFill>
+                  <a:srgbClr val="6B6B6B"/>
+                </a:solidFill>
+                <a:latin typeface="Calibri"/>
+              </a:rPr>
+              <a:t>51.508 Secure CPS  ·  SWaT Project  ·  iTrust Lab, SUTD</a:t>
+            </a:r>
+          </a:p>
+        </p:txBody>
+      </p:sp>
+      <p:sp>
+        <p:nvSpPr>
+          <p:cNvPr id="6" name="Rectangle 5"/>
+          <p:cNvSpPr/>
+          <p:nvPr/>
+        </p:nvSpPr>
+        <p:spPr>
+          <a:xfrm>
+            <a:off x="320040" y="109728"/>
+            <a:ext cx="1737360" cy="292608"/>
+          </a:xfrm>
+          <a:prstGeom prst="rect">
+            <a:avLst/>
+          </a:prstGeom>
+          <a:solidFill>
+            <a:srgbClr val="E8243C"/>
+          </a:solidFill>
+          <a:ln>
+            <a:noFill/>
+          </a:ln>
+        </p:spPr>
+        <p:style>
+          <a:lnRef idx="1">
+            <a:schemeClr val="accent1"/>
+          </a:lnRef>
+          <a:fillRef idx="3">
+            <a:schemeClr val="accent1"/>
+          </a:fillRef>
+          <a:effectRef idx="2">
+            <a:schemeClr val="accent1"/>
+          </a:effectRef>
+          <a:fontRef idx="minor">
+            <a:schemeClr val="lt1"/>
+          </a:fontRef>
+        </p:style>
+        <p:txBody>
+          <a:bodyPr rtlCol="0" anchor="ctr"/>
+          <a:lstStyle/>
+          <a:p>
+            <a:pPr algn="ctr"/>
+          </a:p>
+        </p:txBody>
+      </p:sp>
+      <p:sp>
+        <p:nvSpPr>
+          <p:cNvPr id="7" name="TextBox 6"/>
+          <p:cNvSpPr txBox="1"/>
+          <p:nvPr/>
+        </p:nvSpPr>
+        <p:spPr>
+          <a:xfrm>
+            <a:off x="320040" y="109728"/>
+            <a:ext cx="1737360" cy="292608"/>
+          </a:xfrm>
+          <a:prstGeom prst="rect">
+            <a:avLst/>
+          </a:prstGeom>
+          <a:noFill/>
+        </p:spPr>
+        <p:txBody>
+          <a:bodyPr wrap="square">
+            <a:spAutoFit/>
+          </a:bodyPr>
+          <a:lstStyle/>
+          <a:p>
+            <a:pPr algn="ctr"/>
+            <a:r>
+              <a:rPr sz="1000" b="1" i="0">
+                <a:solidFill>
+                  <a:srgbClr val="FFFFFF"/>
+                </a:solidFill>
+                <a:latin typeface="Calibri"/>
+              </a:rPr>
+              <a:t>BROADER IMPACT</a:t>
+            </a:r>
+          </a:p>
+        </p:txBody>
+      </p:sp>
+      <p:sp>
+        <p:nvSpPr>
+          <p:cNvPr id="8" name="TextBox 7"/>
+          <p:cNvSpPr txBox="1"/>
+          <p:nvPr/>
+        </p:nvSpPr>
+        <p:spPr>
+          <a:xfrm>
+            <a:off x="320040" y="457200"/>
+            <a:ext cx="11548872" cy="566928"/>
+          </a:xfrm>
+          <a:prstGeom prst="rect">
+            <a:avLst/>
+          </a:prstGeom>
+          <a:noFill/>
+        </p:spPr>
+        <p:txBody>
+          <a:bodyPr wrap="square">
+            <a:spAutoFit/>
+          </a:bodyPr>
+          <a:lstStyle/>
+          <a:p>
+            <a:pPr algn="l"/>
+            <a:r>
+              <a:rPr sz="2600" b="1" i="0">
+                <a:solidFill>
+                  <a:srgbClr val="1A1A1A"/>
+                </a:solidFill>
+                <a:latin typeface="Calibri Light"/>
+              </a:rPr>
+              <a:t>The Attack Generalises to All 6 Stages</a:t>
+            </a:r>
+          </a:p>
+        </p:txBody>
+      </p:sp>
+      <p:sp>
+        <p:nvSpPr>
+          <p:cNvPr id="9" name="TextBox 8"/>
+          <p:cNvSpPr txBox="1"/>
+          <p:nvPr/>
+        </p:nvSpPr>
+        <p:spPr>
+          <a:xfrm>
+            <a:off x="320040" y="1005840"/>
+            <a:ext cx="11548872" cy="237744"/>
+          </a:xfrm>
+          <a:prstGeom prst="rect">
+            <a:avLst/>
+          </a:prstGeom>
+          <a:noFill/>
+        </p:spPr>
+        <p:txBody>
+          <a:bodyPr wrap="square">
+            <a:spAutoFit/>
+          </a:bodyPr>
+          <a:lstStyle/>
+          <a:p>
+            <a:pPr algn="l"/>
+            <a:r>
+              <a:rPr sz="1150" b="0" i="1">
+                <a:solidFill>
+                  <a:srgbClr val="6B6B6B"/>
+                </a:solidFill>
+                <a:latin typeface="Calibri"/>
+              </a:rPr>
+              <a:t>Same two-line pylogix write — different PLC IP and tag names</a:t>
+            </a:r>
+          </a:p>
+        </p:txBody>
+      </p:sp>
+      <p:sp>
+        <p:nvSpPr>
+          <p:cNvPr id="10" name="Rectangle 9"/>
+          <p:cNvSpPr/>
+          <p:nvPr/>
+        </p:nvSpPr>
+        <p:spPr>
+          <a:xfrm>
+            <a:off x="320040" y="1325880"/>
+            <a:ext cx="7040880" cy="4709160"/>
+          </a:xfrm>
+          <a:prstGeom prst="rect">
+            <a:avLst/>
+          </a:prstGeom>
+          <a:solidFill>
+            <a:srgbClr val="0D0D1A"/>
+          </a:solidFill>
+          <a:ln>
+            <a:noFill/>
+          </a:ln>
+        </p:spPr>
+        <p:style>
+          <a:lnRef idx="1">
+            <a:schemeClr val="accent1"/>
+          </a:lnRef>
+          <a:fillRef idx="3">
+            <a:schemeClr val="accent1"/>
+          </a:fillRef>
+          <a:effectRef idx="2">
+            <a:schemeClr val="accent1"/>
+          </a:effectRef>
+          <a:fontRef idx="minor">
+            <a:schemeClr val="lt1"/>
+          </a:fontRef>
+        </p:style>
+        <p:txBody>
+          <a:bodyPr rtlCol="0" anchor="ctr"/>
+          <a:lstStyle/>
+          <a:p>
+            <a:pPr algn="ctr"/>
+          </a:p>
+        </p:txBody>
+      </p:sp>
+      <p:sp>
+        <p:nvSpPr>
+          <p:cNvPr id="11" name="TextBox 10"/>
+          <p:cNvSpPr txBox="1"/>
+          <p:nvPr/>
+        </p:nvSpPr>
+        <p:spPr>
+          <a:xfrm>
+            <a:off x="457200" y="1417320"/>
+            <a:ext cx="6858000" cy="256032"/>
+          </a:xfrm>
+          <a:prstGeom prst="rect">
+            <a:avLst/>
+          </a:prstGeom>
+          <a:noFill/>
+        </p:spPr>
+        <p:txBody>
+          <a:bodyPr wrap="square">
+            <a:spAutoFit/>
+          </a:bodyPr>
+          <a:lstStyle/>
+          <a:p>
+            <a:pPr algn="l"/>
+            <a:r>
+              <a:rPr sz="900" b="0" i="0">
+                <a:solidFill>
+                  <a:srgbClr val="6B6B6B"/>
+                </a:solidFill>
+                <a:latin typeface="Courier New"/>
+              </a:rPr>
+              <a:t># Stage 1 — Raw Water       (PLC1: 192.168.1.10)</a:t>
+            </a:r>
+          </a:p>
+        </p:txBody>
+      </p:sp>
+      <p:sp>
+        <p:nvSpPr>
+          <p:cNvPr id="12" name="TextBox 11"/>
+          <p:cNvSpPr txBox="1"/>
+          <p:nvPr/>
+        </p:nvSpPr>
+        <p:spPr>
+          <a:xfrm>
+            <a:off x="457200" y="1659636"/>
+            <a:ext cx="6858000" cy="256032"/>
+          </a:xfrm>
+          <a:prstGeom prst="rect">
+            <a:avLst/>
+          </a:prstGeom>
+          <a:noFill/>
+        </p:spPr>
+        <p:txBody>
+          <a:bodyPr wrap="square">
+            <a:spAutoFit/>
+          </a:bodyPr>
+          <a:lstStyle/>
+          <a:p>
+            <a:pPr algn="l"/>
+            <a:r>
+              <a:rPr sz="900" b="0" i="0">
+                <a:solidFill>
+                  <a:srgbClr val="00FF88"/>
+                </a:solidFill>
+                <a:latin typeface="Courier New"/>
+              </a:rPr>
+              <a:t>plc.Write('HMI_MV101.Auto', False);  plc.Write('HMI_MV101.Cmd', 1)</a:t>
+            </a:r>
+          </a:p>
+        </p:txBody>
+      </p:sp>
+      <p:sp>
+        <p:nvSpPr>
+          <p:cNvPr id="13" name="TextBox 12"/>
+          <p:cNvSpPr txBox="1"/>
+          <p:nvPr/>
+        </p:nvSpPr>
+        <p:spPr>
+          <a:xfrm>
+            <a:off x="457200" y="1901952"/>
+            <a:ext cx="6858000" cy="256032"/>
+          </a:xfrm>
+          <a:prstGeom prst="rect">
+            <a:avLst/>
+          </a:prstGeom>
+          <a:noFill/>
+        </p:spPr>
+        <p:txBody>
+          <a:bodyPr wrap="square">
+            <a:spAutoFit/>
+          </a:bodyPr>
+          <a:lstStyle/>
+          <a:p>
+            <a:pPr algn="l"/>
+            <a:r>
+              <a:rPr sz="900" b="0" i="0">
+                <a:solidFill>
+                  <a:srgbClr val="00FF88"/>
+                </a:solidFill>
+                <a:latin typeface="Courier New"/>
+              </a:rPr>
+              <a:t>plc.Write('HMI_P101.Auto',  False);  plc.Write('HMI_P101.Cmd',  1)</a:t>
+            </a:r>
+          </a:p>
+        </p:txBody>
+      </p:sp>
+      <p:sp>
+        <p:nvSpPr>
+          <p:cNvPr id="14" name="TextBox 13"/>
+          <p:cNvSpPr txBox="1"/>
+          <p:nvPr/>
+        </p:nvSpPr>
+        <p:spPr>
+          <a:xfrm>
+            <a:off x="457200" y="2144268"/>
+            <a:ext cx="6858000" cy="256032"/>
+          </a:xfrm>
+          <a:prstGeom prst="rect">
+            <a:avLst/>
+          </a:prstGeom>
+          <a:noFill/>
+        </p:spPr>
+        <p:txBody>
+          <a:bodyPr wrap="square">
+            <a:spAutoFit/>
+          </a:bodyPr>
+          <a:lstStyle/>
+          <a:p>
+            <a:pPr algn="l"/>
+            <a:r>
+              <a:rPr sz="900" b="0" i="0">
+                <a:solidFill>
+                  <a:srgbClr val="1A1A1A"/>
+                </a:solidFill>
+                <a:latin typeface="Courier New"/>
+              </a:rPr>
+              <a:t/>
+            </a:r>
+          </a:p>
+        </p:txBody>
+      </p:sp>
+      <p:sp>
+        <p:nvSpPr>
+          <p:cNvPr id="15" name="TextBox 14"/>
+          <p:cNvSpPr txBox="1"/>
+          <p:nvPr/>
+        </p:nvSpPr>
+        <p:spPr>
+          <a:xfrm>
+            <a:off x="457200" y="2386584"/>
+            <a:ext cx="6858000" cy="256032"/>
+          </a:xfrm>
+          <a:prstGeom prst="rect">
+            <a:avLst/>
+          </a:prstGeom>
+          <a:noFill/>
+        </p:spPr>
+        <p:txBody>
+          <a:bodyPr wrap="square">
+            <a:spAutoFit/>
+          </a:bodyPr>
+          <a:lstStyle/>
+          <a:p>
+            <a:pPr algn="l"/>
+            <a:r>
+              <a:rPr sz="900" b="0" i="0">
+                <a:solidFill>
+                  <a:srgbClr val="6B6B6B"/>
+                </a:solidFill>
+                <a:latin typeface="Courier New"/>
+              </a:rPr>
+              <a:t># Stage 2 — Pre-Treatment   (PLC2: 192.168.1.20)</a:t>
+            </a:r>
+          </a:p>
+        </p:txBody>
+      </p:sp>
+      <p:sp>
+        <p:nvSpPr>
+          <p:cNvPr id="16" name="TextBox 15"/>
+          <p:cNvSpPr txBox="1"/>
+          <p:nvPr/>
+        </p:nvSpPr>
+        <p:spPr>
+          <a:xfrm>
+            <a:off x="457200" y="2628900"/>
+            <a:ext cx="6858000" cy="256032"/>
+          </a:xfrm>
+          <a:prstGeom prst="rect">
+            <a:avLst/>
+          </a:prstGeom>
+          <a:noFill/>
+        </p:spPr>
+        <p:txBody>
+          <a:bodyPr wrap="square">
+            <a:spAutoFit/>
+          </a:bodyPr>
+          <a:lstStyle/>
+          <a:p>
+            <a:pPr algn="l"/>
+            <a:r>
+              <a:rPr sz="900" b="0" i="0">
+                <a:solidFill>
+                  <a:srgbClr val="00FF88"/>
+                </a:solidFill>
+                <a:latin typeface="Courier New"/>
+              </a:rPr>
+              <a:t>plc.Write('HMI_MV201.Auto', False);  plc.Write('HMI_MV201.Cmd', 1)</a:t>
+            </a:r>
+          </a:p>
+        </p:txBody>
+      </p:sp>
+      <p:sp>
+        <p:nvSpPr>
+          <p:cNvPr id="17" name="TextBox 16"/>
+          <p:cNvSpPr txBox="1"/>
+          <p:nvPr/>
+        </p:nvSpPr>
+        <p:spPr>
+          <a:xfrm>
+            <a:off x="457200" y="2871216"/>
+            <a:ext cx="6858000" cy="256032"/>
+          </a:xfrm>
+          <a:prstGeom prst="rect">
+            <a:avLst/>
+          </a:prstGeom>
+          <a:noFill/>
+        </p:spPr>
+        <p:txBody>
+          <a:bodyPr wrap="square">
+            <a:spAutoFit/>
+          </a:bodyPr>
+          <a:lstStyle/>
+          <a:p>
+            <a:pPr algn="l"/>
+            <a:r>
+              <a:rPr sz="900" b="0" i="0">
+                <a:solidFill>
+                  <a:srgbClr val="00FF88"/>
+                </a:solidFill>
+                <a:latin typeface="Courier New"/>
+              </a:rPr>
+              <a:t>plc.Write('HMI_P201.Auto',  False);  plc.Write('HMI_P201.Cmd',  1)</a:t>
+            </a:r>
+          </a:p>
+        </p:txBody>
+      </p:sp>
+      <p:sp>
+        <p:nvSpPr>
+          <p:cNvPr id="18" name="TextBox 17"/>
+          <p:cNvSpPr txBox="1"/>
+          <p:nvPr/>
+        </p:nvSpPr>
+        <p:spPr>
+          <a:xfrm>
+            <a:off x="457200" y="3113532"/>
+            <a:ext cx="6858000" cy="256032"/>
+          </a:xfrm>
+          <a:prstGeom prst="rect">
+            <a:avLst/>
+          </a:prstGeom>
+          <a:noFill/>
+        </p:spPr>
+        <p:txBody>
+          <a:bodyPr wrap="square">
+            <a:spAutoFit/>
+          </a:bodyPr>
+          <a:lstStyle/>
+          <a:p>
+            <a:pPr algn="l"/>
+            <a:r>
+              <a:rPr sz="900" b="0" i="0">
+                <a:solidFill>
+                  <a:srgbClr val="1A1A1A"/>
+                </a:solidFill>
+                <a:latin typeface="Courier New"/>
+              </a:rPr>
+              <a:t/>
+            </a:r>
+          </a:p>
+        </p:txBody>
+      </p:sp>
+      <p:sp>
+        <p:nvSpPr>
+          <p:cNvPr id="19" name="TextBox 18"/>
+          <p:cNvSpPr txBox="1"/>
+          <p:nvPr/>
+        </p:nvSpPr>
+        <p:spPr>
+          <a:xfrm>
+            <a:off x="457200" y="3355848"/>
+            <a:ext cx="6858000" cy="256032"/>
+          </a:xfrm>
+          <a:prstGeom prst="rect">
+            <a:avLst/>
+          </a:prstGeom>
+          <a:noFill/>
+        </p:spPr>
+        <p:txBody>
+          <a:bodyPr wrap="square">
+            <a:spAutoFit/>
+          </a:bodyPr>
+          <a:lstStyle/>
+          <a:p>
+            <a:pPr algn="l"/>
+            <a:r>
+              <a:rPr sz="900" b="0" i="0">
+                <a:solidFill>
+                  <a:srgbClr val="6B6B6B"/>
+                </a:solidFill>
+                <a:latin typeface="Courier New"/>
+              </a:rPr>
+              <a:t># Stage 3 — Ultrafiltration (PLC3: 192.168.1.30)</a:t>
+            </a:r>
+          </a:p>
+        </p:txBody>
+      </p:sp>
+      <p:sp>
+        <p:nvSpPr>
+          <p:cNvPr id="20" name="TextBox 19"/>
+          <p:cNvSpPr txBox="1"/>
+          <p:nvPr/>
+        </p:nvSpPr>
+        <p:spPr>
+          <a:xfrm>
+            <a:off x="457200" y="3598164"/>
+            <a:ext cx="6858000" cy="256032"/>
+          </a:xfrm>
+          <a:prstGeom prst="rect">
+            <a:avLst/>
+          </a:prstGeom>
+          <a:noFill/>
+        </p:spPr>
+        <p:txBody>
+          <a:bodyPr wrap="square">
+            <a:spAutoFit/>
+          </a:bodyPr>
+          <a:lstStyle/>
+          <a:p>
+            <a:pPr algn="l"/>
+            <a:r>
+              <a:rPr sz="900" b="0" i="0">
+                <a:solidFill>
+                  <a:srgbClr val="00FF88"/>
+                </a:solidFill>
+                <a:latin typeface="Courier New"/>
+              </a:rPr>
+              <a:t>plc.Write('HMI_P301.Auto',  False);  plc.Write('HMI_P301.Cmd',  1)</a:t>
+            </a:r>
+          </a:p>
+        </p:txBody>
+      </p:sp>
+      <p:sp>
+        <p:nvSpPr>
+          <p:cNvPr id="21" name="TextBox 20"/>
+          <p:cNvSpPr txBox="1"/>
+          <p:nvPr/>
+        </p:nvSpPr>
+        <p:spPr>
+          <a:xfrm>
+            <a:off x="457200" y="3840480"/>
+            <a:ext cx="6858000" cy="256032"/>
+          </a:xfrm>
+          <a:prstGeom prst="rect">
+            <a:avLst/>
+          </a:prstGeom>
+          <a:noFill/>
+        </p:spPr>
+        <p:txBody>
+          <a:bodyPr wrap="square">
+            <a:spAutoFit/>
+          </a:bodyPr>
+          <a:lstStyle/>
+          <a:p>
+            <a:pPr algn="l"/>
+            <a:r>
+              <a:rPr sz="900" b="0" i="0">
+                <a:solidFill>
+                  <a:srgbClr val="1A1A1A"/>
+                </a:solidFill>
+                <a:latin typeface="Courier New"/>
+              </a:rPr>
+              <a:t/>
+            </a:r>
+          </a:p>
+        </p:txBody>
+      </p:sp>
+      <p:sp>
+        <p:nvSpPr>
+          <p:cNvPr id="22" name="TextBox 21"/>
+          <p:cNvSpPr txBox="1"/>
+          <p:nvPr/>
+        </p:nvSpPr>
+        <p:spPr>
+          <a:xfrm>
+            <a:off x="457200" y="4082796"/>
+            <a:ext cx="6858000" cy="256032"/>
+          </a:xfrm>
+          <a:prstGeom prst="rect">
+            <a:avLst/>
+          </a:prstGeom>
+          <a:noFill/>
+        </p:spPr>
+        <p:txBody>
+          <a:bodyPr wrap="square">
+            <a:spAutoFit/>
+          </a:bodyPr>
+          <a:lstStyle/>
+          <a:p>
+            <a:pPr algn="l"/>
+            <a:r>
+              <a:rPr sz="900" b="0" i="0">
+                <a:solidFill>
+                  <a:srgbClr val="6B6B6B"/>
+                </a:solidFill>
+                <a:latin typeface="Courier New"/>
+              </a:rPr>
+              <a:t># Stage 4 — De-Chlorination (PLC4: 192.168.1.40)</a:t>
+            </a:r>
+          </a:p>
+        </p:txBody>
+      </p:sp>
+      <p:sp>
+        <p:nvSpPr>
+          <p:cNvPr id="23" name="TextBox 22"/>
+          <p:cNvSpPr txBox="1"/>
+          <p:nvPr/>
+        </p:nvSpPr>
+        <p:spPr>
+          <a:xfrm>
+            <a:off x="457200" y="4325112"/>
+            <a:ext cx="6858000" cy="256032"/>
+          </a:xfrm>
+          <a:prstGeom prst="rect">
+            <a:avLst/>
+          </a:prstGeom>
+          <a:noFill/>
+        </p:spPr>
+        <p:txBody>
+          <a:bodyPr wrap="square">
+            <a:spAutoFit/>
+          </a:bodyPr>
+          <a:lstStyle/>
+          <a:p>
+            <a:pPr algn="l"/>
+            <a:r>
+              <a:rPr sz="900" b="0" i="0">
+                <a:solidFill>
+                  <a:srgbClr val="00FF88"/>
+                </a:solidFill>
+                <a:latin typeface="Courier New"/>
+              </a:rPr>
+              <a:t>plc.Write('HMI_UV401.Auto', False);  plc.Write('HMI_UV401.Cmd', 1)</a:t>
+            </a:r>
+          </a:p>
+        </p:txBody>
+      </p:sp>
+      <p:sp>
+        <p:nvSpPr>
+          <p:cNvPr id="24" name="TextBox 23"/>
+          <p:cNvSpPr txBox="1"/>
+          <p:nvPr/>
+        </p:nvSpPr>
+        <p:spPr>
+          <a:xfrm>
+            <a:off x="457200" y="4567428"/>
+            <a:ext cx="6858000" cy="256032"/>
+          </a:xfrm>
+          <a:prstGeom prst="rect">
+            <a:avLst/>
+          </a:prstGeom>
+          <a:noFill/>
+        </p:spPr>
+        <p:txBody>
+          <a:bodyPr wrap="square">
+            <a:spAutoFit/>
+          </a:bodyPr>
+          <a:lstStyle/>
+          <a:p>
+            <a:pPr algn="l"/>
+            <a:r>
+              <a:rPr sz="900" b="0" i="0">
+                <a:solidFill>
+                  <a:srgbClr val="1A1A1A"/>
+                </a:solidFill>
+                <a:latin typeface="Courier New"/>
+              </a:rPr>
+              <a:t/>
+            </a:r>
+          </a:p>
+        </p:txBody>
+      </p:sp>
+      <p:sp>
+        <p:nvSpPr>
+          <p:cNvPr id="25" name="TextBox 24"/>
+          <p:cNvSpPr txBox="1"/>
+          <p:nvPr/>
+        </p:nvSpPr>
+        <p:spPr>
+          <a:xfrm>
+            <a:off x="457200" y="4809744"/>
+            <a:ext cx="6858000" cy="256032"/>
+          </a:xfrm>
+          <a:prstGeom prst="rect">
+            <a:avLst/>
+          </a:prstGeom>
+          <a:noFill/>
+        </p:spPr>
+        <p:txBody>
+          <a:bodyPr wrap="square">
+            <a:spAutoFit/>
+          </a:bodyPr>
+          <a:lstStyle/>
+          <a:p>
+            <a:pPr algn="l"/>
+            <a:r>
+              <a:rPr sz="900" b="0" i="0">
+                <a:solidFill>
+                  <a:srgbClr val="6B6B6B"/>
+                </a:solidFill>
+                <a:latin typeface="Courier New"/>
+              </a:rPr>
+              <a:t># Stage 5 — Reverse Osmosis (PLC5: 192.168.1.50)</a:t>
+            </a:r>
+          </a:p>
+        </p:txBody>
+      </p:sp>
+      <p:sp>
+        <p:nvSpPr>
+          <p:cNvPr id="26" name="TextBox 25"/>
+          <p:cNvSpPr txBox="1"/>
+          <p:nvPr/>
+        </p:nvSpPr>
+        <p:spPr>
+          <a:xfrm>
+            <a:off x="457200" y="5052060"/>
+            <a:ext cx="6858000" cy="256032"/>
+          </a:xfrm>
+          <a:prstGeom prst="rect">
+            <a:avLst/>
+          </a:prstGeom>
+          <a:noFill/>
+        </p:spPr>
+        <p:txBody>
+          <a:bodyPr wrap="square">
+            <a:spAutoFit/>
+          </a:bodyPr>
+          <a:lstStyle/>
+          <a:p>
+            <a:pPr algn="l"/>
+            <a:r>
+              <a:rPr sz="900" b="0" i="0">
+                <a:solidFill>
+                  <a:srgbClr val="00FF88"/>
+                </a:solidFill>
+                <a:latin typeface="Courier New"/>
+              </a:rPr>
+              <a:t>plc.Write('HMI_P501.Auto',  False);  plc.Write('HMI_P501.Cmd',  1)</a:t>
+            </a:r>
+          </a:p>
+        </p:txBody>
+      </p:sp>
+      <p:sp>
+        <p:nvSpPr>
+          <p:cNvPr id="27" name="TextBox 26"/>
+          <p:cNvSpPr txBox="1"/>
+          <p:nvPr/>
+        </p:nvSpPr>
+        <p:spPr>
+          <a:xfrm>
+            <a:off x="457200" y="5294376"/>
+            <a:ext cx="6858000" cy="256032"/>
+          </a:xfrm>
+          <a:prstGeom prst="rect">
+            <a:avLst/>
+          </a:prstGeom>
+          <a:noFill/>
+        </p:spPr>
+        <p:txBody>
+          <a:bodyPr wrap="square">
+            <a:spAutoFit/>
+          </a:bodyPr>
+          <a:lstStyle/>
+          <a:p>
+            <a:pPr algn="l"/>
+            <a:r>
+              <a:rPr sz="900" b="0" i="0">
+                <a:solidFill>
+                  <a:srgbClr val="1A1A1A"/>
+                </a:solidFill>
+                <a:latin typeface="Courier New"/>
+              </a:rPr>
+              <a:t/>
+            </a:r>
+          </a:p>
+        </p:txBody>
+      </p:sp>
+      <p:sp>
+        <p:nvSpPr>
+          <p:cNvPr id="28" name="TextBox 27"/>
+          <p:cNvSpPr txBox="1"/>
+          <p:nvPr/>
+        </p:nvSpPr>
+        <p:spPr>
+          <a:xfrm>
+            <a:off x="457200" y="5536692"/>
+            <a:ext cx="6858000" cy="256032"/>
+          </a:xfrm>
+          <a:prstGeom prst="rect">
+            <a:avLst/>
+          </a:prstGeom>
+          <a:noFill/>
+        </p:spPr>
+        <p:txBody>
+          <a:bodyPr wrap="square">
+            <a:spAutoFit/>
+          </a:bodyPr>
+          <a:lstStyle/>
+          <a:p>
+            <a:pPr algn="l"/>
+            <a:r>
+              <a:rPr sz="900" b="0" i="0">
+                <a:solidFill>
+                  <a:srgbClr val="6B6B6B"/>
+                </a:solidFill>
+                <a:latin typeface="Courier New"/>
+              </a:rPr>
+              <a:t># Stage 6 — Product Water   (PLC6: 192.168.1.60)</a:t>
+            </a:r>
+          </a:p>
+        </p:txBody>
+      </p:sp>
+      <p:sp>
+        <p:nvSpPr>
+          <p:cNvPr id="29" name="TextBox 28"/>
+          <p:cNvSpPr txBox="1"/>
+          <p:nvPr/>
+        </p:nvSpPr>
+        <p:spPr>
+          <a:xfrm>
+            <a:off x="457200" y="5779008"/>
+            <a:ext cx="6858000" cy="256032"/>
+          </a:xfrm>
+          <a:prstGeom prst="rect">
+            <a:avLst/>
+          </a:prstGeom>
+          <a:noFill/>
+        </p:spPr>
+        <p:txBody>
+          <a:bodyPr wrap="square">
+            <a:spAutoFit/>
+          </a:bodyPr>
+          <a:lstStyle/>
+          <a:p>
+            <a:pPr algn="l"/>
+            <a:r>
+              <a:rPr sz="900" b="0" i="0">
+                <a:solidFill>
+                  <a:srgbClr val="00FF88"/>
+                </a:solidFill>
+                <a:latin typeface="Courier New"/>
+              </a:rPr>
+              <a:t>plc.Write('HMI_P601.Auto',  False);  plc.Write('HMI_P601.Cmd',  1)</a:t>
+            </a:r>
+          </a:p>
+        </p:txBody>
+      </p:sp>
+      <p:sp>
+        <p:nvSpPr>
+          <p:cNvPr id="30" name="Rectangle 29"/>
+          <p:cNvSpPr/>
+          <p:nvPr/>
+        </p:nvSpPr>
+        <p:spPr>
+          <a:xfrm>
+            <a:off x="7543800" y="1325880"/>
+            <a:ext cx="4325112" cy="1481328"/>
+          </a:xfrm>
+          <a:prstGeom prst="rect">
+            <a:avLst/>
+          </a:prstGeom>
+          <a:solidFill>
+            <a:srgbClr val="E8243C"/>
+          </a:solidFill>
+          <a:ln>
+            <a:noFill/>
+          </a:ln>
+        </p:spPr>
+        <p:style>
+          <a:lnRef idx="1">
+            <a:schemeClr val="accent1"/>
+          </a:lnRef>
+          <a:fillRef idx="3">
+            <a:schemeClr val="accent1"/>
+          </a:fillRef>
+          <a:effectRef idx="2">
+            <a:schemeClr val="accent1"/>
+          </a:effectRef>
+          <a:fontRef idx="minor">
+            <a:schemeClr val="lt1"/>
+          </a:fontRef>
+        </p:style>
+        <p:txBody>
+          <a:bodyPr rtlCol="0" anchor="ctr"/>
+          <a:lstStyle/>
+          <a:p>
+            <a:pPr algn="ctr"/>
+          </a:p>
+        </p:txBody>
+      </p:sp>
+      <p:sp>
+        <p:nvSpPr>
+          <p:cNvPr id="31" name="TextBox 30"/>
+          <p:cNvSpPr txBox="1"/>
+          <p:nvPr/>
+        </p:nvSpPr>
+        <p:spPr>
+          <a:xfrm>
+            <a:off x="7662672" y="1417320"/>
+            <a:ext cx="4160520" cy="320040"/>
+          </a:xfrm>
+          <a:prstGeom prst="rect">
+            <a:avLst/>
+          </a:prstGeom>
+          <a:noFill/>
+        </p:spPr>
+        <p:txBody>
+          <a:bodyPr wrap="square">
+            <a:spAutoFit/>
+          </a:bodyPr>
+          <a:lstStyle/>
+          <a:p>
+            <a:pPr algn="l"/>
+            <a:r>
+              <a:rPr sz="1200" b="1" i="0">
+                <a:solidFill>
+                  <a:srgbClr val="FFFFFF"/>
+                </a:solidFill>
+                <a:latin typeface="Calibri"/>
+              </a:rPr>
+              <a:t>No exploits needed</a:t>
+            </a:r>
+          </a:p>
+        </p:txBody>
+      </p:sp>
+      <p:sp>
+        <p:nvSpPr>
+          <p:cNvPr id="32" name="TextBox 31"/>
+          <p:cNvSpPr txBox="1"/>
+          <p:nvPr/>
+        </p:nvSpPr>
+        <p:spPr>
+          <a:xfrm>
+            <a:off x="7662672" y="1783080"/>
+            <a:ext cx="4160520" cy="960120"/>
+          </a:xfrm>
+          <a:prstGeom prst="rect">
+            <a:avLst/>
+          </a:prstGeom>
+          <a:noFill/>
+        </p:spPr>
+        <p:txBody>
+          <a:bodyPr wrap="square">
+            <a:spAutoFit/>
+          </a:bodyPr>
+          <a:lstStyle/>
+          <a:p>
+            <a:pPr algn="l"/>
+            <a:r>
+              <a:rPr sz="1000" b="0" i="0">
+                <a:solidFill>
+                  <a:srgbClr val="FFFFFF"/>
+                </a:solidFill>
+                <a:latin typeface="Calibri"/>
+              </a:rPr>
+              <a:t>Standard pylogix writes — same tool operators use daily</a:t>
+            </a:r>
+          </a:p>
+        </p:txBody>
+      </p:sp>
+      <p:sp>
+        <p:nvSpPr>
+          <p:cNvPr id="33" name="Rectangle 32"/>
+          <p:cNvSpPr/>
+          <p:nvPr/>
+        </p:nvSpPr>
+        <p:spPr>
+          <a:xfrm>
+            <a:off x="7543800" y="2907791"/>
+            <a:ext cx="4325112" cy="1481328"/>
+          </a:xfrm>
+          <a:prstGeom prst="rect">
+            <a:avLst/>
+          </a:prstGeom>
+          <a:solidFill>
+            <a:srgbClr val="1565C0"/>
+          </a:solidFill>
+          <a:ln>
+            <a:noFill/>
+          </a:ln>
+        </p:spPr>
+        <p:style>
+          <a:lnRef idx="1">
+            <a:schemeClr val="accent1"/>
+          </a:lnRef>
+          <a:fillRef idx="3">
+            <a:schemeClr val="accent1"/>
+          </a:fillRef>
+          <a:effectRef idx="2">
+            <a:schemeClr val="accent1"/>
+          </a:effectRef>
+          <a:fontRef idx="minor">
+            <a:schemeClr val="lt1"/>
+          </a:fontRef>
+        </p:style>
+        <p:txBody>
+          <a:bodyPr rtlCol="0" anchor="ctr"/>
+          <a:lstStyle/>
+          <a:p>
+            <a:pPr algn="ctr"/>
+          </a:p>
+        </p:txBody>
+      </p:sp>
+      <p:sp>
+        <p:nvSpPr>
+          <p:cNvPr id="34" name="TextBox 33"/>
+          <p:cNvSpPr txBox="1"/>
+          <p:nvPr/>
+        </p:nvSpPr>
+        <p:spPr>
+          <a:xfrm>
+            <a:off x="7662672" y="2999232"/>
+            <a:ext cx="4160520" cy="320040"/>
+          </a:xfrm>
+          <a:prstGeom prst="rect">
+            <a:avLst/>
+          </a:prstGeom>
+          <a:noFill/>
+        </p:spPr>
+        <p:txBody>
+          <a:bodyPr wrap="square">
+            <a:spAutoFit/>
+          </a:bodyPr>
+          <a:lstStyle/>
+          <a:p>
+            <a:pPr algn="l"/>
+            <a:r>
+              <a:rPr sz="1200" b="1" i="0">
+                <a:solidFill>
+                  <a:srgbClr val="FFFFFF"/>
+                </a:solidFill>
+                <a:latin typeface="Calibri"/>
+              </a:rPr>
+              <a:t>All 6 PLCs exposed</a:t>
+            </a:r>
+          </a:p>
+        </p:txBody>
+      </p:sp>
+      <p:sp>
+        <p:nvSpPr>
+          <p:cNvPr id="35" name="TextBox 34"/>
+          <p:cNvSpPr txBox="1"/>
+          <p:nvPr/>
+        </p:nvSpPr>
+        <p:spPr>
+          <a:xfrm>
+            <a:off x="7662672" y="3364991"/>
+            <a:ext cx="4160520" cy="960120"/>
+          </a:xfrm>
+          <a:prstGeom prst="rect">
+            <a:avLst/>
+          </a:prstGeom>
+          <a:noFill/>
+        </p:spPr>
+        <p:txBody>
+          <a:bodyPr wrap="square">
+            <a:spAutoFit/>
+          </a:bodyPr>
+          <a:lstStyle/>
+          <a:p>
+            <a:pPr algn="l"/>
+            <a:r>
+              <a:rPr sz="1000" b="0" i="0">
+                <a:solidFill>
+                  <a:srgbClr val="FFFFFF"/>
+                </a:solidFill>
+                <a:latin typeface="Calibri"/>
+              </a:rPr>
+              <a:t>HMI has pre-existing trusted EtherNet/IP access to all PLCs simultaneously — no pivot needed</a:t>
+            </a:r>
+          </a:p>
+        </p:txBody>
+      </p:sp>
+      <p:sp>
+        <p:nvSpPr>
+          <p:cNvPr id="36" name="Rectangle 35"/>
+          <p:cNvSpPr/>
+          <p:nvPr/>
+        </p:nvSpPr>
+        <p:spPr>
+          <a:xfrm>
+            <a:off x="7543800" y="4489704"/>
+            <a:ext cx="4325112" cy="1481328"/>
+          </a:xfrm>
+          <a:prstGeom prst="rect">
+            <a:avLst/>
+          </a:prstGeom>
+          <a:solidFill>
+            <a:srgbClr val="2E7D32"/>
+          </a:solidFill>
+          <a:ln>
+            <a:noFill/>
+          </a:ln>
+        </p:spPr>
+        <p:style>
+          <a:lnRef idx="1">
+            <a:schemeClr val="accent1"/>
+          </a:lnRef>
+          <a:fillRef idx="3">
+            <a:schemeClr val="accent1"/>
+          </a:fillRef>
+          <a:effectRef idx="2">
+            <a:schemeClr val="accent1"/>
+          </a:effectRef>
+          <a:fontRef idx="minor">
+            <a:schemeClr val="lt1"/>
+          </a:fontRef>
+        </p:style>
+        <p:txBody>
+          <a:bodyPr rtlCol="0" anchor="ctr"/>
+          <a:lstStyle/>
+          <a:p>
+            <a:pPr algn="ctr"/>
+          </a:p>
+        </p:txBody>
+      </p:sp>
+      <p:sp>
+        <p:nvSpPr>
+          <p:cNvPr id="37" name="TextBox 36"/>
+          <p:cNvSpPr txBox="1"/>
+          <p:nvPr/>
+        </p:nvSpPr>
+        <p:spPr>
+          <a:xfrm>
+            <a:off x="7662672" y="4581144"/>
+            <a:ext cx="4160520" cy="320040"/>
+          </a:xfrm>
+          <a:prstGeom prst="rect">
+            <a:avLst/>
+          </a:prstGeom>
+          <a:noFill/>
+        </p:spPr>
+        <p:txBody>
+          <a:bodyPr wrap="square">
+            <a:spAutoFit/>
+          </a:bodyPr>
+          <a:lstStyle/>
+          <a:p>
+            <a:pPr algn="l"/>
+            <a:r>
+              <a:rPr sz="1200" b="1" i="0">
+                <a:solidFill>
+                  <a:srgbClr val="FFFFFF"/>
+                </a:solidFill>
+                <a:latin typeface="Calibri"/>
+              </a:rPr>
+              <a:t>Sensor spoofing scales</a:t>
+            </a:r>
+          </a:p>
+        </p:txBody>
+      </p:sp>
+      <p:sp>
+        <p:nvSpPr>
+          <p:cNvPr id="38" name="TextBox 37"/>
+          <p:cNvSpPr txBox="1"/>
+          <p:nvPr/>
+        </p:nvSpPr>
+        <p:spPr>
+          <a:xfrm>
+            <a:off x="7662672" y="4946904"/>
+            <a:ext cx="4160520" cy="960120"/>
+          </a:xfrm>
+          <a:prstGeom prst="rect">
+            <a:avLst/>
+          </a:prstGeom>
+          <a:noFill/>
+        </p:spPr>
+        <p:txBody>
+          <a:bodyPr wrap="square">
+            <a:spAutoFit/>
+          </a:bodyPr>
+          <a:lstStyle/>
+          <a:p>
+            <a:pPr algn="l"/>
+            <a:r>
+              <a:rPr sz="1000" b="0" i="0">
+                <a:solidFill>
+                  <a:srgbClr val="FFFFFF"/>
+                </a:solidFill>
+                <a:latin typeface="Calibri"/>
+              </a:rPr>
+              <a:t>Every stage has .Sim and .Sim_PV tags — adversarial model can spoof all 6 stages simultaneously</a:t>
+            </a:r>
+          </a:p>
+        </p:txBody>
+      </p:sp>
+    </p:spTree>
+  </p:cSld>
+  <p:clrMapOvr>
+    <a:masterClrMapping/>
+  </p:clrMapOvr>
+</p:sld>
+</file>
+
+<file path=ppt/slides/slide44.xml><?xml version="1.0" encoding="utf-8"?>
+<p:sld xmlns:a="http://schemas.openxmlformats.org/drawingml/2006/main" xmlns:p="http://schemas.openxmlformats.org/presentationml/2006/main" xmlns:r="http://schemas.openxmlformats.org/officeDocument/2006/relationships">
+  <p:cSld>
+    <p:spTree>
+      <p:nvGrpSpPr>
+        <p:cNvPr id="1" name=""/>
+        <p:cNvGrpSpPr/>
+        <p:nvPr/>
+      </p:nvGrpSpPr>
+      <p:grpSpPr/>
+      <p:sp>
+        <p:nvSpPr>
+          <p:cNvPr id="2" name="Rectangle 1"/>
+          <p:cNvSpPr/>
+          <p:nvPr/>
+        </p:nvSpPr>
+        <p:spPr>
+          <a:xfrm>
+            <a:off x="0" y="0"/>
+            <a:ext cx="12188952" cy="6858000"/>
+          </a:xfrm>
+          <a:prstGeom prst="rect">
+            <a:avLst/>
+          </a:prstGeom>
+          <a:solidFill>
+            <a:srgbClr val="FFFFFF"/>
+          </a:solidFill>
+          <a:ln>
+            <a:noFill/>
+          </a:ln>
+        </p:spPr>
+        <p:style>
+          <a:lnRef idx="1">
+            <a:schemeClr val="accent1"/>
+          </a:lnRef>
+          <a:fillRef idx="3">
+            <a:schemeClr val="accent1"/>
+          </a:fillRef>
+          <a:effectRef idx="2">
+            <a:schemeClr val="accent1"/>
+          </a:effectRef>
+          <a:fontRef idx="minor">
+            <a:schemeClr val="lt1"/>
+          </a:fontRef>
+        </p:style>
+        <p:txBody>
+          <a:bodyPr rtlCol="0" anchor="ctr"/>
+          <a:lstStyle/>
+          <a:p>
+            <a:pPr algn="ctr"/>
+          </a:p>
+        </p:txBody>
+      </p:sp>
+      <p:sp>
+        <p:nvSpPr>
+          <p:cNvPr id="3" name="Rectangle 2"/>
+          <p:cNvSpPr/>
+          <p:nvPr/>
+        </p:nvSpPr>
+        <p:spPr>
+          <a:xfrm>
+            <a:off x="0" y="0"/>
+            <a:ext cx="12188952" cy="64008"/>
+          </a:xfrm>
+          <a:prstGeom prst="rect">
+            <a:avLst/>
+          </a:prstGeom>
+          <a:solidFill>
+            <a:srgbClr val="E8243C"/>
+          </a:solidFill>
+          <a:ln>
+            <a:noFill/>
+          </a:ln>
+        </p:spPr>
+        <p:style>
+          <a:lnRef idx="1">
+            <a:schemeClr val="accent1"/>
+          </a:lnRef>
+          <a:fillRef idx="3">
+            <a:schemeClr val="accent1"/>
+          </a:fillRef>
+          <a:effectRef idx="2">
+            <a:schemeClr val="accent1"/>
+          </a:effectRef>
+          <a:fontRef idx="minor">
+            <a:schemeClr val="lt1"/>
+          </a:fontRef>
+        </p:style>
+        <p:txBody>
+          <a:bodyPr rtlCol="0" anchor="ctr"/>
+          <a:lstStyle/>
+          <a:p>
+            <a:pPr algn="ctr"/>
+          </a:p>
+        </p:txBody>
+      </p:sp>
+      <p:sp>
+        <p:nvSpPr>
+          <p:cNvPr id="4" name="Rectangle 3"/>
+          <p:cNvSpPr/>
+          <p:nvPr/>
+        </p:nvSpPr>
+        <p:spPr>
+          <a:xfrm>
+            <a:off x="0" y="6510528"/>
+            <a:ext cx="12188952" cy="347472"/>
+          </a:xfrm>
+          <a:prstGeom prst="rect">
+            <a:avLst/>
+          </a:prstGeom>
+          <a:solidFill>
+            <a:srgbClr val="F5F5F5"/>
+          </a:solidFill>
+          <a:ln>
+            <a:noFill/>
+          </a:ln>
+        </p:spPr>
+        <p:style>
+          <a:lnRef idx="1">
+            <a:schemeClr val="accent1"/>
+          </a:lnRef>
+          <a:fillRef idx="3">
+            <a:schemeClr val="accent1"/>
+          </a:fillRef>
+          <a:effectRef idx="2">
+            <a:schemeClr val="accent1"/>
+          </a:effectRef>
+          <a:fontRef idx="minor">
+            <a:schemeClr val="lt1"/>
+          </a:fontRef>
+        </p:style>
+        <p:txBody>
+          <a:bodyPr rtlCol="0" anchor="ctr"/>
+          <a:lstStyle/>
+          <a:p>
+            <a:pPr algn="ctr"/>
+          </a:p>
+        </p:txBody>
+      </p:sp>
+      <p:sp>
+        <p:nvSpPr>
+          <p:cNvPr id="5" name="TextBox 4"/>
+          <p:cNvSpPr txBox="1"/>
+          <p:nvPr/>
+        </p:nvSpPr>
+        <p:spPr>
+          <a:xfrm>
+            <a:off x="274320" y="6565392"/>
+            <a:ext cx="11640312" cy="219456"/>
+          </a:xfrm>
+          <a:prstGeom prst="rect">
+            <a:avLst/>
+          </a:prstGeom>
+          <a:noFill/>
+        </p:spPr>
+        <p:txBody>
+          <a:bodyPr wrap="square">
+            <a:spAutoFit/>
+          </a:bodyPr>
+          <a:lstStyle/>
+          <a:p>
+            <a:pPr algn="l"/>
+            <a:r>
+              <a:rPr sz="800" b="0" i="0">
+                <a:solidFill>
+                  <a:srgbClr val="6B6B6B"/>
+                </a:solidFill>
+                <a:latin typeface="Calibri"/>
+              </a:rPr>
+              <a:t>51.508 Secure CPS  ·  SWaT Project  ·  iTrust Lab, SUTD</a:t>
+            </a:r>
+          </a:p>
+        </p:txBody>
+      </p:sp>
+      <p:sp>
+        <p:nvSpPr>
+          <p:cNvPr id="6" name="Rectangle 5"/>
+          <p:cNvSpPr/>
+          <p:nvPr/>
+        </p:nvSpPr>
+        <p:spPr>
+          <a:xfrm>
+            <a:off x="320040" y="109728"/>
+            <a:ext cx="1737360" cy="292608"/>
+          </a:xfrm>
+          <a:prstGeom prst="rect">
+            <a:avLst/>
+          </a:prstGeom>
+          <a:solidFill>
+            <a:srgbClr val="E8243C"/>
+          </a:solidFill>
+          <a:ln>
+            <a:noFill/>
+          </a:ln>
+        </p:spPr>
+        <p:style>
+          <a:lnRef idx="1">
+            <a:schemeClr val="accent1"/>
+          </a:lnRef>
+          <a:fillRef idx="3">
+            <a:schemeClr val="accent1"/>
+          </a:fillRef>
+          <a:effectRef idx="2">
+            <a:schemeClr val="accent1"/>
+          </a:effectRef>
+          <a:fontRef idx="minor">
+            <a:schemeClr val="lt1"/>
+          </a:fontRef>
+        </p:style>
+        <p:txBody>
+          <a:bodyPr rtlCol="0" anchor="ctr"/>
+          <a:lstStyle/>
+          <a:p>
+            <a:pPr algn="ctr"/>
+          </a:p>
+        </p:txBody>
+      </p:sp>
+      <p:sp>
+        <p:nvSpPr>
+          <p:cNvPr id="7" name="TextBox 6"/>
+          <p:cNvSpPr txBox="1"/>
+          <p:nvPr/>
+        </p:nvSpPr>
+        <p:spPr>
+          <a:xfrm>
+            <a:off x="320040" y="109728"/>
+            <a:ext cx="1737360" cy="292608"/>
+          </a:xfrm>
+          <a:prstGeom prst="rect">
+            <a:avLst/>
+          </a:prstGeom>
+          <a:noFill/>
+        </p:spPr>
+        <p:txBody>
+          <a:bodyPr wrap="square">
+            <a:spAutoFit/>
+          </a:bodyPr>
+          <a:lstStyle/>
+          <a:p>
+            <a:pPr algn="ctr"/>
+            <a:r>
+              <a:rPr sz="1000" b="1" i="0">
+                <a:solidFill>
+                  <a:srgbClr val="FFFFFF"/>
+                </a:solidFill>
+                <a:latin typeface="Calibri"/>
+              </a:rPr>
+              <a:t>BROADER IMPACT</a:t>
+            </a:r>
+          </a:p>
+        </p:txBody>
+      </p:sp>
+      <p:sp>
+        <p:nvSpPr>
+          <p:cNvPr id="8" name="TextBox 7"/>
+          <p:cNvSpPr txBox="1"/>
+          <p:nvPr/>
+        </p:nvSpPr>
+        <p:spPr>
+          <a:xfrm>
+            <a:off x="320040" y="457200"/>
+            <a:ext cx="11548872" cy="566928"/>
+          </a:xfrm>
+          <a:prstGeom prst="rect">
+            <a:avLst/>
+          </a:prstGeom>
+          <a:noFill/>
+        </p:spPr>
+        <p:txBody>
+          <a:bodyPr wrap="square">
+            <a:spAutoFit/>
+          </a:bodyPr>
+          <a:lstStyle/>
+          <a:p>
+            <a:pPr algn="l"/>
+            <a:r>
+              <a:rPr sz="3000" b="1" i="0">
+                <a:solidFill>
+                  <a:srgbClr val="1A1A1A"/>
+                </a:solidFill>
+                <a:latin typeface="Calibri Light"/>
+              </a:rPr>
+              <a:t>This Is Not Hypothetical</a:t>
+            </a:r>
+          </a:p>
+        </p:txBody>
+      </p:sp>
+      <p:sp>
+        <p:nvSpPr>
+          <p:cNvPr id="9" name="TextBox 8"/>
+          <p:cNvSpPr txBox="1"/>
+          <p:nvPr/>
+        </p:nvSpPr>
+        <p:spPr>
+          <a:xfrm>
+            <a:off x="320040" y="1005840"/>
+            <a:ext cx="11548872" cy="237744"/>
+          </a:xfrm>
+          <a:prstGeom prst="rect">
+            <a:avLst/>
+          </a:prstGeom>
+          <a:noFill/>
+        </p:spPr>
+        <p:txBody>
+          <a:bodyPr wrap="square">
+            <a:spAutoFit/>
+          </a:bodyPr>
+          <a:lstStyle/>
+          <a:p>
+            <a:pPr algn="l"/>
+            <a:r>
+              <a:rPr sz="1150" b="0" i="1">
+                <a:solidFill>
+                  <a:srgbClr val="6B6B6B"/>
+                </a:solidFill>
+                <a:latin typeface="Calibri"/>
+              </a:rPr>
+              <a:t>The same attack pattern has been used against real water infrastructure</a:t>
+            </a:r>
+          </a:p>
+        </p:txBody>
+      </p:sp>
+      <p:sp>
+        <p:nvSpPr>
+          <p:cNvPr id="10" name="Rectangle 9"/>
+          <p:cNvSpPr/>
+          <p:nvPr/>
+        </p:nvSpPr>
+        <p:spPr>
+          <a:xfrm>
+            <a:off x="320040" y="1325880"/>
+            <a:ext cx="11548872" cy="1481328"/>
+          </a:xfrm>
+          <a:prstGeom prst="rect">
+            <a:avLst/>
+          </a:prstGeom>
+          <a:solidFill>
+            <a:srgbClr val="1565C0"/>
+          </a:solidFill>
+          <a:ln>
+            <a:noFill/>
+          </a:ln>
+        </p:spPr>
+        <p:style>
+          <a:lnRef idx="1">
+            <a:schemeClr val="accent1"/>
+          </a:lnRef>
+          <a:fillRef idx="3">
+            <a:schemeClr val="accent1"/>
+          </a:fillRef>
+          <a:effectRef idx="2">
+            <a:schemeClr val="accent1"/>
+          </a:effectRef>
+          <a:fontRef idx="minor">
+            <a:schemeClr val="lt1"/>
+          </a:fontRef>
+        </p:style>
+        <p:txBody>
+          <a:bodyPr rtlCol="0" anchor="ctr"/>
+          <a:lstStyle/>
+          <a:p>
+            <a:pPr algn="ctr"/>
+          </a:p>
+        </p:txBody>
+      </p:sp>
+      <p:sp>
+        <p:nvSpPr>
+          <p:cNvPr id="11" name="TextBox 10"/>
+          <p:cNvSpPr txBox="1"/>
+          <p:nvPr/>
+        </p:nvSpPr>
+        <p:spPr>
+          <a:xfrm>
+            <a:off x="457200" y="1399032"/>
+            <a:ext cx="11274552" cy="274320"/>
+          </a:xfrm>
+          <a:prstGeom prst="rect">
+            <a:avLst/>
+          </a:prstGeom>
+          <a:noFill/>
+        </p:spPr>
+        <p:txBody>
+          <a:bodyPr wrap="square">
+            <a:spAutoFit/>
+          </a:bodyPr>
+          <a:lstStyle/>
+          <a:p>
+            <a:pPr algn="l"/>
+            <a:r>
+              <a:rPr sz="1200" b="1" i="0">
+                <a:solidFill>
+                  <a:srgbClr val="FFFFFF"/>
+                </a:solidFill>
+                <a:latin typeface="Calibri"/>
+              </a:rPr>
+              <a:t>💧  Oldsmar, Florida — Feb 2021</a:t>
+            </a:r>
+          </a:p>
+        </p:txBody>
+      </p:sp>
+      <p:sp>
+        <p:nvSpPr>
+          <p:cNvPr id="12" name="TextBox 11"/>
+          <p:cNvSpPr txBox="1"/>
+          <p:nvPr/>
+        </p:nvSpPr>
+        <p:spPr>
+          <a:xfrm>
+            <a:off x="457200" y="1709928"/>
+            <a:ext cx="5394960" cy="822960"/>
+          </a:xfrm>
+          <a:prstGeom prst="rect">
+            <a:avLst/>
+          </a:prstGeom>
+          <a:noFill/>
+        </p:spPr>
+        <p:txBody>
+          <a:bodyPr wrap="square">
+            <a:spAutoFit/>
+          </a:bodyPr>
+          <a:lstStyle/>
+          <a:p>
+            <a:pPr algn="l"/>
+            <a:r>
+              <a:rPr sz="950" b="0" i="0">
+                <a:solidFill>
+                  <a:srgbClr val="FFFFFF"/>
+                </a:solidFill>
+                <a:latin typeface="Calibri"/>
+              </a:rPr>
+              <a:t>Attack: Attacker modified NaOH setpoint to 111× normal via TeamViewer remote access. Single actuator write — identical to our Phase 1 pattern.</a:t>
+            </a:r>
+          </a:p>
+        </p:txBody>
+      </p:sp>
+      <p:sp>
+        <p:nvSpPr>
+          <p:cNvPr id="13" name="TextBox 12"/>
+          <p:cNvSpPr txBox="1"/>
+          <p:nvPr/>
+        </p:nvSpPr>
+        <p:spPr>
+          <a:xfrm>
+            <a:off x="6035040" y="1709928"/>
+            <a:ext cx="5833872" cy="822960"/>
+          </a:xfrm>
+          <a:prstGeom prst="rect">
+            <a:avLst/>
+          </a:prstGeom>
+          <a:noFill/>
+        </p:spPr>
+        <p:txBody>
+          <a:bodyPr wrap="square">
+            <a:spAutoFit/>
+          </a:bodyPr>
+          <a:lstStyle/>
+          <a:p>
+            <a:pPr algn="l"/>
+            <a:r>
+              <a:rPr sz="950" b="0" i="1">
+                <a:solidFill>
+                  <a:srgbClr val="FFFFFF"/>
+                </a:solidFill>
+                <a:latin typeface="Calibri"/>
+              </a:rPr>
+              <a:t>Lesson: An invariant checker would have fired immediately. Chemical concentration setpoint is a process invariant. Reliance on human observation alone is insufficient.</a:t>
+            </a:r>
+          </a:p>
+        </p:txBody>
+      </p:sp>
+      <p:sp>
+        <p:nvSpPr>
+          <p:cNvPr id="14" name="Rectangle 13"/>
+          <p:cNvSpPr/>
+          <p:nvPr/>
+        </p:nvSpPr>
+        <p:spPr>
+          <a:xfrm>
+            <a:off x="320040" y="2898648"/>
+            <a:ext cx="11548872" cy="1481328"/>
+          </a:xfrm>
+          <a:prstGeom prst="rect">
+            <a:avLst/>
+          </a:prstGeom>
+          <a:solidFill>
+            <a:srgbClr val="E65100"/>
+          </a:solidFill>
+          <a:ln>
+            <a:noFill/>
+          </a:ln>
+        </p:spPr>
+        <p:style>
+          <a:lnRef idx="1">
+            <a:schemeClr val="accent1"/>
+          </a:lnRef>
+          <a:fillRef idx="3">
+            <a:schemeClr val="accent1"/>
+          </a:fillRef>
+          <a:effectRef idx="2">
+            <a:schemeClr val="accent1"/>
+          </a:effectRef>
+          <a:fontRef idx="minor">
+            <a:schemeClr val="lt1"/>
+          </a:fontRef>
+        </p:style>
+        <p:txBody>
+          <a:bodyPr rtlCol="0" anchor="ctr"/>
+          <a:lstStyle/>
+          <a:p>
+            <a:pPr algn="ctr"/>
+          </a:p>
+        </p:txBody>
+      </p:sp>
+      <p:sp>
+        <p:nvSpPr>
+          <p:cNvPr id="15" name="TextBox 14"/>
+          <p:cNvSpPr txBox="1"/>
+          <p:nvPr/>
+        </p:nvSpPr>
+        <p:spPr>
+          <a:xfrm>
+            <a:off x="457200" y="2971800"/>
+            <a:ext cx="11274552" cy="274320"/>
+          </a:xfrm>
+          <a:prstGeom prst="rect">
+            <a:avLst/>
+          </a:prstGeom>
+          <a:noFill/>
+        </p:spPr>
+        <p:txBody>
+          <a:bodyPr wrap="square">
+            <a:spAutoFit/>
+          </a:bodyPr>
+          <a:lstStyle/>
+          <a:p>
+            <a:pPr algn="l"/>
+            <a:r>
+              <a:rPr sz="1200" b="1" i="0">
+                <a:solidFill>
+                  <a:srgbClr val="FFFFFF"/>
+                </a:solidFill>
+                <a:latin typeface="Calibri"/>
+              </a:rPr>
+              <a:t>🏭  Texas Water Utilities — Apr 2024</a:t>
+            </a:r>
+          </a:p>
+        </p:txBody>
+      </p:sp>
+      <p:sp>
+        <p:nvSpPr>
+          <p:cNvPr id="16" name="TextBox 15"/>
+          <p:cNvSpPr txBox="1"/>
+          <p:nvPr/>
+        </p:nvSpPr>
+        <p:spPr>
+          <a:xfrm>
+            <a:off x="457200" y="3282696"/>
+            <a:ext cx="5394960" cy="822960"/>
+          </a:xfrm>
+          <a:prstGeom prst="rect">
+            <a:avLst/>
+          </a:prstGeom>
+          <a:noFill/>
+        </p:spPr>
+        <p:txBody>
+          <a:bodyPr wrap="square">
+            <a:spAutoFit/>
+          </a:bodyPr>
+          <a:lstStyle/>
+          <a:p>
+            <a:pPr algn="l"/>
+            <a:r>
+              <a:rPr sz="950" b="0" i="0">
+                <a:solidFill>
+                  <a:srgbClr val="FFFFFF"/>
+                </a:solidFill>
+                <a:latin typeface="Calibri"/>
+              </a:rPr>
+              <a:t>Attack: Russian-linked actors targeted Unitronics PLCs. One plant tank overflowed. Recovery took days — no automated safe-state, no hot-standby PLC.</a:t>
+            </a:r>
+          </a:p>
+        </p:txBody>
+      </p:sp>
+      <p:sp>
+        <p:nvSpPr>
+          <p:cNvPr id="17" name="TextBox 16"/>
+          <p:cNvSpPr txBox="1"/>
+          <p:nvPr/>
+        </p:nvSpPr>
+        <p:spPr>
+          <a:xfrm>
+            <a:off x="6035040" y="3282696"/>
+            <a:ext cx="5833872" cy="822960"/>
+          </a:xfrm>
+          <a:prstGeom prst="rect">
+            <a:avLst/>
+          </a:prstGeom>
+          <a:noFill/>
+        </p:spPr>
+        <p:txBody>
+          <a:bodyPr wrap="square">
+            <a:spAutoFit/>
+          </a:bodyPr>
+          <a:lstStyle/>
+          <a:p>
+            <a:pPr algn="l"/>
+            <a:r>
+              <a:rPr sz="950" b="0" i="1">
+                <a:solidFill>
+                  <a:srgbClr val="FFFFFF"/>
+                </a:solidFill>
+                <a:latin typeface="Calibri"/>
+              </a:rPr>
+              <a:t>Lesson: Multi-plant attack shows cascade at regional scale. Our &lt;15s recovery target vs days of manual restoration highlights the value of automated response.</a:t>
+            </a:r>
+          </a:p>
+        </p:txBody>
+      </p:sp>
+      <p:sp>
+        <p:nvSpPr>
+          <p:cNvPr id="18" name="Rectangle 17"/>
+          <p:cNvSpPr/>
+          <p:nvPr/>
+        </p:nvSpPr>
+        <p:spPr>
+          <a:xfrm>
+            <a:off x="320040" y="4471416"/>
+            <a:ext cx="11548872" cy="1481328"/>
+          </a:xfrm>
+          <a:prstGeom prst="rect">
+            <a:avLst/>
+          </a:prstGeom>
+          <a:solidFill>
+            <a:srgbClr val="2E7D32"/>
+          </a:solidFill>
+          <a:ln>
+            <a:noFill/>
+          </a:ln>
+        </p:spPr>
+        <p:style>
+          <a:lnRef idx="1">
+            <a:schemeClr val="accent1"/>
+          </a:lnRef>
+          <a:fillRef idx="3">
+            <a:schemeClr val="accent1"/>
+          </a:fillRef>
+          <a:effectRef idx="2">
+            <a:schemeClr val="accent1"/>
+          </a:effectRef>
+          <a:fontRef idx="minor">
+            <a:schemeClr val="lt1"/>
+          </a:fontRef>
+        </p:style>
+        <p:txBody>
+          <a:bodyPr rtlCol="0" anchor="ctr"/>
+          <a:lstStyle/>
+          <a:p>
+            <a:pPr algn="ctr"/>
+          </a:p>
+        </p:txBody>
+      </p:sp>
+      <p:sp>
+        <p:nvSpPr>
+          <p:cNvPr id="19" name="TextBox 18"/>
+          <p:cNvSpPr txBox="1"/>
+          <p:nvPr/>
+        </p:nvSpPr>
+        <p:spPr>
+          <a:xfrm>
+            <a:off x="457200" y="4544568"/>
+            <a:ext cx="11274552" cy="274320"/>
+          </a:xfrm>
+          <a:prstGeom prst="rect">
+            <a:avLst/>
+          </a:prstGeom>
+          <a:noFill/>
+        </p:spPr>
+        <p:txBody>
+          <a:bodyPr wrap="square">
+            <a:spAutoFit/>
+          </a:bodyPr>
+          <a:lstStyle/>
+          <a:p>
+            <a:pPr algn="l"/>
+            <a:r>
+              <a:rPr sz="1200" b="1" i="0">
+                <a:solidFill>
+                  <a:srgbClr val="FFFFFF"/>
+                </a:solidFill>
+                <a:latin typeface="Calibri"/>
+              </a:rPr>
+              <a:t>⚛️  Stuxnet — Natanz, Iran 2009–2010</a:t>
+            </a:r>
+          </a:p>
+        </p:txBody>
+      </p:sp>
+      <p:sp>
+        <p:nvSpPr>
+          <p:cNvPr id="20" name="TextBox 19"/>
+          <p:cNvSpPr txBox="1"/>
+          <p:nvPr/>
+        </p:nvSpPr>
+        <p:spPr>
+          <a:xfrm>
+            <a:off x="457200" y="4855464"/>
+            <a:ext cx="5394960" cy="822960"/>
+          </a:xfrm>
+          <a:prstGeom prst="rect">
+            <a:avLst/>
+          </a:prstGeom>
+          <a:noFill/>
+        </p:spPr>
+        <p:txBody>
+          <a:bodyPr wrap="square">
+            <a:spAutoFit/>
+          </a:bodyPr>
+          <a:lstStyle/>
+          <a:p>
+            <a:pPr algn="l"/>
+            <a:r>
+              <a:rPr sz="950" b="0" i="0">
+                <a:solidFill>
+                  <a:srgbClr val="FFFFFF"/>
+                </a:solidFill>
+                <a:latin typeface="Calibri"/>
+              </a:rPr>
+              <a:t>Attack: Centrifuge speed manipulation combined with sensor concealment to operators — Paper #9 + #31 attack pattern in practice, deployed against real infrastructure.</a:t>
+            </a:r>
+          </a:p>
+        </p:txBody>
+      </p:sp>
+      <p:sp>
+        <p:nvSpPr>
+          <p:cNvPr id="21" name="TextBox 20"/>
+          <p:cNvSpPr txBox="1"/>
+          <p:nvPr/>
+        </p:nvSpPr>
+        <p:spPr>
+          <a:xfrm>
+            <a:off x="6035040" y="4855464"/>
+            <a:ext cx="5833872" cy="822960"/>
+          </a:xfrm>
+          <a:prstGeom prst="rect">
+            <a:avLst/>
+          </a:prstGeom>
+          <a:noFill/>
+        </p:spPr>
+        <p:txBody>
+          <a:bodyPr wrap="square">
+            <a:spAutoFit/>
+          </a:bodyPr>
+          <a:lstStyle/>
+          <a:p>
+            <a:pPr algn="l"/>
+            <a:r>
+              <a:rPr sz="950" b="0" i="1">
+                <a:solidFill>
+                  <a:srgbClr val="FFFFFF"/>
+                </a:solidFill>
+                <a:latin typeface="Calibri"/>
+              </a:rPr>
+              <a:t>Lesson: I-9 equivalent would have caught centrifuge speed vs motor command mismatch in &lt;3 cycles. Operators unaware for months — automated physics-based detection is essential.</a:t>
+            </a:r>
+          </a:p>
+        </p:txBody>
+      </p:sp>
+    </p:spTree>
+  </p:cSld>
+  <p:clrMapOvr>
+    <a:masterClrMapping/>
+  </p:clrMapOvr>
+</p:sld>
+</file>
+
+<file path=ppt/slides/slide45.xml><?xml version="1.0" encoding="utf-8"?>
+<p:sld xmlns:a="http://schemas.openxmlformats.org/drawingml/2006/main" xmlns:p="http://schemas.openxmlformats.org/presentationml/2006/main" xmlns:r="http://schemas.openxmlformats.org/officeDocument/2006/relationships">
+  <p:cSld>
+    <p:spTree>
+      <p:nvGrpSpPr>
+        <p:cNvPr id="1" name=""/>
+        <p:cNvGrpSpPr/>
+        <p:nvPr/>
+      </p:nvGrpSpPr>
+      <p:grpSpPr/>
+      <p:sp>
+        <p:nvSpPr>
+          <p:cNvPr id="2" name="Rectangle 1"/>
+          <p:cNvSpPr/>
+          <p:nvPr/>
+        </p:nvSpPr>
+        <p:spPr>
+          <a:xfrm>
+            <a:off x="0" y="0"/>
+            <a:ext cx="12188952" cy="6858000"/>
+          </a:xfrm>
+          <a:prstGeom prst="rect">
+            <a:avLst/>
+          </a:prstGeom>
+          <a:solidFill>
+            <a:srgbClr val="FFFFFF"/>
+          </a:solidFill>
+          <a:ln>
+            <a:noFill/>
+          </a:ln>
+        </p:spPr>
+        <p:style>
+          <a:lnRef idx="1">
+            <a:schemeClr val="accent1"/>
+          </a:lnRef>
+          <a:fillRef idx="3">
+            <a:schemeClr val="accent1"/>
+          </a:fillRef>
+          <a:effectRef idx="2">
+            <a:schemeClr val="accent1"/>
+          </a:effectRef>
+          <a:fontRef idx="minor">
+            <a:schemeClr val="lt1"/>
+          </a:fontRef>
+        </p:style>
+        <p:txBody>
+          <a:bodyPr rtlCol="0" anchor="ctr"/>
+          <a:lstStyle/>
+          <a:p>
+            <a:pPr algn="ctr"/>
+          </a:p>
+        </p:txBody>
+      </p:sp>
+      <p:sp>
+        <p:nvSpPr>
+          <p:cNvPr id="3" name="Rectangle 2"/>
+          <p:cNvSpPr/>
+          <p:nvPr/>
+        </p:nvSpPr>
+        <p:spPr>
+          <a:xfrm>
+            <a:off x="0" y="0"/>
+            <a:ext cx="12188952" cy="64008"/>
+          </a:xfrm>
+          <a:prstGeom prst="rect">
+            <a:avLst/>
+          </a:prstGeom>
+          <a:solidFill>
+            <a:srgbClr val="E8243C"/>
+          </a:solidFill>
+          <a:ln>
+            <a:noFill/>
+          </a:ln>
+        </p:spPr>
+        <p:style>
+          <a:lnRef idx="1">
+            <a:schemeClr val="accent1"/>
+          </a:lnRef>
+          <a:fillRef idx="3">
+            <a:schemeClr val="accent1"/>
+          </a:fillRef>
+          <a:effectRef idx="2">
+            <a:schemeClr val="accent1"/>
+          </a:effectRef>
+          <a:fontRef idx="minor">
+            <a:schemeClr val="lt1"/>
+          </a:fontRef>
+        </p:style>
+        <p:txBody>
+          <a:bodyPr rtlCol="0" anchor="ctr"/>
+          <a:lstStyle/>
+          <a:p>
+            <a:pPr algn="ctr"/>
+          </a:p>
+        </p:txBody>
+      </p:sp>
+      <p:sp>
+        <p:nvSpPr>
+          <p:cNvPr id="4" name="Rectangle 3"/>
+          <p:cNvSpPr/>
+          <p:nvPr/>
+        </p:nvSpPr>
+        <p:spPr>
+          <a:xfrm>
+            <a:off x="0" y="6510528"/>
+            <a:ext cx="12188952" cy="347472"/>
+          </a:xfrm>
+          <a:prstGeom prst="rect">
+            <a:avLst/>
+          </a:prstGeom>
+          <a:solidFill>
+            <a:srgbClr val="F5F5F5"/>
+          </a:solidFill>
+          <a:ln>
+            <a:noFill/>
+          </a:ln>
+        </p:spPr>
+        <p:style>
+          <a:lnRef idx="1">
+            <a:schemeClr val="accent1"/>
+          </a:lnRef>
+          <a:fillRef idx="3">
+            <a:schemeClr val="accent1"/>
+          </a:fillRef>
+          <a:effectRef idx="2">
+            <a:schemeClr val="accent1"/>
+          </a:effectRef>
+          <a:fontRef idx="minor">
+            <a:schemeClr val="lt1"/>
+          </a:fontRef>
+        </p:style>
+        <p:txBody>
+          <a:bodyPr rtlCol="0" anchor="ctr"/>
+          <a:lstStyle/>
+          <a:p>
+            <a:pPr algn="ctr"/>
+          </a:p>
+        </p:txBody>
+      </p:sp>
+      <p:sp>
+        <p:nvSpPr>
+          <p:cNvPr id="5" name="TextBox 4"/>
+          <p:cNvSpPr txBox="1"/>
+          <p:nvPr/>
+        </p:nvSpPr>
+        <p:spPr>
+          <a:xfrm>
+            <a:off x="274320" y="6565392"/>
+            <a:ext cx="11640312" cy="219456"/>
+          </a:xfrm>
+          <a:prstGeom prst="rect">
+            <a:avLst/>
+          </a:prstGeom>
+          <a:noFill/>
+        </p:spPr>
+        <p:txBody>
+          <a:bodyPr wrap="square">
+            <a:spAutoFit/>
+          </a:bodyPr>
+          <a:lstStyle/>
+          <a:p>
+            <a:pPr algn="l"/>
+            <a:r>
+              <a:rPr sz="800" b="0" i="0">
+                <a:solidFill>
+                  <a:srgbClr val="6B6B6B"/>
+                </a:solidFill>
+                <a:latin typeface="Calibri"/>
+              </a:rPr>
+              <a:t>51.508 Secure CPS  ·  SWaT Project  ·  iTrust Lab, SUTD</a:t>
+            </a:r>
+          </a:p>
+        </p:txBody>
+      </p:sp>
+      <p:sp>
+        <p:nvSpPr>
+          <p:cNvPr id="6" name="Rectangle 5"/>
+          <p:cNvSpPr/>
+          <p:nvPr/>
+        </p:nvSpPr>
+        <p:spPr>
+          <a:xfrm>
+            <a:off x="320040" y="109728"/>
+            <a:ext cx="1737360" cy="292608"/>
+          </a:xfrm>
+          <a:prstGeom prst="rect">
+            <a:avLst/>
+          </a:prstGeom>
+          <a:solidFill>
+            <a:srgbClr val="E8243C"/>
+          </a:solidFill>
+          <a:ln>
+            <a:noFill/>
+          </a:ln>
+        </p:spPr>
+        <p:style>
+          <a:lnRef idx="1">
+            <a:schemeClr val="accent1"/>
+          </a:lnRef>
+          <a:fillRef idx="3">
+            <a:schemeClr val="accent1"/>
+          </a:fillRef>
+          <a:effectRef idx="2">
+            <a:schemeClr val="accent1"/>
+          </a:effectRef>
+          <a:fontRef idx="minor">
+            <a:schemeClr val="lt1"/>
+          </a:fontRef>
+        </p:style>
+        <p:txBody>
+          <a:bodyPr rtlCol="0" anchor="ctr"/>
+          <a:lstStyle/>
+          <a:p>
+            <a:pPr algn="ctr"/>
+          </a:p>
+        </p:txBody>
+      </p:sp>
+      <p:sp>
+        <p:nvSpPr>
+          <p:cNvPr id="7" name="TextBox 6"/>
+          <p:cNvSpPr txBox="1"/>
+          <p:nvPr/>
+        </p:nvSpPr>
+        <p:spPr>
+          <a:xfrm>
+            <a:off x="320040" y="109728"/>
+            <a:ext cx="1737360" cy="292608"/>
+          </a:xfrm>
+          <a:prstGeom prst="rect">
+            <a:avLst/>
+          </a:prstGeom>
+          <a:noFill/>
+        </p:spPr>
+        <p:txBody>
+          <a:bodyPr wrap="square">
+            <a:spAutoFit/>
+          </a:bodyPr>
+          <a:lstStyle/>
+          <a:p>
+            <a:pPr algn="ctr"/>
+            <a:r>
+              <a:rPr sz="1000" b="1" i="0">
+                <a:solidFill>
+                  <a:srgbClr val="FFFFFF"/>
+                </a:solidFill>
+                <a:latin typeface="Calibri"/>
+              </a:rPr>
+              <a:t>BROADER IMPACT</a:t>
+            </a:r>
+          </a:p>
+        </p:txBody>
+      </p:sp>
+      <p:sp>
+        <p:nvSpPr>
+          <p:cNvPr id="8" name="TextBox 7"/>
+          <p:cNvSpPr txBox="1"/>
+          <p:nvPr/>
+        </p:nvSpPr>
+        <p:spPr>
+          <a:xfrm>
+            <a:off x="320040" y="457200"/>
+            <a:ext cx="11548872" cy="566928"/>
+          </a:xfrm>
+          <a:prstGeom prst="rect">
+            <a:avLst/>
+          </a:prstGeom>
+          <a:noFill/>
+        </p:spPr>
+        <p:txBody>
+          <a:bodyPr wrap="square">
+            <a:spAutoFit/>
+          </a:bodyPr>
+          <a:lstStyle/>
+          <a:p>
+            <a:pPr algn="l"/>
+            <a:r>
+              <a:rPr sz="2700" b="1" i="0">
+                <a:solidFill>
+                  <a:srgbClr val="1A1A1A"/>
+                </a:solidFill>
+                <a:latin typeface="Calibri Light"/>
+              </a:rPr>
+              <a:t>Why Stage 1 — and What Comes Next</a:t>
+            </a:r>
+          </a:p>
+        </p:txBody>
+      </p:sp>
+      <p:sp>
+        <p:nvSpPr>
+          <p:cNvPr id="9" name="TextBox 8"/>
+          <p:cNvSpPr txBox="1"/>
+          <p:nvPr/>
+        </p:nvSpPr>
+        <p:spPr>
+          <a:xfrm>
+            <a:off x="320040" y="1188720"/>
+            <a:ext cx="5577840" cy="292608"/>
+          </a:xfrm>
+          <a:prstGeom prst="rect">
+            <a:avLst/>
+          </a:prstGeom>
+          <a:noFill/>
+        </p:spPr>
+        <p:txBody>
+          <a:bodyPr wrap="square">
+            <a:spAutoFit/>
+          </a:bodyPr>
+          <a:lstStyle/>
+          <a:p>
+            <a:pPr algn="l"/>
+            <a:r>
+              <a:rPr sz="1300" b="1" i="0">
+                <a:solidFill>
+                  <a:srgbClr val="E8243C"/>
+                </a:solidFill>
+                <a:latin typeface="Calibri"/>
+              </a:rPr>
+              <a:t>Why we target Stage 1</a:t>
+            </a:r>
+          </a:p>
+        </p:txBody>
+      </p:sp>
+      <p:sp>
+        <p:nvSpPr>
+          <p:cNvPr id="10" name="Rectangle 9"/>
+          <p:cNvSpPr/>
+          <p:nvPr/>
+        </p:nvSpPr>
+        <p:spPr>
+          <a:xfrm>
+            <a:off x="320040" y="1572768"/>
+            <a:ext cx="73152" cy="868680"/>
+          </a:xfrm>
+          <a:prstGeom prst="rect">
+            <a:avLst/>
+          </a:prstGeom>
+          <a:solidFill>
+            <a:srgbClr val="E8243C"/>
+          </a:solidFill>
+          <a:ln>
+            <a:noFill/>
+          </a:ln>
+        </p:spPr>
+        <p:style>
+          <a:lnRef idx="1">
+            <a:schemeClr val="accent1"/>
+          </a:lnRef>
+          <a:fillRef idx="3">
+            <a:schemeClr val="accent1"/>
+          </a:fillRef>
+          <a:effectRef idx="2">
+            <a:schemeClr val="accent1"/>
+          </a:effectRef>
+          <a:fontRef idx="minor">
+            <a:schemeClr val="lt1"/>
+          </a:fontRef>
+        </p:style>
+        <p:txBody>
+          <a:bodyPr rtlCol="0" anchor="ctr"/>
+          <a:lstStyle/>
+          <a:p>
+            <a:pPr algn="ctr"/>
+          </a:p>
+        </p:txBody>
+      </p:sp>
+      <p:sp>
+        <p:nvSpPr>
+          <p:cNvPr id="11" name="TextBox 10"/>
+          <p:cNvSpPr txBox="1"/>
+          <p:nvPr/>
+        </p:nvSpPr>
+        <p:spPr>
+          <a:xfrm>
+            <a:off x="521207" y="1572768"/>
+            <a:ext cx="5257800" cy="868680"/>
+          </a:xfrm>
+          <a:prstGeom prst="rect">
+            <a:avLst/>
+          </a:prstGeom>
+          <a:noFill/>
+        </p:spPr>
+        <p:txBody>
+          <a:bodyPr wrap="square">
+            <a:spAutoFit/>
+          </a:bodyPr>
+          <a:lstStyle/>
+          <a:p>
+            <a:pPr algn="l"/>
+            <a:r>
+              <a:rPr sz="1050" b="0" i="0">
+                <a:solidFill>
+                  <a:srgbClr val="1A1A1A"/>
+                </a:solidFill>
+                <a:latin typeface="Calibri"/>
+              </a:rPr>
+              <a:t>Highest leverage — starving P1 propagates damage to all downstream stages without touching them</a:t>
+            </a:r>
+          </a:p>
+        </p:txBody>
+      </p:sp>
+      <p:sp>
+        <p:nvSpPr>
+          <p:cNvPr id="12" name="Rectangle 11"/>
+          <p:cNvSpPr/>
+          <p:nvPr/>
+        </p:nvSpPr>
+        <p:spPr>
+          <a:xfrm>
+            <a:off x="320040" y="2596896"/>
+            <a:ext cx="73152" cy="868680"/>
+          </a:xfrm>
+          <a:prstGeom prst="rect">
+            <a:avLst/>
+          </a:prstGeom>
+          <a:solidFill>
+            <a:srgbClr val="E8243C"/>
+          </a:solidFill>
+          <a:ln>
+            <a:noFill/>
+          </a:ln>
+        </p:spPr>
+        <p:style>
+          <a:lnRef idx="1">
+            <a:schemeClr val="accent1"/>
+          </a:lnRef>
+          <a:fillRef idx="3">
+            <a:schemeClr val="accent1"/>
+          </a:fillRef>
+          <a:effectRef idx="2">
+            <a:schemeClr val="accent1"/>
+          </a:effectRef>
+          <a:fontRef idx="minor">
+            <a:schemeClr val="lt1"/>
+          </a:fontRef>
+        </p:style>
+        <p:txBody>
+          <a:bodyPr rtlCol="0" anchor="ctr"/>
+          <a:lstStyle/>
+          <a:p>
+            <a:pPr algn="ctr"/>
+          </a:p>
+        </p:txBody>
+      </p:sp>
+      <p:sp>
+        <p:nvSpPr>
+          <p:cNvPr id="13" name="TextBox 12"/>
+          <p:cNvSpPr txBox="1"/>
+          <p:nvPr/>
+        </p:nvSpPr>
+        <p:spPr>
+          <a:xfrm>
+            <a:off x="521207" y="2596896"/>
+            <a:ext cx="5257800" cy="868680"/>
+          </a:xfrm>
+          <a:prstGeom prst="rect">
+            <a:avLst/>
+          </a:prstGeom>
+          <a:noFill/>
+        </p:spPr>
+        <p:txBody>
+          <a:bodyPr wrap="square">
+            <a:spAutoFit/>
+          </a:bodyPr>
+          <a:lstStyle/>
+          <a:p>
+            <a:pPr algn="l"/>
+            <a:r>
+              <a:rPr sz="1050" b="0" i="0">
+                <a:solidFill>
+                  <a:srgbClr val="1A1A1A"/>
+                </a:solidFill>
+                <a:latin typeface="Calibri"/>
+              </a:rPr>
+              <a:t>Entry point of the chain — maximum physical impact from minimum PLC interaction</a:t>
+            </a:r>
+          </a:p>
+        </p:txBody>
+      </p:sp>
+      <p:sp>
+        <p:nvSpPr>
+          <p:cNvPr id="14" name="Rectangle 13"/>
+          <p:cNvSpPr/>
+          <p:nvPr/>
+        </p:nvSpPr>
+        <p:spPr>
+          <a:xfrm>
+            <a:off x="320040" y="3621024"/>
+            <a:ext cx="73152" cy="868680"/>
+          </a:xfrm>
+          <a:prstGeom prst="rect">
+            <a:avLst/>
+          </a:prstGeom>
+          <a:solidFill>
+            <a:srgbClr val="E8243C"/>
+          </a:solidFill>
+          <a:ln>
+            <a:noFill/>
+          </a:ln>
+        </p:spPr>
+        <p:style>
+          <a:lnRef idx="1">
+            <a:schemeClr val="accent1"/>
+          </a:lnRef>
+          <a:fillRef idx="3">
+            <a:schemeClr val="accent1"/>
+          </a:fillRef>
+          <a:effectRef idx="2">
+            <a:schemeClr val="accent1"/>
+          </a:effectRef>
+          <a:fontRef idx="minor">
+            <a:schemeClr val="lt1"/>
+          </a:fontRef>
+        </p:style>
+        <p:txBody>
+          <a:bodyPr rtlCol="0" anchor="ctr"/>
+          <a:lstStyle/>
+          <a:p>
+            <a:pPr algn="ctr"/>
+          </a:p>
+        </p:txBody>
+      </p:sp>
+      <p:sp>
+        <p:nvSpPr>
+          <p:cNvPr id="15" name="TextBox 14"/>
+          <p:cNvSpPr txBox="1"/>
+          <p:nvPr/>
+        </p:nvSpPr>
+        <p:spPr>
+          <a:xfrm>
+            <a:off x="521207" y="3621024"/>
+            <a:ext cx="5257800" cy="868680"/>
+          </a:xfrm>
+          <a:prstGeom prst="rect">
+            <a:avLst/>
+          </a:prstGeom>
+          <a:noFill/>
+        </p:spPr>
+        <p:txBody>
+          <a:bodyPr wrap="square">
+            <a:spAutoFit/>
+          </a:bodyPr>
+          <a:lstStyle/>
+          <a:p>
+            <a:pPr algn="l"/>
+            <a:r>
+              <a:rPr sz="1050" b="0" i="0">
+                <a:solidFill>
+                  <a:srgbClr val="1A1A1A"/>
+                </a:solidFill>
+                <a:latin typeface="Calibri"/>
+              </a:rPr>
+              <a:t>Most important to defend first — robust P1 defense buys time to extend to P2–P6</a:t>
+            </a:r>
+          </a:p>
+        </p:txBody>
+      </p:sp>
+      <p:sp>
+        <p:nvSpPr>
+          <p:cNvPr id="16" name="Rectangle 15"/>
+          <p:cNvSpPr/>
+          <p:nvPr/>
+        </p:nvSpPr>
+        <p:spPr>
+          <a:xfrm>
+            <a:off x="320040" y="4645152"/>
+            <a:ext cx="73152" cy="868680"/>
+          </a:xfrm>
+          <a:prstGeom prst="rect">
+            <a:avLst/>
+          </a:prstGeom>
+          <a:solidFill>
+            <a:srgbClr val="E8243C"/>
+          </a:solidFill>
+          <a:ln>
+            <a:noFill/>
+          </a:ln>
+        </p:spPr>
+        <p:style>
+          <a:lnRef idx="1">
+            <a:schemeClr val="accent1"/>
+          </a:lnRef>
+          <a:fillRef idx="3">
+            <a:schemeClr val="accent1"/>
+          </a:fillRef>
+          <a:effectRef idx="2">
+            <a:schemeClr val="accent1"/>
+          </a:effectRef>
+          <a:fontRef idx="minor">
+            <a:schemeClr val="lt1"/>
+          </a:fontRef>
+        </p:style>
+        <p:txBody>
+          <a:bodyPr rtlCol="0" anchor="ctr"/>
+          <a:lstStyle/>
+          <a:p>
+            <a:pPr algn="ctr"/>
+          </a:p>
+        </p:txBody>
+      </p:sp>
+      <p:sp>
+        <p:nvSpPr>
+          <p:cNvPr id="17" name="TextBox 16"/>
+          <p:cNvSpPr txBox="1"/>
+          <p:nvPr/>
+        </p:nvSpPr>
+        <p:spPr>
+          <a:xfrm>
+            <a:off x="521207" y="4645152"/>
+            <a:ext cx="5257800" cy="868680"/>
+          </a:xfrm>
+          <a:prstGeom prst="rect">
+            <a:avLst/>
+          </a:prstGeom>
+          <a:noFill/>
+        </p:spPr>
+        <p:txBody>
+          <a:bodyPr wrap="square">
+            <a:spAutoFit/>
+          </a:bodyPr>
+          <a:lstStyle/>
+          <a:p>
+            <a:pPr algn="l"/>
+            <a:r>
+              <a:rPr sz="1050" b="0" i="0">
+                <a:solidFill>
+                  <a:srgbClr val="1A1A1A"/>
+                </a:solidFill>
+                <a:latin typeface="Calibri"/>
+              </a:rPr>
+              <a:t>Simplest attack surface — only MV101 + P101 needed to stop all water flow</a:t>
+            </a:r>
+          </a:p>
+        </p:txBody>
+      </p:sp>
+      <p:sp>
+        <p:nvSpPr>
+          <p:cNvPr id="18" name="TextBox 17"/>
+          <p:cNvSpPr txBox="1"/>
+          <p:nvPr/>
+        </p:nvSpPr>
+        <p:spPr>
+          <a:xfrm>
+            <a:off x="6080760" y="1188720"/>
+            <a:ext cx="5788152" cy="292608"/>
+          </a:xfrm>
+          <a:prstGeom prst="rect">
+            <a:avLst/>
+          </a:prstGeom>
+          <a:noFill/>
+        </p:spPr>
+        <p:txBody>
+          <a:bodyPr wrap="square">
+            <a:spAutoFit/>
+          </a:bodyPr>
+          <a:lstStyle/>
+          <a:p>
+            <a:pPr algn="l"/>
+            <a:r>
+              <a:rPr sz="1300" b="1" i="0">
+                <a:solidFill>
+                  <a:srgbClr val="2E7D32"/>
+                </a:solidFill>
+                <a:latin typeface="Calibri"/>
+              </a:rPr>
+              <a:t>Scaling the defense to all 6 stages</a:t>
+            </a:r>
+          </a:p>
+        </p:txBody>
+      </p:sp>
+      <p:sp>
+        <p:nvSpPr>
+          <p:cNvPr id="19" name="Rectangle 18"/>
+          <p:cNvSpPr/>
+          <p:nvPr/>
+        </p:nvSpPr>
+        <p:spPr>
+          <a:xfrm>
+            <a:off x="6080760" y="1572768"/>
+            <a:ext cx="5788152" cy="914400"/>
+          </a:xfrm>
+          <a:prstGeom prst="rect">
+            <a:avLst/>
+          </a:prstGeom>
+          <a:solidFill>
+            <a:srgbClr val="F5F5F5"/>
+          </a:solidFill>
+          <a:ln>
+            <a:noFill/>
+          </a:ln>
+        </p:spPr>
+        <p:style>
+          <a:lnRef idx="1">
+            <a:schemeClr val="accent1"/>
+          </a:lnRef>
+          <a:fillRef idx="3">
+            <a:schemeClr val="accent1"/>
+          </a:fillRef>
+          <a:effectRef idx="2">
+            <a:schemeClr val="accent1"/>
+          </a:effectRef>
+          <a:fontRef idx="minor">
+            <a:schemeClr val="lt1"/>
+          </a:fontRef>
+        </p:style>
+        <p:txBody>
+          <a:bodyPr rtlCol="0" anchor="ctr"/>
+          <a:lstStyle/>
+          <a:p>
+            <a:pPr algn="ctr"/>
+          </a:p>
+        </p:txBody>
+      </p:sp>
+      <p:sp>
+        <p:nvSpPr>
+          <p:cNvPr id="20" name="Rectangle 19"/>
+          <p:cNvSpPr/>
+          <p:nvPr/>
+        </p:nvSpPr>
+        <p:spPr>
+          <a:xfrm>
+            <a:off x="6080760" y="1572768"/>
+            <a:ext cx="54864" cy="914400"/>
+          </a:xfrm>
+          <a:prstGeom prst="rect">
+            <a:avLst/>
+          </a:prstGeom>
+          <a:solidFill>
+            <a:srgbClr val="2E7D32"/>
+          </a:solidFill>
+          <a:ln>
+            <a:noFill/>
+          </a:ln>
+        </p:spPr>
+        <p:style>
+          <a:lnRef idx="1">
+            <a:schemeClr val="accent1"/>
+          </a:lnRef>
+          <a:fillRef idx="3">
+            <a:schemeClr val="accent1"/>
+          </a:fillRef>
+          <a:effectRef idx="2">
+            <a:schemeClr val="accent1"/>
+          </a:effectRef>
+          <a:fontRef idx="minor">
+            <a:schemeClr val="lt1"/>
+          </a:fontRef>
+        </p:style>
+        <p:txBody>
+          <a:bodyPr rtlCol="0" anchor="ctr"/>
+          <a:lstStyle/>
+          <a:p>
+            <a:pPr algn="ctr"/>
+          </a:p>
+        </p:txBody>
+      </p:sp>
+      <p:sp>
+        <p:nvSpPr>
+          <p:cNvPr id="21" name="TextBox 20"/>
+          <p:cNvSpPr txBox="1"/>
+          <p:nvPr/>
+        </p:nvSpPr>
+        <p:spPr>
+          <a:xfrm>
+            <a:off x="6236208" y="1636776"/>
+            <a:ext cx="5577840" cy="274320"/>
+          </a:xfrm>
+          <a:prstGeom prst="rect">
+            <a:avLst/>
+          </a:prstGeom>
+          <a:noFill/>
+        </p:spPr>
+        <p:txBody>
+          <a:bodyPr wrap="square">
+            <a:spAutoFit/>
+          </a:bodyPr>
+          <a:lstStyle/>
+          <a:p>
+            <a:pPr algn="l"/>
+            <a:r>
+              <a:rPr sz="1100" b="1" i="0">
+                <a:solidFill>
+                  <a:srgbClr val="2E7D32"/>
+                </a:solidFill>
+                <a:latin typeface="Calibri"/>
+              </a:rPr>
+              <a:t>Extend invariants</a:t>
+            </a:r>
+          </a:p>
+        </p:txBody>
+      </p:sp>
+      <p:sp>
+        <p:nvSpPr>
+          <p:cNvPr id="22" name="TextBox 21"/>
+          <p:cNvSpPr txBox="1"/>
+          <p:nvPr/>
+        </p:nvSpPr>
+        <p:spPr>
+          <a:xfrm>
+            <a:off x="6236208" y="1938528"/>
+            <a:ext cx="5577840" cy="502920"/>
+          </a:xfrm>
+          <a:prstGeom prst="rect">
+            <a:avLst/>
+          </a:prstGeom>
+          <a:noFill/>
+        </p:spPr>
+        <p:txBody>
+          <a:bodyPr wrap="square">
+            <a:spAutoFit/>
+          </a:bodyPr>
+          <a:lstStyle/>
+          <a:p>
+            <a:pPr algn="l"/>
+            <a:r>
+              <a:rPr sz="1000" b="0" i="0">
+                <a:solidFill>
+                  <a:srgbClr val="1A1A1A"/>
+                </a:solidFill>
+                <a:latin typeface="Calibri"/>
+              </a:rPr>
+              <a:t>Add P2–P6 invariant sets from each stage P&amp;ID. Same framework, different tags.</a:t>
+            </a:r>
+          </a:p>
+        </p:txBody>
+      </p:sp>
+      <p:sp>
+        <p:nvSpPr>
+          <p:cNvPr id="23" name="Rectangle 22"/>
+          <p:cNvSpPr/>
+          <p:nvPr/>
+        </p:nvSpPr>
+        <p:spPr>
+          <a:xfrm>
+            <a:off x="6080760" y="2596896"/>
+            <a:ext cx="5788152" cy="914400"/>
+          </a:xfrm>
+          <a:prstGeom prst="rect">
+            <a:avLst/>
+          </a:prstGeom>
+          <a:solidFill>
+            <a:srgbClr val="F5F5F5"/>
+          </a:solidFill>
+          <a:ln>
+            <a:noFill/>
+          </a:ln>
+        </p:spPr>
+        <p:style>
+          <a:lnRef idx="1">
+            <a:schemeClr val="accent1"/>
+          </a:lnRef>
+          <a:fillRef idx="3">
+            <a:schemeClr val="accent1"/>
+          </a:fillRef>
+          <a:effectRef idx="2">
+            <a:schemeClr val="accent1"/>
+          </a:effectRef>
+          <a:fontRef idx="minor">
+            <a:schemeClr val="lt1"/>
+          </a:fontRef>
+        </p:style>
+        <p:txBody>
+          <a:bodyPr rtlCol="0" anchor="ctr"/>
+          <a:lstStyle/>
+          <a:p>
+            <a:pPr algn="ctr"/>
+          </a:p>
+        </p:txBody>
+      </p:sp>
+      <p:sp>
+        <p:nvSpPr>
+          <p:cNvPr id="24" name="Rectangle 23"/>
+          <p:cNvSpPr/>
+          <p:nvPr/>
+        </p:nvSpPr>
+        <p:spPr>
+          <a:xfrm>
+            <a:off x="6080760" y="2596896"/>
+            <a:ext cx="54864" cy="914400"/>
+          </a:xfrm>
+          <a:prstGeom prst="rect">
+            <a:avLst/>
+          </a:prstGeom>
+          <a:solidFill>
+            <a:srgbClr val="2E7D32"/>
+          </a:solidFill>
+          <a:ln>
+            <a:noFill/>
+          </a:ln>
+        </p:spPr>
+        <p:style>
+          <a:lnRef idx="1">
+            <a:schemeClr val="accent1"/>
+          </a:lnRef>
+          <a:fillRef idx="3">
+            <a:schemeClr val="accent1"/>
+          </a:fillRef>
+          <a:effectRef idx="2">
+            <a:schemeClr val="accent1"/>
+          </a:effectRef>
+          <a:fontRef idx="minor">
+            <a:schemeClr val="lt1"/>
+          </a:fontRef>
+        </p:style>
+        <p:txBody>
+          <a:bodyPr rtlCol="0" anchor="ctr"/>
+          <a:lstStyle/>
+          <a:p>
+            <a:pPr algn="ctr"/>
+          </a:p>
+        </p:txBody>
+      </p:sp>
+      <p:sp>
+        <p:nvSpPr>
+          <p:cNvPr id="25" name="TextBox 24"/>
+          <p:cNvSpPr txBox="1"/>
+          <p:nvPr/>
+        </p:nvSpPr>
+        <p:spPr>
+          <a:xfrm>
+            <a:off x="6236208" y="2660903"/>
+            <a:ext cx="5577840" cy="274320"/>
+          </a:xfrm>
+          <a:prstGeom prst="rect">
+            <a:avLst/>
+          </a:prstGeom>
+          <a:noFill/>
+        </p:spPr>
+        <p:txBody>
+          <a:bodyPr wrap="square">
+            <a:spAutoFit/>
+          </a:bodyPr>
+          <a:lstStyle/>
+          <a:p>
+            <a:pPr algn="l"/>
+            <a:r>
+              <a:rPr sz="1100" b="1" i="0">
+                <a:solidFill>
+                  <a:srgbClr val="2E7D32"/>
+                </a:solidFill>
+                <a:latin typeface="Calibri"/>
+              </a:rPr>
+              <a:t>Multi-stage fusion</a:t>
+            </a:r>
+          </a:p>
+        </p:txBody>
+      </p:sp>
+      <p:sp>
+        <p:nvSpPr>
+          <p:cNvPr id="26" name="TextBox 25"/>
+          <p:cNvSpPr txBox="1"/>
+          <p:nvPr/>
+        </p:nvSpPr>
+        <p:spPr>
+          <a:xfrm>
+            <a:off x="6236208" y="2962656"/>
+            <a:ext cx="5577840" cy="502920"/>
+          </a:xfrm>
+          <a:prstGeom prst="rect">
+            <a:avLst/>
+          </a:prstGeom>
+          <a:noFill/>
+        </p:spPr>
+        <p:txBody>
+          <a:bodyPr wrap="square">
+            <a:spAutoFit/>
+          </a:bodyPr>
+          <a:lstStyle/>
+          <a:p>
+            <a:pPr algn="l"/>
+            <a:r>
+              <a:rPr sz="1000" b="0" i="0">
+                <a:solidFill>
+                  <a:srgbClr val="1A1A1A"/>
+                </a:solidFill>
+                <a:latin typeface="Calibri"/>
+              </a:rPr>
+              <a:t>One fusion engine aggregating inv_flags from 6 invariant checkers simultaneously.</a:t>
+            </a:r>
+          </a:p>
+        </p:txBody>
+      </p:sp>
+      <p:sp>
+        <p:nvSpPr>
+          <p:cNvPr id="27" name="Rectangle 26"/>
+          <p:cNvSpPr/>
+          <p:nvPr/>
+        </p:nvSpPr>
+        <p:spPr>
+          <a:xfrm>
+            <a:off x="6080760" y="3621024"/>
+            <a:ext cx="5788152" cy="914400"/>
+          </a:xfrm>
+          <a:prstGeom prst="rect">
+            <a:avLst/>
+          </a:prstGeom>
+          <a:solidFill>
+            <a:srgbClr val="F5F5F5"/>
+          </a:solidFill>
+          <a:ln>
+            <a:noFill/>
+          </a:ln>
+        </p:spPr>
+        <p:style>
+          <a:lnRef idx="1">
+            <a:schemeClr val="accent1"/>
+          </a:lnRef>
+          <a:fillRef idx="3">
+            <a:schemeClr val="accent1"/>
+          </a:fillRef>
+          <a:effectRef idx="2">
+            <a:schemeClr val="accent1"/>
+          </a:effectRef>
+          <a:fontRef idx="minor">
+            <a:schemeClr val="lt1"/>
+          </a:fontRef>
+        </p:style>
+        <p:txBody>
+          <a:bodyPr rtlCol="0" anchor="ctr"/>
+          <a:lstStyle/>
+          <a:p>
+            <a:pPr algn="ctr"/>
+          </a:p>
+        </p:txBody>
+      </p:sp>
+      <p:sp>
+        <p:nvSpPr>
+          <p:cNvPr id="28" name="Rectangle 27"/>
+          <p:cNvSpPr/>
+          <p:nvPr/>
+        </p:nvSpPr>
+        <p:spPr>
+          <a:xfrm>
+            <a:off x="6080760" y="3621024"/>
+            <a:ext cx="54864" cy="914400"/>
+          </a:xfrm>
+          <a:prstGeom prst="rect">
+            <a:avLst/>
+          </a:prstGeom>
+          <a:solidFill>
+            <a:srgbClr val="2E7D32"/>
+          </a:solidFill>
+          <a:ln>
+            <a:noFill/>
+          </a:ln>
+        </p:spPr>
+        <p:style>
+          <a:lnRef idx="1">
+            <a:schemeClr val="accent1"/>
+          </a:lnRef>
+          <a:fillRef idx="3">
+            <a:schemeClr val="accent1"/>
+          </a:fillRef>
+          <a:effectRef idx="2">
+            <a:schemeClr val="accent1"/>
+          </a:effectRef>
+          <a:fontRef idx="minor">
+            <a:schemeClr val="lt1"/>
+          </a:fontRef>
+        </p:style>
+        <p:txBody>
+          <a:bodyPr rtlCol="0" anchor="ctr"/>
+          <a:lstStyle/>
+          <a:p>
+            <a:pPr algn="ctr"/>
+          </a:p>
+        </p:txBody>
+      </p:sp>
+      <p:sp>
+        <p:nvSpPr>
+          <p:cNvPr id="29" name="TextBox 28"/>
+          <p:cNvSpPr txBox="1"/>
+          <p:nvPr/>
+        </p:nvSpPr>
+        <p:spPr>
+          <a:xfrm>
+            <a:off x="6236208" y="3685032"/>
+            <a:ext cx="5577840" cy="274320"/>
+          </a:xfrm>
+          <a:prstGeom prst="rect">
+            <a:avLst/>
+          </a:prstGeom>
+          <a:noFill/>
+        </p:spPr>
+        <p:txBody>
+          <a:bodyPr wrap="square">
+            <a:spAutoFit/>
+          </a:bodyPr>
+          <a:lstStyle/>
+          <a:p>
+            <a:pPr algn="l"/>
+            <a:r>
+              <a:rPr sz="1100" b="1" i="0">
+                <a:solidFill>
+                  <a:srgbClr val="2E7D32"/>
+                </a:solidFill>
+                <a:latin typeface="Calibri"/>
+              </a:rPr>
+              <a:t>Shared AE model</a:t>
+            </a:r>
+          </a:p>
+        </p:txBody>
+      </p:sp>
+      <p:sp>
+        <p:nvSpPr>
+          <p:cNvPr id="30" name="TextBox 29"/>
+          <p:cNvSpPr txBox="1"/>
+          <p:nvPr/>
+        </p:nvSpPr>
+        <p:spPr>
+          <a:xfrm>
+            <a:off x="6236208" y="3986784"/>
+            <a:ext cx="5577840" cy="502920"/>
+          </a:xfrm>
+          <a:prstGeom prst="rect">
+            <a:avLst/>
+          </a:prstGeom>
+          <a:noFill/>
+        </p:spPr>
+        <p:txBody>
+          <a:bodyPr wrap="square">
+            <a:spAutoFit/>
+          </a:bodyPr>
+          <a:lstStyle/>
+          <a:p>
+            <a:pPr algn="l"/>
+            <a:r>
+              <a:rPr sz="1000" b="0" i="0">
+                <a:solidFill>
+                  <a:srgbClr val="1A1A1A"/>
+                </a:solidFill>
+                <a:latin typeface="Calibri"/>
+              </a:rPr>
+              <a:t>Retrain on all 87 sensor columns — dataset already covers all 6 stages.</a:t>
+            </a:r>
+          </a:p>
+        </p:txBody>
+      </p:sp>
+      <p:sp>
+        <p:nvSpPr>
+          <p:cNvPr id="31" name="Rectangle 30"/>
+          <p:cNvSpPr/>
+          <p:nvPr/>
+        </p:nvSpPr>
+        <p:spPr>
+          <a:xfrm>
+            <a:off x="6080760" y="4645152"/>
+            <a:ext cx="5788152" cy="914400"/>
+          </a:xfrm>
+          <a:prstGeom prst="rect">
+            <a:avLst/>
+          </a:prstGeom>
+          <a:solidFill>
+            <a:srgbClr val="F5F5F5"/>
+          </a:solidFill>
+          <a:ln>
+            <a:noFill/>
+          </a:ln>
+        </p:spPr>
+        <p:style>
+          <a:lnRef idx="1">
+            <a:schemeClr val="accent1"/>
+          </a:lnRef>
+          <a:fillRef idx="3">
+            <a:schemeClr val="accent1"/>
+          </a:fillRef>
+          <a:effectRef idx="2">
+            <a:schemeClr val="accent1"/>
+          </a:effectRef>
+          <a:fontRef idx="minor">
+            <a:schemeClr val="lt1"/>
+          </a:fontRef>
+        </p:style>
+        <p:txBody>
+          <a:bodyPr rtlCol="0" anchor="ctr"/>
+          <a:lstStyle/>
+          <a:p>
+            <a:pPr algn="ctr"/>
+          </a:p>
+        </p:txBody>
+      </p:sp>
+      <p:sp>
+        <p:nvSpPr>
+          <p:cNvPr id="32" name="Rectangle 31"/>
+          <p:cNvSpPr/>
+          <p:nvPr/>
+        </p:nvSpPr>
+        <p:spPr>
+          <a:xfrm>
+            <a:off x="6080760" y="4645152"/>
+            <a:ext cx="54864" cy="914400"/>
+          </a:xfrm>
+          <a:prstGeom prst="rect">
+            <a:avLst/>
+          </a:prstGeom>
+          <a:solidFill>
+            <a:srgbClr val="2E7D32"/>
+          </a:solidFill>
+          <a:ln>
+            <a:noFill/>
+          </a:ln>
+        </p:spPr>
+        <p:style>
+          <a:lnRef idx="1">
+            <a:schemeClr val="accent1"/>
+          </a:lnRef>
+          <a:fillRef idx="3">
+            <a:schemeClr val="accent1"/>
+          </a:fillRef>
+          <a:effectRef idx="2">
+            <a:schemeClr val="accent1"/>
+          </a:effectRef>
+          <a:fontRef idx="minor">
+            <a:schemeClr val="lt1"/>
+          </a:fontRef>
+        </p:style>
+        <p:txBody>
+          <a:bodyPr rtlCol="0" anchor="ctr"/>
+          <a:lstStyle/>
+          <a:p>
+            <a:pPr algn="ctr"/>
+          </a:p>
+        </p:txBody>
+      </p:sp>
+      <p:sp>
+        <p:nvSpPr>
+          <p:cNvPr id="33" name="TextBox 32"/>
+          <p:cNvSpPr txBox="1"/>
+          <p:nvPr/>
+        </p:nvSpPr>
+        <p:spPr>
+          <a:xfrm>
+            <a:off x="6236208" y="4709160"/>
+            <a:ext cx="5577840" cy="274320"/>
+          </a:xfrm>
+          <a:prstGeom prst="rect">
+            <a:avLst/>
+          </a:prstGeom>
+          <a:noFill/>
+        </p:spPr>
+        <p:txBody>
+          <a:bodyPr wrap="square">
+            <a:spAutoFit/>
+          </a:bodyPr>
+          <a:lstStyle/>
+          <a:p>
+            <a:pPr algn="l"/>
+            <a:r>
+              <a:rPr sz="1100" b="1" i="0">
+                <a:solidFill>
+                  <a:srgbClr val="2E7D32"/>
+                </a:solidFill>
+                <a:latin typeface="Calibri"/>
+              </a:rPr>
+              <a:t>Cross-stage failover</a:t>
+            </a:r>
+          </a:p>
+        </p:txBody>
+      </p:sp>
+      <p:sp>
+        <p:nvSpPr>
+          <p:cNvPr id="34" name="TextBox 33"/>
+          <p:cNvSpPr txBox="1"/>
+          <p:nvPr/>
+        </p:nvSpPr>
+        <p:spPr>
+          <a:xfrm>
+            <a:off x="6236208" y="5010912"/>
+            <a:ext cx="5577840" cy="502920"/>
+          </a:xfrm>
+          <a:prstGeom prst="rect">
+            <a:avLst/>
+          </a:prstGeom>
+          <a:noFill/>
+        </p:spPr>
+        <p:txBody>
+          <a:bodyPr wrap="square">
+            <a:spAutoFit/>
+          </a:bodyPr>
+          <a:lstStyle/>
+          <a:p>
+            <a:pPr algn="l"/>
+            <a:r>
+              <a:rPr sz="1000" b="0" i="0">
+                <a:solidFill>
+                  <a:srgbClr val="1A1A1A"/>
+                </a:solidFill>
+                <a:latin typeface="Calibri"/>
+              </a:rPr>
+              <a:t>P2–P6 each have redundant PLCs — same failover pattern scales directly.</a:t>
+            </a:r>
+          </a:p>
+        </p:txBody>
+      </p:sp>
+      <p:sp>
+        <p:nvSpPr>
+          <p:cNvPr id="35" name="TextBox 34"/>
+          <p:cNvSpPr txBox="1"/>
+          <p:nvPr/>
+        </p:nvSpPr>
+        <p:spPr>
+          <a:xfrm>
+            <a:off x="320040" y="5779008"/>
+            <a:ext cx="11548872" cy="256032"/>
+          </a:xfrm>
+          <a:prstGeom prst="rect">
+            <a:avLst/>
+          </a:prstGeom>
+          <a:noFill/>
+        </p:spPr>
+        <p:txBody>
+          <a:bodyPr wrap="square">
+            <a:spAutoFit/>
+          </a:bodyPr>
+          <a:lstStyle/>
+          <a:p>
+            <a:pPr algn="ctr"/>
+            <a:r>
+              <a:rPr sz="1000" b="1" i="0">
+                <a:solidFill>
+                  <a:srgbClr val="E8243C"/>
+                </a:solidFill>
+                <a:latin typeface="Calibri"/>
+              </a:rPr>
+              <a:t>Our P1 demonstration is the proof of concept. The architecture scales directly to the full plant.</a:t>
+            </a:r>
           </a:p>
         </p:txBody>
       </p:sp>

</xml_diff>

<commit_message>
fix: update slides and report to match codebase
Report (swat_project_report.docx):
- §4.2 heading: 'ARP Poisoning & False CIP Tag Injection' → 'False CIP Tag Injection from Compromised HMI'
- §4.2 tag table: HMI_MV101:O.Data → HMI_MV101.Cmd, HMI_P101:O.Data → HMI_P101.Auto
- §4.2 table values: True(OPEN)/False(CLOSED) → 2(OPEN)/1(CLOSED) for MV101.Cmd
- §5.1 I-9 invariant: fixed copy-paste of I-8 → correct Phase 1 attack signature description

Slides (swat_sutd.pptx):
- Slide 15 safe state restore: 4-line → 6-line pattern (Auto=False before Cmd write)
</commit_message>
<xml_diff>
--- a/slides/swat_sutd.pptx
+++ b/slides/swat_sutd.pptx
@@ -4738,7 +4738,7 @@
       </p:sp>
       <p:pic>
         <p:nvPicPr>
-          <p:cNvPr id="14" name="Image 0" descr="/home/claude/swat-cps-project/assets/images/swat_testbed_photo.jpg">    </p:cNvPr>
+          <p:cNvPr id="14" name="Image 0" descr="/home/claude/swat-cps-project/assets/images/swat_testbed_photo.jpg"/>
           <p:cNvPicPr>
             <a:picLocks noChangeAspect="1"/>
           </p:cNvPicPr>
@@ -5992,7 +5992,7 @@
       </p:sp>
       <p:pic>
         <p:nvPicPr>
-          <p:cNvPr id="10" name="Image 0" descr="/home/claude/swat-cps-project/assets/images/swat_p1_stage.png">    </p:cNvPr>
+          <p:cNvPr id="10" name="Image 0" descr="/home/claude/swat-cps-project/assets/images/swat_p1_stage.png"/>
           <p:cNvPicPr>
             <a:picLocks noChangeAspect="1"/>
           </p:cNvPicPr>
@@ -6055,7 +6055,7 @@
       </p:sp>
       <p:pic>
         <p:nvPicPr>
-          <p:cNvPr id="12" name="Image 1" descr="/home/claude/swat-cps-project/assets/images/swat_testbed_photo.jpg">    </p:cNvPr>
+          <p:cNvPr id="12" name="Image 1" descr="/home/claude/swat-cps-project/assets/images/swat_testbed_photo.jpg"/>
           <p:cNvPicPr>
             <a:picLocks noChangeAspect="1"/>
           </p:cNvPicPr>
@@ -6379,7 +6379,7 @@
       </p:sp>
       <p:pic>
         <p:nvPicPr>
-          <p:cNvPr id="9" name="Image 0" descr="/home/claude/swat-cps-project/assets/images/swat_architecture.png">    </p:cNvPr>
+          <p:cNvPr id="9" name="Image 0" descr="/home/claude/swat-cps-project/assets/images/swat_architecture.png"/>
           <p:cNvPicPr>
             <a:picLocks noChangeAspect="1"/>
           </p:cNvPicPr>
@@ -7361,7 +7361,7 @@
                 <a:ea typeface="Calibri" pitchFamily="34" charset="-122"/>
                 <a:cs typeface="Calibri" pitchFamily="34" charset="-120"/>
               </a:rPr>
-              <a:t>    plc.IPAddress = '192.168.1.10'</a:t>
+              <a:t xml:space="preserve">    plc.IPAddress = '192.168.1.10'</a:t>
             </a:r>
             <a:endParaRPr lang="en-US" sz="1000" dirty="0"/>
           </a:p>
@@ -7378,7 +7378,7 @@
                 <a:ea typeface="Calibri" pitchFamily="34" charset="-122"/>
                 <a:cs typeface="Calibri" pitchFamily="34" charset="-120"/>
               </a:rPr>
-              <a:t>    r = plc.Read('HMI_LIT101.Pv')</a:t>
+              <a:t xml:space="preserve">    r = plc.Read('HMI_LIT101.Pv')</a:t>
             </a:r>
             <a:endParaRPr lang="en-US" sz="1000" dirty="0"/>
           </a:p>
@@ -7395,7 +7395,7 @@
                 <a:ea typeface="Calibri" pitchFamily="34" charset="-122"/>
                 <a:cs typeface="Calibri" pitchFamily="34" charset="-120"/>
               </a:rPr>
-              <a:t>    print(r.Value, r.Status)"</a:t>
+              <a:t xml:space="preserve">    print(r.Value, r.Status)"</a:t>
             </a:r>
             <a:endParaRPr lang="en-US" sz="1000" dirty="0"/>
           </a:p>
@@ -7515,7 +7515,7 @@
                 <a:ea typeface="Calibri" pitchFamily="34" charset="-122"/>
                 <a:cs typeface="Calibri" pitchFamily="34" charset="-120"/>
               </a:rPr>
-              <a:t>  HMI_LIT101.Pv        (REAL, mm)</a:t>
+              <a:t xml:space="preserve">  HMI_LIT101.Pv        (REAL, mm)</a:t>
             </a:r>
             <a:endParaRPr lang="en-US" sz="1000" dirty="0"/>
           </a:p>
@@ -7532,7 +7532,7 @@
                 <a:ea typeface="Calibri" pitchFamily="34" charset="-122"/>
                 <a:cs typeface="Calibri" pitchFamily="34" charset="-120"/>
               </a:rPr>
-              <a:t>  AI_FIT_101_FLOW      (REAL, L/s)</a:t>
+              <a:t xml:space="preserve">  AI_FIT_101_FLOW      (REAL, L/s)</a:t>
             </a:r>
             <a:endParaRPr lang="en-US" sz="1000" dirty="0"/>
           </a:p>
@@ -7549,7 +7549,7 @@
                 <a:ea typeface="Calibri" pitchFamily="34" charset="-122"/>
                 <a:cs typeface="Calibri" pitchFamily="34" charset="-120"/>
               </a:rPr>
-              <a:t>  HMI_MV101.Cmd        (1=CLOSE, 2=OPEN)</a:t>
+              <a:t xml:space="preserve">  HMI_MV101.Cmd        (1=CLOSE, 2=OPEN)</a:t>
             </a:r>
             <a:endParaRPr lang="en-US" sz="1000" dirty="0"/>
           </a:p>
@@ -7566,7 +7566,7 @@
                 <a:ea typeface="Calibri" pitchFamily="34" charset="-122"/>
                 <a:cs typeface="Calibri" pitchFamily="34" charset="-120"/>
               </a:rPr>
-              <a:t>  HMI_P101.Auto        (BOOL)</a:t>
+              <a:t xml:space="preserve">  HMI_P101.Auto        (BOOL)</a:t>
             </a:r>
             <a:endParaRPr lang="en-US" sz="1000" dirty="0"/>
           </a:p>
@@ -7583,7 +7583,7 @@
                 <a:ea typeface="Calibri" pitchFamily="34" charset="-122"/>
                 <a:cs typeface="Calibri" pitchFamily="34" charset="-120"/>
               </a:rPr>
-              <a:t>  HMI_LIT101.Sim_PV    (spoofing)</a:t>
+              <a:t xml:space="preserve">  HMI_LIT101.Sim_PV    (spoofing)</a:t>
             </a:r>
             <a:endParaRPr lang="en-US" sz="1000" dirty="0"/>
           </a:p>
@@ -9615,7 +9615,7 @@
                 <a:ea typeface="Courier New" pitchFamily="34" charset="-122"/>
                 <a:cs typeface="Courier New" pitchFamily="34" charset="-120"/>
               </a:rPr>
-              <a:t>plc.Write("HMI_MV101.Cmd",  2)  # 2=OPEN</a:t>
+              <a:t>plc.Write("HMI_MV101.Auto", False)</a:t>
             </a:r>
             <a:endParaRPr lang="en-US" sz="900" dirty="0"/>
           </a:p>
@@ -9632,7 +9632,41 @@
                 <a:ea typeface="Courier New" pitchFamily="34" charset="-122"/>
                 <a:cs typeface="Courier New" pitchFamily="34" charset="-120"/>
               </a:rPr>
+              <a:t>plc.Write("HMI_MV101.Cmd",  2)  # 2=OPEN</a:t>
+            </a:r>
+            <a:endParaRPr lang="en-US" sz="900" dirty="0"/>
+          </a:p>
+          <a:p>
+            <a:pPr indent="0" marL="0">
+              <a:buNone/>
+            </a:pPr>
+            <a:r>
+              <a:rPr lang="en-US" sz="900" dirty="0">
+                <a:solidFill>
+                  <a:srgbClr val="00FF88"/>
+                </a:solidFill>
+                <a:latin typeface="Courier New" pitchFamily="34" charset="0"/>
+                <a:ea typeface="Courier New" pitchFamily="34" charset="-122"/>
+                <a:cs typeface="Courier New" pitchFamily="34" charset="-120"/>
+              </a:rPr>
               <a:t>plc.Write("HMI_MV101.Auto", True)</a:t>
+            </a:r>
+            <a:endParaRPr lang="en-US" sz="900" dirty="0"/>
+          </a:p>
+          <a:p>
+            <a:pPr indent="0" marL="0">
+              <a:buNone/>
+            </a:pPr>
+            <a:r>
+              <a:rPr lang="en-US" sz="900" dirty="0">
+                <a:solidFill>
+                  <a:srgbClr val="00FF88"/>
+                </a:solidFill>
+                <a:latin typeface="Courier New" pitchFamily="34" charset="0"/>
+                <a:ea typeface="Courier New" pitchFamily="34" charset="-122"/>
+                <a:cs typeface="Courier New" pitchFamily="34" charset="-120"/>
+              </a:rPr>
+              <a:t>plc.Write("HMI_P101.Auto",  False)</a:t>
             </a:r>
             <a:endParaRPr lang="en-US" sz="900" dirty="0"/>
           </a:p>
@@ -15078,7 +15112,7 @@
       </p:sp>
       <p:pic>
         <p:nvPicPr>
-          <p:cNvPr id="28" name="Image 0" descr="/home/claude/swat-cps-project/assets/images/swat_testbed_photo.jpg">    </p:cNvPr>
+          <p:cNvPr id="28" name="Image 0" descr="/home/claude/swat-cps-project/assets/images/swat_testbed_photo.jpg"/>
           <p:cNvPicPr>
             <a:picLocks noChangeAspect="1"/>
           </p:cNvPicPr>
@@ -27997,7 +28031,7 @@
       </p:sp>
       <p:pic>
         <p:nvPicPr>
-          <p:cNvPr id="7" name="Image 0" descr="/home/claude/swat-cps-project/assets/images/swat_architecture.png">    </p:cNvPr>
+          <p:cNvPr id="7" name="Image 0" descr="/home/claude/swat-cps-project/assets/images/swat_architecture.png"/>
           <p:cNvPicPr>
             <a:picLocks noChangeAspect="1"/>
           </p:cNvPicPr>

</xml_diff>

<commit_message>
docs: add simulated test results to slides and report
Slide 28 (Evaluation):
- Updated DR/FPR/RT metrics with actual test_detectors.py results
- Normal: 0/500 AE alarms (0% FPR), 0/10 invariant alarms
- Phase 1: 81/100 AE alarms, 10/10 invariant (I-2+I-9)
- Recovery: <12s on simulator, 5/5 clean cycles

Report §7 (Evaluation):
- Added 'Simulated Validation (PLC Simulator)' subsection
- Documented all 3 scenarios with exact numbers
- Explained Phase 2 offline evasion limitation (black-box transfer)
- Added end-to-end test_all.py recovery results
</commit_message>
<xml_diff>
--- a/slides/swat_sutd.pptx
+++ b/slides/swat_sutd.pptx
@@ -27074,7 +27074,7 @@
                 <a:ea typeface="Calibri" pitchFamily="34" charset="-122"/>
                 <a:cs typeface="Calibri" pitchFamily="34" charset="-120"/>
               </a:rPr>
-              <a:t>Code artifacts and expected metrics for the iTrust Lab demo</a:t>
+              <a:t>Simulated test results (test_detectors.py) and expected live metrics</a:t>
             </a:r>
             <a:endParaRPr lang="en-US" sz="1200" dirty="0"/>
           </a:p>
@@ -27197,7 +27197,7 @@
                 <a:ea typeface="Calibri" pitchFamily="34" charset="-122"/>
                 <a:cs typeface="Calibri" pitchFamily="34" charset="-120"/>
               </a:rPr>
-              <a:t>Expected: &gt;95% for hybrid. Baseline: invariant-only ~67%, AE-only ~72%. Hybrid covers what neither catches alone.</a:t>
+              <a:t>Simulated: Normal 0/500 AE alarms (0% FPR), Phase 1 alone 81/100 AE alarms (81%), Invariant 10/10 (I-2+I-9). Hybrid catches all attack scenarios. Expected live: &gt;95%.</a:t>
             </a:r>
             <a:endParaRPr lang="en-US" sz="1050" dirty="0"/>
           </a:p>
@@ -27320,7 +27320,7 @@
                 <a:ea typeface="Calibri" pitchFamily="34" charset="-122"/>
                 <a:cs typeface="Calibri" pitchFamily="34" charset="-120"/>
               </a:rPr>
-              <a:t>Expected: &lt;3% for hybrid. 95th percentile threshold keeps AE FPR &lt;5%. 3-cycle confirmation window reduces inv false alarms.</a:t>
+              <a:t>Simulated: 0/500 false alarms on normal data (0.0% FPR). AE mean MSE=0.000128 vs threshold=0.000950 (7.4x margin). Invariant 0/10 false alarms. Expected live: &lt;3%.</a:t>
             </a:r>
             <a:endParaRPr lang="en-US" sz="1050" dirty="0"/>
           </a:p>
@@ -27443,7 +27443,7 @@
                 <a:ea typeface="Calibri" pitchFamily="34" charset="-122"/>
                 <a:cs typeface="Calibri" pitchFamily="34" charset="-120"/>
               </a:rPr>
-              <a:t>Target: &lt;15 seconds from ALERT to verified safe state. PLC1B failover &lt;3s. Five clean invariant cycles ~5s.</a:t>
+              <a:t>Simulated: test_all.py completed full 5-step recovery in &lt;12s on PLC simulator. 5/5 clean invariant cycles achieved. Target live: &lt;15s. PLC1B failover &lt;3s.</a:t>
             </a:r>
             <a:endParaRPr lang="en-US" sz="1050" dirty="0"/>
           </a:p>

</xml_diff>

<commit_message>
slides: update slide 28 with live testbed results (16 Apr 2026)
Detection Rate: Invariant detected cycle 1 (I-2/I-6/I-9/I-9b/I-9c), 104 violations.
  AE saturated at MSE=367 (FIT101=-31 sensor fault). LIT-only AE: 94% detection.
FPR: Phase 2 spoofed LIT101 609→1345mm while physical tank drained to 502mm (736mm gap).
  LIT-only simulated: 0/500 false alarms, MSE 19x below threshold.
Recovery: Fusion ALERT at 16:33:11 (3s). Safe state restored on PLC1+PLC2, Sim disabled.
</commit_message>
<xml_diff>
--- a/slides/swat_sutd.pptx
+++ b/slides/swat_sutd.pptx
@@ -27074,7 +27074,7 @@
                 <a:ea typeface="Calibri" pitchFamily="34" charset="-122"/>
                 <a:cs typeface="Calibri" pitchFamily="34" charset="-120"/>
               </a:rPr>
-              <a:t>Simulated test results (test_detectors.py) and expected live metrics</a:t>
+              <a:t>Live testbed results (16 Apr 2026) + simulated validation (test_detectors.py)</a:t>
             </a:r>
             <a:endParaRPr lang="en-US" sz="1200" dirty="0"/>
           </a:p>
@@ -27197,7 +27197,7 @@
                 <a:ea typeface="Calibri" pitchFamily="34" charset="-122"/>
                 <a:cs typeface="Calibri" pitchFamily="34" charset="-120"/>
               </a:rPr>
-              <a:t>Simulated: Normal 0/500 AE alarms (0% FPR), Phase 1 alone 81/100 AE alarms (81%), Invariant 10/10 (I-2+I-9). Hybrid catches all attack scenarios. Expected live: &gt;95%.</a:t>
+              <a:t>Live: Invariant detected on cycle 1 — I-2, I-6, I-9, I-9b, I-9c fired. 104 violation cycles logged. AE flagged MSE=367 (sensor fault). Simulated (LIT-only AE): 94/100 detection, 0% FPR. Hybrid catches all scenarios.</a:t>
             </a:r>
             <a:endParaRPr lang="en-US" sz="1050" dirty="0"/>
           </a:p>
@@ -27320,7 +27320,7 @@
                 <a:ea typeface="Calibri" pitchFamily="34" charset="-122"/>
                 <a:cs typeface="Calibri" pitchFamily="34" charset="-120"/>
               </a:rPr>
-              <a:t>Simulated: 0/500 false alarms on normal data (0.0% FPR). AE mean MSE=0.000128 vs threshold=0.000950 (7.4x margin). Invariant 0/10 false alarms. Expected live: &lt;3%.</a:t>
+              <a:t>Live: Phase 2 spoofed LIT101 from 609mm to 1345mm on HMI while physical tank drained to 502mm — 736mm concealment gap. Simulated (LIT-only AE): 0/500 false alarms (0.0% FPR), MSE 19x below threshold.</a:t>
             </a:r>
             <a:endParaRPr lang="en-US" sz="1050" dirty="0"/>
           </a:p>
@@ -27443,7 +27443,7 @@
                 <a:ea typeface="Calibri" pitchFamily="34" charset="-122"/>
                 <a:cs typeface="Calibri" pitchFamily="34" charset="-120"/>
               </a:rPr>
-              <a:t>Simulated: test_all.py completed full 5-step recovery in &lt;12s on PLC simulator. 5/5 clean invariant cycles achieved. Target live: &lt;15s. PLC1B failover &lt;3s.</a:t>
+              <a:t>Live: Fusion ALERT at 16:33:11 (3s after defence started). Recovery restored safe state on PLC1+PLC2, disabled Sim tags. Post-recovery LIT101=502mm. Simulated: full 5-step recovery in &lt;12s on PLC simulator.</a:t>
             </a:r>
             <a:endParaRPr lang="en-US" sz="1050" dirty="0"/>
           </a:p>

</xml_diff>

<commit_message>
docs: expanded Live Testbed Evaluation with tables + discussion
Report §7 Live Testbed Evaluation now includes:
- Detection Rate table: time vs rate separated, I-9b/I-9c excluded
- False Positive Rate table: live inconclusive (baseline fault), simulated 0%
- Recovery Time table: 3s fusion match, write race finding documented
- Caveat subsection: FIT101=-31 saturation, AE retrained LIT-only
- Key Finding: actuator-command invariants immune to sensor-level evasion

Slide 28 updated with same revised metrics:
- DR: cycle 1 (I-2+I-9), AE time vs rate separated
- FPR: live inconclusive, 736mm concealment gap
- RT: 3s exact match, write race + containment finding
</commit_message>
<xml_diff>
--- a/slides/swat_sutd.pptx
+++ b/slides/swat_sutd.pptx
@@ -27197,7 +27197,7 @@
                 <a:ea typeface="Calibri" pitchFamily="34" charset="-122"/>
                 <a:cs typeface="Calibri" pitchFamily="34" charset="-120"/>
               </a:rPr>
-              <a:t>Live: Invariant detected on cycle 1 — I-2, I-6, I-9, I-9b, I-9c fired. 104 violation cycles logged. AE flagged MSE=367 (sensor fault). Simulated (LIT-only AE): 94/100 detection, 0% FPR. Hybrid catches all scenarios.</a:t>
+              <a:t>Live: Invariant detected cycle 1 (I-2 + I-9). I-9b/I-9c also fired but excluded (supplementary rules). 104 violation cycles. AE detection time: 10s (window fills). Simulated AE detection rate (LIT-only): 94/100 (94%). AE evasion by Phase 2: inconclusive on live (FIT101=-31 saturated AE).</a:t>
             </a:r>
             <a:endParaRPr lang="en-US" sz="1050" dirty="0"/>
           </a:p>
@@ -27320,7 +27320,7 @@
                 <a:ea typeface="Calibri" pitchFamily="34" charset="-122"/>
                 <a:cs typeface="Calibri" pitchFamily="34" charset="-120"/>
               </a:rPr>
-              <a:t>Live: Phase 2 spoofed LIT101 from 609mm to 1345mm on HMI while physical tank drained to 502mm — 736mm concealment gap. Simulated (LIT-only AE): 0/500 false alarms (0.0% FPR), MSE 19x below threshold.</a:t>
+              <a:t>Live FPR: Inconclusive — plant started in attack-equivalent state (MV101=CLOSED, FIT101=-31). Invariants correctly identified unsafe config (true positive). Phase 2 concealment: 736mm gap (HMI 1345mm vs physical 502mm). Simulated: 0/500 AE false alarms (0.0%), MSE 19x below threshold.</a:t>
             </a:r>
             <a:endParaRPr lang="en-US" sz="1050" dirty="0"/>
           </a:p>
@@ -27443,7 +27443,7 @@
                 <a:ea typeface="Calibri" pitchFamily="34" charset="-122"/>
                 <a:cs typeface="Calibri" pitchFamily="34" charset="-120"/>
               </a:rPr>
-              <a:t>Live: Fusion ALERT at 16:33:11 (3s after defence started). Recovery restored safe state on PLC1+PLC2, disabled Sim tags. Post-recovery LIT101=502mm. Simulated: full 5-step recovery in &lt;12s on PLC simulator.</a:t>
+              <a:t>Live: Fusion ALERT in 3s (exact match with design). Recovery writes completed &lt;5s. But safe state did not hold — Phase 1 re-injected MV101=CLOSED every cycle (write race). Plant stabilised ~30s after attack ended. Finding: containment (iptables block) must precede safe-state writes. Simulated: &lt;12s total.</a:t>
             </a:r>
             <a:endParaRPr lang="en-US" sz="1050" dirty="0"/>
           </a:p>

</xml_diff>

<commit_message>
docs: add detailed DR/FPR/RT slides + expanded report evaluation
Slides (49 → 52 slides):
- Slide 28: Summary overview (attack execution, key finding, evidence)
- Slide 29 (new): Detection Rate — invariant 1s, AE 10s/94%, I-9b/I-9c excluded
- Slide 30 (new): False Positive Rate — live inconclusive, simulated 0%, interpretation
- Slide 31 (new): Recovery Time — fusion 3s exact match, write race finding

Report Live Testbed Evaluation:
- 3 formatted tables (DR/FPR/RT) with Expected vs Live vs Simulated
- Write race finding: recovery fought Phase 1 concurrently
- Containment prerequisite: iptables must block before safe-state holds
- I-9b/I-9c excluded from primary detection claim
- AE saturation caveat + LIT-only remediation documented
</commit_message>
<xml_diff>
--- a/slides/swat_sutd.pptx
+++ b/slides/swat_sutd.pptx
@@ -38,6 +38,9 @@
     <p:sldId id="286" r:id="rId32"/>
     <p:sldId id="287" r:id="rId33"/>
     <p:sldId id="288" r:id="rId34"/>
+    <p:sldId id="306" r:id="rId56"/>
+    <p:sldId id="307" r:id="rId57"/>
+    <p:sldId id="308" r:id="rId58"/>
     <p:sldId id="289" r:id="rId35"/>
     <p:sldId id="290" r:id="rId36"/>
     <p:sldId id="291" r:id="rId37"/>
@@ -27074,7 +27077,7 @@
                 <a:ea typeface="Calibri" pitchFamily="34" charset="-122"/>
                 <a:cs typeface="Calibri" pitchFamily="34" charset="-120"/>
               </a:rPr>
-              <a:t>Live testbed results (16 Apr 2026) + simulated validation (test_detectors.py)</a:t>
+              <a:t>Live SWaT testbed (16 Apr 2026) — Attack confirmed, defence validated</a:t>
             </a:r>
             <a:endParaRPr lang="en-US" sz="1200" dirty="0"/>
           </a:p>
@@ -27158,7 +27161,7 @@
                 <a:ea typeface="Calibri" pitchFamily="34" charset="-122"/>
                 <a:cs typeface="Calibri" pitchFamily="34" charset="-120"/>
               </a:rPr>
-              <a:t>Detection Rate (DR)</a:t>
+              <a:t>Attack Execution</a:t>
             </a:r>
             <a:endParaRPr lang="en-US" sz="1100" dirty="0"/>
           </a:p>
@@ -27197,7 +27200,7 @@
                 <a:ea typeface="Calibri" pitchFamily="34" charset="-122"/>
                 <a:cs typeface="Calibri" pitchFamily="34" charset="-120"/>
               </a:rPr>
-              <a:t>Live: Invariant detected cycle 1 (I-2 + I-9). I-9b/I-9c also fired but excluded (supplementary rules). 104 violation cycles. AE detection time: 10s (window fills). Simulated AE detection rate (LIT-only): 94/100 (94%). AE evasion by Phase 2: inconclusive on live (FIT101=-31 saturated AE).</a:t>
+              <a:t>Phase 1: 120 CIP writes 2014 MV101=CLOSED, P101=ON, MV201=OPEN. Physical tank drained from 609mm to 502mm (107mm drop, ~0.9mm/s). Phase 2: 106 adversarial Sim_PV cycles 2014 HMI showed LIT101=1345mm while physical tank was at ~502mm. 736mm concealment gap confirmed on-site.</a:t>
             </a:r>
             <a:endParaRPr lang="en-US" sz="1050" dirty="0"/>
           </a:p>
@@ -27281,7 +27284,7 @@
                 <a:ea typeface="Calibri" pitchFamily="34" charset="-122"/>
                 <a:cs typeface="Calibri" pitchFamily="34" charset="-120"/>
               </a:rPr>
-              <a:t>False Positive Rate (FPR)</a:t>
+              <a:t>Key Finding</a:t>
             </a:r>
             <a:endParaRPr lang="en-US" sz="1100" dirty="0"/>
           </a:p>
@@ -27320,7 +27323,7 @@
                 <a:ea typeface="Calibri" pitchFamily="34" charset="-122"/>
                 <a:cs typeface="Calibri" pitchFamily="34" charset="-120"/>
               </a:rPr>
-              <a:t>Live FPR: Inconclusive — plant started in attack-equivalent state (MV101=CLOSED, FIT101=-31). Invariants correctly identified unsafe config (true positive). Phase 2 concealment: 736mm gap (HMI 1345mm vs physical 502mm). Simulated: 0/500 AE false alarms (0.0%), MSE 19x below threshold.</a:t>
+              <a:t>Invariant layer detected attack within 1 cycle by reading actuator commands (HMI_MV101.Cmd, HMI_P101.Auto) via CIP 2014 these cannot be spoofed by sensor-level Sim_PV writes. Phase 2 completely deceived the HMI, but the hybrid defence caught it anyway. This validates the core thesis: physics-based invariants provide a detection channel immune to ML evasion.</a:t>
             </a:r>
             <a:endParaRPr lang="en-US" sz="1050" dirty="0"/>
           </a:p>
@@ -27404,7 +27407,7 @@
                 <a:ea typeface="Calibri" pitchFamily="34" charset="-122"/>
                 <a:cs typeface="Calibri" pitchFamily="34" charset="-120"/>
               </a:rPr>
-              <a:t>Recovery Time (RT)</a:t>
+              <a:t>Evidence</a:t>
             </a:r>
             <a:endParaRPr lang="en-US" sz="1100" dirty="0"/>
           </a:p>
@@ -27443,7 +27446,7 @@
                 <a:ea typeface="Calibri" pitchFamily="34" charset="-122"/>
                 <a:cs typeface="Calibri" pitchFamily="34" charset="-120"/>
               </a:rPr>
-              <a:t>Live: Fusion ALERT in 3s (exact match with design). Recovery writes completed &lt;5s. But safe state did not hold — Phase 1 re-injected MV101=CLOSED every cycle (write race). Plant stabilised ~30s after attack ended. Finding: containment (iptables block) must precede safe-state writes. Simulated: &lt;12s total.</a:t>
+              <a:t>104 invariant violations logged. Fusion ALERT in 3s. Recovery restored PLC1+PLC2 safe state. All evidence archived: invariant_checker.log, autoencoder.log, fusion.log, phase1.log, phase2.log, state snapshots, timeline.json. Detailed metrics on following 3 slides.</a:t>
             </a:r>
             <a:endParaRPr lang="en-US" sz="1050" dirty="0"/>
           </a:p>
@@ -51086,6 +51089,1910 @@
                 <a:cs typeface="Calibri" pitchFamily="34" charset="-120"/>
               </a:rPr>
               <a:t>Phase 1 concealment replays valid sensor history</a:t>
+            </a:r>
+            <a:endParaRPr lang="en-US" sz="1050" dirty="0"/>
+          </a:p>
+        </p:txBody>
+      </p:sp>
+    </p:spTree>
+  </p:cSld>
+  <p:clrMapOvr>
+    <a:masterClrMapping/>
+  </p:clrMapOvr>
+</p:sld>
+</file>
+
+<file path=ppt/slides/slide50.xml><?xml version="1.0" encoding="utf-8"?>
+<p:sld xmlns:a="http://schemas.openxmlformats.org/drawingml/2006/main" xmlns:r="http://schemas.openxmlformats.org/officeDocument/2006/relationships" xmlns:p="http://schemas.openxmlformats.org/presentationml/2006/main">
+  <p:cSld name="Slide 28">
+    <p:spTree>
+      <p:nvGrpSpPr>
+        <p:cNvPr id="1" name=""/>
+        <p:cNvGrpSpPr/>
+        <p:nvPr/>
+      </p:nvGrpSpPr>
+      <p:grpSpPr>
+        <a:xfrm>
+          <a:off x="0" y="0"/>
+          <a:ext cx="0" cy="0"/>
+          <a:chOff x="0" y="0"/>
+          <a:chExt cx="0" cy="0"/>
+        </a:xfrm>
+      </p:grpSpPr>
+      <p:sp>
+        <p:nvSpPr>
+          <p:cNvPr id="2" name="Shape 0"/>
+          <p:cNvSpPr/>
+          <p:nvPr/>
+        </p:nvSpPr>
+        <p:spPr>
+          <a:xfrm>
+            <a:off x="0" y="0"/>
+            <a:ext cx="12188952" cy="6858000"/>
+          </a:xfrm>
+          <a:prstGeom prst="rect">
+            <a:avLst/>
+          </a:prstGeom>
+          <a:solidFill>
+            <a:srgbClr val="FFFFFF"/>
+          </a:solidFill>
+          <a:ln/>
+        </p:spPr>
+      </p:sp>
+      <p:sp>
+        <p:nvSpPr>
+          <p:cNvPr id="3" name="Shape 1"/>
+          <p:cNvSpPr/>
+          <p:nvPr/>
+        </p:nvSpPr>
+        <p:spPr>
+          <a:xfrm>
+            <a:off x="0" y="0"/>
+            <a:ext cx="12188952" cy="64008"/>
+          </a:xfrm>
+          <a:prstGeom prst="rect">
+            <a:avLst/>
+          </a:prstGeom>
+          <a:solidFill>
+            <a:srgbClr val="E8243C"/>
+          </a:solidFill>
+          <a:ln/>
+        </p:spPr>
+      </p:sp>
+      <p:sp>
+        <p:nvSpPr>
+          <p:cNvPr id="4" name="Shape 2"/>
+          <p:cNvSpPr/>
+          <p:nvPr/>
+        </p:nvSpPr>
+        <p:spPr>
+          <a:xfrm>
+            <a:off x="0" y="6510528"/>
+            <a:ext cx="12188952" cy="347472"/>
+          </a:xfrm>
+          <a:prstGeom prst="rect">
+            <a:avLst/>
+          </a:prstGeom>
+          <a:solidFill>
+            <a:srgbClr val="F5F5F5"/>
+          </a:solidFill>
+          <a:ln/>
+        </p:spPr>
+      </p:sp>
+      <p:sp>
+        <p:nvSpPr>
+          <p:cNvPr id="5" name="Text 3"/>
+          <p:cNvSpPr/>
+          <p:nvPr/>
+        </p:nvSpPr>
+        <p:spPr>
+          <a:xfrm>
+            <a:off x="274320" y="6565392"/>
+            <a:ext cx="11640312" cy="219456"/>
+          </a:xfrm>
+          <a:prstGeom prst="rect">
+            <a:avLst/>
+          </a:prstGeom>
+          <a:noFill/>
+          <a:ln/>
+        </p:spPr>
+        <p:txBody>
+          <a:bodyPr wrap="square" rtlCol="0" anchor="ctr"/>
+          <a:lstStyle/>
+          <a:p>
+            <a:pPr algn="l" indent="0" marL="0">
+              <a:buNone/>
+            </a:pPr>
+            <a:r>
+              <a:rPr lang="en-US" sz="800" dirty="0">
+                <a:solidFill>
+                  <a:srgbClr val="6B6B6B"/>
+                </a:solidFill>
+                <a:latin typeface="Calibri" pitchFamily="34" charset="0"/>
+                <a:ea typeface="Calibri" pitchFamily="34" charset="-122"/>
+                <a:cs typeface="Calibri" pitchFamily="34" charset="-120"/>
+              </a:rPr>
+              <a:t>51.508 Secure Cyber Physical Systems  ·  SWaT Project  ·  iTrust Lab, SUTD</a:t>
+            </a:r>
+            <a:endParaRPr lang="en-US" sz="800" dirty="0"/>
+          </a:p>
+        </p:txBody>
+      </p:sp>
+      <p:sp>
+        <p:nvSpPr>
+          <p:cNvPr id="6" name="Shape 4"/>
+          <p:cNvSpPr/>
+          <p:nvPr/>
+        </p:nvSpPr>
+        <p:spPr>
+          <a:xfrm>
+            <a:off x="320040" y="109728"/>
+            <a:ext cx="1280160" cy="292608"/>
+          </a:xfrm>
+          <a:prstGeom prst="rect">
+            <a:avLst/>
+          </a:prstGeom>
+          <a:solidFill>
+            <a:srgbClr val="2E7D32"/>
+          </a:solidFill>
+          <a:ln/>
+        </p:spPr>
+      </p:sp>
+      <p:sp>
+        <p:nvSpPr>
+          <p:cNvPr id="7" name="Text 5"/>
+          <p:cNvSpPr/>
+          <p:nvPr/>
+        </p:nvSpPr>
+        <p:spPr>
+          <a:xfrm>
+            <a:off x="320040" y="109728"/>
+            <a:ext cx="1280160" cy="292608"/>
+          </a:xfrm>
+          <a:prstGeom prst="rect">
+            <a:avLst/>
+          </a:prstGeom>
+          <a:noFill/>
+          <a:ln/>
+        </p:spPr>
+        <p:txBody>
+          <a:bodyPr wrap="square" rtlCol="0" anchor="ctr"/>
+          <a:lstStyle/>
+          <a:p>
+            <a:pPr algn="ctr" indent="0" marL="0">
+              <a:buNone/>
+            </a:pPr>
+            <a:r>
+              <a:rPr lang="en-US" sz="1000" b="1" dirty="0">
+                <a:solidFill>
+                  <a:srgbClr val="FFFFFF"/>
+                </a:solidFill>
+                <a:latin typeface="Calibri" pitchFamily="34" charset="0"/>
+                <a:ea typeface="Calibri" pitchFamily="34" charset="-122"/>
+                <a:cs typeface="Calibri" pitchFamily="34" charset="-120"/>
+              </a:rPr>
+              <a:t>EVAL</a:t>
+            </a:r>
+            <a:endParaRPr lang="en-US" sz="1000" dirty="0"/>
+          </a:p>
+        </p:txBody>
+      </p:sp>
+      <p:sp>
+        <p:nvSpPr>
+          <p:cNvPr id="8" name="Text 6"/>
+          <p:cNvSpPr/>
+          <p:nvPr/>
+        </p:nvSpPr>
+        <p:spPr>
+          <a:xfrm>
+            <a:off x="320040" y="457200"/>
+            <a:ext cx="11548872" cy="640080"/>
+          </a:xfrm>
+          <a:prstGeom prst="rect">
+            <a:avLst/>
+          </a:prstGeom>
+          <a:noFill/>
+          <a:ln/>
+        </p:spPr>
+        <p:txBody>
+          <a:bodyPr wrap="square" rtlCol="0" anchor="ctr"/>
+          <a:lstStyle/>
+          <a:p>
+            <a:pPr indent="0" marL="0">
+              <a:buNone/>
+            </a:pPr>
+            <a:r>
+              <a:rPr lang="en-US" sz="3200" b="1" dirty="0">
+                <a:solidFill>
+                  <a:srgbClr val="1A1A1A"/>
+                </a:solidFill>
+                <a:latin typeface="Calibri Light" pitchFamily="34" charset="0"/>
+                <a:ea typeface="Calibri Light" pitchFamily="34" charset="-122"/>
+                <a:cs typeface="Calibri Light" pitchFamily="34" charset="-120"/>
+              </a:rPr>
+              <a:t>Detection Rate 2014 Live vs Expected vs Simulated</a:t>
+            </a:r>
+            <a:endParaRPr lang="en-US" sz="3200" dirty="0"/>
+          </a:p>
+        </p:txBody>
+      </p:sp>
+      <p:sp>
+        <p:nvSpPr>
+          <p:cNvPr id="9" name="Text 7"/>
+          <p:cNvSpPr/>
+          <p:nvPr/>
+        </p:nvSpPr>
+        <p:spPr>
+          <a:xfrm>
+            <a:off x="320040" y="1051560"/>
+            <a:ext cx="11548872" cy="256032"/>
+          </a:xfrm>
+          <a:prstGeom prst="rect">
+            <a:avLst/>
+          </a:prstGeom>
+          <a:noFill/>
+          <a:ln/>
+        </p:spPr>
+        <p:txBody>
+          <a:bodyPr wrap="square" rtlCol="0" anchor="ctr"/>
+          <a:lstStyle/>
+          <a:p>
+            <a:pPr indent="0" marL="0">
+              <a:buNone/>
+            </a:pPr>
+            <a:r>
+              <a:rPr lang="en-US" sz="1200" i="1" dirty="0">
+                <a:solidFill>
+                  <a:srgbClr val="6B6B6B"/>
+                </a:solidFill>
+                <a:latin typeface="Calibri" pitchFamily="34" charset="0"/>
+                <a:ea typeface="Calibri" pitchFamily="34" charset="-122"/>
+                <a:cs typeface="Calibri" pitchFamily="34" charset="-120"/>
+              </a:rPr>
+              <a:t>How fast and how reliably does the defence detect Phase 1?</a:t>
+            </a:r>
+            <a:endParaRPr lang="en-US" sz="1200" dirty="0"/>
+          </a:p>
+        </p:txBody>
+      </p:sp>
+      <p:sp>
+        <p:nvSpPr>
+          <p:cNvPr id="10" name="Shape 8"/>
+          <p:cNvSpPr/>
+          <p:nvPr/>
+        </p:nvSpPr>
+        <p:spPr>
+          <a:xfrm>
+            <a:off x="320040" y="1463040"/>
+            <a:ext cx="11548872" cy="1143000"/>
+          </a:xfrm>
+          <a:prstGeom prst="rect">
+            <a:avLst/>
+          </a:prstGeom>
+          <a:solidFill>
+            <a:srgbClr val="F5F5F5"/>
+          </a:solidFill>
+          <a:ln w="12700">
+            <a:solidFill>
+              <a:srgbClr val="E0E0E0"/>
+            </a:solidFill>
+            <a:prstDash val="solid"/>
+          </a:ln>
+        </p:spPr>
+      </p:sp>
+      <p:sp>
+        <p:nvSpPr>
+          <p:cNvPr id="11" name="Shape 9"/>
+          <p:cNvSpPr/>
+          <p:nvPr/>
+        </p:nvSpPr>
+        <p:spPr>
+          <a:xfrm>
+            <a:off x="320040" y="1463040"/>
+            <a:ext cx="54864" cy="1143000"/>
+          </a:xfrm>
+          <a:prstGeom prst="rect">
+            <a:avLst/>
+          </a:prstGeom>
+          <a:solidFill>
+            <a:srgbClr val="2E7D32"/>
+          </a:solidFill>
+          <a:ln/>
+        </p:spPr>
+      </p:sp>
+      <p:sp>
+        <p:nvSpPr>
+          <p:cNvPr id="12" name="Text 10"/>
+          <p:cNvSpPr/>
+          <p:nvPr/>
+        </p:nvSpPr>
+        <p:spPr>
+          <a:xfrm>
+            <a:off x="502920" y="1536192"/>
+            <a:ext cx="11365992" cy="274320"/>
+          </a:xfrm>
+          <a:prstGeom prst="rect">
+            <a:avLst/>
+          </a:prstGeom>
+          <a:noFill/>
+          <a:ln/>
+        </p:spPr>
+        <p:txBody>
+          <a:bodyPr wrap="square" rtlCol="0" anchor="ctr"/>
+          <a:lstStyle/>
+          <a:p>
+            <a:pPr indent="0" marL="0">
+              <a:buNone/>
+            </a:pPr>
+            <a:r>
+              <a:rPr lang="en-US" sz="1100" b="1" dirty="0">
+                <a:solidFill>
+                  <a:srgbClr val="2E7D32"/>
+                </a:solidFill>
+                <a:latin typeface="Calibri" pitchFamily="34" charset="0"/>
+                <a:ea typeface="Calibri" pitchFamily="34" charset="-122"/>
+                <a:cs typeface="Calibri" pitchFamily="34" charset="-120"/>
+              </a:rPr>
+              <a:t>Invariant Detection Time</a:t>
+            </a:r>
+            <a:endParaRPr lang="en-US" sz="1100" dirty="0"/>
+          </a:p>
+        </p:txBody>
+      </p:sp>
+      <p:sp>
+        <p:nvSpPr>
+          <p:cNvPr id="13" name="Text 11"/>
+          <p:cNvSpPr/>
+          <p:nvPr/>
+        </p:nvSpPr>
+        <p:spPr>
+          <a:xfrm>
+            <a:off x="502920" y="1828800"/>
+            <a:ext cx="11365992" cy="667512"/>
+          </a:xfrm>
+          <a:prstGeom prst="rect">
+            <a:avLst/>
+          </a:prstGeom>
+          <a:noFill/>
+          <a:ln/>
+        </p:spPr>
+        <p:txBody>
+          <a:bodyPr wrap="square" rtlCol="0" anchor="t"/>
+          <a:lstStyle/>
+          <a:p>
+            <a:pPr indent="0" marL="0">
+              <a:buNone/>
+            </a:pPr>
+            <a:r>
+              <a:rPr lang="en-US" sz="1050" dirty="0">
+                <a:solidFill>
+                  <a:srgbClr val="2D2D2D"/>
+                </a:solidFill>
+                <a:latin typeface="Calibri" pitchFamily="34" charset="0"/>
+                <a:ea typeface="Calibri" pitchFamily="34" charset="-122"/>
+                <a:cs typeface="Calibri" pitchFamily="34" charset="-120"/>
+              </a:rPr>
+              <a:t>Expected: 120136s. Live: 1s (cycle 1, I-2 + I-9 fired). Simulated: 1s (cycle 1). I-9 is the Phase 1 signature invariant: MV101=CLOSED + P101=ON in normal range. I-9b/I-9c also fired but excluded from primary claim (supplementary rules for PLC failover and sensor fault edge cases). 104 total violation cycles over the 120s attack.</a:t>
+            </a:r>
+            <a:endParaRPr lang="en-US" sz="1050" dirty="0"/>
+          </a:p>
+        </p:txBody>
+      </p:sp>
+      <p:sp>
+        <p:nvSpPr>
+          <p:cNvPr id="14" name="Shape 12"/>
+          <p:cNvSpPr/>
+          <p:nvPr/>
+        </p:nvSpPr>
+        <p:spPr>
+          <a:xfrm>
+            <a:off x="320040" y="2743200"/>
+            <a:ext cx="11548872" cy="1143000"/>
+          </a:xfrm>
+          <a:prstGeom prst="rect">
+            <a:avLst/>
+          </a:prstGeom>
+          <a:solidFill>
+            <a:srgbClr val="F5F5F5"/>
+          </a:solidFill>
+          <a:ln w="12700">
+            <a:solidFill>
+              <a:srgbClr val="E0E0E0"/>
+            </a:solidFill>
+            <a:prstDash val="solid"/>
+          </a:ln>
+        </p:spPr>
+      </p:sp>
+      <p:sp>
+        <p:nvSpPr>
+          <p:cNvPr id="15" name="Shape 13"/>
+          <p:cNvSpPr/>
+          <p:nvPr/>
+        </p:nvSpPr>
+        <p:spPr>
+          <a:xfrm>
+            <a:off x="320040" y="2743200"/>
+            <a:ext cx="54864" cy="1143000"/>
+          </a:xfrm>
+          <a:prstGeom prst="rect">
+            <a:avLst/>
+          </a:prstGeom>
+          <a:solidFill>
+            <a:srgbClr val="2E7D32"/>
+          </a:solidFill>
+          <a:ln/>
+        </p:spPr>
+      </p:sp>
+      <p:sp>
+        <p:nvSpPr>
+          <p:cNvPr id="16" name="Text 14"/>
+          <p:cNvSpPr/>
+          <p:nvPr/>
+        </p:nvSpPr>
+        <p:spPr>
+          <a:xfrm>
+            <a:off x="502920" y="2816352"/>
+            <a:ext cx="11365992" cy="274320"/>
+          </a:xfrm>
+          <a:prstGeom prst="rect">
+            <a:avLst/>
+          </a:prstGeom>
+          <a:noFill/>
+          <a:ln/>
+        </p:spPr>
+        <p:txBody>
+          <a:bodyPr wrap="square" rtlCol="0" anchor="ctr"/>
+          <a:lstStyle/>
+          <a:p>
+            <a:pPr indent="0" marL="0">
+              <a:buNone/>
+            </a:pPr>
+            <a:r>
+              <a:rPr lang="en-US" sz="1100" b="1" dirty="0">
+                <a:solidFill>
+                  <a:srgbClr val="2E7D32"/>
+                </a:solidFill>
+                <a:latin typeface="Calibri" pitchFamily="34" charset="0"/>
+                <a:ea typeface="Calibri" pitchFamily="34" charset="-122"/>
+                <a:cs typeface="Calibri" pitchFamily="34" charset="-120"/>
+              </a:rPr>
+              <a:t>AE Detection Time + Rate</a:t>
+            </a:r>
+            <a:endParaRPr lang="en-US" sz="1100" dirty="0"/>
+          </a:p>
+        </p:txBody>
+      </p:sp>
+      <p:sp>
+        <p:nvSpPr>
+          <p:cNvPr id="17" name="Text 15"/>
+          <p:cNvSpPr/>
+          <p:nvPr/>
+        </p:nvSpPr>
+        <p:spPr>
+          <a:xfrm>
+            <a:off x="502920" y="3108960"/>
+            <a:ext cx="11365992" cy="667512"/>
+          </a:xfrm>
+          <a:prstGeom prst="rect">
+            <a:avLst/>
+          </a:prstGeom>
+          <a:noFill/>
+          <a:ln/>
+        </p:spPr>
+        <p:txBody>
+          <a:bodyPr wrap="square" rtlCol="0" anchor="t"/>
+          <a:lstStyle/>
+          <a:p>
+            <a:pPr indent="0" marL="0">
+              <a:buNone/>
+            </a:pPr>
+            <a:r>
+              <a:rPr lang="en-US" sz="1050" dirty="0">
+                <a:solidFill>
+                  <a:srgbClr val="2D2D2D"/>
+                </a:solidFill>
+                <a:latin typeface="Calibri" pitchFamily="34" charset="0"/>
+                <a:ea typeface="Calibri" pitchFamily="34" charset="-122"/>
+                <a:cs typeface="Calibri" pitchFamily="34" charset="-120"/>
+              </a:rPr>
+              <a:t>Expected time: 10201315s (window=10 must fill). Live: 10s (cycle 10). Expected rate: &gt;90%. Simulated (LIT-only AE): 94/100 = 94%. Live rate: inconclusive 2014 FIT101=-31 sensor fault produced MSE=367 (500,00000d7 above threshold), saturating the AE before Phase 2 even started. Models retrained on LIT101 only to prevent this.</a:t>
+            </a:r>
+            <a:endParaRPr lang="en-US" sz="1050" dirty="0"/>
+          </a:p>
+        </p:txBody>
+      </p:sp>
+      <p:sp>
+        <p:nvSpPr>
+          <p:cNvPr id="18" name="Shape 16"/>
+          <p:cNvSpPr/>
+          <p:nvPr/>
+        </p:nvSpPr>
+        <p:spPr>
+          <a:xfrm>
+            <a:off x="320040" y="4023360"/>
+            <a:ext cx="11548872" cy="1143000"/>
+          </a:xfrm>
+          <a:prstGeom prst="rect">
+            <a:avLst/>
+          </a:prstGeom>
+          <a:solidFill>
+            <a:srgbClr val="F5F5F5"/>
+          </a:solidFill>
+          <a:ln w="12700">
+            <a:solidFill>
+              <a:srgbClr val="E0E0E0"/>
+            </a:solidFill>
+            <a:prstDash val="solid"/>
+          </a:ln>
+        </p:spPr>
+      </p:sp>
+      <p:sp>
+        <p:nvSpPr>
+          <p:cNvPr id="19" name="Shape 17"/>
+          <p:cNvSpPr/>
+          <p:nvPr/>
+        </p:nvSpPr>
+        <p:spPr>
+          <a:xfrm>
+            <a:off x="320040" y="4023360"/>
+            <a:ext cx="54864" cy="1143000"/>
+          </a:xfrm>
+          <a:prstGeom prst="rect">
+            <a:avLst/>
+          </a:prstGeom>
+          <a:solidFill>
+            <a:srgbClr val="2E7D32"/>
+          </a:solidFill>
+          <a:ln/>
+        </p:spPr>
+      </p:sp>
+      <p:sp>
+        <p:nvSpPr>
+          <p:cNvPr id="20" name="Text 18"/>
+          <p:cNvSpPr/>
+          <p:nvPr/>
+        </p:nvSpPr>
+        <p:spPr>
+          <a:xfrm>
+            <a:off x="502920" y="4096512"/>
+            <a:ext cx="11365992" cy="274320"/>
+          </a:xfrm>
+          <a:prstGeom prst="rect">
+            <a:avLst/>
+          </a:prstGeom>
+          <a:noFill/>
+          <a:ln/>
+        </p:spPr>
+        <p:txBody>
+          <a:bodyPr wrap="square" rtlCol="0" anchor="ctr"/>
+          <a:lstStyle/>
+          <a:p>
+            <a:pPr indent="0" marL="0">
+              <a:buNone/>
+            </a:pPr>
+            <a:r>
+              <a:rPr lang="en-US" sz="1100" b="1" dirty="0">
+                <a:solidFill>
+                  <a:srgbClr val="2E7D32"/>
+                </a:solidFill>
+                <a:latin typeface="Calibri" pitchFamily="34" charset="0"/>
+                <a:ea typeface="Calibri" pitchFamily="34" charset="-122"/>
+                <a:cs typeface="Calibri" pitchFamily="34" charset="-120"/>
+              </a:rPr>
+              <a:t>Hybrid Detection Under Phase 1+2</a:t>
+            </a:r>
+            <a:endParaRPr lang="en-US" sz="1100" dirty="0"/>
+          </a:p>
+        </p:txBody>
+      </p:sp>
+      <p:sp>
+        <p:nvSpPr>
+          <p:cNvPr id="21" name="Text 19"/>
+          <p:cNvSpPr/>
+          <p:nvPr/>
+        </p:nvSpPr>
+        <p:spPr>
+          <a:xfrm>
+            <a:off x="502920" y="4389120"/>
+            <a:ext cx="11365992" cy="667512"/>
+          </a:xfrm>
+          <a:prstGeom prst="rect">
+            <a:avLst/>
+          </a:prstGeom>
+          <a:noFill/>
+          <a:ln/>
+        </p:spPr>
+        <p:txBody>
+          <a:bodyPr wrap="square" rtlCol="0" anchor="t"/>
+          <a:lstStyle/>
+          <a:p>
+            <a:pPr indent="0" marL="0">
+              <a:buNone/>
+            </a:pPr>
+            <a:r>
+              <a:rPr lang="en-US" sz="1050" dirty="0">
+                <a:solidFill>
+                  <a:srgbClr val="2D2D2D"/>
+                </a:solidFill>
+                <a:latin typeface="Calibri" pitchFamily="34" charset="0"/>
+                <a:ea typeface="Calibri" pitchFamily="34" charset="-122"/>
+                <a:cs typeface="Calibri" pitchFamily="34" charset="-120"/>
+              </a:rPr>
+              <a:t>Expected: 120136s (invariant catches, AE may be evaded). Live: 1s (invariant). AE evasion by Phase 2 not independently measurable (FIT101 fault confounded). Simulated: invariant 10/10 regardless of evasion. Phase 2 concealment gap: 736mm (HMI showed 1345mm, physical ~502mm). Core thesis confirmed: actuator-command invariants cannot be evaded by sensor-level perturbation.</a:t>
+            </a:r>
+            <a:endParaRPr lang="en-US" sz="1050" dirty="0"/>
+          </a:p>
+        </p:txBody>
+      </p:sp>
+    </p:spTree>
+  </p:cSld>
+  <p:clrMapOvr>
+    <a:masterClrMapping/>
+  </p:clrMapOvr>
+</p:sld>
+</file>
+
+<file path=ppt/slides/slide51.xml><?xml version="1.0" encoding="utf-8"?>
+<p:sld xmlns:a="http://schemas.openxmlformats.org/drawingml/2006/main" xmlns:r="http://schemas.openxmlformats.org/officeDocument/2006/relationships" xmlns:p="http://schemas.openxmlformats.org/presentationml/2006/main">
+  <p:cSld name="Slide 28">
+    <p:spTree>
+      <p:nvGrpSpPr>
+        <p:cNvPr id="1" name=""/>
+        <p:cNvGrpSpPr/>
+        <p:nvPr/>
+      </p:nvGrpSpPr>
+      <p:grpSpPr>
+        <a:xfrm>
+          <a:off x="0" y="0"/>
+          <a:ext cx="0" cy="0"/>
+          <a:chOff x="0" y="0"/>
+          <a:chExt cx="0" cy="0"/>
+        </a:xfrm>
+      </p:grpSpPr>
+      <p:sp>
+        <p:nvSpPr>
+          <p:cNvPr id="2" name="Shape 0"/>
+          <p:cNvSpPr/>
+          <p:nvPr/>
+        </p:nvSpPr>
+        <p:spPr>
+          <a:xfrm>
+            <a:off x="0" y="0"/>
+            <a:ext cx="12188952" cy="6858000"/>
+          </a:xfrm>
+          <a:prstGeom prst="rect">
+            <a:avLst/>
+          </a:prstGeom>
+          <a:solidFill>
+            <a:srgbClr val="FFFFFF"/>
+          </a:solidFill>
+          <a:ln/>
+        </p:spPr>
+      </p:sp>
+      <p:sp>
+        <p:nvSpPr>
+          <p:cNvPr id="3" name="Shape 1"/>
+          <p:cNvSpPr/>
+          <p:nvPr/>
+        </p:nvSpPr>
+        <p:spPr>
+          <a:xfrm>
+            <a:off x="0" y="0"/>
+            <a:ext cx="12188952" cy="64008"/>
+          </a:xfrm>
+          <a:prstGeom prst="rect">
+            <a:avLst/>
+          </a:prstGeom>
+          <a:solidFill>
+            <a:srgbClr val="E8243C"/>
+          </a:solidFill>
+          <a:ln/>
+        </p:spPr>
+      </p:sp>
+      <p:sp>
+        <p:nvSpPr>
+          <p:cNvPr id="4" name="Shape 2"/>
+          <p:cNvSpPr/>
+          <p:nvPr/>
+        </p:nvSpPr>
+        <p:spPr>
+          <a:xfrm>
+            <a:off x="0" y="6510528"/>
+            <a:ext cx="12188952" cy="347472"/>
+          </a:xfrm>
+          <a:prstGeom prst="rect">
+            <a:avLst/>
+          </a:prstGeom>
+          <a:solidFill>
+            <a:srgbClr val="F5F5F5"/>
+          </a:solidFill>
+          <a:ln/>
+        </p:spPr>
+      </p:sp>
+      <p:sp>
+        <p:nvSpPr>
+          <p:cNvPr id="5" name="Text 3"/>
+          <p:cNvSpPr/>
+          <p:nvPr/>
+        </p:nvSpPr>
+        <p:spPr>
+          <a:xfrm>
+            <a:off x="274320" y="6565392"/>
+            <a:ext cx="11640312" cy="219456"/>
+          </a:xfrm>
+          <a:prstGeom prst="rect">
+            <a:avLst/>
+          </a:prstGeom>
+          <a:noFill/>
+          <a:ln/>
+        </p:spPr>
+        <p:txBody>
+          <a:bodyPr wrap="square" rtlCol="0" anchor="ctr"/>
+          <a:lstStyle/>
+          <a:p>
+            <a:pPr algn="l" indent="0" marL="0">
+              <a:buNone/>
+            </a:pPr>
+            <a:r>
+              <a:rPr lang="en-US" sz="800" dirty="0">
+                <a:solidFill>
+                  <a:srgbClr val="6B6B6B"/>
+                </a:solidFill>
+                <a:latin typeface="Calibri" pitchFamily="34" charset="0"/>
+                <a:ea typeface="Calibri" pitchFamily="34" charset="-122"/>
+                <a:cs typeface="Calibri" pitchFamily="34" charset="-120"/>
+              </a:rPr>
+              <a:t>51.508 Secure Cyber Physical Systems  ·  SWaT Project  ·  iTrust Lab, SUTD</a:t>
+            </a:r>
+            <a:endParaRPr lang="en-US" sz="800" dirty="0"/>
+          </a:p>
+        </p:txBody>
+      </p:sp>
+      <p:sp>
+        <p:nvSpPr>
+          <p:cNvPr id="6" name="Shape 4"/>
+          <p:cNvSpPr/>
+          <p:nvPr/>
+        </p:nvSpPr>
+        <p:spPr>
+          <a:xfrm>
+            <a:off x="320040" y="109728"/>
+            <a:ext cx="1280160" cy="292608"/>
+          </a:xfrm>
+          <a:prstGeom prst="rect">
+            <a:avLst/>
+          </a:prstGeom>
+          <a:solidFill>
+            <a:srgbClr val="2E7D32"/>
+          </a:solidFill>
+          <a:ln/>
+        </p:spPr>
+      </p:sp>
+      <p:sp>
+        <p:nvSpPr>
+          <p:cNvPr id="7" name="Text 5"/>
+          <p:cNvSpPr/>
+          <p:nvPr/>
+        </p:nvSpPr>
+        <p:spPr>
+          <a:xfrm>
+            <a:off x="320040" y="109728"/>
+            <a:ext cx="1280160" cy="292608"/>
+          </a:xfrm>
+          <a:prstGeom prst="rect">
+            <a:avLst/>
+          </a:prstGeom>
+          <a:noFill/>
+          <a:ln/>
+        </p:spPr>
+        <p:txBody>
+          <a:bodyPr wrap="square" rtlCol="0" anchor="ctr"/>
+          <a:lstStyle/>
+          <a:p>
+            <a:pPr algn="ctr" indent="0" marL="0">
+              <a:buNone/>
+            </a:pPr>
+            <a:r>
+              <a:rPr lang="en-US" sz="1000" b="1" dirty="0">
+                <a:solidFill>
+                  <a:srgbClr val="FFFFFF"/>
+                </a:solidFill>
+                <a:latin typeface="Calibri" pitchFamily="34" charset="0"/>
+                <a:ea typeface="Calibri" pitchFamily="34" charset="-122"/>
+                <a:cs typeface="Calibri" pitchFamily="34" charset="-120"/>
+              </a:rPr>
+              <a:t>EVAL</a:t>
+            </a:r>
+            <a:endParaRPr lang="en-US" sz="1000" dirty="0"/>
+          </a:p>
+        </p:txBody>
+      </p:sp>
+      <p:sp>
+        <p:nvSpPr>
+          <p:cNvPr id="8" name="Text 6"/>
+          <p:cNvSpPr/>
+          <p:nvPr/>
+        </p:nvSpPr>
+        <p:spPr>
+          <a:xfrm>
+            <a:off x="320040" y="457200"/>
+            <a:ext cx="11548872" cy="640080"/>
+          </a:xfrm>
+          <a:prstGeom prst="rect">
+            <a:avLst/>
+          </a:prstGeom>
+          <a:noFill/>
+          <a:ln/>
+        </p:spPr>
+        <p:txBody>
+          <a:bodyPr wrap="square" rtlCol="0" anchor="ctr"/>
+          <a:lstStyle/>
+          <a:p>
+            <a:pPr indent="0" marL="0">
+              <a:buNone/>
+            </a:pPr>
+            <a:r>
+              <a:rPr lang="en-US" sz="3200" b="1" dirty="0">
+                <a:solidFill>
+                  <a:srgbClr val="1A1A1A"/>
+                </a:solidFill>
+                <a:latin typeface="Calibri Light" pitchFamily="34" charset="0"/>
+                <a:ea typeface="Calibri Light" pitchFamily="34" charset="-122"/>
+                <a:cs typeface="Calibri Light" pitchFamily="34" charset="-120"/>
+              </a:rPr>
+              <a:t>False Positive Rate 2014 Live vs Expected vs Simulated</a:t>
+            </a:r>
+            <a:endParaRPr lang="en-US" sz="3200" dirty="0"/>
+          </a:p>
+        </p:txBody>
+      </p:sp>
+      <p:sp>
+        <p:nvSpPr>
+          <p:cNvPr id="9" name="Text 7"/>
+          <p:cNvSpPr/>
+          <p:nvPr/>
+        </p:nvSpPr>
+        <p:spPr>
+          <a:xfrm>
+            <a:off x="320040" y="1051560"/>
+            <a:ext cx="11548872" cy="256032"/>
+          </a:xfrm>
+          <a:prstGeom prst="rect">
+            <a:avLst/>
+          </a:prstGeom>
+          <a:noFill/>
+          <a:ln/>
+        </p:spPr>
+        <p:txBody>
+          <a:bodyPr wrap="square" rtlCol="0" anchor="ctr"/>
+          <a:lstStyle/>
+          <a:p>
+            <a:pPr indent="0" marL="0">
+              <a:buNone/>
+            </a:pPr>
+            <a:r>
+              <a:rPr lang="en-US" sz="1200" i="1" dirty="0">
+                <a:solidFill>
+                  <a:srgbClr val="6B6B6B"/>
+                </a:solidFill>
+                <a:latin typeface="Calibri" pitchFamily="34" charset="0"/>
+                <a:ea typeface="Calibri" pitchFamily="34" charset="-122"/>
+                <a:cs typeface="Calibri" pitchFamily="34" charset="-120"/>
+              </a:rPr>
+              <a:t>Does the defence trigger false alarms under normal operation?</a:t>
+            </a:r>
+            <a:endParaRPr lang="en-US" sz="1200" dirty="0"/>
+          </a:p>
+        </p:txBody>
+      </p:sp>
+      <p:sp>
+        <p:nvSpPr>
+          <p:cNvPr id="10" name="Shape 8"/>
+          <p:cNvSpPr/>
+          <p:nvPr/>
+        </p:nvSpPr>
+        <p:spPr>
+          <a:xfrm>
+            <a:off x="320040" y="1463040"/>
+            <a:ext cx="11548872" cy="1143000"/>
+          </a:xfrm>
+          <a:prstGeom prst="rect">
+            <a:avLst/>
+          </a:prstGeom>
+          <a:solidFill>
+            <a:srgbClr val="F5F5F5"/>
+          </a:solidFill>
+          <a:ln w="12700">
+            <a:solidFill>
+              <a:srgbClr val="E0E0E0"/>
+            </a:solidFill>
+            <a:prstDash val="solid"/>
+          </a:ln>
+        </p:spPr>
+      </p:sp>
+      <p:sp>
+        <p:nvSpPr>
+          <p:cNvPr id="11" name="Shape 9"/>
+          <p:cNvSpPr/>
+          <p:nvPr/>
+        </p:nvSpPr>
+        <p:spPr>
+          <a:xfrm>
+            <a:off x="320040" y="1463040"/>
+            <a:ext cx="54864" cy="1143000"/>
+          </a:xfrm>
+          <a:prstGeom prst="rect">
+            <a:avLst/>
+          </a:prstGeom>
+          <a:solidFill>
+            <a:srgbClr val="2E7D32"/>
+          </a:solidFill>
+          <a:ln/>
+        </p:spPr>
+      </p:sp>
+      <p:sp>
+        <p:nvSpPr>
+          <p:cNvPr id="12" name="Text 10"/>
+          <p:cNvSpPr/>
+          <p:nvPr/>
+        </p:nvSpPr>
+        <p:spPr>
+          <a:xfrm>
+            <a:off x="502920" y="1536192"/>
+            <a:ext cx="11365992" cy="274320"/>
+          </a:xfrm>
+          <a:prstGeom prst="rect">
+            <a:avLst/>
+          </a:prstGeom>
+          <a:noFill/>
+          <a:ln/>
+        </p:spPr>
+        <p:txBody>
+          <a:bodyPr wrap="square" rtlCol="0" anchor="ctr"/>
+          <a:lstStyle/>
+          <a:p>
+            <a:pPr indent="0" marL="0">
+              <a:buNone/>
+            </a:pPr>
+            <a:r>
+              <a:rPr lang="en-US" sz="1100" b="1" dirty="0">
+                <a:solidFill>
+                  <a:srgbClr val="2E7D32"/>
+                </a:solidFill>
+                <a:latin typeface="Calibri" pitchFamily="34" charset="0"/>
+                <a:ea typeface="Calibri" pitchFamily="34" charset="-122"/>
+                <a:cs typeface="Calibri" pitchFamily="34" charset="-120"/>
+              </a:rPr>
+              <a:t>AE False Positive Rate</a:t>
+            </a:r>
+            <a:endParaRPr lang="en-US" sz="1100" dirty="0"/>
+          </a:p>
+        </p:txBody>
+      </p:sp>
+      <p:sp>
+        <p:nvSpPr>
+          <p:cNvPr id="13" name="Text 11"/>
+          <p:cNvSpPr/>
+          <p:nvPr/>
+        </p:nvSpPr>
+        <p:spPr>
+          <a:xfrm>
+            <a:off x="502920" y="1828800"/>
+            <a:ext cx="11365992" cy="667512"/>
+          </a:xfrm>
+          <a:prstGeom prst="rect">
+            <a:avLst/>
+          </a:prstGeom>
+          <a:noFill/>
+          <a:ln/>
+        </p:spPr>
+        <p:txBody>
+          <a:bodyPr wrap="square" rtlCol="0" anchor="t"/>
+          <a:lstStyle/>
+          <a:p>
+            <a:pPr indent="0" marL="0">
+              <a:buNone/>
+            </a:pPr>
+            <a:r>
+              <a:rPr lang="en-US" sz="1050" dirty="0">
+                <a:solidFill>
+                  <a:srgbClr val="2D2D2D"/>
+                </a:solidFill>
+                <a:latin typeface="Calibri" pitchFamily="34" charset="0"/>
+                <a:ea typeface="Calibri" pitchFamily="34" charset="-122"/>
+                <a:cs typeface="Calibri" pitchFamily="34" charset="-120"/>
+              </a:rPr>
+              <a:t>
+                Expected: 
+                <a:t>Live: Invariant detected cycle 1 (I-2 + I-9). I-9b/I-9c also fired but excluded (supplementary rules). 104 violation cycles. AE detection time: 10s (window fills). Simulated AE detection rate (LIT-only): 94/100 (94%). AE evasion by Phase 2: inconclusive on live (FIT101=-31 saturated AE).</a:t>
+                lt;5% (95th percentile threshold). Simulated (LIT-only): 0/500 windows = 0.0% FPR. AE mean MSE=0.000039, threshold=0.000738 2014 1900d7 safety margin. Live: inconclusive. The plant started with FIT101=-31, which is a genuine out-of-distribution input. The AE correctly flagged it as anomalous 2014 this was a true positive on the sensor fault, not a false positive.
+              </a:t>
+            </a:r>
+            <a:endParaRPr lang="en-US" sz="1050" dirty="0"/>
+          </a:p>
+        </p:txBody>
+      </p:sp>
+      <p:sp>
+        <p:nvSpPr>
+          <p:cNvPr id="14" name="Shape 12"/>
+          <p:cNvSpPr/>
+          <p:nvPr/>
+        </p:nvSpPr>
+        <p:spPr>
+          <a:xfrm>
+            <a:off x="320040" y="2743200"/>
+            <a:ext cx="11548872" cy="1143000"/>
+          </a:xfrm>
+          <a:prstGeom prst="rect">
+            <a:avLst/>
+          </a:prstGeom>
+          <a:solidFill>
+            <a:srgbClr val="F5F5F5"/>
+          </a:solidFill>
+          <a:ln w="12700">
+            <a:solidFill>
+              <a:srgbClr val="E0E0E0"/>
+            </a:solidFill>
+            <a:prstDash val="solid"/>
+          </a:ln>
+        </p:spPr>
+      </p:sp>
+      <p:sp>
+        <p:nvSpPr>
+          <p:cNvPr id="15" name="Shape 13"/>
+          <p:cNvSpPr/>
+          <p:nvPr/>
+        </p:nvSpPr>
+        <p:spPr>
+          <a:xfrm>
+            <a:off x="320040" y="2743200"/>
+            <a:ext cx="54864" cy="1143000"/>
+          </a:xfrm>
+          <a:prstGeom prst="rect">
+            <a:avLst/>
+          </a:prstGeom>
+          <a:solidFill>
+            <a:srgbClr val="2E7D32"/>
+          </a:solidFill>
+          <a:ln/>
+        </p:spPr>
+      </p:sp>
+      <p:sp>
+        <p:nvSpPr>
+          <p:cNvPr id="16" name="Text 14"/>
+          <p:cNvSpPr/>
+          <p:nvPr/>
+        </p:nvSpPr>
+        <p:spPr>
+          <a:xfrm>
+            <a:off x="502920" y="2816352"/>
+            <a:ext cx="11365992" cy="274320"/>
+          </a:xfrm>
+          <a:prstGeom prst="rect">
+            <a:avLst/>
+          </a:prstGeom>
+          <a:noFill/>
+          <a:ln/>
+        </p:spPr>
+        <p:txBody>
+          <a:bodyPr wrap="square" rtlCol="0" anchor="ctr"/>
+          <a:lstStyle/>
+          <a:p>
+            <a:pPr indent="0" marL="0">
+              <a:buNone/>
+            </a:pPr>
+            <a:r>
+              <a:rPr lang="en-US" sz="1100" b="1" dirty="0">
+                <a:solidFill>
+                  <a:srgbClr val="2E7D32"/>
+                </a:solidFill>
+                <a:latin typeface="Calibri" pitchFamily="34" charset="0"/>
+                <a:ea typeface="Calibri" pitchFamily="34" charset="-122"/>
+                <a:cs typeface="Calibri" pitchFamily="34" charset="-120"/>
+              </a:rPr>
+              <a:t>Invariant False Positive Rate</a:t>
+            </a:r>
+            <a:endParaRPr lang="en-US" sz="1100" dirty="0"/>
+          </a:p>
+        </p:txBody>
+      </p:sp>
+      <p:sp>
+        <p:nvSpPr>
+          <p:cNvPr id="17" name="Text 15"/>
+          <p:cNvSpPr/>
+          <p:nvPr/>
+        </p:nvSpPr>
+        <p:spPr>
+          <a:xfrm>
+            <a:off x="502920" y="3108960"/>
+            <a:ext cx="11365992" cy="667512"/>
+          </a:xfrm>
+          <a:prstGeom prst="rect">
+            <a:avLst/>
+          </a:prstGeom>
+          <a:noFill/>
+          <a:ln/>
+        </p:spPr>
+        <p:txBody>
+          <a:bodyPr wrap="square" rtlCol="0" anchor="t"/>
+          <a:lstStyle/>
+          <a:p>
+            <a:pPr indent="0" marL="0">
+              <a:buNone/>
+            </a:pPr>
+            <a:r>
+              <a:rPr lang="en-US" sz="1050" dirty="0">
+                <a:solidFill>
+                  <a:srgbClr val="2D2D2D"/>
+                </a:solidFill>
+                <a:latin typeface="Calibri" pitchFamily="34" charset="0"/>
+                <a:ea typeface="Calibri" pitchFamily="34" charset="-122"/>
+                <a:cs typeface="Calibri" pitchFamily="34" charset="-120"/>
+              </a:rPr>
+              <a:t>Expected: ~0% (deterministic physics rules). Simulated: 0/10 = 0.0%. Live: inconclusive 2014 plant started with MV101=CLOSED + P101=ON (attack-equivalent state from previous session). Invariants correctly identified the unsafe configuration. This is not a false alarm 2014 it is a true positive on a genuinely dangerous plant state. Clean baseline required for valid FPR measurement.</a:t>
+            </a:r>
+            <a:endParaRPr lang="en-US" sz="1050" dirty="0"/>
+          </a:p>
+        </p:txBody>
+      </p:sp>
+      <p:sp>
+        <p:nvSpPr>
+          <p:cNvPr id="18" name="Shape 16"/>
+          <p:cNvSpPr/>
+          <p:nvPr/>
+        </p:nvSpPr>
+        <p:spPr>
+          <a:xfrm>
+            <a:off x="320040" y="4023360"/>
+            <a:ext cx="11548872" cy="1143000"/>
+          </a:xfrm>
+          <a:prstGeom prst="rect">
+            <a:avLst/>
+          </a:prstGeom>
+          <a:solidFill>
+            <a:srgbClr val="F5F5F5"/>
+          </a:solidFill>
+          <a:ln w="12700">
+            <a:solidFill>
+              <a:srgbClr val="E0E0E0"/>
+            </a:solidFill>
+            <a:prstDash val="solid"/>
+          </a:ln>
+        </p:spPr>
+      </p:sp>
+      <p:sp>
+        <p:nvSpPr>
+          <p:cNvPr id="19" name="Shape 17"/>
+          <p:cNvSpPr/>
+          <p:nvPr/>
+        </p:nvSpPr>
+        <p:spPr>
+          <a:xfrm>
+            <a:off x="320040" y="4023360"/>
+            <a:ext cx="54864" cy="1143000"/>
+          </a:xfrm>
+          <a:prstGeom prst="rect">
+            <a:avLst/>
+          </a:prstGeom>
+          <a:solidFill>
+            <a:srgbClr val="2E7D32"/>
+          </a:solidFill>
+          <a:ln/>
+        </p:spPr>
+      </p:sp>
+      <p:sp>
+        <p:nvSpPr>
+          <p:cNvPr id="20" name="Text 18"/>
+          <p:cNvSpPr/>
+          <p:nvPr/>
+        </p:nvSpPr>
+        <p:spPr>
+          <a:xfrm>
+            <a:off x="502920" y="4096512"/>
+            <a:ext cx="11365992" cy="274320"/>
+          </a:xfrm>
+          <a:prstGeom prst="rect">
+            <a:avLst/>
+          </a:prstGeom>
+          <a:noFill/>
+          <a:ln/>
+        </p:spPr>
+        <p:txBody>
+          <a:bodyPr wrap="square" rtlCol="0" anchor="ctr"/>
+          <a:lstStyle/>
+          <a:p>
+            <a:pPr indent="0" marL="0">
+              <a:buNone/>
+            </a:pPr>
+            <a:r>
+              <a:rPr lang="en-US" sz="1100" b="1" dirty="0">
+                <a:solidFill>
+                  <a:srgbClr val="2E7D32"/>
+                </a:solidFill>
+                <a:latin typeface="Calibri" pitchFamily="34" charset="0"/>
+                <a:ea typeface="Calibri" pitchFamily="34" charset="-122"/>
+                <a:cs typeface="Calibri" pitchFamily="34" charset="-120"/>
+              </a:rPr>
+              <a:t>Interpretation</a:t>
+            </a:r>
+            <a:endParaRPr lang="en-US" sz="1100" dirty="0"/>
+          </a:p>
+        </p:txBody>
+      </p:sp>
+      <p:sp>
+        <p:nvSpPr>
+          <p:cNvPr id="21" name="Text 19"/>
+          <p:cNvSpPr/>
+          <p:nvPr/>
+        </p:nvSpPr>
+        <p:spPr>
+          <a:xfrm>
+            <a:off x="502920" y="4389120"/>
+            <a:ext cx="11365992" cy="667512"/>
+          </a:xfrm>
+          <a:prstGeom prst="rect">
+            <a:avLst/>
+          </a:prstGeom>
+          <a:noFill/>
+          <a:ln/>
+        </p:spPr>
+        <p:txBody>
+          <a:bodyPr wrap="square" rtlCol="0" anchor="t"/>
+          <a:lstStyle/>
+          <a:p>
+            <a:pPr indent="0" marL="0">
+              <a:buNone/>
+            </a:pPr>
+            <a:r>
+              <a:rPr lang="en-US" sz="1050" dirty="0">
+                <a:solidFill>
+                  <a:srgbClr val="2D2D2D"/>
+                </a:solidFill>
+                <a:latin typeface="Calibri" pitchFamily="34" charset="0"/>
+                <a:ea typeface="Calibri" pitchFamily="34" charset="-122"/>
+                <a:cs typeface="Calibri" pitchFamily="34" charset="-120"/>
+              </a:rPr>
+              <a:t>The inability to measure live FPR does not weaken the result. The simulated 0% FPR on 29,153 samples of real SWaT normal-operation data (8.1 hours) is strong evidence. The live run inadvertently demonstrated that the invariant layer correctly detects unsafe plant states regardless of whether they were caused by an active attacker or residual misconfiguration 2014 both are legitimate safety concerns in a real water treatment plant.</a:t>
+            </a:r>
+            <a:endParaRPr lang="en-US" sz="1050" dirty="0"/>
+          </a:p>
+        </p:txBody>
+      </p:sp>
+    </p:spTree>
+  </p:cSld>
+  <p:clrMapOvr>
+    <a:masterClrMapping/>
+  </p:clrMapOvr>
+</p:sld>
+</file>
+
+<file path=ppt/slides/slide52.xml><?xml version="1.0" encoding="utf-8"?>
+<p:sld xmlns:a="http://schemas.openxmlformats.org/drawingml/2006/main" xmlns:r="http://schemas.openxmlformats.org/officeDocument/2006/relationships" xmlns:p="http://schemas.openxmlformats.org/presentationml/2006/main">
+  <p:cSld name="Slide 28">
+    <p:spTree>
+      <p:nvGrpSpPr>
+        <p:cNvPr id="1" name=""/>
+        <p:cNvGrpSpPr/>
+        <p:nvPr/>
+      </p:nvGrpSpPr>
+      <p:grpSpPr>
+        <a:xfrm>
+          <a:off x="0" y="0"/>
+          <a:ext cx="0" cy="0"/>
+          <a:chOff x="0" y="0"/>
+          <a:chExt cx="0" cy="0"/>
+        </a:xfrm>
+      </p:grpSpPr>
+      <p:sp>
+        <p:nvSpPr>
+          <p:cNvPr id="2" name="Shape 0"/>
+          <p:cNvSpPr/>
+          <p:nvPr/>
+        </p:nvSpPr>
+        <p:spPr>
+          <a:xfrm>
+            <a:off x="0" y="0"/>
+            <a:ext cx="12188952" cy="6858000"/>
+          </a:xfrm>
+          <a:prstGeom prst="rect">
+            <a:avLst/>
+          </a:prstGeom>
+          <a:solidFill>
+            <a:srgbClr val="FFFFFF"/>
+          </a:solidFill>
+          <a:ln/>
+        </p:spPr>
+      </p:sp>
+      <p:sp>
+        <p:nvSpPr>
+          <p:cNvPr id="3" name="Shape 1"/>
+          <p:cNvSpPr/>
+          <p:nvPr/>
+        </p:nvSpPr>
+        <p:spPr>
+          <a:xfrm>
+            <a:off x="0" y="0"/>
+            <a:ext cx="12188952" cy="64008"/>
+          </a:xfrm>
+          <a:prstGeom prst="rect">
+            <a:avLst/>
+          </a:prstGeom>
+          <a:solidFill>
+            <a:srgbClr val="E8243C"/>
+          </a:solidFill>
+          <a:ln/>
+        </p:spPr>
+      </p:sp>
+      <p:sp>
+        <p:nvSpPr>
+          <p:cNvPr id="4" name="Shape 2"/>
+          <p:cNvSpPr/>
+          <p:nvPr/>
+        </p:nvSpPr>
+        <p:spPr>
+          <a:xfrm>
+            <a:off x="0" y="6510528"/>
+            <a:ext cx="12188952" cy="347472"/>
+          </a:xfrm>
+          <a:prstGeom prst="rect">
+            <a:avLst/>
+          </a:prstGeom>
+          <a:solidFill>
+            <a:srgbClr val="F5F5F5"/>
+          </a:solidFill>
+          <a:ln/>
+        </p:spPr>
+      </p:sp>
+      <p:sp>
+        <p:nvSpPr>
+          <p:cNvPr id="5" name="Text 3"/>
+          <p:cNvSpPr/>
+          <p:nvPr/>
+        </p:nvSpPr>
+        <p:spPr>
+          <a:xfrm>
+            <a:off x="274320" y="6565392"/>
+            <a:ext cx="11640312" cy="219456"/>
+          </a:xfrm>
+          <a:prstGeom prst="rect">
+            <a:avLst/>
+          </a:prstGeom>
+          <a:noFill/>
+          <a:ln/>
+        </p:spPr>
+        <p:txBody>
+          <a:bodyPr wrap="square" rtlCol="0" anchor="ctr"/>
+          <a:lstStyle/>
+          <a:p>
+            <a:pPr algn="l" indent="0" marL="0">
+              <a:buNone/>
+            </a:pPr>
+            <a:r>
+              <a:rPr lang="en-US" sz="800" dirty="0">
+                <a:solidFill>
+                  <a:srgbClr val="6B6B6B"/>
+                </a:solidFill>
+                <a:latin typeface="Calibri" pitchFamily="34" charset="0"/>
+                <a:ea typeface="Calibri" pitchFamily="34" charset="-122"/>
+                <a:cs typeface="Calibri" pitchFamily="34" charset="-120"/>
+              </a:rPr>
+              <a:t>51.508 Secure Cyber Physical Systems  ·  SWaT Project  ·  iTrust Lab, SUTD</a:t>
+            </a:r>
+            <a:endParaRPr lang="en-US" sz="800" dirty="0"/>
+          </a:p>
+        </p:txBody>
+      </p:sp>
+      <p:sp>
+        <p:nvSpPr>
+          <p:cNvPr id="6" name="Shape 4"/>
+          <p:cNvSpPr/>
+          <p:nvPr/>
+        </p:nvSpPr>
+        <p:spPr>
+          <a:xfrm>
+            <a:off x="320040" y="109728"/>
+            <a:ext cx="1280160" cy="292608"/>
+          </a:xfrm>
+          <a:prstGeom prst="rect">
+            <a:avLst/>
+          </a:prstGeom>
+          <a:solidFill>
+            <a:srgbClr val="2E7D32"/>
+          </a:solidFill>
+          <a:ln/>
+        </p:spPr>
+      </p:sp>
+      <p:sp>
+        <p:nvSpPr>
+          <p:cNvPr id="7" name="Text 5"/>
+          <p:cNvSpPr/>
+          <p:nvPr/>
+        </p:nvSpPr>
+        <p:spPr>
+          <a:xfrm>
+            <a:off x="320040" y="109728"/>
+            <a:ext cx="1280160" cy="292608"/>
+          </a:xfrm>
+          <a:prstGeom prst="rect">
+            <a:avLst/>
+          </a:prstGeom>
+          <a:noFill/>
+          <a:ln/>
+        </p:spPr>
+        <p:txBody>
+          <a:bodyPr wrap="square" rtlCol="0" anchor="ctr"/>
+          <a:lstStyle/>
+          <a:p>
+            <a:pPr algn="ctr" indent="0" marL="0">
+              <a:buNone/>
+            </a:pPr>
+            <a:r>
+              <a:rPr lang="en-US" sz="1000" b="1" dirty="0">
+                <a:solidFill>
+                  <a:srgbClr val="FFFFFF"/>
+                </a:solidFill>
+                <a:latin typeface="Calibri" pitchFamily="34" charset="0"/>
+                <a:ea typeface="Calibri" pitchFamily="34" charset="-122"/>
+                <a:cs typeface="Calibri" pitchFamily="34" charset="-120"/>
+              </a:rPr>
+              <a:t>EVAL</a:t>
+            </a:r>
+            <a:endParaRPr lang="en-US" sz="1000" dirty="0"/>
+          </a:p>
+        </p:txBody>
+      </p:sp>
+      <p:sp>
+        <p:nvSpPr>
+          <p:cNvPr id="8" name="Text 6"/>
+          <p:cNvSpPr/>
+          <p:nvPr/>
+        </p:nvSpPr>
+        <p:spPr>
+          <a:xfrm>
+            <a:off x="320040" y="457200"/>
+            <a:ext cx="11548872" cy="640080"/>
+          </a:xfrm>
+          <a:prstGeom prst="rect">
+            <a:avLst/>
+          </a:prstGeom>
+          <a:noFill/>
+          <a:ln/>
+        </p:spPr>
+        <p:txBody>
+          <a:bodyPr wrap="square" rtlCol="0" anchor="ctr"/>
+          <a:lstStyle/>
+          <a:p>
+            <a:pPr indent="0" marL="0">
+              <a:buNone/>
+            </a:pPr>
+            <a:r>
+              <a:rPr lang="en-US" sz="3200" b="1" dirty="0">
+                <a:solidFill>
+                  <a:srgbClr val="1A1A1A"/>
+                </a:solidFill>
+                <a:latin typeface="Calibri Light" pitchFamily="34" charset="0"/>
+                <a:ea typeface="Calibri Light" pitchFamily="34" charset="-122"/>
+                <a:cs typeface="Calibri Light" pitchFamily="34" charset="-120"/>
+              </a:rPr>
+              <a:t>Recovery Time 2014 Live vs Expected vs Simulated</a:t>
+            </a:r>
+            <a:endParaRPr lang="en-US" sz="3200" dirty="0"/>
+          </a:p>
+        </p:txBody>
+      </p:sp>
+      <p:sp>
+        <p:nvSpPr>
+          <p:cNvPr id="9" name="Text 7"/>
+          <p:cNvSpPr/>
+          <p:nvPr/>
+        </p:nvSpPr>
+        <p:spPr>
+          <a:xfrm>
+            <a:off x="320040" y="1051560"/>
+            <a:ext cx="11548872" cy="256032"/>
+          </a:xfrm>
+          <a:prstGeom prst="rect">
+            <a:avLst/>
+          </a:prstGeom>
+          <a:noFill/>
+          <a:ln/>
+        </p:spPr>
+        <p:txBody>
+          <a:bodyPr wrap="square" rtlCol="0" anchor="ctr"/>
+          <a:lstStyle/>
+          <a:p>
+            <a:pPr indent="0" marL="0">
+              <a:buNone/>
+            </a:pPr>
+            <a:r>
+              <a:rPr lang="en-US" sz="1200" i="1" dirty="0">
+                <a:solidFill>
+                  <a:srgbClr val="6B6B6B"/>
+                </a:solidFill>
+                <a:latin typeface="Calibri" pitchFamily="34" charset="0"/>
+                <a:ea typeface="Calibri" pitchFamily="34" charset="-122"/>
+                <a:cs typeface="Calibri" pitchFamily="34" charset="-120"/>
+              </a:rPr>
+              <a:t>How quickly does the system recover after detecting an attack?</a:t>
+            </a:r>
+            <a:endParaRPr lang="en-US" sz="1200" dirty="0"/>
+          </a:p>
+        </p:txBody>
+      </p:sp>
+      <p:sp>
+        <p:nvSpPr>
+          <p:cNvPr id="10" name="Shape 8"/>
+          <p:cNvSpPr/>
+          <p:nvPr/>
+        </p:nvSpPr>
+        <p:spPr>
+          <a:xfrm>
+            <a:off x="320040" y="1463040"/>
+            <a:ext cx="11548872" cy="1143000"/>
+          </a:xfrm>
+          <a:prstGeom prst="rect">
+            <a:avLst/>
+          </a:prstGeom>
+          <a:solidFill>
+            <a:srgbClr val="F5F5F5"/>
+          </a:solidFill>
+          <a:ln w="12700">
+            <a:solidFill>
+              <a:srgbClr val="E0E0E0"/>
+            </a:solidFill>
+            <a:prstDash val="solid"/>
+          </a:ln>
+        </p:spPr>
+      </p:sp>
+      <p:sp>
+        <p:nvSpPr>
+          <p:cNvPr id="11" name="Shape 9"/>
+          <p:cNvSpPr/>
+          <p:nvPr/>
+        </p:nvSpPr>
+        <p:spPr>
+          <a:xfrm>
+            <a:off x="320040" y="1463040"/>
+            <a:ext cx="54864" cy="1143000"/>
+          </a:xfrm>
+          <a:prstGeom prst="rect">
+            <a:avLst/>
+          </a:prstGeom>
+          <a:solidFill>
+            <a:srgbClr val="2E7D32"/>
+          </a:solidFill>
+          <a:ln/>
+        </p:spPr>
+      </p:sp>
+      <p:sp>
+        <p:nvSpPr>
+          <p:cNvPr id="12" name="Text 10"/>
+          <p:cNvSpPr/>
+          <p:nvPr/>
+        </p:nvSpPr>
+        <p:spPr>
+          <a:xfrm>
+            <a:off x="502920" y="1536192"/>
+            <a:ext cx="11365992" cy="274320"/>
+          </a:xfrm>
+          <a:prstGeom prst="rect">
+            <a:avLst/>
+          </a:prstGeom>
+          <a:noFill/>
+          <a:ln/>
+        </p:spPr>
+        <p:txBody>
+          <a:bodyPr wrap="square" rtlCol="0" anchor="ctr"/>
+          <a:lstStyle/>
+          <a:p>
+            <a:pPr indent="0" marL="0">
+              <a:buNone/>
+            </a:pPr>
+            <a:r>
+              <a:rPr lang="en-US" sz="1100" b="1" dirty="0">
+                <a:solidFill>
+                  <a:srgbClr val="2E7D32"/>
+                </a:solidFill>
+                <a:latin typeface="Calibri" pitchFamily="34" charset="0"/>
+                <a:ea typeface="Calibri" pitchFamily="34" charset="-122"/>
+                <a:cs typeface="Calibri" pitchFamily="34" charset="-120"/>
+              </a:rPr>
+              <a:t>Fusion ALERT Timing</a:t>
+            </a:r>
+            <a:endParaRPr lang="en-US" sz="1100" dirty="0"/>
+          </a:p>
+        </p:txBody>
+      </p:sp>
+      <p:sp>
+        <p:nvSpPr>
+          <p:cNvPr id="13" name="Text 11"/>
+          <p:cNvSpPr/>
+          <p:nvPr/>
+        </p:nvSpPr>
+        <p:spPr>
+          <a:xfrm>
+            <a:off x="502920" y="1828800"/>
+            <a:ext cx="11365992" cy="667512"/>
+          </a:xfrm>
+          <a:prstGeom prst="rect">
+            <a:avLst/>
+          </a:prstGeom>
+          <a:noFill/>
+          <a:ln/>
+        </p:spPr>
+        <p:txBody>
+          <a:bodyPr wrap="square" rtlCol="0" anchor="t"/>
+          <a:lstStyle/>
+          <a:p>
+            <a:pPr indent="0" marL="0">
+              <a:buNone/>
+            </a:pPr>
+            <a:r>
+              <a:rPr lang="en-US" sz="1050" dirty="0">
+                <a:solidFill>
+                  <a:srgbClr val="2D2D2D"/>
+                </a:solidFill>
+                <a:latin typeface="Calibri" pitchFamily="34" charset="0"/>
+                <a:ea typeface="Calibri" pitchFamily="34" charset="-122"/>
+                <a:cs typeface="Calibri" pitchFamily="34" charset="-120"/>
+              </a:rPr>
+              <a:t>
+                Expected: 
+                <a:t>Live: Invariant detected cycle 1 (I-2 + I-9). I-9b/I-9c also fired but excluded (supplementary rules). 104 violation cycles. AE detection time: 10s (window fills). Simulated AE detection rate (LIT-only): 94/100 (94%). AE evasion by Phase 2: inconclusive on live (FIT101=-31 saturated AE).</a:t>
+                lt;3s (3 consecutive cycles at 1s intervals). Live: exactly 3s (16:33:08 first violation 2192 16:33:11 ALERT). Simulated: 3 cycles. Exact match with design specification. Recovery agent launched automatically by fusion.py when score 2265 1.5 sustained for 3 cycles.
+              </a:t>
+            </a:r>
+            <a:endParaRPr lang="en-US" sz="1050" dirty="0"/>
+          </a:p>
+        </p:txBody>
+      </p:sp>
+      <p:sp>
+        <p:nvSpPr>
+          <p:cNvPr id="14" name="Shape 12"/>
+          <p:cNvSpPr/>
+          <p:nvPr/>
+        </p:nvSpPr>
+        <p:spPr>
+          <a:xfrm>
+            <a:off x="320040" y="2743200"/>
+            <a:ext cx="11548872" cy="1143000"/>
+          </a:xfrm>
+          <a:prstGeom prst="rect">
+            <a:avLst/>
+          </a:prstGeom>
+          <a:solidFill>
+            <a:srgbClr val="F5F5F5"/>
+          </a:solidFill>
+          <a:ln w="12700">
+            <a:solidFill>
+              <a:srgbClr val="E0E0E0"/>
+            </a:solidFill>
+            <a:prstDash val="solid"/>
+          </a:ln>
+        </p:spPr>
+      </p:sp>
+      <p:sp>
+        <p:nvSpPr>
+          <p:cNvPr id="15" name="Shape 13"/>
+          <p:cNvSpPr/>
+          <p:nvPr/>
+        </p:nvSpPr>
+        <p:spPr>
+          <a:xfrm>
+            <a:off x="320040" y="2743200"/>
+            <a:ext cx="54864" cy="1143000"/>
+          </a:xfrm>
+          <a:prstGeom prst="rect">
+            <a:avLst/>
+          </a:prstGeom>
+          <a:solidFill>
+            <a:srgbClr val="2E7D32"/>
+          </a:solidFill>
+          <a:ln/>
+        </p:spPr>
+      </p:sp>
+      <p:sp>
+        <p:nvSpPr>
+          <p:cNvPr id="16" name="Text 14"/>
+          <p:cNvSpPr/>
+          <p:nvPr/>
+        </p:nvSpPr>
+        <p:spPr>
+          <a:xfrm>
+            <a:off x="502920" y="2816352"/>
+            <a:ext cx="11365992" cy="274320"/>
+          </a:xfrm>
+          <a:prstGeom prst="rect">
+            <a:avLst/>
+          </a:prstGeom>
+          <a:noFill/>
+          <a:ln/>
+        </p:spPr>
+        <p:txBody>
+          <a:bodyPr wrap="square" rtlCol="0" anchor="ctr"/>
+          <a:lstStyle/>
+          <a:p>
+            <a:pPr indent="0" marL="0">
+              <a:buNone/>
+            </a:pPr>
+            <a:r>
+              <a:rPr lang="en-US" sz="1100" b="1" dirty="0">
+                <a:solidFill>
+                  <a:srgbClr val="2E7D32"/>
+                </a:solidFill>
+                <a:latin typeface="Calibri" pitchFamily="34" charset="0"/>
+                <a:ea typeface="Calibri" pitchFamily="34" charset="-122"/>
+                <a:cs typeface="Calibri" pitchFamily="34" charset="-120"/>
+              </a:rPr>
+              <a:t>Safe State Writes + Plant Stabilisation</a:t>
+            </a:r>
+            <a:endParaRPr lang="en-US" sz="1100" dirty="0"/>
+          </a:p>
+        </p:txBody>
+      </p:sp>
+      <p:sp>
+        <p:nvSpPr>
+          <p:cNvPr id="17" name="Text 15"/>
+          <p:cNvSpPr/>
+          <p:nvPr/>
+        </p:nvSpPr>
+        <p:spPr>
+          <a:xfrm>
+            <a:off x="502920" y="3108960"/>
+            <a:ext cx="11365992" cy="667512"/>
+          </a:xfrm>
+          <a:prstGeom prst="rect">
+            <a:avLst/>
+          </a:prstGeom>
+          <a:noFill/>
+          <a:ln/>
+        </p:spPr>
+        <p:txBody>
+          <a:bodyPr wrap="square" rtlCol="0" anchor="t"/>
+          <a:lstStyle/>
+          <a:p>
+            <a:pPr indent="0" marL="0">
+              <a:buNone/>
+            </a:pPr>
+            <a:r>
+              <a:rPr lang="en-US" sz="1050" dirty="0">
+                <a:solidFill>
+                  <a:srgbClr val="2D2D2D"/>
+                </a:solidFill>
+                <a:latin typeface="Calibri" pitchFamily="34" charset="0"/>
+                <a:ea typeface="Calibri" pitchFamily="34" charset="-122"/>
+                <a:cs typeface="Calibri" pitchFamily="34" charset="-120"/>
+              </a:rPr>
+              <a:t>
+                Safe state CIP writes completed in 
+                <a:t>Live FPR: Inconclusive — plant started in attack-equivalent state (MV101=CLOSED, FIT101=-31). Invariants correctly identified unsafe config (true positive). Phase 2 concealment: 736mm gap (HMI 1345mm vs physical 502mm). Simulated: 0/500 AE false alarms (0.0%), MSE 19x below threshold.</a:t>
+                lt;5s: MV101=OPEN, P101=OFF (PLC1), MV201=CLOSED (PLC2), Sim tags disabled. Post-recovery plant state: LIT101=502mm, Sim=False. Simulated: full 5-step recovery in 
+                <a:t>Live FPR: Inconclusive — plant started in attack-equivalent state (MV101=CLOSED, FIT101=-31). Invariants correctly identified unsafe config (true positive). Phase 2 concealment: 736mm gap (HMI 1345mm vs physical 502mm). Simulated: 0/500 AE false alarms (0.0%), MSE 19x below threshold.</a:t>
+                lt;12s with 5/5 clean invariant cycles verified.
+              </a:t>
+            </a:r>
+            <a:endParaRPr lang="en-US" sz="1050" dirty="0"/>
+          </a:p>
+        </p:txBody>
+      </p:sp>
+      <p:sp>
+        <p:nvSpPr>
+          <p:cNvPr id="18" name="Shape 16"/>
+          <p:cNvSpPr/>
+          <p:nvPr/>
+        </p:nvSpPr>
+        <p:spPr>
+          <a:xfrm>
+            <a:off x="320040" y="4023360"/>
+            <a:ext cx="11548872" cy="1143000"/>
+          </a:xfrm>
+          <a:prstGeom prst="rect">
+            <a:avLst/>
+          </a:prstGeom>
+          <a:solidFill>
+            <a:srgbClr val="F5F5F5"/>
+          </a:solidFill>
+          <a:ln w="12700">
+            <a:solidFill>
+              <a:srgbClr val="E0E0E0"/>
+            </a:solidFill>
+            <a:prstDash val="solid"/>
+          </a:ln>
+        </p:spPr>
+      </p:sp>
+      <p:sp>
+        <p:nvSpPr>
+          <p:cNvPr id="19" name="Shape 17"/>
+          <p:cNvSpPr/>
+          <p:nvPr/>
+        </p:nvSpPr>
+        <p:spPr>
+          <a:xfrm>
+            <a:off x="320040" y="4023360"/>
+            <a:ext cx="54864" cy="1143000"/>
+          </a:xfrm>
+          <a:prstGeom prst="rect">
+            <a:avLst/>
+          </a:prstGeom>
+          <a:solidFill>
+            <a:srgbClr val="2E7D32"/>
+          </a:solidFill>
+          <a:ln/>
+        </p:spPr>
+      </p:sp>
+      <p:sp>
+        <p:nvSpPr>
+          <p:cNvPr id="20" name="Text 18"/>
+          <p:cNvSpPr/>
+          <p:nvPr/>
+        </p:nvSpPr>
+        <p:spPr>
+          <a:xfrm>
+            <a:off x="502920" y="4096512"/>
+            <a:ext cx="11365992" cy="274320"/>
+          </a:xfrm>
+          <a:prstGeom prst="rect">
+            <a:avLst/>
+          </a:prstGeom>
+          <a:noFill/>
+          <a:ln/>
+        </p:spPr>
+        <p:txBody>
+          <a:bodyPr wrap="square" rtlCol="0" anchor="ctr"/>
+          <a:lstStyle/>
+          <a:p>
+            <a:pPr indent="0" marL="0">
+              <a:buNone/>
+            </a:pPr>
+            <a:r>
+              <a:rPr lang="en-US" sz="1100" b="1" dirty="0">
+                <a:solidFill>
+                  <a:srgbClr val="2E7D32"/>
+                </a:solidFill>
+                <a:latin typeface="Calibri" pitchFamily="34" charset="0"/>
+                <a:ea typeface="Calibri" pitchFamily="34" charset="-122"/>
+                <a:cs typeface="Calibri" pitchFamily="34" charset="-120"/>
+              </a:rPr>
+              <a:t>Write Race Finding</a:t>
+            </a:r>
+            <a:endParaRPr lang="en-US" sz="1100" dirty="0"/>
+          </a:p>
+        </p:txBody>
+      </p:sp>
+      <p:sp>
+        <p:nvSpPr>
+          <p:cNvPr id="21" name="Text 19"/>
+          <p:cNvSpPr/>
+          <p:nvPr/>
+        </p:nvSpPr>
+        <p:spPr>
+          <a:xfrm>
+            <a:off x="502920" y="4389120"/>
+            <a:ext cx="11365992" cy="667512"/>
+          </a:xfrm>
+          <a:prstGeom prst="rect">
+            <a:avLst/>
+          </a:prstGeom>
+          <a:noFill/>
+          <a:ln/>
+        </p:spPr>
+        <p:txBody>
+          <a:bodyPr wrap="square" rtlCol="0" anchor="t"/>
+          <a:lstStyle/>
+          <a:p>
+            <a:pPr indent="0" marL="0">
+              <a:buNone/>
+            </a:pPr>
+            <a:r>
+              <a:rPr lang="en-US" sz="1050" dirty="0">
+                <a:solidFill>
+                  <a:srgbClr val="2D2D2D"/>
+                </a:solidFill>
+                <a:latin typeface="Calibri" pitchFamily="34" charset="0"/>
+                <a:ea typeface="Calibri" pitchFamily="34" charset="-122"/>
+                <a:cs typeface="Calibri" pitchFamily="34" charset="-120"/>
+              </a:rPr>
+              <a:t>Total stabilisation took ~30s because recovery and Phase 1 entered a write race: recovery wrote MV101=OPEN, Phase 1 immediately re-wrote MV101=CLOSED on the next cycle. Plant only stabilised after Phase 1 timer elapsed. Key lesson: containment (Step 2: iptables block on attacker IP) MUST succeed before safe-state writes can hold. In production the attacker is on a separate host; in the demo both ran on the same HMI, so iptables could not block the re-injection.</a:t>
             </a:r>
             <a:endParaRPr lang="en-US" sz="1050" dirty="0"/>
           </a:p>

</xml_diff>

<commit_message>
slides: add 3 evaluation slides (DR/FPR/RT) using python-pptx
Properly created via python-pptx (not XML duplication):
- Slide 29: Detection Rate — invariant 1s, AE 10s/94%, hybrid, concealment gap
- Slide 30: False Positive Rate — AE 0%, invariant 0%, interpretation
- Slide 31: Recovery Time — fusion 3s, safe state <5s, write race finding

52 slides total (was 49)
</commit_message>
<xml_diff>
--- a/slides/swat_sutd.pptx
+++ b/slides/swat_sutd.pptx
@@ -33,14 +33,14 @@
     <p:sldId id="281" r:id="rId27"/>
     <p:sldId id="282" r:id="rId28"/>
     <p:sldId id="283" r:id="rId29"/>
+    <p:sldId id="305" r:id="rId56"/>
+    <p:sldId id="306" r:id="rId57"/>
+    <p:sldId id="307" r:id="rId58"/>
     <p:sldId id="284" r:id="rId30"/>
     <p:sldId id="285" r:id="rId31"/>
     <p:sldId id="286" r:id="rId32"/>
     <p:sldId id="287" r:id="rId33"/>
     <p:sldId id="288" r:id="rId34"/>
-    <p:sldId id="306" r:id="rId56"/>
-    <p:sldId id="307" r:id="rId57"/>
-    <p:sldId id="308" r:id="rId58"/>
     <p:sldId id="289" r:id="rId35"/>
     <p:sldId id="290" r:id="rId36"/>
     <p:sldId id="291" r:id="rId37"/>
@@ -27077,7 +27077,7 @@
                 <a:ea typeface="Calibri" pitchFamily="34" charset="-122"/>
                 <a:cs typeface="Calibri" pitchFamily="34" charset="-120"/>
               </a:rPr>
-              <a:t>Live SWaT testbed (16 Apr 2026) — Attack confirmed, defence validated</a:t>
+              <a:t>Live testbed results (16 Apr 2026) + simulated validation (test_detectors.py)</a:t>
             </a:r>
             <a:endParaRPr lang="en-US" sz="1200" dirty="0"/>
           </a:p>
@@ -27161,7 +27161,7 @@
                 <a:ea typeface="Calibri" pitchFamily="34" charset="-122"/>
                 <a:cs typeface="Calibri" pitchFamily="34" charset="-120"/>
               </a:rPr>
-              <a:t>Attack Execution</a:t>
+              <a:t>Detection Rate (DR)</a:t>
             </a:r>
             <a:endParaRPr lang="en-US" sz="1100" dirty="0"/>
           </a:p>
@@ -27200,7 +27200,7 @@
                 <a:ea typeface="Calibri" pitchFamily="34" charset="-122"/>
                 <a:cs typeface="Calibri" pitchFamily="34" charset="-120"/>
               </a:rPr>
-              <a:t>Phase 1: 120 CIP writes 2014 MV101=CLOSED, P101=ON, MV201=OPEN. Physical tank drained from 609mm to 502mm (107mm drop, ~0.9mm/s). Phase 2: 106 adversarial Sim_PV cycles 2014 HMI showed LIT101=1345mm while physical tank was at ~502mm. 736mm concealment gap confirmed on-site.</a:t>
+              <a:t>Live: Invariant detected cycle 1 (I-2 + I-9). I-9b/I-9c also fired but excluded (supplementary rules). 104 violation cycles. AE detection time: 10s (window fills). Simulated AE detection rate (LIT-only): 94/100 (94%). AE evasion by Phase 2: inconclusive on live (FIT101=-31 saturated AE).</a:t>
             </a:r>
             <a:endParaRPr lang="en-US" sz="1050" dirty="0"/>
           </a:p>
@@ -27284,7 +27284,7 @@
                 <a:ea typeface="Calibri" pitchFamily="34" charset="-122"/>
                 <a:cs typeface="Calibri" pitchFamily="34" charset="-120"/>
               </a:rPr>
-              <a:t>Key Finding</a:t>
+              <a:t>False Positive Rate (FPR)</a:t>
             </a:r>
             <a:endParaRPr lang="en-US" sz="1100" dirty="0"/>
           </a:p>
@@ -27323,7 +27323,7 @@
                 <a:ea typeface="Calibri" pitchFamily="34" charset="-122"/>
                 <a:cs typeface="Calibri" pitchFamily="34" charset="-120"/>
               </a:rPr>
-              <a:t>Invariant layer detected attack within 1 cycle by reading actuator commands (HMI_MV101.Cmd, HMI_P101.Auto) via CIP 2014 these cannot be spoofed by sensor-level Sim_PV writes. Phase 2 completely deceived the HMI, but the hybrid defence caught it anyway. This validates the core thesis: physics-based invariants provide a detection channel immune to ML evasion.</a:t>
+              <a:t>Live FPR: Inconclusive — plant started in attack-equivalent state (MV101=CLOSED, FIT101=-31). Invariants correctly identified unsafe config (true positive). Phase 2 concealment: 736mm gap (HMI 1345mm vs physical 502mm). Simulated: 0/500 AE false alarms (0.0%), MSE 19x below threshold.</a:t>
             </a:r>
             <a:endParaRPr lang="en-US" sz="1050" dirty="0"/>
           </a:p>
@@ -27407,7 +27407,7 @@
                 <a:ea typeface="Calibri" pitchFamily="34" charset="-122"/>
                 <a:cs typeface="Calibri" pitchFamily="34" charset="-120"/>
               </a:rPr>
-              <a:t>Evidence</a:t>
+              <a:t>Recovery Time (RT)</a:t>
             </a:r>
             <a:endParaRPr lang="en-US" sz="1100" dirty="0"/>
           </a:p>
@@ -27446,7 +27446,7 @@
                 <a:ea typeface="Calibri" pitchFamily="34" charset="-122"/>
                 <a:cs typeface="Calibri" pitchFamily="34" charset="-120"/>
               </a:rPr>
-              <a:t>104 invariant violations logged. Fusion ALERT in 3s. Recovery restored PLC1+PLC2 safe state. All evidence archived: invariant_checker.log, autoencoder.log, fusion.log, phase1.log, phase2.log, state snapshots, timeline.json. Detailed metrics on following 3 slides.</a:t>
+              <a:t>Live: Fusion ALERT in 3s (exact match with design). Recovery writes completed &lt;5s. But safe state did not hold — Phase 1 re-injected MV101=CLOSED every cycle (write race). Plant stabilised ~30s after attack ended. Finding: containment (iptables block) must precede safe-state writes. Simulated: &lt;12s total.</a:t>
             </a:r>
             <a:endParaRPr lang="en-US" sz="1050" dirty="0"/>
           </a:p>
@@ -51103,624 +51103,342 @@
 </file>
 
 <file path=ppt/slides/slide50.xml><?xml version="1.0" encoding="utf-8"?>
-<p:sld xmlns:a="http://schemas.openxmlformats.org/drawingml/2006/main" xmlns:r="http://schemas.openxmlformats.org/officeDocument/2006/relationships" xmlns:p="http://schemas.openxmlformats.org/presentationml/2006/main">
-  <p:cSld name="Slide 28">
+<p:sld xmlns:a="http://schemas.openxmlformats.org/drawingml/2006/main" xmlns:p="http://schemas.openxmlformats.org/presentationml/2006/main" xmlns:r="http://schemas.openxmlformats.org/officeDocument/2006/relationships">
+  <p:cSld>
     <p:spTree>
       <p:nvGrpSpPr>
         <p:cNvPr id="1" name=""/>
         <p:cNvGrpSpPr/>
         <p:nvPr/>
       </p:nvGrpSpPr>
-      <p:grpSpPr>
-        <a:xfrm>
-          <a:off x="0" y="0"/>
-          <a:ext cx="0" cy="0"/>
-          <a:chOff x="0" y="0"/>
-          <a:chExt cx="0" cy="0"/>
-        </a:xfrm>
-      </p:grpSpPr>
-      <p:sp>
-        <p:nvSpPr>
-          <p:cNvPr id="2" name="Shape 0"/>
-          <p:cNvSpPr/>
-          <p:nvPr/>
-        </p:nvSpPr>
-        <p:spPr>
-          <a:xfrm>
-            <a:off x="0" y="0"/>
-            <a:ext cx="12188952" cy="6858000"/>
-          </a:xfrm>
-          <a:prstGeom prst="rect">
-            <a:avLst/>
-          </a:prstGeom>
-          <a:solidFill>
-            <a:srgbClr val="FFFFFF"/>
-          </a:solidFill>
-          <a:ln/>
-        </p:spPr>
-      </p:sp>
-      <p:sp>
-        <p:nvSpPr>
-          <p:cNvPr id="3" name="Shape 1"/>
-          <p:cNvSpPr/>
-          <p:nvPr/>
-        </p:nvSpPr>
-        <p:spPr>
-          <a:xfrm>
-            <a:off x="0" y="0"/>
-            <a:ext cx="12188952" cy="64008"/>
-          </a:xfrm>
-          <a:prstGeom prst="rect">
-            <a:avLst/>
-          </a:prstGeom>
-          <a:solidFill>
-            <a:srgbClr val="E8243C"/>
-          </a:solidFill>
-          <a:ln/>
-        </p:spPr>
-      </p:sp>
-      <p:sp>
-        <p:nvSpPr>
-          <p:cNvPr id="4" name="Shape 2"/>
-          <p:cNvSpPr/>
-          <p:nvPr/>
-        </p:nvSpPr>
-        <p:spPr>
-          <a:xfrm>
-            <a:off x="0" y="6510528"/>
-            <a:ext cx="12188952" cy="347472"/>
-          </a:xfrm>
-          <a:prstGeom prst="rect">
-            <a:avLst/>
-          </a:prstGeom>
-          <a:solidFill>
-            <a:srgbClr val="F5F5F5"/>
-          </a:solidFill>
-          <a:ln/>
-        </p:spPr>
-      </p:sp>
-      <p:sp>
-        <p:nvSpPr>
-          <p:cNvPr id="5" name="Text 3"/>
-          <p:cNvSpPr/>
-          <p:nvPr/>
-        </p:nvSpPr>
-        <p:spPr>
-          <a:xfrm>
-            <a:off x="274320" y="6565392"/>
-            <a:ext cx="11640312" cy="219456"/>
-          </a:xfrm>
-          <a:prstGeom prst="rect">
-            <a:avLst/>
-          </a:prstGeom>
-          <a:noFill/>
-          <a:ln/>
-        </p:spPr>
-        <p:txBody>
-          <a:bodyPr wrap="square" rtlCol="0" anchor="ctr"/>
-          <a:lstStyle/>
-          <a:p>
-            <a:pPr algn="l" indent="0" marL="0">
-              <a:buNone/>
-            </a:pPr>
-            <a:r>
-              <a:rPr lang="en-US" sz="800" dirty="0">
-                <a:solidFill>
-                  <a:srgbClr val="6B6B6B"/>
-                </a:solidFill>
-                <a:latin typeface="Calibri" pitchFamily="34" charset="0"/>
-                <a:ea typeface="Calibri" pitchFamily="34" charset="-122"/>
-                <a:cs typeface="Calibri" pitchFamily="34" charset="-120"/>
+      <p:grpSpPr/>
+      <p:sp>
+        <p:nvSpPr>
+          <p:cNvPr id="2" name="TextBox 1"/>
+          <p:cNvSpPr txBox="1"/>
+          <p:nvPr/>
+        </p:nvSpPr>
+        <p:spPr>
+          <a:xfrm>
+            <a:off x="457200" y="182880"/>
+            <a:ext cx="1828800" cy="274320"/>
+          </a:xfrm>
+          <a:prstGeom prst="rect">
+            <a:avLst/>
+          </a:prstGeom>
+          <a:noFill/>
+        </p:spPr>
+        <p:txBody>
+          <a:bodyPr wrap="square">
+            <a:spAutoFit/>
+          </a:bodyPr>
+          <a:lstStyle/>
+          <a:p>
+            <a:r>
+              <a:rPr sz="1000" b="1">
+                <a:solidFill>
+                  <a:srgbClr val="CC0000"/>
+                </a:solidFill>
+              </a:rPr>
+              <a:t>EVAL</a:t>
+            </a:r>
+          </a:p>
+        </p:txBody>
+      </p:sp>
+      <p:sp>
+        <p:nvSpPr>
+          <p:cNvPr id="3" name="TextBox 2"/>
+          <p:cNvSpPr txBox="1"/>
+          <p:nvPr/>
+        </p:nvSpPr>
+        <p:spPr>
+          <a:xfrm>
+            <a:off x="457200" y="411480"/>
+            <a:ext cx="8229600" cy="457200"/>
+          </a:xfrm>
+          <a:prstGeom prst="rect">
+            <a:avLst/>
+          </a:prstGeom>
+          <a:noFill/>
+        </p:spPr>
+        <p:txBody>
+          <a:bodyPr wrap="square">
+            <a:spAutoFit/>
+          </a:bodyPr>
+          <a:lstStyle/>
+          <a:p>
+            <a:r>
+              <a:rPr sz="2200" b="1">
+                <a:solidFill>
+                  <a:srgbClr val="1F3864"/>
+                </a:solidFill>
+              </a:rPr>
+              <a:t>Detection Rate — Live vs Expected vs Simulated</a:t>
+            </a:r>
+          </a:p>
+        </p:txBody>
+      </p:sp>
+      <p:sp>
+        <p:nvSpPr>
+          <p:cNvPr id="4" name="TextBox 3"/>
+          <p:cNvSpPr txBox="1"/>
+          <p:nvPr/>
+        </p:nvSpPr>
+        <p:spPr>
+          <a:xfrm>
+            <a:off x="457200" y="868680"/>
+            <a:ext cx="8229600" cy="274320"/>
+          </a:xfrm>
+          <a:prstGeom prst="rect">
+            <a:avLst/>
+          </a:prstGeom>
+          <a:noFill/>
+        </p:spPr>
+        <p:txBody>
+          <a:bodyPr wrap="square">
+            <a:spAutoFit/>
+          </a:bodyPr>
+          <a:lstStyle/>
+          <a:p>
+            <a:r>
+              <a:rPr sz="1100" b="0">
+                <a:solidFill>
+                  <a:srgbClr val="666666"/>
+                </a:solidFill>
+              </a:rPr>
+              <a:t>How fast and how reliably does the defence detect Phase 1?</a:t>
+            </a:r>
+          </a:p>
+        </p:txBody>
+      </p:sp>
+      <p:sp>
+        <p:nvSpPr>
+          <p:cNvPr id="5" name="TextBox 4"/>
+          <p:cNvSpPr txBox="1"/>
+          <p:nvPr/>
+        </p:nvSpPr>
+        <p:spPr>
+          <a:xfrm>
+            <a:off x="457200" y="1280160"/>
+            <a:ext cx="8229600" cy="274320"/>
+          </a:xfrm>
+          <a:prstGeom prst="rect">
+            <a:avLst/>
+          </a:prstGeom>
+          <a:noFill/>
+        </p:spPr>
+        <p:txBody>
+          <a:bodyPr wrap="square">
+            <a:spAutoFit/>
+          </a:bodyPr>
+          <a:lstStyle/>
+          <a:p>
+            <a:r>
+              <a:rPr sz="1300" b="1">
+                <a:solidFill>
+                  <a:srgbClr val="2E75B6"/>
+                </a:solidFill>
+              </a:rPr>
+              <a:t>Invariant Detection Time</a:t>
+            </a:r>
+          </a:p>
+        </p:txBody>
+      </p:sp>
+      <p:sp>
+        <p:nvSpPr>
+          <p:cNvPr id="6" name="TextBox 5"/>
+          <p:cNvSpPr txBox="1"/>
+          <p:nvPr/>
+        </p:nvSpPr>
+        <p:spPr>
+          <a:xfrm>
+            <a:off x="457200" y="1600200"/>
+            <a:ext cx="8229600" cy="1097280"/>
+          </a:xfrm>
+          <a:prstGeom prst="rect">
+            <a:avLst/>
+          </a:prstGeom>
+          <a:noFill/>
+        </p:spPr>
+        <p:txBody>
+          <a:bodyPr wrap="square">
+            <a:spAutoFit/>
+          </a:bodyPr>
+          <a:lstStyle/>
+          <a:p>
+            <a:r>
+              <a:rPr sz="1000" b="0">
+                <a:solidFill>
+                  <a:srgbClr val="333333"/>
+                </a:solidFill>
+              </a:rPr>
+              <a:t>Expected: 1–6s. Live: 1s (cycle 1, I-2 + I-9 fired). Simulated: 1s (cycle 1). I-9 is the Phase 1 signature invariant: MV101=CLOSED + P101=ON in normal range. I-9b/I-9c also fired but excluded from primary claim (supplementary rules). 104 total violation cycles over the 120s attack.</a:t>
+            </a:r>
+          </a:p>
+        </p:txBody>
+      </p:sp>
+      <p:sp>
+        <p:nvSpPr>
+          <p:cNvPr id="7" name="TextBox 6"/>
+          <p:cNvSpPr txBox="1"/>
+          <p:nvPr/>
+        </p:nvSpPr>
+        <p:spPr>
+          <a:xfrm>
+            <a:off x="457200" y="2834640"/>
+            <a:ext cx="8229600" cy="274320"/>
+          </a:xfrm>
+          <a:prstGeom prst="rect">
+            <a:avLst/>
+          </a:prstGeom>
+          <a:noFill/>
+        </p:spPr>
+        <p:txBody>
+          <a:bodyPr wrap="square">
+            <a:spAutoFit/>
+          </a:bodyPr>
+          <a:lstStyle/>
+          <a:p>
+            <a:r>
+              <a:rPr sz="1300" b="1">
+                <a:solidFill>
+                  <a:srgbClr val="2E75B6"/>
+                </a:solidFill>
+              </a:rPr>
+              <a:t>AE Detection Time + Rate</a:t>
+            </a:r>
+          </a:p>
+        </p:txBody>
+      </p:sp>
+      <p:sp>
+        <p:nvSpPr>
+          <p:cNvPr id="8" name="TextBox 7"/>
+          <p:cNvSpPr txBox="1"/>
+          <p:nvPr/>
+        </p:nvSpPr>
+        <p:spPr>
+          <a:xfrm>
+            <a:off x="457200" y="3154680"/>
+            <a:ext cx="8229600" cy="1097280"/>
+          </a:xfrm>
+          <a:prstGeom prst="rect">
+            <a:avLst/>
+          </a:prstGeom>
+          <a:noFill/>
+        </p:spPr>
+        <p:txBody>
+          <a:bodyPr wrap="square">
+            <a:spAutoFit/>
+          </a:bodyPr>
+          <a:lstStyle/>
+          <a:p>
+            <a:r>
+              <a:rPr sz="1000" b="0">
+                <a:solidFill>
+                  <a:srgbClr val="333333"/>
+                </a:solidFill>
+              </a:rPr>
+              <a:t>Expected time: 10–15s (window=10 must fill). Live: 10s (cycle 10). Expected rate: &gt;90%. Simulated (LIT-only AE): 94/100 = 94%. Live rate: inconclusive — FIT101=-31 sensor fault produced MSE=367 (500,000× above threshold), saturating the AE before Phase 2 started. Models retrained on LIT101 only.</a:t>
+            </a:r>
+          </a:p>
+        </p:txBody>
+      </p:sp>
+      <p:sp>
+        <p:nvSpPr>
+          <p:cNvPr id="9" name="TextBox 8"/>
+          <p:cNvSpPr txBox="1"/>
+          <p:nvPr/>
+        </p:nvSpPr>
+        <p:spPr>
+          <a:xfrm>
+            <a:off x="457200" y="4389120"/>
+            <a:ext cx="8229600" cy="274320"/>
+          </a:xfrm>
+          <a:prstGeom prst="rect">
+            <a:avLst/>
+          </a:prstGeom>
+          <a:noFill/>
+        </p:spPr>
+        <p:txBody>
+          <a:bodyPr wrap="square">
+            <a:spAutoFit/>
+          </a:bodyPr>
+          <a:lstStyle/>
+          <a:p>
+            <a:r>
+              <a:rPr sz="1300" b="1">
+                <a:solidFill>
+                  <a:srgbClr val="2E75B6"/>
+                </a:solidFill>
+              </a:rPr>
+              <a:t>Hybrid Detection Under Phase 1+2</a:t>
+            </a:r>
+          </a:p>
+        </p:txBody>
+      </p:sp>
+      <p:sp>
+        <p:nvSpPr>
+          <p:cNvPr id="10" name="TextBox 9"/>
+          <p:cNvSpPr txBox="1"/>
+          <p:nvPr/>
+        </p:nvSpPr>
+        <p:spPr>
+          <a:xfrm>
+            <a:off x="457200" y="4709160"/>
+            <a:ext cx="8229600" cy="1097280"/>
+          </a:xfrm>
+          <a:prstGeom prst="rect">
+            <a:avLst/>
+          </a:prstGeom>
+          <a:noFill/>
+        </p:spPr>
+        <p:txBody>
+          <a:bodyPr wrap="square">
+            <a:spAutoFit/>
+          </a:bodyPr>
+          <a:lstStyle/>
+          <a:p>
+            <a:r>
+              <a:rPr sz="1000" b="0">
+                <a:solidFill>
+                  <a:srgbClr val="333333"/>
+                </a:solidFill>
+              </a:rPr>
+              <a:t>Expected: 1–6s (invariant catches, AE may be evaded). Live: 1s (invariant). AE evasion by Phase 2: inconclusive (FIT101 fault confounded). Simulated: invariant 10/10 regardless. Concealment gap: 736mm (HMI 1345mm vs physical 502mm). Core thesis: actuator-command invariants immune to sensor-level perturbation.</a:t>
+            </a:r>
+          </a:p>
+        </p:txBody>
+      </p:sp>
+      <p:sp>
+        <p:nvSpPr>
+          <p:cNvPr id="11" name="TextBox 10"/>
+          <p:cNvSpPr txBox="1"/>
+          <p:nvPr/>
+        </p:nvSpPr>
+        <p:spPr>
+          <a:xfrm>
+            <a:off x="457200" y="6492240"/>
+            <a:ext cx="8229600" cy="228600"/>
+          </a:xfrm>
+          <a:prstGeom prst="rect">
+            <a:avLst/>
+          </a:prstGeom>
+          <a:noFill/>
+        </p:spPr>
+        <p:txBody>
+          <a:bodyPr wrap="square">
+            <a:spAutoFit/>
+          </a:bodyPr>
+          <a:lstStyle/>
+          <a:p>
+            <a:r>
+              <a:rPr sz="800" b="0">
+                <a:solidFill>
+                  <a:srgbClr val="999999"/>
+                </a:solidFill>
               </a:rPr>
               <a:t>51.508 Secure Cyber Physical Systems  ·  SWaT Project  ·  iTrust Lab, SUTD</a:t>
             </a:r>
-            <a:endParaRPr lang="en-US" sz="800" dirty="0"/>
-          </a:p>
-        </p:txBody>
-      </p:sp>
-      <p:sp>
-        <p:nvSpPr>
-          <p:cNvPr id="6" name="Shape 4"/>
-          <p:cNvSpPr/>
-          <p:nvPr/>
-        </p:nvSpPr>
-        <p:spPr>
-          <a:xfrm>
-            <a:off x="320040" y="109728"/>
-            <a:ext cx="1280160" cy="292608"/>
-          </a:xfrm>
-          <a:prstGeom prst="rect">
-            <a:avLst/>
-          </a:prstGeom>
-          <a:solidFill>
-            <a:srgbClr val="2E7D32"/>
-          </a:solidFill>
-          <a:ln/>
-        </p:spPr>
-      </p:sp>
-      <p:sp>
-        <p:nvSpPr>
-          <p:cNvPr id="7" name="Text 5"/>
-          <p:cNvSpPr/>
-          <p:nvPr/>
-        </p:nvSpPr>
-        <p:spPr>
-          <a:xfrm>
-            <a:off x="320040" y="109728"/>
-            <a:ext cx="1280160" cy="292608"/>
-          </a:xfrm>
-          <a:prstGeom prst="rect">
-            <a:avLst/>
-          </a:prstGeom>
-          <a:noFill/>
-          <a:ln/>
-        </p:spPr>
-        <p:txBody>
-          <a:bodyPr wrap="square" rtlCol="0" anchor="ctr"/>
-          <a:lstStyle/>
-          <a:p>
-            <a:pPr algn="ctr" indent="0" marL="0">
-              <a:buNone/>
-            </a:pPr>
-            <a:r>
-              <a:rPr lang="en-US" sz="1000" b="1" dirty="0">
-                <a:solidFill>
-                  <a:srgbClr val="FFFFFF"/>
-                </a:solidFill>
-                <a:latin typeface="Calibri" pitchFamily="34" charset="0"/>
-                <a:ea typeface="Calibri" pitchFamily="34" charset="-122"/>
-                <a:cs typeface="Calibri" pitchFamily="34" charset="-120"/>
-              </a:rPr>
-              <a:t>EVAL</a:t>
-            </a:r>
-            <a:endParaRPr lang="en-US" sz="1000" dirty="0"/>
-          </a:p>
-        </p:txBody>
-      </p:sp>
-      <p:sp>
-        <p:nvSpPr>
-          <p:cNvPr id="8" name="Text 6"/>
-          <p:cNvSpPr/>
-          <p:nvPr/>
-        </p:nvSpPr>
-        <p:spPr>
-          <a:xfrm>
-            <a:off x="320040" y="457200"/>
-            <a:ext cx="11548872" cy="640080"/>
-          </a:xfrm>
-          <a:prstGeom prst="rect">
-            <a:avLst/>
-          </a:prstGeom>
-          <a:noFill/>
-          <a:ln/>
-        </p:spPr>
-        <p:txBody>
-          <a:bodyPr wrap="square" rtlCol="0" anchor="ctr"/>
-          <a:lstStyle/>
-          <a:p>
-            <a:pPr indent="0" marL="0">
-              <a:buNone/>
-            </a:pPr>
-            <a:r>
-              <a:rPr lang="en-US" sz="3200" b="1" dirty="0">
-                <a:solidFill>
-                  <a:srgbClr val="1A1A1A"/>
-                </a:solidFill>
-                <a:latin typeface="Calibri Light" pitchFamily="34" charset="0"/>
-                <a:ea typeface="Calibri Light" pitchFamily="34" charset="-122"/>
-                <a:cs typeface="Calibri Light" pitchFamily="34" charset="-120"/>
-              </a:rPr>
-              <a:t>Detection Rate 2014 Live vs Expected vs Simulated</a:t>
-            </a:r>
-            <a:endParaRPr lang="en-US" sz="3200" dirty="0"/>
-          </a:p>
-        </p:txBody>
-      </p:sp>
-      <p:sp>
-        <p:nvSpPr>
-          <p:cNvPr id="9" name="Text 7"/>
-          <p:cNvSpPr/>
-          <p:nvPr/>
-        </p:nvSpPr>
-        <p:spPr>
-          <a:xfrm>
-            <a:off x="320040" y="1051560"/>
-            <a:ext cx="11548872" cy="256032"/>
-          </a:xfrm>
-          <a:prstGeom prst="rect">
-            <a:avLst/>
-          </a:prstGeom>
-          <a:noFill/>
-          <a:ln/>
-        </p:spPr>
-        <p:txBody>
-          <a:bodyPr wrap="square" rtlCol="0" anchor="ctr"/>
-          <a:lstStyle/>
-          <a:p>
-            <a:pPr indent="0" marL="0">
-              <a:buNone/>
-            </a:pPr>
-            <a:r>
-              <a:rPr lang="en-US" sz="1200" i="1" dirty="0">
-                <a:solidFill>
-                  <a:srgbClr val="6B6B6B"/>
-                </a:solidFill>
-                <a:latin typeface="Calibri" pitchFamily="34" charset="0"/>
-                <a:ea typeface="Calibri" pitchFamily="34" charset="-122"/>
-                <a:cs typeface="Calibri" pitchFamily="34" charset="-120"/>
-              </a:rPr>
-              <a:t>How fast and how reliably does the defence detect Phase 1?</a:t>
-            </a:r>
-            <a:endParaRPr lang="en-US" sz="1200" dirty="0"/>
-          </a:p>
-        </p:txBody>
-      </p:sp>
-      <p:sp>
-        <p:nvSpPr>
-          <p:cNvPr id="10" name="Shape 8"/>
-          <p:cNvSpPr/>
-          <p:nvPr/>
-        </p:nvSpPr>
-        <p:spPr>
-          <a:xfrm>
-            <a:off x="320040" y="1463040"/>
-            <a:ext cx="11548872" cy="1143000"/>
-          </a:xfrm>
-          <a:prstGeom prst="rect">
-            <a:avLst/>
-          </a:prstGeom>
-          <a:solidFill>
-            <a:srgbClr val="F5F5F5"/>
-          </a:solidFill>
-          <a:ln w="12700">
-            <a:solidFill>
-              <a:srgbClr val="E0E0E0"/>
-            </a:solidFill>
-            <a:prstDash val="solid"/>
-          </a:ln>
-        </p:spPr>
-      </p:sp>
-      <p:sp>
-        <p:nvSpPr>
-          <p:cNvPr id="11" name="Shape 9"/>
-          <p:cNvSpPr/>
-          <p:nvPr/>
-        </p:nvSpPr>
-        <p:spPr>
-          <a:xfrm>
-            <a:off x="320040" y="1463040"/>
-            <a:ext cx="54864" cy="1143000"/>
-          </a:xfrm>
-          <a:prstGeom prst="rect">
-            <a:avLst/>
-          </a:prstGeom>
-          <a:solidFill>
-            <a:srgbClr val="2E7D32"/>
-          </a:solidFill>
-          <a:ln/>
-        </p:spPr>
-      </p:sp>
-      <p:sp>
-        <p:nvSpPr>
-          <p:cNvPr id="12" name="Text 10"/>
-          <p:cNvSpPr/>
-          <p:nvPr/>
-        </p:nvSpPr>
-        <p:spPr>
-          <a:xfrm>
-            <a:off x="502920" y="1536192"/>
-            <a:ext cx="11365992" cy="274320"/>
-          </a:xfrm>
-          <a:prstGeom prst="rect">
-            <a:avLst/>
-          </a:prstGeom>
-          <a:noFill/>
-          <a:ln/>
-        </p:spPr>
-        <p:txBody>
-          <a:bodyPr wrap="square" rtlCol="0" anchor="ctr"/>
-          <a:lstStyle/>
-          <a:p>
-            <a:pPr indent="0" marL="0">
-              <a:buNone/>
-            </a:pPr>
-            <a:r>
-              <a:rPr lang="en-US" sz="1100" b="1" dirty="0">
-                <a:solidFill>
-                  <a:srgbClr val="2E7D32"/>
-                </a:solidFill>
-                <a:latin typeface="Calibri" pitchFamily="34" charset="0"/>
-                <a:ea typeface="Calibri" pitchFamily="34" charset="-122"/>
-                <a:cs typeface="Calibri" pitchFamily="34" charset="-120"/>
-              </a:rPr>
-              <a:t>Invariant Detection Time</a:t>
-            </a:r>
-            <a:endParaRPr lang="en-US" sz="1100" dirty="0"/>
-          </a:p>
-        </p:txBody>
-      </p:sp>
-      <p:sp>
-        <p:nvSpPr>
-          <p:cNvPr id="13" name="Text 11"/>
-          <p:cNvSpPr/>
-          <p:nvPr/>
-        </p:nvSpPr>
-        <p:spPr>
-          <a:xfrm>
-            <a:off x="502920" y="1828800"/>
-            <a:ext cx="11365992" cy="667512"/>
-          </a:xfrm>
-          <a:prstGeom prst="rect">
-            <a:avLst/>
-          </a:prstGeom>
-          <a:noFill/>
-          <a:ln/>
-        </p:spPr>
-        <p:txBody>
-          <a:bodyPr wrap="square" rtlCol="0" anchor="t"/>
-          <a:lstStyle/>
-          <a:p>
-            <a:pPr indent="0" marL="0">
-              <a:buNone/>
-            </a:pPr>
-            <a:r>
-              <a:rPr lang="en-US" sz="1050" dirty="0">
-                <a:solidFill>
-                  <a:srgbClr val="2D2D2D"/>
-                </a:solidFill>
-                <a:latin typeface="Calibri" pitchFamily="34" charset="0"/>
-                <a:ea typeface="Calibri" pitchFamily="34" charset="-122"/>
-                <a:cs typeface="Calibri" pitchFamily="34" charset="-120"/>
-              </a:rPr>
-              <a:t>Expected: 120136s. Live: 1s (cycle 1, I-2 + I-9 fired). Simulated: 1s (cycle 1). I-9 is the Phase 1 signature invariant: MV101=CLOSED + P101=ON in normal range. I-9b/I-9c also fired but excluded from primary claim (supplementary rules for PLC failover and sensor fault edge cases). 104 total violation cycles over the 120s attack.</a:t>
-            </a:r>
-            <a:endParaRPr lang="en-US" sz="1050" dirty="0"/>
-          </a:p>
-        </p:txBody>
-      </p:sp>
-      <p:sp>
-        <p:nvSpPr>
-          <p:cNvPr id="14" name="Shape 12"/>
-          <p:cNvSpPr/>
-          <p:nvPr/>
-        </p:nvSpPr>
-        <p:spPr>
-          <a:xfrm>
-            <a:off x="320040" y="2743200"/>
-            <a:ext cx="11548872" cy="1143000"/>
-          </a:xfrm>
-          <a:prstGeom prst="rect">
-            <a:avLst/>
-          </a:prstGeom>
-          <a:solidFill>
-            <a:srgbClr val="F5F5F5"/>
-          </a:solidFill>
-          <a:ln w="12700">
-            <a:solidFill>
-              <a:srgbClr val="E0E0E0"/>
-            </a:solidFill>
-            <a:prstDash val="solid"/>
-          </a:ln>
-        </p:spPr>
-      </p:sp>
-      <p:sp>
-        <p:nvSpPr>
-          <p:cNvPr id="15" name="Shape 13"/>
-          <p:cNvSpPr/>
-          <p:nvPr/>
-        </p:nvSpPr>
-        <p:spPr>
-          <a:xfrm>
-            <a:off x="320040" y="2743200"/>
-            <a:ext cx="54864" cy="1143000"/>
-          </a:xfrm>
-          <a:prstGeom prst="rect">
-            <a:avLst/>
-          </a:prstGeom>
-          <a:solidFill>
-            <a:srgbClr val="2E7D32"/>
-          </a:solidFill>
-          <a:ln/>
-        </p:spPr>
-      </p:sp>
-      <p:sp>
-        <p:nvSpPr>
-          <p:cNvPr id="16" name="Text 14"/>
-          <p:cNvSpPr/>
-          <p:nvPr/>
-        </p:nvSpPr>
-        <p:spPr>
-          <a:xfrm>
-            <a:off x="502920" y="2816352"/>
-            <a:ext cx="11365992" cy="274320"/>
-          </a:xfrm>
-          <a:prstGeom prst="rect">
-            <a:avLst/>
-          </a:prstGeom>
-          <a:noFill/>
-          <a:ln/>
-        </p:spPr>
-        <p:txBody>
-          <a:bodyPr wrap="square" rtlCol="0" anchor="ctr"/>
-          <a:lstStyle/>
-          <a:p>
-            <a:pPr indent="0" marL="0">
-              <a:buNone/>
-            </a:pPr>
-            <a:r>
-              <a:rPr lang="en-US" sz="1100" b="1" dirty="0">
-                <a:solidFill>
-                  <a:srgbClr val="2E7D32"/>
-                </a:solidFill>
-                <a:latin typeface="Calibri" pitchFamily="34" charset="0"/>
-                <a:ea typeface="Calibri" pitchFamily="34" charset="-122"/>
-                <a:cs typeface="Calibri" pitchFamily="34" charset="-120"/>
-              </a:rPr>
-              <a:t>AE Detection Time + Rate</a:t>
-            </a:r>
-            <a:endParaRPr lang="en-US" sz="1100" dirty="0"/>
-          </a:p>
-        </p:txBody>
-      </p:sp>
-      <p:sp>
-        <p:nvSpPr>
-          <p:cNvPr id="17" name="Text 15"/>
-          <p:cNvSpPr/>
-          <p:nvPr/>
-        </p:nvSpPr>
-        <p:spPr>
-          <a:xfrm>
-            <a:off x="502920" y="3108960"/>
-            <a:ext cx="11365992" cy="667512"/>
-          </a:xfrm>
-          <a:prstGeom prst="rect">
-            <a:avLst/>
-          </a:prstGeom>
-          <a:noFill/>
-          <a:ln/>
-        </p:spPr>
-        <p:txBody>
-          <a:bodyPr wrap="square" rtlCol="0" anchor="t"/>
-          <a:lstStyle/>
-          <a:p>
-            <a:pPr indent="0" marL="0">
-              <a:buNone/>
-            </a:pPr>
-            <a:r>
-              <a:rPr lang="en-US" sz="1050" dirty="0">
-                <a:solidFill>
-                  <a:srgbClr val="2D2D2D"/>
-                </a:solidFill>
-                <a:latin typeface="Calibri" pitchFamily="34" charset="0"/>
-                <a:ea typeface="Calibri" pitchFamily="34" charset="-122"/>
-                <a:cs typeface="Calibri" pitchFamily="34" charset="-120"/>
-              </a:rPr>
-              <a:t>Expected time: 10201315s (window=10 must fill). Live: 10s (cycle 10). Expected rate: &gt;90%. Simulated (LIT-only AE): 94/100 = 94%. Live rate: inconclusive 2014 FIT101=-31 sensor fault produced MSE=367 (500,00000d7 above threshold), saturating the AE before Phase 2 even started. Models retrained on LIT101 only to prevent this.</a:t>
-            </a:r>
-            <a:endParaRPr lang="en-US" sz="1050" dirty="0"/>
-          </a:p>
-        </p:txBody>
-      </p:sp>
-      <p:sp>
-        <p:nvSpPr>
-          <p:cNvPr id="18" name="Shape 16"/>
-          <p:cNvSpPr/>
-          <p:nvPr/>
-        </p:nvSpPr>
-        <p:spPr>
-          <a:xfrm>
-            <a:off x="320040" y="4023360"/>
-            <a:ext cx="11548872" cy="1143000"/>
-          </a:xfrm>
-          <a:prstGeom prst="rect">
-            <a:avLst/>
-          </a:prstGeom>
-          <a:solidFill>
-            <a:srgbClr val="F5F5F5"/>
-          </a:solidFill>
-          <a:ln w="12700">
-            <a:solidFill>
-              <a:srgbClr val="E0E0E0"/>
-            </a:solidFill>
-            <a:prstDash val="solid"/>
-          </a:ln>
-        </p:spPr>
-      </p:sp>
-      <p:sp>
-        <p:nvSpPr>
-          <p:cNvPr id="19" name="Shape 17"/>
-          <p:cNvSpPr/>
-          <p:nvPr/>
-        </p:nvSpPr>
-        <p:spPr>
-          <a:xfrm>
-            <a:off x="320040" y="4023360"/>
-            <a:ext cx="54864" cy="1143000"/>
-          </a:xfrm>
-          <a:prstGeom prst="rect">
-            <a:avLst/>
-          </a:prstGeom>
-          <a:solidFill>
-            <a:srgbClr val="2E7D32"/>
-          </a:solidFill>
-          <a:ln/>
-        </p:spPr>
-      </p:sp>
-      <p:sp>
-        <p:nvSpPr>
-          <p:cNvPr id="20" name="Text 18"/>
-          <p:cNvSpPr/>
-          <p:nvPr/>
-        </p:nvSpPr>
-        <p:spPr>
-          <a:xfrm>
-            <a:off x="502920" y="4096512"/>
-            <a:ext cx="11365992" cy="274320"/>
-          </a:xfrm>
-          <a:prstGeom prst="rect">
-            <a:avLst/>
-          </a:prstGeom>
-          <a:noFill/>
-          <a:ln/>
-        </p:spPr>
-        <p:txBody>
-          <a:bodyPr wrap="square" rtlCol="0" anchor="ctr"/>
-          <a:lstStyle/>
-          <a:p>
-            <a:pPr indent="0" marL="0">
-              <a:buNone/>
-            </a:pPr>
-            <a:r>
-              <a:rPr lang="en-US" sz="1100" b="1" dirty="0">
-                <a:solidFill>
-                  <a:srgbClr val="2E7D32"/>
-                </a:solidFill>
-                <a:latin typeface="Calibri" pitchFamily="34" charset="0"/>
-                <a:ea typeface="Calibri" pitchFamily="34" charset="-122"/>
-                <a:cs typeface="Calibri" pitchFamily="34" charset="-120"/>
-              </a:rPr>
-              <a:t>Hybrid Detection Under Phase 1+2</a:t>
-            </a:r>
-            <a:endParaRPr lang="en-US" sz="1100" dirty="0"/>
-          </a:p>
-        </p:txBody>
-      </p:sp>
-      <p:sp>
-        <p:nvSpPr>
-          <p:cNvPr id="21" name="Text 19"/>
-          <p:cNvSpPr/>
-          <p:nvPr/>
-        </p:nvSpPr>
-        <p:spPr>
-          <a:xfrm>
-            <a:off x="502920" y="4389120"/>
-            <a:ext cx="11365992" cy="667512"/>
-          </a:xfrm>
-          <a:prstGeom prst="rect">
-            <a:avLst/>
-          </a:prstGeom>
-          <a:noFill/>
-          <a:ln/>
-        </p:spPr>
-        <p:txBody>
-          <a:bodyPr wrap="square" rtlCol="0" anchor="t"/>
-          <a:lstStyle/>
-          <a:p>
-            <a:pPr indent="0" marL="0">
-              <a:buNone/>
-            </a:pPr>
-            <a:r>
-              <a:rPr lang="en-US" sz="1050" dirty="0">
-                <a:solidFill>
-                  <a:srgbClr val="2D2D2D"/>
-                </a:solidFill>
-                <a:latin typeface="Calibri" pitchFamily="34" charset="0"/>
-                <a:ea typeface="Calibri" pitchFamily="34" charset="-122"/>
-                <a:cs typeface="Calibri" pitchFamily="34" charset="-120"/>
-              </a:rPr>
-              <a:t>Expected: 120136s (invariant catches, AE may be evaded). Live: 1s (invariant). AE evasion by Phase 2 not independently measurable (FIT101 fault confounded). Simulated: invariant 10/10 regardless of evasion. Phase 2 concealment gap: 736mm (HMI showed 1345mm, physical ~502mm). Core thesis confirmed: actuator-command invariants cannot be evaded by sensor-level perturbation.</a:t>
-            </a:r>
-            <a:endParaRPr lang="en-US" sz="1050" dirty="0"/>
           </a:p>
         </p:txBody>
       </p:sp>
@@ -51733,628 +51451,342 @@
 </file>
 
 <file path=ppt/slides/slide51.xml><?xml version="1.0" encoding="utf-8"?>
-<p:sld xmlns:a="http://schemas.openxmlformats.org/drawingml/2006/main" xmlns:r="http://schemas.openxmlformats.org/officeDocument/2006/relationships" xmlns:p="http://schemas.openxmlformats.org/presentationml/2006/main">
-  <p:cSld name="Slide 28">
+<p:sld xmlns:a="http://schemas.openxmlformats.org/drawingml/2006/main" xmlns:p="http://schemas.openxmlformats.org/presentationml/2006/main" xmlns:r="http://schemas.openxmlformats.org/officeDocument/2006/relationships">
+  <p:cSld>
     <p:spTree>
       <p:nvGrpSpPr>
         <p:cNvPr id="1" name=""/>
         <p:cNvGrpSpPr/>
         <p:nvPr/>
       </p:nvGrpSpPr>
-      <p:grpSpPr>
-        <a:xfrm>
-          <a:off x="0" y="0"/>
-          <a:ext cx="0" cy="0"/>
-          <a:chOff x="0" y="0"/>
-          <a:chExt cx="0" cy="0"/>
-        </a:xfrm>
-      </p:grpSpPr>
-      <p:sp>
-        <p:nvSpPr>
-          <p:cNvPr id="2" name="Shape 0"/>
-          <p:cNvSpPr/>
-          <p:nvPr/>
-        </p:nvSpPr>
-        <p:spPr>
-          <a:xfrm>
-            <a:off x="0" y="0"/>
-            <a:ext cx="12188952" cy="6858000"/>
-          </a:xfrm>
-          <a:prstGeom prst="rect">
-            <a:avLst/>
-          </a:prstGeom>
-          <a:solidFill>
-            <a:srgbClr val="FFFFFF"/>
-          </a:solidFill>
-          <a:ln/>
-        </p:spPr>
-      </p:sp>
-      <p:sp>
-        <p:nvSpPr>
-          <p:cNvPr id="3" name="Shape 1"/>
-          <p:cNvSpPr/>
-          <p:nvPr/>
-        </p:nvSpPr>
-        <p:spPr>
-          <a:xfrm>
-            <a:off x="0" y="0"/>
-            <a:ext cx="12188952" cy="64008"/>
-          </a:xfrm>
-          <a:prstGeom prst="rect">
-            <a:avLst/>
-          </a:prstGeom>
-          <a:solidFill>
-            <a:srgbClr val="E8243C"/>
-          </a:solidFill>
-          <a:ln/>
-        </p:spPr>
-      </p:sp>
-      <p:sp>
-        <p:nvSpPr>
-          <p:cNvPr id="4" name="Shape 2"/>
-          <p:cNvSpPr/>
-          <p:nvPr/>
-        </p:nvSpPr>
-        <p:spPr>
-          <a:xfrm>
-            <a:off x="0" y="6510528"/>
-            <a:ext cx="12188952" cy="347472"/>
-          </a:xfrm>
-          <a:prstGeom prst="rect">
-            <a:avLst/>
-          </a:prstGeom>
-          <a:solidFill>
-            <a:srgbClr val="F5F5F5"/>
-          </a:solidFill>
-          <a:ln/>
-        </p:spPr>
-      </p:sp>
-      <p:sp>
-        <p:nvSpPr>
-          <p:cNvPr id="5" name="Text 3"/>
-          <p:cNvSpPr/>
-          <p:nvPr/>
-        </p:nvSpPr>
-        <p:spPr>
-          <a:xfrm>
-            <a:off x="274320" y="6565392"/>
-            <a:ext cx="11640312" cy="219456"/>
-          </a:xfrm>
-          <a:prstGeom prst="rect">
-            <a:avLst/>
-          </a:prstGeom>
-          <a:noFill/>
-          <a:ln/>
-        </p:spPr>
-        <p:txBody>
-          <a:bodyPr wrap="square" rtlCol="0" anchor="ctr"/>
-          <a:lstStyle/>
-          <a:p>
-            <a:pPr algn="l" indent="0" marL="0">
-              <a:buNone/>
-            </a:pPr>
-            <a:r>
-              <a:rPr lang="en-US" sz="800" dirty="0">
-                <a:solidFill>
-                  <a:srgbClr val="6B6B6B"/>
-                </a:solidFill>
-                <a:latin typeface="Calibri" pitchFamily="34" charset="0"/>
-                <a:ea typeface="Calibri" pitchFamily="34" charset="-122"/>
-                <a:cs typeface="Calibri" pitchFamily="34" charset="-120"/>
+      <p:grpSpPr/>
+      <p:sp>
+        <p:nvSpPr>
+          <p:cNvPr id="2" name="TextBox 1"/>
+          <p:cNvSpPr txBox="1"/>
+          <p:nvPr/>
+        </p:nvSpPr>
+        <p:spPr>
+          <a:xfrm>
+            <a:off x="457200" y="182880"/>
+            <a:ext cx="1828800" cy="274320"/>
+          </a:xfrm>
+          <a:prstGeom prst="rect">
+            <a:avLst/>
+          </a:prstGeom>
+          <a:noFill/>
+        </p:spPr>
+        <p:txBody>
+          <a:bodyPr wrap="square">
+            <a:spAutoFit/>
+          </a:bodyPr>
+          <a:lstStyle/>
+          <a:p>
+            <a:r>
+              <a:rPr sz="1000" b="1">
+                <a:solidFill>
+                  <a:srgbClr val="CC0000"/>
+                </a:solidFill>
+              </a:rPr>
+              <a:t>EVAL</a:t>
+            </a:r>
+          </a:p>
+        </p:txBody>
+      </p:sp>
+      <p:sp>
+        <p:nvSpPr>
+          <p:cNvPr id="3" name="TextBox 2"/>
+          <p:cNvSpPr txBox="1"/>
+          <p:nvPr/>
+        </p:nvSpPr>
+        <p:spPr>
+          <a:xfrm>
+            <a:off x="457200" y="411480"/>
+            <a:ext cx="8229600" cy="457200"/>
+          </a:xfrm>
+          <a:prstGeom prst="rect">
+            <a:avLst/>
+          </a:prstGeom>
+          <a:noFill/>
+        </p:spPr>
+        <p:txBody>
+          <a:bodyPr wrap="square">
+            <a:spAutoFit/>
+          </a:bodyPr>
+          <a:lstStyle/>
+          <a:p>
+            <a:r>
+              <a:rPr sz="2200" b="1">
+                <a:solidFill>
+                  <a:srgbClr val="1F3864"/>
+                </a:solidFill>
+              </a:rPr>
+              <a:t>False Positive Rate — Live vs Expected vs Simulated</a:t>
+            </a:r>
+          </a:p>
+        </p:txBody>
+      </p:sp>
+      <p:sp>
+        <p:nvSpPr>
+          <p:cNvPr id="4" name="TextBox 3"/>
+          <p:cNvSpPr txBox="1"/>
+          <p:nvPr/>
+        </p:nvSpPr>
+        <p:spPr>
+          <a:xfrm>
+            <a:off x="457200" y="868680"/>
+            <a:ext cx="8229600" cy="274320"/>
+          </a:xfrm>
+          <a:prstGeom prst="rect">
+            <a:avLst/>
+          </a:prstGeom>
+          <a:noFill/>
+        </p:spPr>
+        <p:txBody>
+          <a:bodyPr wrap="square">
+            <a:spAutoFit/>
+          </a:bodyPr>
+          <a:lstStyle/>
+          <a:p>
+            <a:r>
+              <a:rPr sz="1100" b="0">
+                <a:solidFill>
+                  <a:srgbClr val="666666"/>
+                </a:solidFill>
+              </a:rPr>
+              <a:t>Does the defence trigger false alarms under normal operation?</a:t>
+            </a:r>
+          </a:p>
+        </p:txBody>
+      </p:sp>
+      <p:sp>
+        <p:nvSpPr>
+          <p:cNvPr id="5" name="TextBox 4"/>
+          <p:cNvSpPr txBox="1"/>
+          <p:nvPr/>
+        </p:nvSpPr>
+        <p:spPr>
+          <a:xfrm>
+            <a:off x="457200" y="1280160"/>
+            <a:ext cx="8229600" cy="274320"/>
+          </a:xfrm>
+          <a:prstGeom prst="rect">
+            <a:avLst/>
+          </a:prstGeom>
+          <a:noFill/>
+        </p:spPr>
+        <p:txBody>
+          <a:bodyPr wrap="square">
+            <a:spAutoFit/>
+          </a:bodyPr>
+          <a:lstStyle/>
+          <a:p>
+            <a:r>
+              <a:rPr sz="1300" b="1">
+                <a:solidFill>
+                  <a:srgbClr val="2E75B6"/>
+                </a:solidFill>
+              </a:rPr>
+              <a:t>AE False Positive Rate</a:t>
+            </a:r>
+          </a:p>
+        </p:txBody>
+      </p:sp>
+      <p:sp>
+        <p:nvSpPr>
+          <p:cNvPr id="6" name="TextBox 5"/>
+          <p:cNvSpPr txBox="1"/>
+          <p:nvPr/>
+        </p:nvSpPr>
+        <p:spPr>
+          <a:xfrm>
+            <a:off x="457200" y="1600200"/>
+            <a:ext cx="8229600" cy="1097280"/>
+          </a:xfrm>
+          <a:prstGeom prst="rect">
+            <a:avLst/>
+          </a:prstGeom>
+          <a:noFill/>
+        </p:spPr>
+        <p:txBody>
+          <a:bodyPr wrap="square">
+            <a:spAutoFit/>
+          </a:bodyPr>
+          <a:lstStyle/>
+          <a:p>
+            <a:r>
+              <a:rPr sz="1000" b="0">
+                <a:solidFill>
+                  <a:srgbClr val="333333"/>
+                </a:solidFill>
+              </a:rPr>
+              <a:t>Expected: &lt;5% (95th pct threshold). Simulated (LIT-only): 0/500 = 0.0% FPR. Mean MSE=0.000039, threshold=0.000738 — 19× safety margin. Live: inconclusive — FIT101=-31 was a genuine anomaly (true positive, not false positive).</a:t>
+            </a:r>
+          </a:p>
+        </p:txBody>
+      </p:sp>
+      <p:sp>
+        <p:nvSpPr>
+          <p:cNvPr id="7" name="TextBox 6"/>
+          <p:cNvSpPr txBox="1"/>
+          <p:nvPr/>
+        </p:nvSpPr>
+        <p:spPr>
+          <a:xfrm>
+            <a:off x="457200" y="2834640"/>
+            <a:ext cx="8229600" cy="274320"/>
+          </a:xfrm>
+          <a:prstGeom prst="rect">
+            <a:avLst/>
+          </a:prstGeom>
+          <a:noFill/>
+        </p:spPr>
+        <p:txBody>
+          <a:bodyPr wrap="square">
+            <a:spAutoFit/>
+          </a:bodyPr>
+          <a:lstStyle/>
+          <a:p>
+            <a:r>
+              <a:rPr sz="1300" b="1">
+                <a:solidFill>
+                  <a:srgbClr val="2E75B6"/>
+                </a:solidFill>
+              </a:rPr>
+              <a:t>Invariant False Positive Rate</a:t>
+            </a:r>
+          </a:p>
+        </p:txBody>
+      </p:sp>
+      <p:sp>
+        <p:nvSpPr>
+          <p:cNvPr id="8" name="TextBox 7"/>
+          <p:cNvSpPr txBox="1"/>
+          <p:nvPr/>
+        </p:nvSpPr>
+        <p:spPr>
+          <a:xfrm>
+            <a:off x="457200" y="3154680"/>
+            <a:ext cx="8229600" cy="1097280"/>
+          </a:xfrm>
+          <a:prstGeom prst="rect">
+            <a:avLst/>
+          </a:prstGeom>
+          <a:noFill/>
+        </p:spPr>
+        <p:txBody>
+          <a:bodyPr wrap="square">
+            <a:spAutoFit/>
+          </a:bodyPr>
+          <a:lstStyle/>
+          <a:p>
+            <a:r>
+              <a:rPr sz="1000" b="0">
+                <a:solidFill>
+                  <a:srgbClr val="333333"/>
+                </a:solidFill>
+              </a:rPr>
+              <a:t>Expected: ~0% (deterministic). Simulated: 0/10 = 0.0%. Live: inconclusive — plant started in attack-equivalent state (MV101=CLOSED, P101=ON). Invariants correctly identified unsafe configuration — true positive, not false alarm.</a:t>
+            </a:r>
+          </a:p>
+        </p:txBody>
+      </p:sp>
+      <p:sp>
+        <p:nvSpPr>
+          <p:cNvPr id="9" name="TextBox 8"/>
+          <p:cNvSpPr txBox="1"/>
+          <p:nvPr/>
+        </p:nvSpPr>
+        <p:spPr>
+          <a:xfrm>
+            <a:off x="457200" y="4389120"/>
+            <a:ext cx="8229600" cy="274320"/>
+          </a:xfrm>
+          <a:prstGeom prst="rect">
+            <a:avLst/>
+          </a:prstGeom>
+          <a:noFill/>
+        </p:spPr>
+        <p:txBody>
+          <a:bodyPr wrap="square">
+            <a:spAutoFit/>
+          </a:bodyPr>
+          <a:lstStyle/>
+          <a:p>
+            <a:r>
+              <a:rPr sz="1300" b="1">
+                <a:solidFill>
+                  <a:srgbClr val="2E75B6"/>
+                </a:solidFill>
+              </a:rPr>
+              <a:t>Interpretation</a:t>
+            </a:r>
+          </a:p>
+        </p:txBody>
+      </p:sp>
+      <p:sp>
+        <p:nvSpPr>
+          <p:cNvPr id="10" name="TextBox 9"/>
+          <p:cNvSpPr txBox="1"/>
+          <p:nvPr/>
+        </p:nvSpPr>
+        <p:spPr>
+          <a:xfrm>
+            <a:off x="457200" y="4709160"/>
+            <a:ext cx="8229600" cy="1097280"/>
+          </a:xfrm>
+          <a:prstGeom prst="rect">
+            <a:avLst/>
+          </a:prstGeom>
+          <a:noFill/>
+        </p:spPr>
+        <p:txBody>
+          <a:bodyPr wrap="square">
+            <a:spAutoFit/>
+          </a:bodyPr>
+          <a:lstStyle/>
+          <a:p>
+            <a:r>
+              <a:rPr sz="1000" b="0">
+                <a:solidFill>
+                  <a:srgbClr val="333333"/>
+                </a:solidFill>
+              </a:rPr>
+              <a:t>Simulated 0% FPR on 29,153 samples (8.1 hrs real SWaT data) is strong evidence. The live run demonstrated the invariant layer correctly detects unsafe states regardless of cause (attacker vs residual misconfiguration) — both are legitimate safety concerns in production water treatment.</a:t>
+            </a:r>
+          </a:p>
+        </p:txBody>
+      </p:sp>
+      <p:sp>
+        <p:nvSpPr>
+          <p:cNvPr id="11" name="TextBox 10"/>
+          <p:cNvSpPr txBox="1"/>
+          <p:nvPr/>
+        </p:nvSpPr>
+        <p:spPr>
+          <a:xfrm>
+            <a:off x="457200" y="6492240"/>
+            <a:ext cx="8229600" cy="228600"/>
+          </a:xfrm>
+          <a:prstGeom prst="rect">
+            <a:avLst/>
+          </a:prstGeom>
+          <a:noFill/>
+        </p:spPr>
+        <p:txBody>
+          <a:bodyPr wrap="square">
+            <a:spAutoFit/>
+          </a:bodyPr>
+          <a:lstStyle/>
+          <a:p>
+            <a:r>
+              <a:rPr sz="800" b="0">
+                <a:solidFill>
+                  <a:srgbClr val="999999"/>
+                </a:solidFill>
               </a:rPr>
               <a:t>51.508 Secure Cyber Physical Systems  ·  SWaT Project  ·  iTrust Lab, SUTD</a:t>
             </a:r>
-            <a:endParaRPr lang="en-US" sz="800" dirty="0"/>
-          </a:p>
-        </p:txBody>
-      </p:sp>
-      <p:sp>
-        <p:nvSpPr>
-          <p:cNvPr id="6" name="Shape 4"/>
-          <p:cNvSpPr/>
-          <p:nvPr/>
-        </p:nvSpPr>
-        <p:spPr>
-          <a:xfrm>
-            <a:off x="320040" y="109728"/>
-            <a:ext cx="1280160" cy="292608"/>
-          </a:xfrm>
-          <a:prstGeom prst="rect">
-            <a:avLst/>
-          </a:prstGeom>
-          <a:solidFill>
-            <a:srgbClr val="2E7D32"/>
-          </a:solidFill>
-          <a:ln/>
-        </p:spPr>
-      </p:sp>
-      <p:sp>
-        <p:nvSpPr>
-          <p:cNvPr id="7" name="Text 5"/>
-          <p:cNvSpPr/>
-          <p:nvPr/>
-        </p:nvSpPr>
-        <p:spPr>
-          <a:xfrm>
-            <a:off x="320040" y="109728"/>
-            <a:ext cx="1280160" cy="292608"/>
-          </a:xfrm>
-          <a:prstGeom prst="rect">
-            <a:avLst/>
-          </a:prstGeom>
-          <a:noFill/>
-          <a:ln/>
-        </p:spPr>
-        <p:txBody>
-          <a:bodyPr wrap="square" rtlCol="0" anchor="ctr"/>
-          <a:lstStyle/>
-          <a:p>
-            <a:pPr algn="ctr" indent="0" marL="0">
-              <a:buNone/>
-            </a:pPr>
-            <a:r>
-              <a:rPr lang="en-US" sz="1000" b="1" dirty="0">
-                <a:solidFill>
-                  <a:srgbClr val="FFFFFF"/>
-                </a:solidFill>
-                <a:latin typeface="Calibri" pitchFamily="34" charset="0"/>
-                <a:ea typeface="Calibri" pitchFamily="34" charset="-122"/>
-                <a:cs typeface="Calibri" pitchFamily="34" charset="-120"/>
-              </a:rPr>
-              <a:t>EVAL</a:t>
-            </a:r>
-            <a:endParaRPr lang="en-US" sz="1000" dirty="0"/>
-          </a:p>
-        </p:txBody>
-      </p:sp>
-      <p:sp>
-        <p:nvSpPr>
-          <p:cNvPr id="8" name="Text 6"/>
-          <p:cNvSpPr/>
-          <p:nvPr/>
-        </p:nvSpPr>
-        <p:spPr>
-          <a:xfrm>
-            <a:off x="320040" y="457200"/>
-            <a:ext cx="11548872" cy="640080"/>
-          </a:xfrm>
-          <a:prstGeom prst="rect">
-            <a:avLst/>
-          </a:prstGeom>
-          <a:noFill/>
-          <a:ln/>
-        </p:spPr>
-        <p:txBody>
-          <a:bodyPr wrap="square" rtlCol="0" anchor="ctr"/>
-          <a:lstStyle/>
-          <a:p>
-            <a:pPr indent="0" marL="0">
-              <a:buNone/>
-            </a:pPr>
-            <a:r>
-              <a:rPr lang="en-US" sz="3200" b="1" dirty="0">
-                <a:solidFill>
-                  <a:srgbClr val="1A1A1A"/>
-                </a:solidFill>
-                <a:latin typeface="Calibri Light" pitchFamily="34" charset="0"/>
-                <a:ea typeface="Calibri Light" pitchFamily="34" charset="-122"/>
-                <a:cs typeface="Calibri Light" pitchFamily="34" charset="-120"/>
-              </a:rPr>
-              <a:t>False Positive Rate 2014 Live vs Expected vs Simulated</a:t>
-            </a:r>
-            <a:endParaRPr lang="en-US" sz="3200" dirty="0"/>
-          </a:p>
-        </p:txBody>
-      </p:sp>
-      <p:sp>
-        <p:nvSpPr>
-          <p:cNvPr id="9" name="Text 7"/>
-          <p:cNvSpPr/>
-          <p:nvPr/>
-        </p:nvSpPr>
-        <p:spPr>
-          <a:xfrm>
-            <a:off x="320040" y="1051560"/>
-            <a:ext cx="11548872" cy="256032"/>
-          </a:xfrm>
-          <a:prstGeom prst="rect">
-            <a:avLst/>
-          </a:prstGeom>
-          <a:noFill/>
-          <a:ln/>
-        </p:spPr>
-        <p:txBody>
-          <a:bodyPr wrap="square" rtlCol="0" anchor="ctr"/>
-          <a:lstStyle/>
-          <a:p>
-            <a:pPr indent="0" marL="0">
-              <a:buNone/>
-            </a:pPr>
-            <a:r>
-              <a:rPr lang="en-US" sz="1200" i="1" dirty="0">
-                <a:solidFill>
-                  <a:srgbClr val="6B6B6B"/>
-                </a:solidFill>
-                <a:latin typeface="Calibri" pitchFamily="34" charset="0"/>
-                <a:ea typeface="Calibri" pitchFamily="34" charset="-122"/>
-                <a:cs typeface="Calibri" pitchFamily="34" charset="-120"/>
-              </a:rPr>
-              <a:t>Does the defence trigger false alarms under normal operation?</a:t>
-            </a:r>
-            <a:endParaRPr lang="en-US" sz="1200" dirty="0"/>
-          </a:p>
-        </p:txBody>
-      </p:sp>
-      <p:sp>
-        <p:nvSpPr>
-          <p:cNvPr id="10" name="Shape 8"/>
-          <p:cNvSpPr/>
-          <p:nvPr/>
-        </p:nvSpPr>
-        <p:spPr>
-          <a:xfrm>
-            <a:off x="320040" y="1463040"/>
-            <a:ext cx="11548872" cy="1143000"/>
-          </a:xfrm>
-          <a:prstGeom prst="rect">
-            <a:avLst/>
-          </a:prstGeom>
-          <a:solidFill>
-            <a:srgbClr val="F5F5F5"/>
-          </a:solidFill>
-          <a:ln w="12700">
-            <a:solidFill>
-              <a:srgbClr val="E0E0E0"/>
-            </a:solidFill>
-            <a:prstDash val="solid"/>
-          </a:ln>
-        </p:spPr>
-      </p:sp>
-      <p:sp>
-        <p:nvSpPr>
-          <p:cNvPr id="11" name="Shape 9"/>
-          <p:cNvSpPr/>
-          <p:nvPr/>
-        </p:nvSpPr>
-        <p:spPr>
-          <a:xfrm>
-            <a:off x="320040" y="1463040"/>
-            <a:ext cx="54864" cy="1143000"/>
-          </a:xfrm>
-          <a:prstGeom prst="rect">
-            <a:avLst/>
-          </a:prstGeom>
-          <a:solidFill>
-            <a:srgbClr val="2E7D32"/>
-          </a:solidFill>
-          <a:ln/>
-        </p:spPr>
-      </p:sp>
-      <p:sp>
-        <p:nvSpPr>
-          <p:cNvPr id="12" name="Text 10"/>
-          <p:cNvSpPr/>
-          <p:nvPr/>
-        </p:nvSpPr>
-        <p:spPr>
-          <a:xfrm>
-            <a:off x="502920" y="1536192"/>
-            <a:ext cx="11365992" cy="274320"/>
-          </a:xfrm>
-          <a:prstGeom prst="rect">
-            <a:avLst/>
-          </a:prstGeom>
-          <a:noFill/>
-          <a:ln/>
-        </p:spPr>
-        <p:txBody>
-          <a:bodyPr wrap="square" rtlCol="0" anchor="ctr"/>
-          <a:lstStyle/>
-          <a:p>
-            <a:pPr indent="0" marL="0">
-              <a:buNone/>
-            </a:pPr>
-            <a:r>
-              <a:rPr lang="en-US" sz="1100" b="1" dirty="0">
-                <a:solidFill>
-                  <a:srgbClr val="2E7D32"/>
-                </a:solidFill>
-                <a:latin typeface="Calibri" pitchFamily="34" charset="0"/>
-                <a:ea typeface="Calibri" pitchFamily="34" charset="-122"/>
-                <a:cs typeface="Calibri" pitchFamily="34" charset="-120"/>
-              </a:rPr>
-              <a:t>AE False Positive Rate</a:t>
-            </a:r>
-            <a:endParaRPr lang="en-US" sz="1100" dirty="0"/>
-          </a:p>
-        </p:txBody>
-      </p:sp>
-      <p:sp>
-        <p:nvSpPr>
-          <p:cNvPr id="13" name="Text 11"/>
-          <p:cNvSpPr/>
-          <p:nvPr/>
-        </p:nvSpPr>
-        <p:spPr>
-          <a:xfrm>
-            <a:off x="502920" y="1828800"/>
-            <a:ext cx="11365992" cy="667512"/>
-          </a:xfrm>
-          <a:prstGeom prst="rect">
-            <a:avLst/>
-          </a:prstGeom>
-          <a:noFill/>
-          <a:ln/>
-        </p:spPr>
-        <p:txBody>
-          <a:bodyPr wrap="square" rtlCol="0" anchor="t"/>
-          <a:lstStyle/>
-          <a:p>
-            <a:pPr indent="0" marL="0">
-              <a:buNone/>
-            </a:pPr>
-            <a:r>
-              <a:rPr lang="en-US" sz="1050" dirty="0">
-                <a:solidFill>
-                  <a:srgbClr val="2D2D2D"/>
-                </a:solidFill>
-                <a:latin typeface="Calibri" pitchFamily="34" charset="0"/>
-                <a:ea typeface="Calibri" pitchFamily="34" charset="-122"/>
-                <a:cs typeface="Calibri" pitchFamily="34" charset="-120"/>
-              </a:rPr>
-              <a:t>
-                Expected: 
-                <a:t>Live: Invariant detected cycle 1 (I-2 + I-9). I-9b/I-9c also fired but excluded (supplementary rules). 104 violation cycles. AE detection time: 10s (window fills). Simulated AE detection rate (LIT-only): 94/100 (94%). AE evasion by Phase 2: inconclusive on live (FIT101=-31 saturated AE).</a:t>
-                lt;5% (95th percentile threshold). Simulated (LIT-only): 0/500 windows = 0.0% FPR. AE mean MSE=0.000039, threshold=0.000738 2014 1900d7 safety margin. Live: inconclusive. The plant started with FIT101=-31, which is a genuine out-of-distribution input. The AE correctly flagged it as anomalous 2014 this was a true positive on the sensor fault, not a false positive.
-              </a:t>
-            </a:r>
-            <a:endParaRPr lang="en-US" sz="1050" dirty="0"/>
-          </a:p>
-        </p:txBody>
-      </p:sp>
-      <p:sp>
-        <p:nvSpPr>
-          <p:cNvPr id="14" name="Shape 12"/>
-          <p:cNvSpPr/>
-          <p:nvPr/>
-        </p:nvSpPr>
-        <p:spPr>
-          <a:xfrm>
-            <a:off x="320040" y="2743200"/>
-            <a:ext cx="11548872" cy="1143000"/>
-          </a:xfrm>
-          <a:prstGeom prst="rect">
-            <a:avLst/>
-          </a:prstGeom>
-          <a:solidFill>
-            <a:srgbClr val="F5F5F5"/>
-          </a:solidFill>
-          <a:ln w="12700">
-            <a:solidFill>
-              <a:srgbClr val="E0E0E0"/>
-            </a:solidFill>
-            <a:prstDash val="solid"/>
-          </a:ln>
-        </p:spPr>
-      </p:sp>
-      <p:sp>
-        <p:nvSpPr>
-          <p:cNvPr id="15" name="Shape 13"/>
-          <p:cNvSpPr/>
-          <p:nvPr/>
-        </p:nvSpPr>
-        <p:spPr>
-          <a:xfrm>
-            <a:off x="320040" y="2743200"/>
-            <a:ext cx="54864" cy="1143000"/>
-          </a:xfrm>
-          <a:prstGeom prst="rect">
-            <a:avLst/>
-          </a:prstGeom>
-          <a:solidFill>
-            <a:srgbClr val="2E7D32"/>
-          </a:solidFill>
-          <a:ln/>
-        </p:spPr>
-      </p:sp>
-      <p:sp>
-        <p:nvSpPr>
-          <p:cNvPr id="16" name="Text 14"/>
-          <p:cNvSpPr/>
-          <p:nvPr/>
-        </p:nvSpPr>
-        <p:spPr>
-          <a:xfrm>
-            <a:off x="502920" y="2816352"/>
-            <a:ext cx="11365992" cy="274320"/>
-          </a:xfrm>
-          <a:prstGeom prst="rect">
-            <a:avLst/>
-          </a:prstGeom>
-          <a:noFill/>
-          <a:ln/>
-        </p:spPr>
-        <p:txBody>
-          <a:bodyPr wrap="square" rtlCol="0" anchor="ctr"/>
-          <a:lstStyle/>
-          <a:p>
-            <a:pPr indent="0" marL="0">
-              <a:buNone/>
-            </a:pPr>
-            <a:r>
-              <a:rPr lang="en-US" sz="1100" b="1" dirty="0">
-                <a:solidFill>
-                  <a:srgbClr val="2E7D32"/>
-                </a:solidFill>
-                <a:latin typeface="Calibri" pitchFamily="34" charset="0"/>
-                <a:ea typeface="Calibri" pitchFamily="34" charset="-122"/>
-                <a:cs typeface="Calibri" pitchFamily="34" charset="-120"/>
-              </a:rPr>
-              <a:t>Invariant False Positive Rate</a:t>
-            </a:r>
-            <a:endParaRPr lang="en-US" sz="1100" dirty="0"/>
-          </a:p>
-        </p:txBody>
-      </p:sp>
-      <p:sp>
-        <p:nvSpPr>
-          <p:cNvPr id="17" name="Text 15"/>
-          <p:cNvSpPr/>
-          <p:nvPr/>
-        </p:nvSpPr>
-        <p:spPr>
-          <a:xfrm>
-            <a:off x="502920" y="3108960"/>
-            <a:ext cx="11365992" cy="667512"/>
-          </a:xfrm>
-          <a:prstGeom prst="rect">
-            <a:avLst/>
-          </a:prstGeom>
-          <a:noFill/>
-          <a:ln/>
-        </p:spPr>
-        <p:txBody>
-          <a:bodyPr wrap="square" rtlCol="0" anchor="t"/>
-          <a:lstStyle/>
-          <a:p>
-            <a:pPr indent="0" marL="0">
-              <a:buNone/>
-            </a:pPr>
-            <a:r>
-              <a:rPr lang="en-US" sz="1050" dirty="0">
-                <a:solidFill>
-                  <a:srgbClr val="2D2D2D"/>
-                </a:solidFill>
-                <a:latin typeface="Calibri" pitchFamily="34" charset="0"/>
-                <a:ea typeface="Calibri" pitchFamily="34" charset="-122"/>
-                <a:cs typeface="Calibri" pitchFamily="34" charset="-120"/>
-              </a:rPr>
-              <a:t>Expected: ~0% (deterministic physics rules). Simulated: 0/10 = 0.0%. Live: inconclusive 2014 plant started with MV101=CLOSED + P101=ON (attack-equivalent state from previous session). Invariants correctly identified the unsafe configuration. This is not a false alarm 2014 it is a true positive on a genuinely dangerous plant state. Clean baseline required for valid FPR measurement.</a:t>
-            </a:r>
-            <a:endParaRPr lang="en-US" sz="1050" dirty="0"/>
-          </a:p>
-        </p:txBody>
-      </p:sp>
-      <p:sp>
-        <p:nvSpPr>
-          <p:cNvPr id="18" name="Shape 16"/>
-          <p:cNvSpPr/>
-          <p:nvPr/>
-        </p:nvSpPr>
-        <p:spPr>
-          <a:xfrm>
-            <a:off x="320040" y="4023360"/>
-            <a:ext cx="11548872" cy="1143000"/>
-          </a:xfrm>
-          <a:prstGeom prst="rect">
-            <a:avLst/>
-          </a:prstGeom>
-          <a:solidFill>
-            <a:srgbClr val="F5F5F5"/>
-          </a:solidFill>
-          <a:ln w="12700">
-            <a:solidFill>
-              <a:srgbClr val="E0E0E0"/>
-            </a:solidFill>
-            <a:prstDash val="solid"/>
-          </a:ln>
-        </p:spPr>
-      </p:sp>
-      <p:sp>
-        <p:nvSpPr>
-          <p:cNvPr id="19" name="Shape 17"/>
-          <p:cNvSpPr/>
-          <p:nvPr/>
-        </p:nvSpPr>
-        <p:spPr>
-          <a:xfrm>
-            <a:off x="320040" y="4023360"/>
-            <a:ext cx="54864" cy="1143000"/>
-          </a:xfrm>
-          <a:prstGeom prst="rect">
-            <a:avLst/>
-          </a:prstGeom>
-          <a:solidFill>
-            <a:srgbClr val="2E7D32"/>
-          </a:solidFill>
-          <a:ln/>
-        </p:spPr>
-      </p:sp>
-      <p:sp>
-        <p:nvSpPr>
-          <p:cNvPr id="20" name="Text 18"/>
-          <p:cNvSpPr/>
-          <p:nvPr/>
-        </p:nvSpPr>
-        <p:spPr>
-          <a:xfrm>
-            <a:off x="502920" y="4096512"/>
-            <a:ext cx="11365992" cy="274320"/>
-          </a:xfrm>
-          <a:prstGeom prst="rect">
-            <a:avLst/>
-          </a:prstGeom>
-          <a:noFill/>
-          <a:ln/>
-        </p:spPr>
-        <p:txBody>
-          <a:bodyPr wrap="square" rtlCol="0" anchor="ctr"/>
-          <a:lstStyle/>
-          <a:p>
-            <a:pPr indent="0" marL="0">
-              <a:buNone/>
-            </a:pPr>
-            <a:r>
-              <a:rPr lang="en-US" sz="1100" b="1" dirty="0">
-                <a:solidFill>
-                  <a:srgbClr val="2E7D32"/>
-                </a:solidFill>
-                <a:latin typeface="Calibri" pitchFamily="34" charset="0"/>
-                <a:ea typeface="Calibri" pitchFamily="34" charset="-122"/>
-                <a:cs typeface="Calibri" pitchFamily="34" charset="-120"/>
-              </a:rPr>
-              <a:t>Interpretation</a:t>
-            </a:r>
-            <a:endParaRPr lang="en-US" sz="1100" dirty="0"/>
-          </a:p>
-        </p:txBody>
-      </p:sp>
-      <p:sp>
-        <p:nvSpPr>
-          <p:cNvPr id="21" name="Text 19"/>
-          <p:cNvSpPr/>
-          <p:nvPr/>
-        </p:nvSpPr>
-        <p:spPr>
-          <a:xfrm>
-            <a:off x="502920" y="4389120"/>
-            <a:ext cx="11365992" cy="667512"/>
-          </a:xfrm>
-          <a:prstGeom prst="rect">
-            <a:avLst/>
-          </a:prstGeom>
-          <a:noFill/>
-          <a:ln/>
-        </p:spPr>
-        <p:txBody>
-          <a:bodyPr wrap="square" rtlCol="0" anchor="t"/>
-          <a:lstStyle/>
-          <a:p>
-            <a:pPr indent="0" marL="0">
-              <a:buNone/>
-            </a:pPr>
-            <a:r>
-              <a:rPr lang="en-US" sz="1050" dirty="0">
-                <a:solidFill>
-                  <a:srgbClr val="2D2D2D"/>
-                </a:solidFill>
-                <a:latin typeface="Calibri" pitchFamily="34" charset="0"/>
-                <a:ea typeface="Calibri" pitchFamily="34" charset="-122"/>
-                <a:cs typeface="Calibri" pitchFamily="34" charset="-120"/>
-              </a:rPr>
-              <a:t>The inability to measure live FPR does not weaken the result. The simulated 0% FPR on 29,153 samples of real SWaT normal-operation data (8.1 hours) is strong evidence. The live run inadvertently demonstrated that the invariant layer correctly detects unsafe plant states regardless of whether they were caused by an active attacker or residual misconfiguration 2014 both are legitimate safety concerns in a real water treatment plant.</a:t>
-            </a:r>
-            <a:endParaRPr lang="en-US" sz="1050" dirty="0"/>
           </a:p>
         </p:txBody>
       </p:sp>
@@ -52367,634 +51799,342 @@
 </file>
 
 <file path=ppt/slides/slide52.xml><?xml version="1.0" encoding="utf-8"?>
-<p:sld xmlns:a="http://schemas.openxmlformats.org/drawingml/2006/main" xmlns:r="http://schemas.openxmlformats.org/officeDocument/2006/relationships" xmlns:p="http://schemas.openxmlformats.org/presentationml/2006/main">
-  <p:cSld name="Slide 28">
+<p:sld xmlns:a="http://schemas.openxmlformats.org/drawingml/2006/main" xmlns:p="http://schemas.openxmlformats.org/presentationml/2006/main" xmlns:r="http://schemas.openxmlformats.org/officeDocument/2006/relationships">
+  <p:cSld>
     <p:spTree>
       <p:nvGrpSpPr>
         <p:cNvPr id="1" name=""/>
         <p:cNvGrpSpPr/>
         <p:nvPr/>
       </p:nvGrpSpPr>
-      <p:grpSpPr>
-        <a:xfrm>
-          <a:off x="0" y="0"/>
-          <a:ext cx="0" cy="0"/>
-          <a:chOff x="0" y="0"/>
-          <a:chExt cx="0" cy="0"/>
-        </a:xfrm>
-      </p:grpSpPr>
-      <p:sp>
-        <p:nvSpPr>
-          <p:cNvPr id="2" name="Shape 0"/>
-          <p:cNvSpPr/>
-          <p:nvPr/>
-        </p:nvSpPr>
-        <p:spPr>
-          <a:xfrm>
-            <a:off x="0" y="0"/>
-            <a:ext cx="12188952" cy="6858000"/>
-          </a:xfrm>
-          <a:prstGeom prst="rect">
-            <a:avLst/>
-          </a:prstGeom>
-          <a:solidFill>
-            <a:srgbClr val="FFFFFF"/>
-          </a:solidFill>
-          <a:ln/>
-        </p:spPr>
-      </p:sp>
-      <p:sp>
-        <p:nvSpPr>
-          <p:cNvPr id="3" name="Shape 1"/>
-          <p:cNvSpPr/>
-          <p:nvPr/>
-        </p:nvSpPr>
-        <p:spPr>
-          <a:xfrm>
-            <a:off x="0" y="0"/>
-            <a:ext cx="12188952" cy="64008"/>
-          </a:xfrm>
-          <a:prstGeom prst="rect">
-            <a:avLst/>
-          </a:prstGeom>
-          <a:solidFill>
-            <a:srgbClr val="E8243C"/>
-          </a:solidFill>
-          <a:ln/>
-        </p:spPr>
-      </p:sp>
-      <p:sp>
-        <p:nvSpPr>
-          <p:cNvPr id="4" name="Shape 2"/>
-          <p:cNvSpPr/>
-          <p:nvPr/>
-        </p:nvSpPr>
-        <p:spPr>
-          <a:xfrm>
-            <a:off x="0" y="6510528"/>
-            <a:ext cx="12188952" cy="347472"/>
-          </a:xfrm>
-          <a:prstGeom prst="rect">
-            <a:avLst/>
-          </a:prstGeom>
-          <a:solidFill>
-            <a:srgbClr val="F5F5F5"/>
-          </a:solidFill>
-          <a:ln/>
-        </p:spPr>
-      </p:sp>
-      <p:sp>
-        <p:nvSpPr>
-          <p:cNvPr id="5" name="Text 3"/>
-          <p:cNvSpPr/>
-          <p:nvPr/>
-        </p:nvSpPr>
-        <p:spPr>
-          <a:xfrm>
-            <a:off x="274320" y="6565392"/>
-            <a:ext cx="11640312" cy="219456"/>
-          </a:xfrm>
-          <a:prstGeom prst="rect">
-            <a:avLst/>
-          </a:prstGeom>
-          <a:noFill/>
-          <a:ln/>
-        </p:spPr>
-        <p:txBody>
-          <a:bodyPr wrap="square" rtlCol="0" anchor="ctr"/>
-          <a:lstStyle/>
-          <a:p>
-            <a:pPr algn="l" indent="0" marL="0">
-              <a:buNone/>
-            </a:pPr>
-            <a:r>
-              <a:rPr lang="en-US" sz="800" dirty="0">
-                <a:solidFill>
-                  <a:srgbClr val="6B6B6B"/>
-                </a:solidFill>
-                <a:latin typeface="Calibri" pitchFamily="34" charset="0"/>
-                <a:ea typeface="Calibri" pitchFamily="34" charset="-122"/>
-                <a:cs typeface="Calibri" pitchFamily="34" charset="-120"/>
+      <p:grpSpPr/>
+      <p:sp>
+        <p:nvSpPr>
+          <p:cNvPr id="2" name="TextBox 1"/>
+          <p:cNvSpPr txBox="1"/>
+          <p:nvPr/>
+        </p:nvSpPr>
+        <p:spPr>
+          <a:xfrm>
+            <a:off x="457200" y="182880"/>
+            <a:ext cx="1828800" cy="274320"/>
+          </a:xfrm>
+          <a:prstGeom prst="rect">
+            <a:avLst/>
+          </a:prstGeom>
+          <a:noFill/>
+        </p:spPr>
+        <p:txBody>
+          <a:bodyPr wrap="square">
+            <a:spAutoFit/>
+          </a:bodyPr>
+          <a:lstStyle/>
+          <a:p>
+            <a:r>
+              <a:rPr sz="1000" b="1">
+                <a:solidFill>
+                  <a:srgbClr val="CC0000"/>
+                </a:solidFill>
+              </a:rPr>
+              <a:t>EVAL</a:t>
+            </a:r>
+          </a:p>
+        </p:txBody>
+      </p:sp>
+      <p:sp>
+        <p:nvSpPr>
+          <p:cNvPr id="3" name="TextBox 2"/>
+          <p:cNvSpPr txBox="1"/>
+          <p:nvPr/>
+        </p:nvSpPr>
+        <p:spPr>
+          <a:xfrm>
+            <a:off x="457200" y="411480"/>
+            <a:ext cx="8229600" cy="457200"/>
+          </a:xfrm>
+          <a:prstGeom prst="rect">
+            <a:avLst/>
+          </a:prstGeom>
+          <a:noFill/>
+        </p:spPr>
+        <p:txBody>
+          <a:bodyPr wrap="square">
+            <a:spAutoFit/>
+          </a:bodyPr>
+          <a:lstStyle/>
+          <a:p>
+            <a:r>
+              <a:rPr sz="2200" b="1">
+                <a:solidFill>
+                  <a:srgbClr val="1F3864"/>
+                </a:solidFill>
+              </a:rPr>
+              <a:t>Recovery Time — Live vs Expected vs Simulated</a:t>
+            </a:r>
+          </a:p>
+        </p:txBody>
+      </p:sp>
+      <p:sp>
+        <p:nvSpPr>
+          <p:cNvPr id="4" name="TextBox 3"/>
+          <p:cNvSpPr txBox="1"/>
+          <p:nvPr/>
+        </p:nvSpPr>
+        <p:spPr>
+          <a:xfrm>
+            <a:off x="457200" y="868680"/>
+            <a:ext cx="8229600" cy="274320"/>
+          </a:xfrm>
+          <a:prstGeom prst="rect">
+            <a:avLst/>
+          </a:prstGeom>
+          <a:noFill/>
+        </p:spPr>
+        <p:txBody>
+          <a:bodyPr wrap="square">
+            <a:spAutoFit/>
+          </a:bodyPr>
+          <a:lstStyle/>
+          <a:p>
+            <a:r>
+              <a:rPr sz="1100" b="0">
+                <a:solidFill>
+                  <a:srgbClr val="666666"/>
+                </a:solidFill>
+              </a:rPr>
+              <a:t>How quickly does the system recover after detecting an attack?</a:t>
+            </a:r>
+          </a:p>
+        </p:txBody>
+      </p:sp>
+      <p:sp>
+        <p:nvSpPr>
+          <p:cNvPr id="5" name="TextBox 4"/>
+          <p:cNvSpPr txBox="1"/>
+          <p:nvPr/>
+        </p:nvSpPr>
+        <p:spPr>
+          <a:xfrm>
+            <a:off x="457200" y="1280160"/>
+            <a:ext cx="8229600" cy="274320"/>
+          </a:xfrm>
+          <a:prstGeom prst="rect">
+            <a:avLst/>
+          </a:prstGeom>
+          <a:noFill/>
+        </p:spPr>
+        <p:txBody>
+          <a:bodyPr wrap="square">
+            <a:spAutoFit/>
+          </a:bodyPr>
+          <a:lstStyle/>
+          <a:p>
+            <a:r>
+              <a:rPr sz="1300" b="1">
+                <a:solidFill>
+                  <a:srgbClr val="2E75B6"/>
+                </a:solidFill>
+              </a:rPr>
+              <a:t>Fusion ALERT Timing</a:t>
+            </a:r>
+          </a:p>
+        </p:txBody>
+      </p:sp>
+      <p:sp>
+        <p:nvSpPr>
+          <p:cNvPr id="6" name="TextBox 5"/>
+          <p:cNvSpPr txBox="1"/>
+          <p:nvPr/>
+        </p:nvSpPr>
+        <p:spPr>
+          <a:xfrm>
+            <a:off x="457200" y="1600200"/>
+            <a:ext cx="8229600" cy="1097280"/>
+          </a:xfrm>
+          <a:prstGeom prst="rect">
+            <a:avLst/>
+          </a:prstGeom>
+          <a:noFill/>
+        </p:spPr>
+        <p:txBody>
+          <a:bodyPr wrap="square">
+            <a:spAutoFit/>
+          </a:bodyPr>
+          <a:lstStyle/>
+          <a:p>
+            <a:r>
+              <a:rPr sz="1000" b="0">
+                <a:solidFill>
+                  <a:srgbClr val="333333"/>
+                </a:solidFill>
+              </a:rPr>
+              <a:t>Expected: &lt;3s (3 consecutive cycles). Live: exactly 3s (16:33:08 → 16:33:11). Simulated: 3 cycles. Exact match with design. Recovery launched automatically by fusion.py when score ≥ 1.5 for 3 cycles.</a:t>
+            </a:r>
+          </a:p>
+        </p:txBody>
+      </p:sp>
+      <p:sp>
+        <p:nvSpPr>
+          <p:cNvPr id="7" name="TextBox 6"/>
+          <p:cNvSpPr txBox="1"/>
+          <p:nvPr/>
+        </p:nvSpPr>
+        <p:spPr>
+          <a:xfrm>
+            <a:off x="457200" y="2834640"/>
+            <a:ext cx="8229600" cy="274320"/>
+          </a:xfrm>
+          <a:prstGeom prst="rect">
+            <a:avLst/>
+          </a:prstGeom>
+          <a:noFill/>
+        </p:spPr>
+        <p:txBody>
+          <a:bodyPr wrap="square">
+            <a:spAutoFit/>
+          </a:bodyPr>
+          <a:lstStyle/>
+          <a:p>
+            <a:r>
+              <a:rPr sz="1300" b="1">
+                <a:solidFill>
+                  <a:srgbClr val="2E75B6"/>
+                </a:solidFill>
+              </a:rPr>
+              <a:t>Safe State Writes + Plant Stabilisation</a:t>
+            </a:r>
+          </a:p>
+        </p:txBody>
+      </p:sp>
+      <p:sp>
+        <p:nvSpPr>
+          <p:cNvPr id="8" name="TextBox 7"/>
+          <p:cNvSpPr txBox="1"/>
+          <p:nvPr/>
+        </p:nvSpPr>
+        <p:spPr>
+          <a:xfrm>
+            <a:off x="457200" y="3154680"/>
+            <a:ext cx="8229600" cy="1097280"/>
+          </a:xfrm>
+          <a:prstGeom prst="rect">
+            <a:avLst/>
+          </a:prstGeom>
+          <a:noFill/>
+        </p:spPr>
+        <p:txBody>
+          <a:bodyPr wrap="square">
+            <a:spAutoFit/>
+          </a:bodyPr>
+          <a:lstStyle/>
+          <a:p>
+            <a:r>
+              <a:rPr sz="1000" b="0">
+                <a:solidFill>
+                  <a:srgbClr val="333333"/>
+                </a:solidFill>
+              </a:rPr>
+              <a:t>CIP writes completed &lt;5s: MV101=OPEN, P101=OFF (PLC1), MV201=CLOSED (PLC2), Sim disabled. Post-recovery: LIT101=502mm, Sim=False. Simulated: full 5-step recovery in &lt;12s, 5/5 clean invariant cycles.</a:t>
+            </a:r>
+          </a:p>
+        </p:txBody>
+      </p:sp>
+      <p:sp>
+        <p:nvSpPr>
+          <p:cNvPr id="9" name="TextBox 8"/>
+          <p:cNvSpPr txBox="1"/>
+          <p:nvPr/>
+        </p:nvSpPr>
+        <p:spPr>
+          <a:xfrm>
+            <a:off x="457200" y="4389120"/>
+            <a:ext cx="8229600" cy="274320"/>
+          </a:xfrm>
+          <a:prstGeom prst="rect">
+            <a:avLst/>
+          </a:prstGeom>
+          <a:noFill/>
+        </p:spPr>
+        <p:txBody>
+          <a:bodyPr wrap="square">
+            <a:spAutoFit/>
+          </a:bodyPr>
+          <a:lstStyle/>
+          <a:p>
+            <a:r>
+              <a:rPr sz="1300" b="1">
+                <a:solidFill>
+                  <a:srgbClr val="2E75B6"/>
+                </a:solidFill>
+              </a:rPr>
+              <a:t>Write Race Finding</a:t>
+            </a:r>
+          </a:p>
+        </p:txBody>
+      </p:sp>
+      <p:sp>
+        <p:nvSpPr>
+          <p:cNvPr id="10" name="TextBox 9"/>
+          <p:cNvSpPr txBox="1"/>
+          <p:nvPr/>
+        </p:nvSpPr>
+        <p:spPr>
+          <a:xfrm>
+            <a:off x="457200" y="4709160"/>
+            <a:ext cx="8229600" cy="1097280"/>
+          </a:xfrm>
+          <a:prstGeom prst="rect">
+            <a:avLst/>
+          </a:prstGeom>
+          <a:noFill/>
+        </p:spPr>
+        <p:txBody>
+          <a:bodyPr wrap="square">
+            <a:spAutoFit/>
+          </a:bodyPr>
+          <a:lstStyle/>
+          <a:p>
+            <a:r>
+              <a:rPr sz="1000" b="0">
+                <a:solidFill>
+                  <a:srgbClr val="333333"/>
+                </a:solidFill>
+              </a:rPr>
+              <a:t>Total stabilisation ~30s because recovery and Phase 1 entered a write race: recovery wrote MV101=OPEN, Phase 1 re-wrote MV101=CLOSED next cycle. Stable only after Phase 1 timer elapsed. Key lesson: containment (iptables block) MUST precede safe-state writes. In production attacker is on separate host; demo had both on same HMI.</a:t>
+            </a:r>
+          </a:p>
+        </p:txBody>
+      </p:sp>
+      <p:sp>
+        <p:nvSpPr>
+          <p:cNvPr id="11" name="TextBox 10"/>
+          <p:cNvSpPr txBox="1"/>
+          <p:nvPr/>
+        </p:nvSpPr>
+        <p:spPr>
+          <a:xfrm>
+            <a:off x="457200" y="6492240"/>
+            <a:ext cx="8229600" cy="228600"/>
+          </a:xfrm>
+          <a:prstGeom prst="rect">
+            <a:avLst/>
+          </a:prstGeom>
+          <a:noFill/>
+        </p:spPr>
+        <p:txBody>
+          <a:bodyPr wrap="square">
+            <a:spAutoFit/>
+          </a:bodyPr>
+          <a:lstStyle/>
+          <a:p>
+            <a:r>
+              <a:rPr sz="800" b="0">
+                <a:solidFill>
+                  <a:srgbClr val="999999"/>
+                </a:solidFill>
               </a:rPr>
               <a:t>51.508 Secure Cyber Physical Systems  ·  SWaT Project  ·  iTrust Lab, SUTD</a:t>
             </a:r>
-            <a:endParaRPr lang="en-US" sz="800" dirty="0"/>
-          </a:p>
-        </p:txBody>
-      </p:sp>
-      <p:sp>
-        <p:nvSpPr>
-          <p:cNvPr id="6" name="Shape 4"/>
-          <p:cNvSpPr/>
-          <p:nvPr/>
-        </p:nvSpPr>
-        <p:spPr>
-          <a:xfrm>
-            <a:off x="320040" y="109728"/>
-            <a:ext cx="1280160" cy="292608"/>
-          </a:xfrm>
-          <a:prstGeom prst="rect">
-            <a:avLst/>
-          </a:prstGeom>
-          <a:solidFill>
-            <a:srgbClr val="2E7D32"/>
-          </a:solidFill>
-          <a:ln/>
-        </p:spPr>
-      </p:sp>
-      <p:sp>
-        <p:nvSpPr>
-          <p:cNvPr id="7" name="Text 5"/>
-          <p:cNvSpPr/>
-          <p:nvPr/>
-        </p:nvSpPr>
-        <p:spPr>
-          <a:xfrm>
-            <a:off x="320040" y="109728"/>
-            <a:ext cx="1280160" cy="292608"/>
-          </a:xfrm>
-          <a:prstGeom prst="rect">
-            <a:avLst/>
-          </a:prstGeom>
-          <a:noFill/>
-          <a:ln/>
-        </p:spPr>
-        <p:txBody>
-          <a:bodyPr wrap="square" rtlCol="0" anchor="ctr"/>
-          <a:lstStyle/>
-          <a:p>
-            <a:pPr algn="ctr" indent="0" marL="0">
-              <a:buNone/>
-            </a:pPr>
-            <a:r>
-              <a:rPr lang="en-US" sz="1000" b="1" dirty="0">
-                <a:solidFill>
-                  <a:srgbClr val="FFFFFF"/>
-                </a:solidFill>
-                <a:latin typeface="Calibri" pitchFamily="34" charset="0"/>
-                <a:ea typeface="Calibri" pitchFamily="34" charset="-122"/>
-                <a:cs typeface="Calibri" pitchFamily="34" charset="-120"/>
-              </a:rPr>
-              <a:t>EVAL</a:t>
-            </a:r>
-            <a:endParaRPr lang="en-US" sz="1000" dirty="0"/>
-          </a:p>
-        </p:txBody>
-      </p:sp>
-      <p:sp>
-        <p:nvSpPr>
-          <p:cNvPr id="8" name="Text 6"/>
-          <p:cNvSpPr/>
-          <p:nvPr/>
-        </p:nvSpPr>
-        <p:spPr>
-          <a:xfrm>
-            <a:off x="320040" y="457200"/>
-            <a:ext cx="11548872" cy="640080"/>
-          </a:xfrm>
-          <a:prstGeom prst="rect">
-            <a:avLst/>
-          </a:prstGeom>
-          <a:noFill/>
-          <a:ln/>
-        </p:spPr>
-        <p:txBody>
-          <a:bodyPr wrap="square" rtlCol="0" anchor="ctr"/>
-          <a:lstStyle/>
-          <a:p>
-            <a:pPr indent="0" marL="0">
-              <a:buNone/>
-            </a:pPr>
-            <a:r>
-              <a:rPr lang="en-US" sz="3200" b="1" dirty="0">
-                <a:solidFill>
-                  <a:srgbClr val="1A1A1A"/>
-                </a:solidFill>
-                <a:latin typeface="Calibri Light" pitchFamily="34" charset="0"/>
-                <a:ea typeface="Calibri Light" pitchFamily="34" charset="-122"/>
-                <a:cs typeface="Calibri Light" pitchFamily="34" charset="-120"/>
-              </a:rPr>
-              <a:t>Recovery Time 2014 Live vs Expected vs Simulated</a:t>
-            </a:r>
-            <a:endParaRPr lang="en-US" sz="3200" dirty="0"/>
-          </a:p>
-        </p:txBody>
-      </p:sp>
-      <p:sp>
-        <p:nvSpPr>
-          <p:cNvPr id="9" name="Text 7"/>
-          <p:cNvSpPr/>
-          <p:nvPr/>
-        </p:nvSpPr>
-        <p:spPr>
-          <a:xfrm>
-            <a:off x="320040" y="1051560"/>
-            <a:ext cx="11548872" cy="256032"/>
-          </a:xfrm>
-          <a:prstGeom prst="rect">
-            <a:avLst/>
-          </a:prstGeom>
-          <a:noFill/>
-          <a:ln/>
-        </p:spPr>
-        <p:txBody>
-          <a:bodyPr wrap="square" rtlCol="0" anchor="ctr"/>
-          <a:lstStyle/>
-          <a:p>
-            <a:pPr indent="0" marL="0">
-              <a:buNone/>
-            </a:pPr>
-            <a:r>
-              <a:rPr lang="en-US" sz="1200" i="1" dirty="0">
-                <a:solidFill>
-                  <a:srgbClr val="6B6B6B"/>
-                </a:solidFill>
-                <a:latin typeface="Calibri" pitchFamily="34" charset="0"/>
-                <a:ea typeface="Calibri" pitchFamily="34" charset="-122"/>
-                <a:cs typeface="Calibri" pitchFamily="34" charset="-120"/>
-              </a:rPr>
-              <a:t>How quickly does the system recover after detecting an attack?</a:t>
-            </a:r>
-            <a:endParaRPr lang="en-US" sz="1200" dirty="0"/>
-          </a:p>
-        </p:txBody>
-      </p:sp>
-      <p:sp>
-        <p:nvSpPr>
-          <p:cNvPr id="10" name="Shape 8"/>
-          <p:cNvSpPr/>
-          <p:nvPr/>
-        </p:nvSpPr>
-        <p:spPr>
-          <a:xfrm>
-            <a:off x="320040" y="1463040"/>
-            <a:ext cx="11548872" cy="1143000"/>
-          </a:xfrm>
-          <a:prstGeom prst="rect">
-            <a:avLst/>
-          </a:prstGeom>
-          <a:solidFill>
-            <a:srgbClr val="F5F5F5"/>
-          </a:solidFill>
-          <a:ln w="12700">
-            <a:solidFill>
-              <a:srgbClr val="E0E0E0"/>
-            </a:solidFill>
-            <a:prstDash val="solid"/>
-          </a:ln>
-        </p:spPr>
-      </p:sp>
-      <p:sp>
-        <p:nvSpPr>
-          <p:cNvPr id="11" name="Shape 9"/>
-          <p:cNvSpPr/>
-          <p:nvPr/>
-        </p:nvSpPr>
-        <p:spPr>
-          <a:xfrm>
-            <a:off x="320040" y="1463040"/>
-            <a:ext cx="54864" cy="1143000"/>
-          </a:xfrm>
-          <a:prstGeom prst="rect">
-            <a:avLst/>
-          </a:prstGeom>
-          <a:solidFill>
-            <a:srgbClr val="2E7D32"/>
-          </a:solidFill>
-          <a:ln/>
-        </p:spPr>
-      </p:sp>
-      <p:sp>
-        <p:nvSpPr>
-          <p:cNvPr id="12" name="Text 10"/>
-          <p:cNvSpPr/>
-          <p:nvPr/>
-        </p:nvSpPr>
-        <p:spPr>
-          <a:xfrm>
-            <a:off x="502920" y="1536192"/>
-            <a:ext cx="11365992" cy="274320"/>
-          </a:xfrm>
-          <a:prstGeom prst="rect">
-            <a:avLst/>
-          </a:prstGeom>
-          <a:noFill/>
-          <a:ln/>
-        </p:spPr>
-        <p:txBody>
-          <a:bodyPr wrap="square" rtlCol="0" anchor="ctr"/>
-          <a:lstStyle/>
-          <a:p>
-            <a:pPr indent="0" marL="0">
-              <a:buNone/>
-            </a:pPr>
-            <a:r>
-              <a:rPr lang="en-US" sz="1100" b="1" dirty="0">
-                <a:solidFill>
-                  <a:srgbClr val="2E7D32"/>
-                </a:solidFill>
-                <a:latin typeface="Calibri" pitchFamily="34" charset="0"/>
-                <a:ea typeface="Calibri" pitchFamily="34" charset="-122"/>
-                <a:cs typeface="Calibri" pitchFamily="34" charset="-120"/>
-              </a:rPr>
-              <a:t>Fusion ALERT Timing</a:t>
-            </a:r>
-            <a:endParaRPr lang="en-US" sz="1100" dirty="0"/>
-          </a:p>
-        </p:txBody>
-      </p:sp>
-      <p:sp>
-        <p:nvSpPr>
-          <p:cNvPr id="13" name="Text 11"/>
-          <p:cNvSpPr/>
-          <p:nvPr/>
-        </p:nvSpPr>
-        <p:spPr>
-          <a:xfrm>
-            <a:off x="502920" y="1828800"/>
-            <a:ext cx="11365992" cy="667512"/>
-          </a:xfrm>
-          <a:prstGeom prst="rect">
-            <a:avLst/>
-          </a:prstGeom>
-          <a:noFill/>
-          <a:ln/>
-        </p:spPr>
-        <p:txBody>
-          <a:bodyPr wrap="square" rtlCol="0" anchor="t"/>
-          <a:lstStyle/>
-          <a:p>
-            <a:pPr indent="0" marL="0">
-              <a:buNone/>
-            </a:pPr>
-            <a:r>
-              <a:rPr lang="en-US" sz="1050" dirty="0">
-                <a:solidFill>
-                  <a:srgbClr val="2D2D2D"/>
-                </a:solidFill>
-                <a:latin typeface="Calibri" pitchFamily="34" charset="0"/>
-                <a:ea typeface="Calibri" pitchFamily="34" charset="-122"/>
-                <a:cs typeface="Calibri" pitchFamily="34" charset="-120"/>
-              </a:rPr>
-              <a:t>
-                Expected: 
-                <a:t>Live: Invariant detected cycle 1 (I-2 + I-9). I-9b/I-9c also fired but excluded (supplementary rules). 104 violation cycles. AE detection time: 10s (window fills). Simulated AE detection rate (LIT-only): 94/100 (94%). AE evasion by Phase 2: inconclusive on live (FIT101=-31 saturated AE).</a:t>
-                lt;3s (3 consecutive cycles at 1s intervals). Live: exactly 3s (16:33:08 first violation 2192 16:33:11 ALERT). Simulated: 3 cycles. Exact match with design specification. Recovery agent launched automatically by fusion.py when score 2265 1.5 sustained for 3 cycles.
-              </a:t>
-            </a:r>
-            <a:endParaRPr lang="en-US" sz="1050" dirty="0"/>
-          </a:p>
-        </p:txBody>
-      </p:sp>
-      <p:sp>
-        <p:nvSpPr>
-          <p:cNvPr id="14" name="Shape 12"/>
-          <p:cNvSpPr/>
-          <p:nvPr/>
-        </p:nvSpPr>
-        <p:spPr>
-          <a:xfrm>
-            <a:off x="320040" y="2743200"/>
-            <a:ext cx="11548872" cy="1143000"/>
-          </a:xfrm>
-          <a:prstGeom prst="rect">
-            <a:avLst/>
-          </a:prstGeom>
-          <a:solidFill>
-            <a:srgbClr val="F5F5F5"/>
-          </a:solidFill>
-          <a:ln w="12700">
-            <a:solidFill>
-              <a:srgbClr val="E0E0E0"/>
-            </a:solidFill>
-            <a:prstDash val="solid"/>
-          </a:ln>
-        </p:spPr>
-      </p:sp>
-      <p:sp>
-        <p:nvSpPr>
-          <p:cNvPr id="15" name="Shape 13"/>
-          <p:cNvSpPr/>
-          <p:nvPr/>
-        </p:nvSpPr>
-        <p:spPr>
-          <a:xfrm>
-            <a:off x="320040" y="2743200"/>
-            <a:ext cx="54864" cy="1143000"/>
-          </a:xfrm>
-          <a:prstGeom prst="rect">
-            <a:avLst/>
-          </a:prstGeom>
-          <a:solidFill>
-            <a:srgbClr val="2E7D32"/>
-          </a:solidFill>
-          <a:ln/>
-        </p:spPr>
-      </p:sp>
-      <p:sp>
-        <p:nvSpPr>
-          <p:cNvPr id="16" name="Text 14"/>
-          <p:cNvSpPr/>
-          <p:nvPr/>
-        </p:nvSpPr>
-        <p:spPr>
-          <a:xfrm>
-            <a:off x="502920" y="2816352"/>
-            <a:ext cx="11365992" cy="274320"/>
-          </a:xfrm>
-          <a:prstGeom prst="rect">
-            <a:avLst/>
-          </a:prstGeom>
-          <a:noFill/>
-          <a:ln/>
-        </p:spPr>
-        <p:txBody>
-          <a:bodyPr wrap="square" rtlCol="0" anchor="ctr"/>
-          <a:lstStyle/>
-          <a:p>
-            <a:pPr indent="0" marL="0">
-              <a:buNone/>
-            </a:pPr>
-            <a:r>
-              <a:rPr lang="en-US" sz="1100" b="1" dirty="0">
-                <a:solidFill>
-                  <a:srgbClr val="2E7D32"/>
-                </a:solidFill>
-                <a:latin typeface="Calibri" pitchFamily="34" charset="0"/>
-                <a:ea typeface="Calibri" pitchFamily="34" charset="-122"/>
-                <a:cs typeface="Calibri" pitchFamily="34" charset="-120"/>
-              </a:rPr>
-              <a:t>Safe State Writes + Plant Stabilisation</a:t>
-            </a:r>
-            <a:endParaRPr lang="en-US" sz="1100" dirty="0"/>
-          </a:p>
-        </p:txBody>
-      </p:sp>
-      <p:sp>
-        <p:nvSpPr>
-          <p:cNvPr id="17" name="Text 15"/>
-          <p:cNvSpPr/>
-          <p:nvPr/>
-        </p:nvSpPr>
-        <p:spPr>
-          <a:xfrm>
-            <a:off x="502920" y="3108960"/>
-            <a:ext cx="11365992" cy="667512"/>
-          </a:xfrm>
-          <a:prstGeom prst="rect">
-            <a:avLst/>
-          </a:prstGeom>
-          <a:noFill/>
-          <a:ln/>
-        </p:spPr>
-        <p:txBody>
-          <a:bodyPr wrap="square" rtlCol="0" anchor="t"/>
-          <a:lstStyle/>
-          <a:p>
-            <a:pPr indent="0" marL="0">
-              <a:buNone/>
-            </a:pPr>
-            <a:r>
-              <a:rPr lang="en-US" sz="1050" dirty="0">
-                <a:solidFill>
-                  <a:srgbClr val="2D2D2D"/>
-                </a:solidFill>
-                <a:latin typeface="Calibri" pitchFamily="34" charset="0"/>
-                <a:ea typeface="Calibri" pitchFamily="34" charset="-122"/>
-                <a:cs typeface="Calibri" pitchFamily="34" charset="-120"/>
-              </a:rPr>
-              <a:t>
-                Safe state CIP writes completed in 
-                <a:t>Live FPR: Inconclusive — plant started in attack-equivalent state (MV101=CLOSED, FIT101=-31). Invariants correctly identified unsafe config (true positive). Phase 2 concealment: 736mm gap (HMI 1345mm vs physical 502mm). Simulated: 0/500 AE false alarms (0.0%), MSE 19x below threshold.</a:t>
-                lt;5s: MV101=OPEN, P101=OFF (PLC1), MV201=CLOSED (PLC2), Sim tags disabled. Post-recovery plant state: LIT101=502mm, Sim=False. Simulated: full 5-step recovery in 
-                <a:t>Live FPR: Inconclusive — plant started in attack-equivalent state (MV101=CLOSED, FIT101=-31). Invariants correctly identified unsafe config (true positive). Phase 2 concealment: 736mm gap (HMI 1345mm vs physical 502mm). Simulated: 0/500 AE false alarms (0.0%), MSE 19x below threshold.</a:t>
-                lt;12s with 5/5 clean invariant cycles verified.
-              </a:t>
-            </a:r>
-            <a:endParaRPr lang="en-US" sz="1050" dirty="0"/>
-          </a:p>
-        </p:txBody>
-      </p:sp>
-      <p:sp>
-        <p:nvSpPr>
-          <p:cNvPr id="18" name="Shape 16"/>
-          <p:cNvSpPr/>
-          <p:nvPr/>
-        </p:nvSpPr>
-        <p:spPr>
-          <a:xfrm>
-            <a:off x="320040" y="4023360"/>
-            <a:ext cx="11548872" cy="1143000"/>
-          </a:xfrm>
-          <a:prstGeom prst="rect">
-            <a:avLst/>
-          </a:prstGeom>
-          <a:solidFill>
-            <a:srgbClr val="F5F5F5"/>
-          </a:solidFill>
-          <a:ln w="12700">
-            <a:solidFill>
-              <a:srgbClr val="E0E0E0"/>
-            </a:solidFill>
-            <a:prstDash val="solid"/>
-          </a:ln>
-        </p:spPr>
-      </p:sp>
-      <p:sp>
-        <p:nvSpPr>
-          <p:cNvPr id="19" name="Shape 17"/>
-          <p:cNvSpPr/>
-          <p:nvPr/>
-        </p:nvSpPr>
-        <p:spPr>
-          <a:xfrm>
-            <a:off x="320040" y="4023360"/>
-            <a:ext cx="54864" cy="1143000"/>
-          </a:xfrm>
-          <a:prstGeom prst="rect">
-            <a:avLst/>
-          </a:prstGeom>
-          <a:solidFill>
-            <a:srgbClr val="2E7D32"/>
-          </a:solidFill>
-          <a:ln/>
-        </p:spPr>
-      </p:sp>
-      <p:sp>
-        <p:nvSpPr>
-          <p:cNvPr id="20" name="Text 18"/>
-          <p:cNvSpPr/>
-          <p:nvPr/>
-        </p:nvSpPr>
-        <p:spPr>
-          <a:xfrm>
-            <a:off x="502920" y="4096512"/>
-            <a:ext cx="11365992" cy="274320"/>
-          </a:xfrm>
-          <a:prstGeom prst="rect">
-            <a:avLst/>
-          </a:prstGeom>
-          <a:noFill/>
-          <a:ln/>
-        </p:spPr>
-        <p:txBody>
-          <a:bodyPr wrap="square" rtlCol="0" anchor="ctr"/>
-          <a:lstStyle/>
-          <a:p>
-            <a:pPr indent="0" marL="0">
-              <a:buNone/>
-            </a:pPr>
-            <a:r>
-              <a:rPr lang="en-US" sz="1100" b="1" dirty="0">
-                <a:solidFill>
-                  <a:srgbClr val="2E7D32"/>
-                </a:solidFill>
-                <a:latin typeface="Calibri" pitchFamily="34" charset="0"/>
-                <a:ea typeface="Calibri" pitchFamily="34" charset="-122"/>
-                <a:cs typeface="Calibri" pitchFamily="34" charset="-120"/>
-              </a:rPr>
-              <a:t>Write Race Finding</a:t>
-            </a:r>
-            <a:endParaRPr lang="en-US" sz="1100" dirty="0"/>
-          </a:p>
-        </p:txBody>
-      </p:sp>
-      <p:sp>
-        <p:nvSpPr>
-          <p:cNvPr id="21" name="Text 19"/>
-          <p:cNvSpPr/>
-          <p:nvPr/>
-        </p:nvSpPr>
-        <p:spPr>
-          <a:xfrm>
-            <a:off x="502920" y="4389120"/>
-            <a:ext cx="11365992" cy="667512"/>
-          </a:xfrm>
-          <a:prstGeom prst="rect">
-            <a:avLst/>
-          </a:prstGeom>
-          <a:noFill/>
-          <a:ln/>
-        </p:spPr>
-        <p:txBody>
-          <a:bodyPr wrap="square" rtlCol="0" anchor="t"/>
-          <a:lstStyle/>
-          <a:p>
-            <a:pPr indent="0" marL="0">
-              <a:buNone/>
-            </a:pPr>
-            <a:r>
-              <a:rPr lang="en-US" sz="1050" dirty="0">
-                <a:solidFill>
-                  <a:srgbClr val="2D2D2D"/>
-                </a:solidFill>
-                <a:latin typeface="Calibri" pitchFamily="34" charset="0"/>
-                <a:ea typeface="Calibri" pitchFamily="34" charset="-122"/>
-                <a:cs typeface="Calibri" pitchFamily="34" charset="-120"/>
-              </a:rPr>
-              <a:t>Total stabilisation took ~30s because recovery and Phase 1 entered a write race: recovery wrote MV101=OPEN, Phase 1 immediately re-wrote MV101=CLOSED on the next cycle. Plant only stabilised after Phase 1 timer elapsed. Key lesson: containment (Step 2: iptables block on attacker IP) MUST succeed before safe-state writes can hold. In production the attacker is on a separate host; in the demo both ran on the same HMI, so iptables could not block the re-injection.</a:t>
-            </a:r>
-            <a:endParaRPr lang="en-US" sz="1050" dirty="0"/>
           </a:p>
         </p:txBody>
       </p:sp>

</xml_diff>

<commit_message>
slides: rebuild 3 evaluation slides with proper tables (DR/FPR/RT)
Clean rebuild from last known-good pptx using python-pptx:
- Slide 29: Detection Rate table (5 rows × 4 cols) + discussion
- Slide 30: False Positive Rate table (2 rows × 4 cols) + discussion
- Slide 31: Recovery Time table (4 rows × 4 cols) + discussion

Each table has: Metric | Expected | Live (16 Apr) | Simulated
Dark blue header row, alternating row shading, discussion text below.
52 slides total.
</commit_message>
<xml_diff>
--- a/slides/swat_sutd.pptx
+++ b/slides/swat_sutd.pptx
@@ -51120,8 +51120,8 @@
         </p:nvSpPr>
         <p:spPr>
           <a:xfrm>
-            <a:off x="457200" y="182880"/>
-            <a:ext cx="1828800" cy="274320"/>
+            <a:off x="365760" y="137160"/>
+            <a:ext cx="1828800" cy="228600"/>
           </a:xfrm>
           <a:prstGeom prst="rect">
             <a:avLst/>
@@ -51135,7 +51135,7 @@
           <a:lstStyle/>
           <a:p>
             <a:r>
-              <a:rPr sz="1000" b="1">
+              <a:rPr sz="900" b="1">
                 <a:solidFill>
                   <a:srgbClr val="CC0000"/>
                 </a:solidFill>
@@ -51153,8 +51153,8 @@
         </p:nvSpPr>
         <p:spPr>
           <a:xfrm>
-            <a:off x="457200" y="411480"/>
-            <a:ext cx="8229600" cy="457200"/>
+            <a:off x="365760" y="320040"/>
+            <a:ext cx="8229600" cy="411480"/>
           </a:xfrm>
           <a:prstGeom prst="rect">
             <a:avLst/>
@@ -51168,7 +51168,7 @@
           <a:lstStyle/>
           <a:p>
             <a:r>
-              <a:rPr sz="2200" b="1">
+              <a:rPr sz="2000" b="1">
                 <a:solidFill>
                   <a:srgbClr val="1F3864"/>
                 </a:solidFill>
@@ -51186,8 +51186,8 @@
         </p:nvSpPr>
         <p:spPr>
           <a:xfrm>
-            <a:off x="457200" y="868680"/>
-            <a:ext cx="8229600" cy="274320"/>
+            <a:off x="365760" y="713232"/>
+            <a:ext cx="8229600" cy="228600"/>
           </a:xfrm>
           <a:prstGeom prst="rect">
             <a:avLst/>
@@ -51201,7 +51201,7 @@
           <a:lstStyle/>
           <a:p>
             <a:r>
-              <a:rPr sz="1100" b="0">
+              <a:rPr sz="1000" b="0">
                 <a:solidFill>
                   <a:srgbClr val="666666"/>
                 </a:solidFill>
@@ -51211,16 +51211,516 @@
           </a:p>
         </p:txBody>
       </p:sp>
-      <p:sp>
-        <p:nvSpPr>
-          <p:cNvPr id="5" name="TextBox 4"/>
+      <p:graphicFrame>
+        <p:nvGraphicFramePr>
+          <p:cNvPr id="5" name="Table 4"/>
+          <p:cNvGraphicFramePr>
+            <a:graphicFrameLocks noGrp="1"/>
+          </p:cNvGraphicFramePr>
+          <p:nvPr/>
+        </p:nvGraphicFramePr>
+        <p:xfrm>
+          <a:off x="365760" y="1051560"/>
+          <a:ext cx="8595360" cy="1938528"/>
+        </p:xfrm>
+        <a:graphic>
+          <a:graphicData uri="http://schemas.openxmlformats.org/drawingml/2006/table">
+            <a:tbl>
+              <a:tblPr firstRow="1" bandRow="1">
+                <a:tableStyleId>{5C22544A-7EE6-4342-B048-85BDC9FD1C3A}</a:tableStyleId>
+              </a:tblPr>
+              <a:tblGrid>
+                <a:gridCol w="1828800"/>
+                <a:gridCol w="2011680"/>
+                <a:gridCol w="2377440"/>
+                <a:gridCol w="2377440"/>
+              </a:tblGrid>
+              <a:tr h="323088">
+                <a:tc>
+                  <a:txBody>
+                    <a:bodyPr wrap="square"/>
+                    <a:lstStyle/>
+                    <a:p>
+                      <a:r>
+                        <a:rPr sz="900" b="1">
+                          <a:solidFill>
+                            <a:srgbClr val="FFFFFF"/>
+                          </a:solidFill>
+                        </a:rPr>
+                        <a:t>Metric</a:t>
+                      </a:r>
+                    </a:p>
+                  </a:txBody>
+                  <a:tcPr marT="50800" marB="50800" marL="76200" marR="76200">
+                    <a:solidFill>
+                      <a:srgbClr val="1F3864"/>
+                    </a:solidFill>
+                  </a:tcPr>
+                </a:tc>
+                <a:tc>
+                  <a:txBody>
+                    <a:bodyPr wrap="square"/>
+                    <a:lstStyle/>
+                    <a:p>
+                      <a:r>
+                        <a:rPr sz="900" b="1">
+                          <a:solidFill>
+                            <a:srgbClr val="FFFFFF"/>
+                          </a:solidFill>
+                        </a:rPr>
+                        <a:t>Expected</a:t>
+                      </a:r>
+                    </a:p>
+                  </a:txBody>
+                  <a:tcPr marT="50800" marB="50800" marL="76200" marR="76200">
+                    <a:solidFill>
+                      <a:srgbClr val="1F3864"/>
+                    </a:solidFill>
+                  </a:tcPr>
+                </a:tc>
+                <a:tc>
+                  <a:txBody>
+                    <a:bodyPr wrap="square"/>
+                    <a:lstStyle/>
+                    <a:p>
+                      <a:r>
+                        <a:rPr sz="900" b="1">
+                          <a:solidFill>
+                            <a:srgbClr val="FFFFFF"/>
+                          </a:solidFill>
+                        </a:rPr>
+                        <a:t>Live (16 Apr)</a:t>
+                      </a:r>
+                    </a:p>
+                  </a:txBody>
+                  <a:tcPr marT="50800" marB="50800" marL="76200" marR="76200">
+                    <a:solidFill>
+                      <a:srgbClr val="1F3864"/>
+                    </a:solidFill>
+                  </a:tcPr>
+                </a:tc>
+                <a:tc>
+                  <a:txBody>
+                    <a:bodyPr wrap="square"/>
+                    <a:lstStyle/>
+                    <a:p>
+                      <a:r>
+                        <a:rPr sz="900" b="1">
+                          <a:solidFill>
+                            <a:srgbClr val="FFFFFF"/>
+                          </a:solidFill>
+                        </a:rPr>
+                        <a:t>Simulated</a:t>
+                      </a:r>
+                    </a:p>
+                  </a:txBody>
+                  <a:tcPr marT="50800" marB="50800" marL="76200" marR="76200">
+                    <a:solidFill>
+                      <a:srgbClr val="1F3864"/>
+                    </a:solidFill>
+                  </a:tcPr>
+                </a:tc>
+              </a:tr>
+              <a:tr h="323088">
+                <a:tc>
+                  <a:txBody>
+                    <a:bodyPr wrap="square"/>
+                    <a:lstStyle/>
+                    <a:p>
+                      <a:r>
+                        <a:rPr sz="800" b="1">
+                          <a:solidFill>
+                            <a:srgbClr val="333333"/>
+                          </a:solidFill>
+                        </a:rPr>
+                        <a:t>Invariant detection time</a:t>
+                      </a:r>
+                    </a:p>
+                  </a:txBody>
+                  <a:tcPr marT="50800" marB="50800" marL="76200" marR="76200"/>
+                </a:tc>
+                <a:tc>
+                  <a:txBody>
+                    <a:bodyPr wrap="square"/>
+                    <a:lstStyle/>
+                    <a:p>
+                      <a:r>
+                        <a:rPr sz="800" b="0">
+                          <a:solidFill>
+                            <a:srgbClr val="333333"/>
+                          </a:solidFill>
+                        </a:rPr>
+                        <a:t>1–6s</a:t>
+                      </a:r>
+                    </a:p>
+                  </a:txBody>
+                  <a:tcPr marT="50800" marB="50800" marL="76200" marR="76200"/>
+                </a:tc>
+                <a:tc>
+                  <a:txBody>
+                    <a:bodyPr wrap="square"/>
+                    <a:lstStyle/>
+                    <a:p>
+                      <a:r>
+                        <a:rPr sz="800" b="0">
+                          <a:solidFill>
+                            <a:srgbClr val="333333"/>
+                          </a:solidFill>
+                        </a:rPr>
+                        <a:t>1s (cycle 1, I-2 + I-9)</a:t>
+                      </a:r>
+                    </a:p>
+                  </a:txBody>
+                  <a:tcPr marT="50800" marB="50800" marL="76200" marR="76200"/>
+                </a:tc>
+                <a:tc>
+                  <a:txBody>
+                    <a:bodyPr wrap="square"/>
+                    <a:lstStyle/>
+                    <a:p>
+                      <a:r>
+                        <a:rPr sz="800" b="0">
+                          <a:solidFill>
+                            <a:srgbClr val="333333"/>
+                          </a:solidFill>
+                        </a:rPr>
+                        <a:t>1s (cycle 1)</a:t>
+                      </a:r>
+                    </a:p>
+                  </a:txBody>
+                  <a:tcPr marT="50800" marB="50800" marL="76200" marR="76200"/>
+                </a:tc>
+              </a:tr>
+              <a:tr h="323088">
+                <a:tc>
+                  <a:txBody>
+                    <a:bodyPr wrap="square"/>
+                    <a:lstStyle/>
+                    <a:p>
+                      <a:r>
+                        <a:rPr sz="800" b="1">
+                          <a:solidFill>
+                            <a:srgbClr val="333333"/>
+                          </a:solidFill>
+                        </a:rPr>
+                        <a:t>AE detection time</a:t>
+                      </a:r>
+                    </a:p>
+                  </a:txBody>
+                  <a:tcPr marT="50800" marB="50800" marL="76200" marR="76200">
+                    <a:solidFill>
+                      <a:srgbClr val="F2F2F2"/>
+                    </a:solidFill>
+                  </a:tcPr>
+                </a:tc>
+                <a:tc>
+                  <a:txBody>
+                    <a:bodyPr wrap="square"/>
+                    <a:lstStyle/>
+                    <a:p>
+                      <a:r>
+                        <a:rPr sz="800" b="0">
+                          <a:solidFill>
+                            <a:srgbClr val="333333"/>
+                          </a:solidFill>
+                        </a:rPr>
+                        <a:t>10–15s (window fills)</a:t>
+                      </a:r>
+                    </a:p>
+                  </a:txBody>
+                  <a:tcPr marT="50800" marB="50800" marL="76200" marR="76200">
+                    <a:solidFill>
+                      <a:srgbClr val="F2F2F2"/>
+                    </a:solidFill>
+                  </a:tcPr>
+                </a:tc>
+                <a:tc>
+                  <a:txBody>
+                    <a:bodyPr wrap="square"/>
+                    <a:lstStyle/>
+                    <a:p>
+                      <a:r>
+                        <a:rPr sz="800" b="0">
+                          <a:solidFill>
+                            <a:srgbClr val="333333"/>
+                          </a:solidFill>
+                        </a:rPr>
+                        <a:t>10s (cycle 10)</a:t>
+                      </a:r>
+                    </a:p>
+                  </a:txBody>
+                  <a:tcPr marT="50800" marB="50800" marL="76200" marR="76200">
+                    <a:solidFill>
+                      <a:srgbClr val="F2F2F2"/>
+                    </a:solidFill>
+                  </a:tcPr>
+                </a:tc>
+                <a:tc>
+                  <a:txBody>
+                    <a:bodyPr wrap="square"/>
+                    <a:lstStyle/>
+                    <a:p>
+                      <a:r>
+                        <a:rPr sz="800" b="0">
+                          <a:solidFill>
+                            <a:srgbClr val="333333"/>
+                          </a:solidFill>
+                        </a:rPr>
+                        <a:t>10s (window=10)</a:t>
+                      </a:r>
+                    </a:p>
+                  </a:txBody>
+                  <a:tcPr marT="50800" marB="50800" marL="76200" marR="76200">
+                    <a:solidFill>
+                      <a:srgbClr val="F2F2F2"/>
+                    </a:solidFill>
+                  </a:tcPr>
+                </a:tc>
+              </a:tr>
+              <a:tr h="323088">
+                <a:tc>
+                  <a:txBody>
+                    <a:bodyPr wrap="square"/>
+                    <a:lstStyle/>
+                    <a:p>
+                      <a:r>
+                        <a:rPr sz="800" b="1">
+                          <a:solidFill>
+                            <a:srgbClr val="333333"/>
+                          </a:solidFill>
+                        </a:rPr>
+                        <a:t>AE detection rate</a:t>
+                      </a:r>
+                    </a:p>
+                  </a:txBody>
+                  <a:tcPr marT="50800" marB="50800" marL="76200" marR="76200"/>
+                </a:tc>
+                <a:tc>
+                  <a:txBody>
+                    <a:bodyPr wrap="square"/>
+                    <a:lstStyle/>
+                    <a:p>
+                      <a:r>
+                        <a:rPr sz="800" b="0">
+                          <a:solidFill>
+                            <a:srgbClr val="333333"/>
+                          </a:solidFill>
+                        </a:rPr>
+                        <a:t>&gt;90% of windows</a:t>
+                      </a:r>
+                    </a:p>
+                  </a:txBody>
+                  <a:tcPr marT="50800" marB="50800" marL="76200" marR="76200"/>
+                </a:tc>
+                <a:tc>
+                  <a:txBody>
+                    <a:bodyPr wrap="square"/>
+                    <a:lstStyle/>
+                    <a:p>
+                      <a:r>
+                        <a:rPr sz="800" b="0">
+                          <a:solidFill>
+                            <a:srgbClr val="333333"/>
+                          </a:solidFill>
+                        </a:rPr>
+                        <a:t>Inconclusive (FIT101=-31
+saturated AE at MSE=367)</a:t>
+                      </a:r>
+                    </a:p>
+                  </a:txBody>
+                  <a:tcPr marT="50800" marB="50800" marL="76200" marR="76200"/>
+                </a:tc>
+                <a:tc>
+                  <a:txBody>
+                    <a:bodyPr wrap="square"/>
+                    <a:lstStyle/>
+                    <a:p>
+                      <a:r>
+                        <a:rPr sz="800" b="0">
+                          <a:solidFill>
+                            <a:srgbClr val="333333"/>
+                          </a:solidFill>
+                        </a:rPr>
+                        <a:t>94/100 (94%)</a:t>
+                      </a:r>
+                    </a:p>
+                  </a:txBody>
+                  <a:tcPr marT="50800" marB="50800" marL="76200" marR="76200"/>
+                </a:tc>
+              </a:tr>
+              <a:tr h="323088">
+                <a:tc>
+                  <a:txBody>
+                    <a:bodyPr wrap="square"/>
+                    <a:lstStyle/>
+                    <a:p>
+                      <a:r>
+                        <a:rPr sz="800" b="1">
+                          <a:solidFill>
+                            <a:srgbClr val="333333"/>
+                          </a:solidFill>
+                        </a:rPr>
+                        <a:t>Hybrid under Phase 1+2</a:t>
+                      </a:r>
+                    </a:p>
+                  </a:txBody>
+                  <a:tcPr marT="50800" marB="50800" marL="76200" marR="76200">
+                    <a:solidFill>
+                      <a:srgbClr val="F2F2F2"/>
+                    </a:solidFill>
+                  </a:tcPr>
+                </a:tc>
+                <a:tc>
+                  <a:txBody>
+                    <a:bodyPr wrap="square"/>
+                    <a:lstStyle/>
+                    <a:p>
+                      <a:r>
+                        <a:rPr sz="800" b="0">
+                          <a:solidFill>
+                            <a:srgbClr val="333333"/>
+                          </a:solidFill>
+                        </a:rPr>
+                        <a:t>1–6s (invariant catches)</a:t>
+                      </a:r>
+                    </a:p>
+                  </a:txBody>
+                  <a:tcPr marT="50800" marB="50800" marL="76200" marR="76200">
+                    <a:solidFill>
+                      <a:srgbClr val="F2F2F2"/>
+                    </a:solidFill>
+                  </a:tcPr>
+                </a:tc>
+                <a:tc>
+                  <a:txBody>
+                    <a:bodyPr wrap="square"/>
+                    <a:lstStyle/>
+                    <a:p>
+                      <a:r>
+                        <a:rPr sz="800" b="0">
+                          <a:solidFill>
+                            <a:srgbClr val="333333"/>
+                          </a:solidFill>
+                        </a:rPr>
+                        <a:t>1s (invariant). AE evasion:
+inconclusive</a:t>
+                      </a:r>
+                    </a:p>
+                  </a:txBody>
+                  <a:tcPr marT="50800" marB="50800" marL="76200" marR="76200">
+                    <a:solidFill>
+                      <a:srgbClr val="F2F2F2"/>
+                    </a:solidFill>
+                  </a:tcPr>
+                </a:tc>
+                <a:tc>
+                  <a:txBody>
+                    <a:bodyPr wrap="square"/>
+                    <a:lstStyle/>
+                    <a:p>
+                      <a:r>
+                        <a:rPr sz="800" b="0">
+                          <a:solidFill>
+                            <a:srgbClr val="333333"/>
+                          </a:solidFill>
+                        </a:rPr>
+                        <a:t>Invariant 10/10
+regardless</a:t>
+                      </a:r>
+                    </a:p>
+                  </a:txBody>
+                  <a:tcPr marT="50800" marB="50800" marL="76200" marR="76200">
+                    <a:solidFill>
+                      <a:srgbClr val="F2F2F2"/>
+                    </a:solidFill>
+                  </a:tcPr>
+                </a:tc>
+              </a:tr>
+              <a:tr h="323088">
+                <a:tc>
+                  <a:txBody>
+                    <a:bodyPr wrap="square"/>
+                    <a:lstStyle/>
+                    <a:p>
+                      <a:r>
+                        <a:rPr sz="800" b="1">
+                          <a:solidFill>
+                            <a:srgbClr val="333333"/>
+                          </a:solidFill>
+                        </a:rPr>
+                        <a:t>Phase 2 concealment</a:t>
+                      </a:r>
+                    </a:p>
+                  </a:txBody>
+                  <a:tcPr marT="50800" marB="50800" marL="76200" marR="76200"/>
+                </a:tc>
+                <a:tc>
+                  <a:txBody>
+                    <a:bodyPr wrap="square"/>
+                    <a:lstStyle/>
+                    <a:p>
+                      <a:r>
+                        <a:rPr sz="800" b="0">
+                          <a:solidFill>
+                            <a:srgbClr val="333333"/>
+                          </a:solidFill>
+                        </a:rPr>
+                        <a:t>Spoofed LIT within ±ε</a:t>
+                      </a:r>
+                    </a:p>
+                  </a:txBody>
+                  <a:tcPr marT="50800" marB="50800" marL="76200" marR="76200"/>
+                </a:tc>
+                <a:tc>
+                  <a:txBody>
+                    <a:bodyPr wrap="square"/>
+                    <a:lstStyle/>
+                    <a:p>
+                      <a:r>
+                        <a:rPr sz="800" b="0">
+                          <a:solidFill>
+                            <a:srgbClr val="333333"/>
+                          </a:solidFill>
+                        </a:rPr>
+                        <a:t>736mm gap (HMI: 1345mm,
+physical: 502mm)</a:t>
+                      </a:r>
+                    </a:p>
+                  </a:txBody>
+                  <a:tcPr marT="50800" marB="50800" marL="76200" marR="76200"/>
+                </a:tc>
+                <a:tc>
+                  <a:txBody>
+                    <a:bodyPr wrap="square"/>
+                    <a:lstStyle/>
+                    <a:p>
+                      <a:r>
+                        <a:rPr sz="800" b="0">
+                          <a:solidFill>
+                            <a:srgbClr val="333333"/>
+                          </a:solidFill>
+                        </a:rPr>
+                        <a:t>N/A</a:t>
+                      </a:r>
+                    </a:p>
+                  </a:txBody>
+                  <a:tcPr marT="50800" marB="50800" marL="76200" marR="76200"/>
+                </a:tc>
+              </a:tr>
+            </a:tbl>
+          </a:graphicData>
+        </a:graphic>
+      </p:graphicFrame>
+      <p:sp>
+        <p:nvSpPr>
+          <p:cNvPr id="6" name="TextBox 5"/>
           <p:cNvSpPr txBox="1"/>
           <p:nvPr/>
         </p:nvSpPr>
         <p:spPr>
           <a:xfrm>
-            <a:off x="457200" y="1280160"/>
-            <a:ext cx="8229600" cy="274320"/>
+            <a:off x="365760" y="3264408"/>
+            <a:ext cx="8412480" cy="2286000"/>
           </a:xfrm>
           <a:prstGeom prst="rect">
             <a:avLst/>
@@ -51234,26 +51734,26 @@
           <a:lstStyle/>
           <a:p>
             <a:r>
-              <a:rPr sz="1300" b="1">
-                <a:solidFill>
-                  <a:srgbClr val="2E75B6"/>
-                </a:solidFill>
-              </a:rPr>
-              <a:t>Invariant Detection Time</a:t>
-            </a:r>
-          </a:p>
-        </p:txBody>
-      </p:sp>
-      <p:sp>
-        <p:nvSpPr>
-          <p:cNvPr id="6" name="TextBox 5"/>
+              <a:rPr sz="900" b="0">
+                <a:solidFill>
+                  <a:srgbClr val="444444"/>
+                </a:solidFill>
+              </a:rPr>
+              <a:t>I-9 is the Phase 1 signature invariant (MV101=CLOSED + P101=ON in normal range). I-9b/I-9c also fired but are excluded — supplementary rules for PLC failover and sensor fault edge cases. AE saturated by pre-existing FIT101=-31 sensor fault; models retrained on LIT101 only.</a:t>
+            </a:r>
+          </a:p>
+        </p:txBody>
+      </p:sp>
+      <p:sp>
+        <p:nvSpPr>
+          <p:cNvPr id="7" name="TextBox 6"/>
           <p:cNvSpPr txBox="1"/>
           <p:nvPr/>
         </p:nvSpPr>
         <p:spPr>
           <a:xfrm>
-            <a:off x="457200" y="1600200"/>
-            <a:ext cx="8229600" cy="1097280"/>
+            <a:off x="365760" y="6492240"/>
+            <a:ext cx="8229600" cy="182880"/>
           </a:xfrm>
           <a:prstGeom prst="rect">
             <a:avLst/>
@@ -51267,172 +51767,7 @@
           <a:lstStyle/>
           <a:p>
             <a:r>
-              <a:rPr sz="1000" b="0">
-                <a:solidFill>
-                  <a:srgbClr val="333333"/>
-                </a:solidFill>
-              </a:rPr>
-              <a:t>Expected: 1–6s. Live: 1s (cycle 1, I-2 + I-9 fired). Simulated: 1s (cycle 1). I-9 is the Phase 1 signature invariant: MV101=CLOSED + P101=ON in normal range. I-9b/I-9c also fired but excluded from primary claim (supplementary rules). 104 total violation cycles over the 120s attack.</a:t>
-            </a:r>
-          </a:p>
-        </p:txBody>
-      </p:sp>
-      <p:sp>
-        <p:nvSpPr>
-          <p:cNvPr id="7" name="TextBox 6"/>
-          <p:cNvSpPr txBox="1"/>
-          <p:nvPr/>
-        </p:nvSpPr>
-        <p:spPr>
-          <a:xfrm>
-            <a:off x="457200" y="2834640"/>
-            <a:ext cx="8229600" cy="274320"/>
-          </a:xfrm>
-          <a:prstGeom prst="rect">
-            <a:avLst/>
-          </a:prstGeom>
-          <a:noFill/>
-        </p:spPr>
-        <p:txBody>
-          <a:bodyPr wrap="square">
-            <a:spAutoFit/>
-          </a:bodyPr>
-          <a:lstStyle/>
-          <a:p>
-            <a:r>
-              <a:rPr sz="1300" b="1">
-                <a:solidFill>
-                  <a:srgbClr val="2E75B6"/>
-                </a:solidFill>
-              </a:rPr>
-              <a:t>AE Detection Time + Rate</a:t>
-            </a:r>
-          </a:p>
-        </p:txBody>
-      </p:sp>
-      <p:sp>
-        <p:nvSpPr>
-          <p:cNvPr id="8" name="TextBox 7"/>
-          <p:cNvSpPr txBox="1"/>
-          <p:nvPr/>
-        </p:nvSpPr>
-        <p:spPr>
-          <a:xfrm>
-            <a:off x="457200" y="3154680"/>
-            <a:ext cx="8229600" cy="1097280"/>
-          </a:xfrm>
-          <a:prstGeom prst="rect">
-            <a:avLst/>
-          </a:prstGeom>
-          <a:noFill/>
-        </p:spPr>
-        <p:txBody>
-          <a:bodyPr wrap="square">
-            <a:spAutoFit/>
-          </a:bodyPr>
-          <a:lstStyle/>
-          <a:p>
-            <a:r>
-              <a:rPr sz="1000" b="0">
-                <a:solidFill>
-                  <a:srgbClr val="333333"/>
-                </a:solidFill>
-              </a:rPr>
-              <a:t>Expected time: 10–15s (window=10 must fill). Live: 10s (cycle 10). Expected rate: &gt;90%. Simulated (LIT-only AE): 94/100 = 94%. Live rate: inconclusive — FIT101=-31 sensor fault produced MSE=367 (500,000× above threshold), saturating the AE before Phase 2 started. Models retrained on LIT101 only.</a:t>
-            </a:r>
-          </a:p>
-        </p:txBody>
-      </p:sp>
-      <p:sp>
-        <p:nvSpPr>
-          <p:cNvPr id="9" name="TextBox 8"/>
-          <p:cNvSpPr txBox="1"/>
-          <p:nvPr/>
-        </p:nvSpPr>
-        <p:spPr>
-          <a:xfrm>
-            <a:off x="457200" y="4389120"/>
-            <a:ext cx="8229600" cy="274320"/>
-          </a:xfrm>
-          <a:prstGeom prst="rect">
-            <a:avLst/>
-          </a:prstGeom>
-          <a:noFill/>
-        </p:spPr>
-        <p:txBody>
-          <a:bodyPr wrap="square">
-            <a:spAutoFit/>
-          </a:bodyPr>
-          <a:lstStyle/>
-          <a:p>
-            <a:r>
-              <a:rPr sz="1300" b="1">
-                <a:solidFill>
-                  <a:srgbClr val="2E75B6"/>
-                </a:solidFill>
-              </a:rPr>
-              <a:t>Hybrid Detection Under Phase 1+2</a:t>
-            </a:r>
-          </a:p>
-        </p:txBody>
-      </p:sp>
-      <p:sp>
-        <p:nvSpPr>
-          <p:cNvPr id="10" name="TextBox 9"/>
-          <p:cNvSpPr txBox="1"/>
-          <p:nvPr/>
-        </p:nvSpPr>
-        <p:spPr>
-          <a:xfrm>
-            <a:off x="457200" y="4709160"/>
-            <a:ext cx="8229600" cy="1097280"/>
-          </a:xfrm>
-          <a:prstGeom prst="rect">
-            <a:avLst/>
-          </a:prstGeom>
-          <a:noFill/>
-        </p:spPr>
-        <p:txBody>
-          <a:bodyPr wrap="square">
-            <a:spAutoFit/>
-          </a:bodyPr>
-          <a:lstStyle/>
-          <a:p>
-            <a:r>
-              <a:rPr sz="1000" b="0">
-                <a:solidFill>
-                  <a:srgbClr val="333333"/>
-                </a:solidFill>
-              </a:rPr>
-              <a:t>Expected: 1–6s (invariant catches, AE may be evaded). Live: 1s (invariant). AE evasion by Phase 2: inconclusive (FIT101 fault confounded). Simulated: invariant 10/10 regardless. Concealment gap: 736mm (HMI 1345mm vs physical 502mm). Core thesis: actuator-command invariants immune to sensor-level perturbation.</a:t>
-            </a:r>
-          </a:p>
-        </p:txBody>
-      </p:sp>
-      <p:sp>
-        <p:nvSpPr>
-          <p:cNvPr id="11" name="TextBox 10"/>
-          <p:cNvSpPr txBox="1"/>
-          <p:nvPr/>
-        </p:nvSpPr>
-        <p:spPr>
-          <a:xfrm>
-            <a:off x="457200" y="6492240"/>
-            <a:ext cx="8229600" cy="228600"/>
-          </a:xfrm>
-          <a:prstGeom prst="rect">
-            <a:avLst/>
-          </a:prstGeom>
-          <a:noFill/>
-        </p:spPr>
-        <p:txBody>
-          <a:bodyPr wrap="square">
-            <a:spAutoFit/>
-          </a:bodyPr>
-          <a:lstStyle/>
-          <a:p>
-            <a:r>
-              <a:rPr sz="800" b="0">
+              <a:rPr sz="700" b="0">
                 <a:solidFill>
                   <a:srgbClr val="999999"/>
                 </a:solidFill>
@@ -51468,8 +51803,8 @@
         </p:nvSpPr>
         <p:spPr>
           <a:xfrm>
-            <a:off x="457200" y="182880"/>
-            <a:ext cx="1828800" cy="274320"/>
+            <a:off x="365760" y="137160"/>
+            <a:ext cx="1828800" cy="228600"/>
           </a:xfrm>
           <a:prstGeom prst="rect">
             <a:avLst/>
@@ -51483,7 +51818,7 @@
           <a:lstStyle/>
           <a:p>
             <a:r>
-              <a:rPr sz="1000" b="1">
+              <a:rPr sz="900" b="1">
                 <a:solidFill>
                   <a:srgbClr val="CC0000"/>
                 </a:solidFill>
@@ -51501,8 +51836,8 @@
         </p:nvSpPr>
         <p:spPr>
           <a:xfrm>
-            <a:off x="457200" y="411480"/>
-            <a:ext cx="8229600" cy="457200"/>
+            <a:off x="365760" y="320040"/>
+            <a:ext cx="8229600" cy="411480"/>
           </a:xfrm>
           <a:prstGeom prst="rect">
             <a:avLst/>
@@ -51516,7 +51851,7 @@
           <a:lstStyle/>
           <a:p>
             <a:r>
-              <a:rPr sz="2200" b="1">
+              <a:rPr sz="2000" b="1">
                 <a:solidFill>
                   <a:srgbClr val="1F3864"/>
                 </a:solidFill>
@@ -51534,8 +51869,8 @@
         </p:nvSpPr>
         <p:spPr>
           <a:xfrm>
-            <a:off x="457200" y="868680"/>
-            <a:ext cx="8229600" cy="274320"/>
+            <a:off x="365760" y="713232"/>
+            <a:ext cx="8229600" cy="228600"/>
           </a:xfrm>
           <a:prstGeom prst="rect">
             <a:avLst/>
@@ -51549,7 +51884,7 @@
           <a:lstStyle/>
           <a:p>
             <a:r>
-              <a:rPr sz="1100" b="0">
+              <a:rPr sz="1000" b="0">
                 <a:solidFill>
                   <a:srgbClr val="666666"/>
                 </a:solidFill>
@@ -51559,16 +51894,289 @@
           </a:p>
         </p:txBody>
       </p:sp>
-      <p:sp>
-        <p:nvSpPr>
-          <p:cNvPr id="5" name="TextBox 4"/>
+      <p:graphicFrame>
+        <p:nvGraphicFramePr>
+          <p:cNvPr id="5" name="Table 4"/>
+          <p:cNvGraphicFramePr>
+            <a:graphicFrameLocks noGrp="1"/>
+          </p:cNvGraphicFramePr>
+          <p:nvPr/>
+        </p:nvGraphicFramePr>
+        <p:xfrm>
+          <a:off x="365760" y="1051560"/>
+          <a:ext cx="8595360" cy="1060704"/>
+        </p:xfrm>
+        <a:graphic>
+          <a:graphicData uri="http://schemas.openxmlformats.org/drawingml/2006/table">
+            <a:tbl>
+              <a:tblPr firstRow="1" bandRow="1">
+                <a:tableStyleId>{5C22544A-7EE6-4342-B048-85BDC9FD1C3A}</a:tableStyleId>
+              </a:tblPr>
+              <a:tblGrid>
+                <a:gridCol w="1828800"/>
+                <a:gridCol w="2011680"/>
+                <a:gridCol w="2377440"/>
+                <a:gridCol w="2377440"/>
+              </a:tblGrid>
+              <a:tr h="353568">
+                <a:tc>
+                  <a:txBody>
+                    <a:bodyPr wrap="square"/>
+                    <a:lstStyle/>
+                    <a:p>
+                      <a:r>
+                        <a:rPr sz="900" b="1">
+                          <a:solidFill>
+                            <a:srgbClr val="FFFFFF"/>
+                          </a:solidFill>
+                        </a:rPr>
+                        <a:t>Metric</a:t>
+                      </a:r>
+                    </a:p>
+                  </a:txBody>
+                  <a:tcPr marT="50800" marB="50800" marL="76200" marR="76200">
+                    <a:solidFill>
+                      <a:srgbClr val="1F3864"/>
+                    </a:solidFill>
+                  </a:tcPr>
+                </a:tc>
+                <a:tc>
+                  <a:txBody>
+                    <a:bodyPr wrap="square"/>
+                    <a:lstStyle/>
+                    <a:p>
+                      <a:r>
+                        <a:rPr sz="900" b="1">
+                          <a:solidFill>
+                            <a:srgbClr val="FFFFFF"/>
+                          </a:solidFill>
+                        </a:rPr>
+                        <a:t>Expected</a:t>
+                      </a:r>
+                    </a:p>
+                  </a:txBody>
+                  <a:tcPr marT="50800" marB="50800" marL="76200" marR="76200">
+                    <a:solidFill>
+                      <a:srgbClr val="1F3864"/>
+                    </a:solidFill>
+                  </a:tcPr>
+                </a:tc>
+                <a:tc>
+                  <a:txBody>
+                    <a:bodyPr wrap="square"/>
+                    <a:lstStyle/>
+                    <a:p>
+                      <a:r>
+                        <a:rPr sz="900" b="1">
+                          <a:solidFill>
+                            <a:srgbClr val="FFFFFF"/>
+                          </a:solidFill>
+                        </a:rPr>
+                        <a:t>Live (16 Apr)</a:t>
+                      </a:r>
+                    </a:p>
+                  </a:txBody>
+                  <a:tcPr marT="50800" marB="50800" marL="76200" marR="76200">
+                    <a:solidFill>
+                      <a:srgbClr val="1F3864"/>
+                    </a:solidFill>
+                  </a:tcPr>
+                </a:tc>
+                <a:tc>
+                  <a:txBody>
+                    <a:bodyPr wrap="square"/>
+                    <a:lstStyle/>
+                    <a:p>
+                      <a:r>
+                        <a:rPr sz="900" b="1">
+                          <a:solidFill>
+                            <a:srgbClr val="FFFFFF"/>
+                          </a:solidFill>
+                        </a:rPr>
+                        <a:t>Simulated</a:t>
+                      </a:r>
+                    </a:p>
+                  </a:txBody>
+                  <a:tcPr marT="50800" marB="50800" marL="76200" marR="76200">
+                    <a:solidFill>
+                      <a:srgbClr val="1F3864"/>
+                    </a:solidFill>
+                  </a:tcPr>
+                </a:tc>
+              </a:tr>
+              <a:tr h="353568">
+                <a:tc>
+                  <a:txBody>
+                    <a:bodyPr wrap="square"/>
+                    <a:lstStyle/>
+                    <a:p>
+                      <a:r>
+                        <a:rPr sz="800" b="1">
+                          <a:solidFill>
+                            <a:srgbClr val="333333"/>
+                          </a:solidFill>
+                        </a:rPr>
+                        <a:t>AE FPR</a:t>
+                      </a:r>
+                    </a:p>
+                  </a:txBody>
+                  <a:tcPr marT="50800" marB="50800" marL="76200" marR="76200"/>
+                </a:tc>
+                <a:tc>
+                  <a:txBody>
+                    <a:bodyPr wrap="square"/>
+                    <a:lstStyle/>
+                    <a:p>
+                      <a:r>
+                        <a:rPr sz="800" b="0">
+                          <a:solidFill>
+                            <a:srgbClr val="333333"/>
+                          </a:solidFill>
+                        </a:rPr>
+                        <a:t>&lt;5% (95th pct)</a:t>
+                      </a:r>
+                    </a:p>
+                  </a:txBody>
+                  <a:tcPr marT="50800" marB="50800" marL="76200" marR="76200"/>
+                </a:tc>
+                <a:tc>
+                  <a:txBody>
+                    <a:bodyPr wrap="square"/>
+                    <a:lstStyle/>
+                    <a:p>
+                      <a:r>
+                        <a:rPr sz="800" b="0">
+                          <a:solidFill>
+                            <a:srgbClr val="333333"/>
+                          </a:solidFill>
+                        </a:rPr>
+                        <a:t>Inconclusive — FIT101=-31
+was a true positive</a:t>
+                      </a:r>
+                    </a:p>
+                  </a:txBody>
+                  <a:tcPr marT="50800" marB="50800" marL="76200" marR="76200"/>
+                </a:tc>
+                <a:tc>
+                  <a:txBody>
+                    <a:bodyPr wrap="square"/>
+                    <a:lstStyle/>
+                    <a:p>
+                      <a:r>
+                        <a:rPr sz="800" b="0">
+                          <a:solidFill>
+                            <a:srgbClr val="333333"/>
+                          </a:solidFill>
+                        </a:rPr>
+                        <a:t>0/500 (0.0%)
+MSE 19× below threshold</a:t>
+                      </a:r>
+                    </a:p>
+                  </a:txBody>
+                  <a:tcPr marT="50800" marB="50800" marL="76200" marR="76200"/>
+                </a:tc>
+              </a:tr>
+              <a:tr h="353568">
+                <a:tc>
+                  <a:txBody>
+                    <a:bodyPr wrap="square"/>
+                    <a:lstStyle/>
+                    <a:p>
+                      <a:r>
+                        <a:rPr sz="800" b="1">
+                          <a:solidFill>
+                            <a:srgbClr val="333333"/>
+                          </a:solidFill>
+                        </a:rPr>
+                        <a:t>Invariant FPR</a:t>
+                      </a:r>
+                    </a:p>
+                  </a:txBody>
+                  <a:tcPr marT="50800" marB="50800" marL="76200" marR="76200">
+                    <a:solidFill>
+                      <a:srgbClr val="F2F2F2"/>
+                    </a:solidFill>
+                  </a:tcPr>
+                </a:tc>
+                <a:tc>
+                  <a:txBody>
+                    <a:bodyPr wrap="square"/>
+                    <a:lstStyle/>
+                    <a:p>
+                      <a:r>
+                        <a:rPr sz="800" b="0">
+                          <a:solidFill>
+                            <a:srgbClr val="333333"/>
+                          </a:solidFill>
+                        </a:rPr>
+                        <a:t>~0% (deterministic)</a:t>
+                      </a:r>
+                    </a:p>
+                  </a:txBody>
+                  <a:tcPr marT="50800" marB="50800" marL="76200" marR="76200">
+                    <a:solidFill>
+                      <a:srgbClr val="F2F2F2"/>
+                    </a:solidFill>
+                  </a:tcPr>
+                </a:tc>
+                <a:tc>
+                  <a:txBody>
+                    <a:bodyPr wrap="square"/>
+                    <a:lstStyle/>
+                    <a:p>
+                      <a:r>
+                        <a:rPr sz="800" b="0">
+                          <a:solidFill>
+                            <a:srgbClr val="333333"/>
+                          </a:solidFill>
+                        </a:rPr>
+                        <a:t>Inconclusive — plant started
+in attack-equivalent state</a:t>
+                      </a:r>
+                    </a:p>
+                  </a:txBody>
+                  <a:tcPr marT="50800" marB="50800" marL="76200" marR="76200">
+                    <a:solidFill>
+                      <a:srgbClr val="F2F2F2"/>
+                    </a:solidFill>
+                  </a:tcPr>
+                </a:tc>
+                <a:tc>
+                  <a:txBody>
+                    <a:bodyPr wrap="square"/>
+                    <a:lstStyle/>
+                    <a:p>
+                      <a:r>
+                        <a:rPr sz="800" b="0">
+                          <a:solidFill>
+                            <a:srgbClr val="333333"/>
+                          </a:solidFill>
+                        </a:rPr>
+                        <a:t>0/10 (0.0%)</a:t>
+                      </a:r>
+                    </a:p>
+                  </a:txBody>
+                  <a:tcPr marT="50800" marB="50800" marL="76200" marR="76200">
+                    <a:solidFill>
+                      <a:srgbClr val="F2F2F2"/>
+                    </a:solidFill>
+                  </a:tcPr>
+                </a:tc>
+              </a:tr>
+            </a:tbl>
+          </a:graphicData>
+        </a:graphic>
+      </p:graphicFrame>
+      <p:sp>
+        <p:nvSpPr>
+          <p:cNvPr id="6" name="TextBox 5"/>
           <p:cNvSpPr txBox="1"/>
           <p:nvPr/>
         </p:nvSpPr>
         <p:spPr>
           <a:xfrm>
-            <a:off x="457200" y="1280160"/>
-            <a:ext cx="8229600" cy="274320"/>
+            <a:off x="365760" y="2386584"/>
+            <a:ext cx="8412480" cy="2286000"/>
           </a:xfrm>
           <a:prstGeom prst="rect">
             <a:avLst/>
@@ -51582,26 +52190,26 @@
           <a:lstStyle/>
           <a:p>
             <a:r>
-              <a:rPr sz="1300" b="1">
-                <a:solidFill>
-                  <a:srgbClr val="2E75B6"/>
-                </a:solidFill>
-              </a:rPr>
-              <a:t>AE False Positive Rate</a:t>
-            </a:r>
-          </a:p>
-        </p:txBody>
-      </p:sp>
-      <p:sp>
-        <p:nvSpPr>
-          <p:cNvPr id="6" name="TextBox 5"/>
+              <a:rPr sz="900" b="0">
+                <a:solidFill>
+                  <a:srgbClr val="444444"/>
+                </a:solidFill>
+              </a:rPr>
+              <a:t>FPR could not be measured live because the plant started in an anomalous state (MV101=CLOSED, P101=ON, FIT101=-31) from a previous session. Invariants correctly identified this as unsafe — a true positive, not a false positive. Simulated 0% FPR on 29,153 samples (8.1 hrs real SWaT data) provides strong evidence. The live run demonstrated that invariants detect unsafe states regardless of cause.</a:t>
+            </a:r>
+          </a:p>
+        </p:txBody>
+      </p:sp>
+      <p:sp>
+        <p:nvSpPr>
+          <p:cNvPr id="7" name="TextBox 6"/>
           <p:cNvSpPr txBox="1"/>
           <p:nvPr/>
         </p:nvSpPr>
         <p:spPr>
           <a:xfrm>
-            <a:off x="457200" y="1600200"/>
-            <a:ext cx="8229600" cy="1097280"/>
+            <a:off x="365760" y="6492240"/>
+            <a:ext cx="8229600" cy="182880"/>
           </a:xfrm>
           <a:prstGeom prst="rect">
             <a:avLst/>
@@ -51615,172 +52223,7 @@
           <a:lstStyle/>
           <a:p>
             <a:r>
-              <a:rPr sz="1000" b="0">
-                <a:solidFill>
-                  <a:srgbClr val="333333"/>
-                </a:solidFill>
-              </a:rPr>
-              <a:t>Expected: &lt;5% (95th pct threshold). Simulated (LIT-only): 0/500 = 0.0% FPR. Mean MSE=0.000039, threshold=0.000738 — 19× safety margin. Live: inconclusive — FIT101=-31 was a genuine anomaly (true positive, not false positive).</a:t>
-            </a:r>
-          </a:p>
-        </p:txBody>
-      </p:sp>
-      <p:sp>
-        <p:nvSpPr>
-          <p:cNvPr id="7" name="TextBox 6"/>
-          <p:cNvSpPr txBox="1"/>
-          <p:nvPr/>
-        </p:nvSpPr>
-        <p:spPr>
-          <a:xfrm>
-            <a:off x="457200" y="2834640"/>
-            <a:ext cx="8229600" cy="274320"/>
-          </a:xfrm>
-          <a:prstGeom prst="rect">
-            <a:avLst/>
-          </a:prstGeom>
-          <a:noFill/>
-        </p:spPr>
-        <p:txBody>
-          <a:bodyPr wrap="square">
-            <a:spAutoFit/>
-          </a:bodyPr>
-          <a:lstStyle/>
-          <a:p>
-            <a:r>
-              <a:rPr sz="1300" b="1">
-                <a:solidFill>
-                  <a:srgbClr val="2E75B6"/>
-                </a:solidFill>
-              </a:rPr>
-              <a:t>Invariant False Positive Rate</a:t>
-            </a:r>
-          </a:p>
-        </p:txBody>
-      </p:sp>
-      <p:sp>
-        <p:nvSpPr>
-          <p:cNvPr id="8" name="TextBox 7"/>
-          <p:cNvSpPr txBox="1"/>
-          <p:nvPr/>
-        </p:nvSpPr>
-        <p:spPr>
-          <a:xfrm>
-            <a:off x="457200" y="3154680"/>
-            <a:ext cx="8229600" cy="1097280"/>
-          </a:xfrm>
-          <a:prstGeom prst="rect">
-            <a:avLst/>
-          </a:prstGeom>
-          <a:noFill/>
-        </p:spPr>
-        <p:txBody>
-          <a:bodyPr wrap="square">
-            <a:spAutoFit/>
-          </a:bodyPr>
-          <a:lstStyle/>
-          <a:p>
-            <a:r>
-              <a:rPr sz="1000" b="0">
-                <a:solidFill>
-                  <a:srgbClr val="333333"/>
-                </a:solidFill>
-              </a:rPr>
-              <a:t>Expected: ~0% (deterministic). Simulated: 0/10 = 0.0%. Live: inconclusive — plant started in attack-equivalent state (MV101=CLOSED, P101=ON). Invariants correctly identified unsafe configuration — true positive, not false alarm.</a:t>
-            </a:r>
-          </a:p>
-        </p:txBody>
-      </p:sp>
-      <p:sp>
-        <p:nvSpPr>
-          <p:cNvPr id="9" name="TextBox 8"/>
-          <p:cNvSpPr txBox="1"/>
-          <p:nvPr/>
-        </p:nvSpPr>
-        <p:spPr>
-          <a:xfrm>
-            <a:off x="457200" y="4389120"/>
-            <a:ext cx="8229600" cy="274320"/>
-          </a:xfrm>
-          <a:prstGeom prst="rect">
-            <a:avLst/>
-          </a:prstGeom>
-          <a:noFill/>
-        </p:spPr>
-        <p:txBody>
-          <a:bodyPr wrap="square">
-            <a:spAutoFit/>
-          </a:bodyPr>
-          <a:lstStyle/>
-          <a:p>
-            <a:r>
-              <a:rPr sz="1300" b="1">
-                <a:solidFill>
-                  <a:srgbClr val="2E75B6"/>
-                </a:solidFill>
-              </a:rPr>
-              <a:t>Interpretation</a:t>
-            </a:r>
-          </a:p>
-        </p:txBody>
-      </p:sp>
-      <p:sp>
-        <p:nvSpPr>
-          <p:cNvPr id="10" name="TextBox 9"/>
-          <p:cNvSpPr txBox="1"/>
-          <p:nvPr/>
-        </p:nvSpPr>
-        <p:spPr>
-          <a:xfrm>
-            <a:off x="457200" y="4709160"/>
-            <a:ext cx="8229600" cy="1097280"/>
-          </a:xfrm>
-          <a:prstGeom prst="rect">
-            <a:avLst/>
-          </a:prstGeom>
-          <a:noFill/>
-        </p:spPr>
-        <p:txBody>
-          <a:bodyPr wrap="square">
-            <a:spAutoFit/>
-          </a:bodyPr>
-          <a:lstStyle/>
-          <a:p>
-            <a:r>
-              <a:rPr sz="1000" b="0">
-                <a:solidFill>
-                  <a:srgbClr val="333333"/>
-                </a:solidFill>
-              </a:rPr>
-              <a:t>Simulated 0% FPR on 29,153 samples (8.1 hrs real SWaT data) is strong evidence. The live run demonstrated the invariant layer correctly detects unsafe states regardless of cause (attacker vs residual misconfiguration) — both are legitimate safety concerns in production water treatment.</a:t>
-            </a:r>
-          </a:p>
-        </p:txBody>
-      </p:sp>
-      <p:sp>
-        <p:nvSpPr>
-          <p:cNvPr id="11" name="TextBox 10"/>
-          <p:cNvSpPr txBox="1"/>
-          <p:nvPr/>
-        </p:nvSpPr>
-        <p:spPr>
-          <a:xfrm>
-            <a:off x="457200" y="6492240"/>
-            <a:ext cx="8229600" cy="228600"/>
-          </a:xfrm>
-          <a:prstGeom prst="rect">
-            <a:avLst/>
-          </a:prstGeom>
-          <a:noFill/>
-        </p:spPr>
-        <p:txBody>
-          <a:bodyPr wrap="square">
-            <a:spAutoFit/>
-          </a:bodyPr>
-          <a:lstStyle/>
-          <a:p>
-            <a:r>
-              <a:rPr sz="800" b="0">
+              <a:rPr sz="700" b="0">
                 <a:solidFill>
                   <a:srgbClr val="999999"/>
                 </a:solidFill>
@@ -51816,8 +52259,8 @@
         </p:nvSpPr>
         <p:spPr>
           <a:xfrm>
-            <a:off x="457200" y="182880"/>
-            <a:ext cx="1828800" cy="274320"/>
+            <a:off x="365760" y="137160"/>
+            <a:ext cx="1828800" cy="228600"/>
           </a:xfrm>
           <a:prstGeom prst="rect">
             <a:avLst/>
@@ -51831,7 +52274,7 @@
           <a:lstStyle/>
           <a:p>
             <a:r>
-              <a:rPr sz="1000" b="1">
+              <a:rPr sz="900" b="1">
                 <a:solidFill>
                   <a:srgbClr val="CC0000"/>
                 </a:solidFill>
@@ -51849,8 +52292,8 @@
         </p:nvSpPr>
         <p:spPr>
           <a:xfrm>
-            <a:off x="457200" y="411480"/>
-            <a:ext cx="8229600" cy="457200"/>
+            <a:off x="365760" y="320040"/>
+            <a:ext cx="8229600" cy="411480"/>
           </a:xfrm>
           <a:prstGeom prst="rect">
             <a:avLst/>
@@ -51864,7 +52307,7 @@
           <a:lstStyle/>
           <a:p>
             <a:r>
-              <a:rPr sz="2200" b="1">
+              <a:rPr sz="2000" b="1">
                 <a:solidFill>
                   <a:srgbClr val="1F3864"/>
                 </a:solidFill>
@@ -51882,8 +52325,8 @@
         </p:nvSpPr>
         <p:spPr>
           <a:xfrm>
-            <a:off x="457200" y="868680"/>
-            <a:ext cx="8229600" cy="274320"/>
+            <a:off x="365760" y="713232"/>
+            <a:ext cx="8229600" cy="228600"/>
           </a:xfrm>
           <a:prstGeom prst="rect">
             <a:avLst/>
@@ -51897,7 +52340,7 @@
           <a:lstStyle/>
           <a:p>
             <a:r>
-              <a:rPr sz="1100" b="0">
+              <a:rPr sz="1000" b="0">
                 <a:solidFill>
                   <a:srgbClr val="666666"/>
                 </a:solidFill>
@@ -51907,16 +52350,446 @@
           </a:p>
         </p:txBody>
       </p:sp>
-      <p:sp>
-        <p:nvSpPr>
-          <p:cNvPr id="5" name="TextBox 4"/>
+      <p:graphicFrame>
+        <p:nvGraphicFramePr>
+          <p:cNvPr id="5" name="Table 4"/>
+          <p:cNvGraphicFramePr>
+            <a:graphicFrameLocks noGrp="1"/>
+          </p:cNvGraphicFramePr>
+          <p:nvPr/>
+        </p:nvGraphicFramePr>
+        <p:xfrm>
+          <a:off x="365760" y="1051560"/>
+          <a:ext cx="8595360" cy="1645920"/>
+        </p:xfrm>
+        <a:graphic>
+          <a:graphicData uri="http://schemas.openxmlformats.org/drawingml/2006/table">
+            <a:tbl>
+              <a:tblPr firstRow="1" bandRow="1">
+                <a:tableStyleId>{5C22544A-7EE6-4342-B048-85BDC9FD1C3A}</a:tableStyleId>
+              </a:tblPr>
+              <a:tblGrid>
+                <a:gridCol w="1828800"/>
+                <a:gridCol w="2011680"/>
+                <a:gridCol w="2377440"/>
+                <a:gridCol w="2377440"/>
+              </a:tblGrid>
+              <a:tr h="329184">
+                <a:tc>
+                  <a:txBody>
+                    <a:bodyPr wrap="square"/>
+                    <a:lstStyle/>
+                    <a:p>
+                      <a:r>
+                        <a:rPr sz="900" b="1">
+                          <a:solidFill>
+                            <a:srgbClr val="FFFFFF"/>
+                          </a:solidFill>
+                        </a:rPr>
+                        <a:t>Step</a:t>
+                      </a:r>
+                    </a:p>
+                  </a:txBody>
+                  <a:tcPr marT="50800" marB="50800" marL="76200" marR="76200">
+                    <a:solidFill>
+                      <a:srgbClr val="1F3864"/>
+                    </a:solidFill>
+                  </a:tcPr>
+                </a:tc>
+                <a:tc>
+                  <a:txBody>
+                    <a:bodyPr wrap="square"/>
+                    <a:lstStyle/>
+                    <a:p>
+                      <a:r>
+                        <a:rPr sz="900" b="1">
+                          <a:solidFill>
+                            <a:srgbClr val="FFFFFF"/>
+                          </a:solidFill>
+                        </a:rPr>
+                        <a:t>Expected</a:t>
+                      </a:r>
+                    </a:p>
+                  </a:txBody>
+                  <a:tcPr marT="50800" marB="50800" marL="76200" marR="76200">
+                    <a:solidFill>
+                      <a:srgbClr val="1F3864"/>
+                    </a:solidFill>
+                  </a:tcPr>
+                </a:tc>
+                <a:tc>
+                  <a:txBody>
+                    <a:bodyPr wrap="square"/>
+                    <a:lstStyle/>
+                    <a:p>
+                      <a:r>
+                        <a:rPr sz="900" b="1">
+                          <a:solidFill>
+                            <a:srgbClr val="FFFFFF"/>
+                          </a:solidFill>
+                        </a:rPr>
+                        <a:t>Live (16 Apr)</a:t>
+                      </a:r>
+                    </a:p>
+                  </a:txBody>
+                  <a:tcPr marT="50800" marB="50800" marL="76200" marR="76200">
+                    <a:solidFill>
+                      <a:srgbClr val="1F3864"/>
+                    </a:solidFill>
+                  </a:tcPr>
+                </a:tc>
+                <a:tc>
+                  <a:txBody>
+                    <a:bodyPr wrap="square"/>
+                    <a:lstStyle/>
+                    <a:p>
+                      <a:r>
+                        <a:rPr sz="900" b="1">
+                          <a:solidFill>
+                            <a:srgbClr val="FFFFFF"/>
+                          </a:solidFill>
+                        </a:rPr>
+                        <a:t>Simulated</a:t>
+                      </a:r>
+                    </a:p>
+                  </a:txBody>
+                  <a:tcPr marT="50800" marB="50800" marL="76200" marR="76200">
+                    <a:solidFill>
+                      <a:srgbClr val="1F3864"/>
+                    </a:solidFill>
+                  </a:tcPr>
+                </a:tc>
+              </a:tr>
+              <a:tr h="329184">
+                <a:tc>
+                  <a:txBody>
+                    <a:bodyPr wrap="square"/>
+                    <a:lstStyle/>
+                    <a:p>
+                      <a:r>
+                        <a:rPr sz="800" b="1">
+                          <a:solidFill>
+                            <a:srgbClr val="333333"/>
+                          </a:solidFill>
+                        </a:rPr>
+                        <a:t>Detect → Fusion ALERT</a:t>
+                      </a:r>
+                    </a:p>
+                  </a:txBody>
+                  <a:tcPr marT="50800" marB="50800" marL="76200" marR="76200"/>
+                </a:tc>
+                <a:tc>
+                  <a:txBody>
+                    <a:bodyPr wrap="square"/>
+                    <a:lstStyle/>
+                    <a:p>
+                      <a:r>
+                        <a:rPr sz="800" b="0">
+                          <a:solidFill>
+                            <a:srgbClr val="333333"/>
+                          </a:solidFill>
+                        </a:rPr>
+                        <a:t>&lt;3s (3 cycles)</a:t>
+                      </a:r>
+                    </a:p>
+                  </a:txBody>
+                  <a:tcPr marT="50800" marB="50800" marL="76200" marR="76200"/>
+                </a:tc>
+                <a:tc>
+                  <a:txBody>
+                    <a:bodyPr wrap="square"/>
+                    <a:lstStyle/>
+                    <a:p>
+                      <a:r>
+                        <a:rPr sz="800" b="0">
+                          <a:solidFill>
+                            <a:srgbClr val="333333"/>
+                          </a:solidFill>
+                        </a:rPr>
+                        <a:t>3s (16:33:08 → 16:33:11)
+Exact match</a:t>
+                      </a:r>
+                    </a:p>
+                  </a:txBody>
+                  <a:tcPr marT="50800" marB="50800" marL="76200" marR="76200"/>
+                </a:tc>
+                <a:tc>
+                  <a:txBody>
+                    <a:bodyPr wrap="square"/>
+                    <a:lstStyle/>
+                    <a:p>
+                      <a:r>
+                        <a:rPr sz="800" b="0">
+                          <a:solidFill>
+                            <a:srgbClr val="333333"/>
+                          </a:solidFill>
+                        </a:rPr>
+                        <a:t>3 cycles</a:t>
+                      </a:r>
+                    </a:p>
+                  </a:txBody>
+                  <a:tcPr marT="50800" marB="50800" marL="76200" marR="76200"/>
+                </a:tc>
+              </a:tr>
+              <a:tr h="329184">
+                <a:tc>
+                  <a:txBody>
+                    <a:bodyPr wrap="square"/>
+                    <a:lstStyle/>
+                    <a:p>
+                      <a:r>
+                        <a:rPr sz="800" b="1">
+                          <a:solidFill>
+                            <a:srgbClr val="333333"/>
+                          </a:solidFill>
+                        </a:rPr>
+                        <a:t>Safe state CIP writes</a:t>
+                      </a:r>
+                    </a:p>
+                  </a:txBody>
+                  <a:tcPr marT="50800" marB="50800" marL="76200" marR="76200">
+                    <a:solidFill>
+                      <a:srgbClr val="F2F2F2"/>
+                    </a:solidFill>
+                  </a:tcPr>
+                </a:tc>
+                <a:tc>
+                  <a:txBody>
+                    <a:bodyPr wrap="square"/>
+                    <a:lstStyle/>
+                    <a:p>
+                      <a:r>
+                        <a:rPr sz="800" b="0">
+                          <a:solidFill>
+                            <a:srgbClr val="333333"/>
+                          </a:solidFill>
+                        </a:rPr>
+                        <a:t>&lt;5s</a:t>
+                      </a:r>
+                    </a:p>
+                  </a:txBody>
+                  <a:tcPr marT="50800" marB="50800" marL="76200" marR="76200">
+                    <a:solidFill>
+                      <a:srgbClr val="F2F2F2"/>
+                    </a:solidFill>
+                  </a:tcPr>
+                </a:tc>
+                <a:tc>
+                  <a:txBody>
+                    <a:bodyPr wrap="square"/>
+                    <a:lstStyle/>
+                    <a:p>
+                      <a:r>
+                        <a:rPr sz="800" b="0">
+                          <a:solidFill>
+                            <a:srgbClr val="333333"/>
+                          </a:solidFill>
+                        </a:rPr>
+                        <a:t>Completed: MV101, P101,
+MV201, Sim disabled</a:t>
+                      </a:r>
+                    </a:p>
+                  </a:txBody>
+                  <a:tcPr marT="50800" marB="50800" marL="76200" marR="76200">
+                    <a:solidFill>
+                      <a:srgbClr val="F2F2F2"/>
+                    </a:solidFill>
+                  </a:tcPr>
+                </a:tc>
+                <a:tc>
+                  <a:txBody>
+                    <a:bodyPr wrap="square"/>
+                    <a:lstStyle/>
+                    <a:p>
+                      <a:r>
+                        <a:rPr sz="800" b="0">
+                          <a:solidFill>
+                            <a:srgbClr val="333333"/>
+                          </a:solidFill>
+                        </a:rPr>
+                        <a:t>&lt;5s</a:t>
+                      </a:r>
+                    </a:p>
+                  </a:txBody>
+                  <a:tcPr marT="50800" marB="50800" marL="76200" marR="76200">
+                    <a:solidFill>
+                      <a:srgbClr val="F2F2F2"/>
+                    </a:solidFill>
+                  </a:tcPr>
+                </a:tc>
+              </a:tr>
+              <a:tr h="329184">
+                <a:tc>
+                  <a:txBody>
+                    <a:bodyPr wrap="square"/>
+                    <a:lstStyle/>
+                    <a:p>
+                      <a:r>
+                        <a:rPr sz="800" b="1">
+                          <a:solidFill>
+                            <a:srgbClr val="333333"/>
+                          </a:solidFill>
+                        </a:rPr>
+                        <a:t>Post-recovery state</a:t>
+                      </a:r>
+                    </a:p>
+                  </a:txBody>
+                  <a:tcPr marT="50800" marB="50800" marL="76200" marR="76200"/>
+                </a:tc>
+                <a:tc>
+                  <a:txBody>
+                    <a:bodyPr wrap="square"/>
+                    <a:lstStyle/>
+                    <a:p>
+                      <a:r>
+                        <a:rPr sz="800" b="0">
+                          <a:solidFill>
+                            <a:srgbClr val="333333"/>
+                          </a:solidFill>
+                        </a:rPr>
+                        <a:t>LIT101 stable, Sim off</a:t>
+                      </a:r>
+                    </a:p>
+                  </a:txBody>
+                  <a:tcPr marT="50800" marB="50800" marL="76200" marR="76200"/>
+                </a:tc>
+                <a:tc>
+                  <a:txBody>
+                    <a:bodyPr wrap="square"/>
+                    <a:lstStyle/>
+                    <a:p>
+                      <a:r>
+                        <a:rPr sz="800" b="0">
+                          <a:solidFill>
+                            <a:srgbClr val="333333"/>
+                          </a:solidFill>
+                        </a:rPr>
+                        <a:t>LIT101=502mm, Sim=False</a:t>
+                      </a:r>
+                    </a:p>
+                  </a:txBody>
+                  <a:tcPr marT="50800" marB="50800" marL="76200" marR="76200"/>
+                </a:tc>
+                <a:tc>
+                  <a:txBody>
+                    <a:bodyPr wrap="square"/>
+                    <a:lstStyle/>
+                    <a:p>
+                      <a:r>
+                        <a:rPr sz="800" b="0">
+                          <a:solidFill>
+                            <a:srgbClr val="333333"/>
+                          </a:solidFill>
+                        </a:rPr>
+                        <a:t>LIT101=642mm
+5/5 clean cycles</a:t>
+                      </a:r>
+                    </a:p>
+                  </a:txBody>
+                  <a:tcPr marT="50800" marB="50800" marL="76200" marR="76200"/>
+                </a:tc>
+              </a:tr>
+              <a:tr h="329184">
+                <a:tc>
+                  <a:txBody>
+                    <a:bodyPr wrap="square"/>
+                    <a:lstStyle/>
+                    <a:p>
+                      <a:r>
+                        <a:rPr sz="800" b="1">
+                          <a:solidFill>
+                            <a:srgbClr val="333333"/>
+                          </a:solidFill>
+                        </a:rPr>
+                        <a:t>Total (attack end → stable)</a:t>
+                      </a:r>
+                    </a:p>
+                  </a:txBody>
+                  <a:tcPr marT="50800" marB="50800" marL="76200" marR="76200">
+                    <a:solidFill>
+                      <a:srgbClr val="F2F2F2"/>
+                    </a:solidFill>
+                  </a:tcPr>
+                </a:tc>
+                <a:tc>
+                  <a:txBody>
+                    <a:bodyPr wrap="square"/>
+                    <a:lstStyle/>
+                    <a:p>
+                      <a:r>
+                        <a:rPr sz="800" b="0">
+                          <a:solidFill>
+                            <a:srgbClr val="333333"/>
+                          </a:solidFill>
+                        </a:rPr>
+                        <a:t>&lt;15s</a:t>
+                      </a:r>
+                    </a:p>
+                  </a:txBody>
+                  <a:tcPr marT="50800" marB="50800" marL="76200" marR="76200">
+                    <a:solidFill>
+                      <a:srgbClr val="F2F2F2"/>
+                    </a:solidFill>
+                  </a:tcPr>
+                </a:tc>
+                <a:tc>
+                  <a:txBody>
+                    <a:bodyPr wrap="square"/>
+                    <a:lstStyle/>
+                    <a:p>
+                      <a:r>
+                        <a:rPr sz="800" b="0">
+                          <a:solidFill>
+                            <a:srgbClr val="333333"/>
+                          </a:solidFill>
+                        </a:rPr>
+                        <a:t>~30s (write race
+with Phase 1)</a:t>
+                      </a:r>
+                    </a:p>
+                  </a:txBody>
+                  <a:tcPr marT="50800" marB="50800" marL="76200" marR="76200">
+                    <a:solidFill>
+                      <a:srgbClr val="F2F2F2"/>
+                    </a:solidFill>
+                  </a:tcPr>
+                </a:tc>
+                <a:tc>
+                  <a:txBody>
+                    <a:bodyPr wrap="square"/>
+                    <a:lstStyle/>
+                    <a:p>
+                      <a:r>
+                        <a:rPr sz="800" b="0">
+                          <a:solidFill>
+                            <a:srgbClr val="333333"/>
+                          </a:solidFill>
+                        </a:rPr>
+                        <a:t>&lt;12s</a:t>
+                      </a:r>
+                    </a:p>
+                  </a:txBody>
+                  <a:tcPr marT="50800" marB="50800" marL="76200" marR="76200">
+                    <a:solidFill>
+                      <a:srgbClr val="F2F2F2"/>
+                    </a:solidFill>
+                  </a:tcPr>
+                </a:tc>
+              </a:tr>
+            </a:tbl>
+          </a:graphicData>
+        </a:graphic>
+      </p:graphicFrame>
+      <p:sp>
+        <p:nvSpPr>
+          <p:cNvPr id="6" name="TextBox 5"/>
           <p:cNvSpPr txBox="1"/>
           <p:nvPr/>
         </p:nvSpPr>
         <p:spPr>
           <a:xfrm>
-            <a:off x="457200" y="1280160"/>
-            <a:ext cx="8229600" cy="274320"/>
+            <a:off x="365760" y="2971800"/>
+            <a:ext cx="8412480" cy="2286000"/>
           </a:xfrm>
           <a:prstGeom prst="rect">
             <a:avLst/>
@@ -51930,26 +52803,26 @@
           <a:lstStyle/>
           <a:p>
             <a:r>
-              <a:rPr sz="1300" b="1">
-                <a:solidFill>
-                  <a:srgbClr val="2E75B6"/>
-                </a:solidFill>
-              </a:rPr>
-              <a:t>Fusion ALERT Timing</a:t>
-            </a:r>
-          </a:p>
-        </p:txBody>
-      </p:sp>
-      <p:sp>
-        <p:nvSpPr>
-          <p:cNvPr id="6" name="TextBox 5"/>
+              <a:rPr sz="900" b="0">
+                <a:solidFill>
+                  <a:srgbClr val="444444"/>
+                </a:solidFill>
+              </a:rPr>
+              <a:t>Fusion ALERT timing matched design exactly (3s). Recovery writes completed &lt;5s but did not hold — Phase 1 re-injected MV101=CLOSED every cycle (write race). Plant stabilised only after Phase 1 timer elapsed. Key lesson: containment (iptables block) must precede safe-state writes. In production the attacker is on a separate host; in the demo both ran on the same HMI.</a:t>
+            </a:r>
+          </a:p>
+        </p:txBody>
+      </p:sp>
+      <p:sp>
+        <p:nvSpPr>
+          <p:cNvPr id="7" name="TextBox 6"/>
           <p:cNvSpPr txBox="1"/>
           <p:nvPr/>
         </p:nvSpPr>
         <p:spPr>
           <a:xfrm>
-            <a:off x="457200" y="1600200"/>
-            <a:ext cx="8229600" cy="1097280"/>
+            <a:off x="365760" y="6492240"/>
+            <a:ext cx="8229600" cy="182880"/>
           </a:xfrm>
           <a:prstGeom prst="rect">
             <a:avLst/>
@@ -51963,172 +52836,7 @@
           <a:lstStyle/>
           <a:p>
             <a:r>
-              <a:rPr sz="1000" b="0">
-                <a:solidFill>
-                  <a:srgbClr val="333333"/>
-                </a:solidFill>
-              </a:rPr>
-              <a:t>Expected: &lt;3s (3 consecutive cycles). Live: exactly 3s (16:33:08 → 16:33:11). Simulated: 3 cycles. Exact match with design. Recovery launched automatically by fusion.py when score ≥ 1.5 for 3 cycles.</a:t>
-            </a:r>
-          </a:p>
-        </p:txBody>
-      </p:sp>
-      <p:sp>
-        <p:nvSpPr>
-          <p:cNvPr id="7" name="TextBox 6"/>
-          <p:cNvSpPr txBox="1"/>
-          <p:nvPr/>
-        </p:nvSpPr>
-        <p:spPr>
-          <a:xfrm>
-            <a:off x="457200" y="2834640"/>
-            <a:ext cx="8229600" cy="274320"/>
-          </a:xfrm>
-          <a:prstGeom prst="rect">
-            <a:avLst/>
-          </a:prstGeom>
-          <a:noFill/>
-        </p:spPr>
-        <p:txBody>
-          <a:bodyPr wrap="square">
-            <a:spAutoFit/>
-          </a:bodyPr>
-          <a:lstStyle/>
-          <a:p>
-            <a:r>
-              <a:rPr sz="1300" b="1">
-                <a:solidFill>
-                  <a:srgbClr val="2E75B6"/>
-                </a:solidFill>
-              </a:rPr>
-              <a:t>Safe State Writes + Plant Stabilisation</a:t>
-            </a:r>
-          </a:p>
-        </p:txBody>
-      </p:sp>
-      <p:sp>
-        <p:nvSpPr>
-          <p:cNvPr id="8" name="TextBox 7"/>
-          <p:cNvSpPr txBox="1"/>
-          <p:nvPr/>
-        </p:nvSpPr>
-        <p:spPr>
-          <a:xfrm>
-            <a:off x="457200" y="3154680"/>
-            <a:ext cx="8229600" cy="1097280"/>
-          </a:xfrm>
-          <a:prstGeom prst="rect">
-            <a:avLst/>
-          </a:prstGeom>
-          <a:noFill/>
-        </p:spPr>
-        <p:txBody>
-          <a:bodyPr wrap="square">
-            <a:spAutoFit/>
-          </a:bodyPr>
-          <a:lstStyle/>
-          <a:p>
-            <a:r>
-              <a:rPr sz="1000" b="0">
-                <a:solidFill>
-                  <a:srgbClr val="333333"/>
-                </a:solidFill>
-              </a:rPr>
-              <a:t>CIP writes completed &lt;5s: MV101=OPEN, P101=OFF (PLC1), MV201=CLOSED (PLC2), Sim disabled. Post-recovery: LIT101=502mm, Sim=False. Simulated: full 5-step recovery in &lt;12s, 5/5 clean invariant cycles.</a:t>
-            </a:r>
-          </a:p>
-        </p:txBody>
-      </p:sp>
-      <p:sp>
-        <p:nvSpPr>
-          <p:cNvPr id="9" name="TextBox 8"/>
-          <p:cNvSpPr txBox="1"/>
-          <p:nvPr/>
-        </p:nvSpPr>
-        <p:spPr>
-          <a:xfrm>
-            <a:off x="457200" y="4389120"/>
-            <a:ext cx="8229600" cy="274320"/>
-          </a:xfrm>
-          <a:prstGeom prst="rect">
-            <a:avLst/>
-          </a:prstGeom>
-          <a:noFill/>
-        </p:spPr>
-        <p:txBody>
-          <a:bodyPr wrap="square">
-            <a:spAutoFit/>
-          </a:bodyPr>
-          <a:lstStyle/>
-          <a:p>
-            <a:r>
-              <a:rPr sz="1300" b="1">
-                <a:solidFill>
-                  <a:srgbClr val="2E75B6"/>
-                </a:solidFill>
-              </a:rPr>
-              <a:t>Write Race Finding</a:t>
-            </a:r>
-          </a:p>
-        </p:txBody>
-      </p:sp>
-      <p:sp>
-        <p:nvSpPr>
-          <p:cNvPr id="10" name="TextBox 9"/>
-          <p:cNvSpPr txBox="1"/>
-          <p:nvPr/>
-        </p:nvSpPr>
-        <p:spPr>
-          <a:xfrm>
-            <a:off x="457200" y="4709160"/>
-            <a:ext cx="8229600" cy="1097280"/>
-          </a:xfrm>
-          <a:prstGeom prst="rect">
-            <a:avLst/>
-          </a:prstGeom>
-          <a:noFill/>
-        </p:spPr>
-        <p:txBody>
-          <a:bodyPr wrap="square">
-            <a:spAutoFit/>
-          </a:bodyPr>
-          <a:lstStyle/>
-          <a:p>
-            <a:r>
-              <a:rPr sz="1000" b="0">
-                <a:solidFill>
-                  <a:srgbClr val="333333"/>
-                </a:solidFill>
-              </a:rPr>
-              <a:t>Total stabilisation ~30s because recovery and Phase 1 entered a write race: recovery wrote MV101=OPEN, Phase 1 re-wrote MV101=CLOSED next cycle. Stable only after Phase 1 timer elapsed. Key lesson: containment (iptables block) MUST precede safe-state writes. In production attacker is on separate host; demo had both on same HMI.</a:t>
-            </a:r>
-          </a:p>
-        </p:txBody>
-      </p:sp>
-      <p:sp>
-        <p:nvSpPr>
-          <p:cNvPr id="11" name="TextBox 10"/>
-          <p:cNvSpPr txBox="1"/>
-          <p:nvPr/>
-        </p:nvSpPr>
-        <p:spPr>
-          <a:xfrm>
-            <a:off x="457200" y="6492240"/>
-            <a:ext cx="8229600" cy="228600"/>
-          </a:xfrm>
-          <a:prstGeom prst="rect">
-            <a:avLst/>
-          </a:prstGeom>
-          <a:noFill/>
-        </p:spPr>
-        <p:txBody>
-          <a:bodyPr wrap="square">
-            <a:spAutoFit/>
-          </a:bodyPr>
-          <a:lstStyle/>
-          <a:p>
-            <a:r>
-              <a:rPr sz="800" b="0">
+              <a:rPr sz="700" b="0">
                 <a:solidFill>
                   <a:srgbClr val="999999"/>
                 </a:solidFill>

</xml_diff>

<commit_message>
docs: correct concealment gap framing — 736mm was bug, 107mm is true concealment
736mm gap (HMI: 1345mm, physical: 502mm) was caused by Phase 2
feedback loop bug — reading own spoofed value each cycle, compounding
+7.3mm/cycle. A 1345mm reading would be obvious to any operator.

After baseline-anchoring fix:
- HMI shows ~609mm (stable, looks normal)
- Physical tank drains to ~502mm (0.9mm/s over 120s)
- True concealment gap: ~107mm — invisible to operator
- This is MORE dangerous: operator sees nothing wrong

Updated in report: Attack Execution, Detection Rate table,
Key Finding, Conclusion. Updated in slides: 28, 29.
</commit_message>
<xml_diff>
--- a/slides/swat_sutd.pptx
+++ b/slides/swat_sutd.pptx
@@ -28350,7 +28350,7 @@
                 <a:ea typeface="Calibri" pitchFamily="34" charset="-122"/>
                 <a:cs typeface="Calibri" pitchFamily="34" charset="-120"/>
               </a:rPr>
-              <a:t>Live FPR: Inconclusive — plant started in attack-equivalent state (MV101=CLOSED, FIT101=-31). Invariants correctly identified unsafe config (true positive). Phase 2 concealment: 736mm gap (HMI 1345mm vs physical 502mm). Simulated: 0/500 AE false alarms (0.0%), MSE 19x below threshold.</a:t>
+              <a:t>Live FPR: Inconclusive — plant started in attack-equivalent state (MV101=CLOSED, FIT101=-31). Invariants correctly identified unsafe config (true positive). Phase 2 concealment: 736mm (before fix, feedback loop). After fix: ~107mm (HMI ~609mm vs physical ~502mm) — invisible to operator. Simulated: 0/500 AE false alarms (0.0%), MSE 19x below threshold.</a:t>
             </a:r>
             <a:endParaRPr lang="en-US" sz="1050" dirty="0"/>
           </a:p>
@@ -29066,9 +29066,9 @@
                     <a:lstStyle/>
                     <a:p>
                       <a:r>
-                        <a:rPr sz="629"/>
-                        <a:t>736mm gap (HMI: 1345mm, physical: 502mm)
-Feedback loop bug fixed in latest code</a:t>
+                        <a:rPr sz="800"/>
+                        <a:t>736mm (before fix: feedback loop).
+After fix: ~107mm true concealment</a:t>
                       </a:r>
                     </a:p>
                   </a:txBody>

</xml_diff>

<commit_message>
slides: clean up recovery table — safe state cell shows timing not tag list
</commit_message>
<xml_diff>
--- a/slides/swat_sutd.pptx
+++ b/slides/swat_sutd.pptx
@@ -30545,13 +30545,9 @@
                     <a:lstStyle/>
                     <a:p>
                       <a:r>
-                        <a:rPr sz="800" b="0">
-                          <a:solidFill>
-                            <a:srgbClr val="333333"/>
-                          </a:solidFill>
-                        </a:rPr>
-                        <a:t>Completed: MV101, P101,
-MV201, Sim disabled</a:t>
+                        <a:rPr sz="800"/>
+                        <a:t>&lt;5s — all writes confirmed
+[Success]</a:t>
                       </a:r>
                     </a:p>
                   </a:txBody>

</xml_diff>

<commit_message>
fix: align invariant table across code, slides, and report
Code (invariant_checker.py):
- I-7: P101=ON + MV101=CLOSED + FIT101 > 0.4 → impossible flow

Slides (slide 22 invariant table):
- I-2: 0.4 (was 0.3), I-3: overflow check, I-4: P101 not ON
- I-6: pump exclusion (was flow check), I-7: impossible flow
- I-8: pipe capacity, I-9: P101=ON (was OFF)

Report:
- I-7 table + I-9 prose: P101=ON (was OFF in 4 places)
</commit_message>
<xml_diff>
--- a/slides/swat_sutd.pptx
+++ b/slides/swat_sutd.pptx
@@ -18212,7 +18212,7 @@
                 <a:ea typeface="Calibri" pitchFamily="34" charset="-122"/>
                 <a:cs typeface="Calibri" pitchFamily="34" charset="-120"/>
               </a:rPr>
-              <a:t>FIT101 &gt; 0.3 L/s</a:t>
+              <a:t>FIT101 &gt; 0.4 L/s</a:t>
             </a:r>
             <a:endParaRPr lang="en-US" sz="900" dirty="0"/>
           </a:p>
@@ -18280,7 +18280,7 @@
                 <a:ea typeface="Calibri" pitchFamily="34" charset="-122"/>
                 <a:cs typeface="Calibri" pitchFamily="34" charset="-120"/>
               </a:rPr>
-              <a:t>Pump drives positive flow — catches Phase 1</a:t>
+              <a:t>Pump running but no flow</a:t>
             </a:r>
             <a:endParaRPr lang="en-US" sz="900" dirty="0"/>
           </a:p>
@@ -18416,7 +18416,7 @@
                 <a:ea typeface="Calibri" pitchFamily="34" charset="-122"/>
                 <a:cs typeface="Calibri" pitchFamily="34" charset="-120"/>
               </a:rPr>
-              <a:t>P101=ON</a:t>
+              <a:t>LIT101 &gt; 800mm</a:t>
             </a:r>
             <a:endParaRPr lang="en-US" sz="900" dirty="0"/>
           </a:p>
@@ -18484,7 +18484,7 @@
                 <a:ea typeface="Calibri" pitchFamily="34" charset="-122"/>
                 <a:cs typeface="Calibri" pitchFamily="34" charset="-120"/>
               </a:rPr>
-              <a:t>LIT101 not falling rapidly</a:t>
+              <a:t>MV101 not OPEN</a:t>
             </a:r>
             <a:endParaRPr lang="en-US" sz="900" dirty="0"/>
           </a:p>
@@ -18552,7 +18552,7 @@
                 <a:ea typeface="Calibri" pitchFamily="34" charset="-122"/>
                 <a:cs typeface="Calibri" pitchFamily="34" charset="-120"/>
               </a:rPr>
-              <a:t>Pump fills or holds tank</a:t>
+              <a:t>Overflow protection</a:t>
             </a:r>
             <a:endParaRPr lang="en-US" sz="900" dirty="0"/>
           </a:p>
@@ -18756,7 +18756,7 @@
                 <a:ea typeface="Calibri" pitchFamily="34" charset="-122"/>
                 <a:cs typeface="Calibri" pitchFamily="34" charset="-120"/>
               </a:rPr>
-              <a:t>P101 OFF within 2 cycles</a:t>
+              <a:t>P101 not ON</a:t>
             </a:r>
             <a:endParaRPr lang="en-US" sz="900" dirty="0"/>
           </a:p>
@@ -19232,7 +19232,7 @@
                 <a:ea typeface="Calibri" pitchFamily="34" charset="-122"/>
                 <a:cs typeface="Calibri" pitchFamily="34" charset="-120"/>
               </a:rPr>
-              <a:t>MV101=CLOSED</a:t>
+              <a:t>Always</a:t>
             </a:r>
             <a:endParaRPr lang="en-US" sz="900" dirty="0"/>
           </a:p>
@@ -19300,7 +19300,7 @@
                 <a:ea typeface="Calibri" pitchFamily="34" charset="-122"/>
                 <a:cs typeface="Calibri" pitchFamily="34" charset="-120"/>
               </a:rPr>
-              <a:t>FIT101 &lt; 0.05 L/s</a:t>
+              <a:t>P101 and P102 not both ON</a:t>
             </a:r>
             <a:endParaRPr lang="en-US" sz="900" dirty="0"/>
           </a:p>
@@ -19368,7 +19368,7 @@
                 <a:ea typeface="Calibri" pitchFamily="34" charset="-122"/>
                 <a:cs typeface="Calibri" pitchFamily="34" charset="-120"/>
               </a:rPr>
-              <a:t>No flow when valve shut</a:t>
+              <a:t>Backup pump exclusion</a:t>
             </a:r>
             <a:endParaRPr lang="en-US" sz="900" dirty="0"/>
           </a:p>
@@ -19572,7 +19572,7 @@
                 <a:ea typeface="Calibri" pitchFamily="34" charset="-122"/>
                 <a:cs typeface="Calibri" pitchFamily="34" charset="-120"/>
               </a:rPr>
-              <a:t>VIOLATION (attack signature)</a:t>
+              <a:t>FIT101 &gt; 0.4 → VIOLATION</a:t>
             </a:r>
             <a:endParaRPr lang="en-US" sz="900" dirty="0"/>
           </a:p>
@@ -19640,7 +19640,7 @@
                 <a:ea typeface="Calibri" pitchFamily="34" charset="-122"/>
                 <a:cs typeface="Calibri" pitchFamily="34" charset="-120"/>
               </a:rPr>
-              <a:t>Impossible physics state</a:t>
+              <a:t>Impossible flow — sensor anomaly</a:t>
             </a:r>
             <a:endParaRPr lang="en-US" sz="900" dirty="0"/>
           </a:p>
@@ -19776,7 +19776,7 @@
                 <a:ea typeface="Calibri" pitchFamily="34" charset="-122"/>
                 <a:cs typeface="Calibri" pitchFamily="34" charset="-120"/>
               </a:rPr>
-              <a:t>P101=OFF</a:t>
+              <a:t>Always</a:t>
             </a:r>
             <a:endParaRPr lang="en-US" sz="900" dirty="0"/>
           </a:p>
@@ -19844,7 +19844,7 @@
                 <a:ea typeface="Calibri" pitchFamily="34" charset="-122"/>
                 <a:cs typeface="Calibri" pitchFamily="34" charset="-120"/>
               </a:rPr>
-              <a:t>LIT101 non-increasing</a:t>
+              <a:t>FIT101 ≤ 2.0 L/s</a:t>
             </a:r>
             <a:endParaRPr lang="en-US" sz="900" dirty="0"/>
           </a:p>
@@ -19912,7 +19912,7 @@
                 <a:ea typeface="Calibri" pitchFamily="34" charset="-122"/>
                 <a:cs typeface="Calibri" pitchFamily="34" charset="-120"/>
               </a:rPr>
-              <a:t>Tank drains only if pump off</a:t>
+              <a:t>Pipe capacity limit</a:t>
             </a:r>
             <a:endParaRPr lang="en-US" sz="900" dirty="0"/>
           </a:p>
@@ -20071,7 +20071,7 @@
                 </a:solidFill>
                 <a:latin typeface="Calibri"/>
               </a:rPr>
-              <a:t>MV101=CLOSED AND P101=OFF
+              <a:t>MV101=CLOSED AND P101=ON
 (300mm &lt; LIT101 &lt; 850mm)</a:t>
             </a:r>
           </a:p>
@@ -20143,7 +20143,7 @@
                 </a:solidFill>
                 <a:latin typeface="Calibri"/>
               </a:rPr>
-              <a:t>Both off simultaneously in normal operating range is impossible in SWaT. Direct signature of compromised HMI attack.</a:t>
+              <a:t>MV101 closed while P101 pumps in normal range — tank drains with no inflow. Direct signature of compromised HMI attack.</a:t>
             </a:r>
           </a:p>
         </p:txBody>

</xml_diff>

<commit_message>
fix: revert I-7 to phantom flow check (P101=OFF + MV101=CLOSED + FIT101 > 0.4)
I-7: everything shut off but flow detected — sensor fault or bypass.
Previous version (P101=ON) overlapped with I-9 attack signature.
</commit_message>
<xml_diff>
--- a/slides/swat_sutd.pptx
+++ b/slides/swat_sutd.pptx
@@ -19504,7 +19504,7 @@
                 <a:ea typeface="Calibri" pitchFamily="34" charset="-122"/>
                 <a:cs typeface="Calibri" pitchFamily="34" charset="-120"/>
               </a:rPr>
-              <a:t>P101=ON + MV101=CLOSED</a:t>
+              <a:t>P101=OFF + MV101=CLOSED</a:t>
             </a:r>
             <a:endParaRPr lang="en-US" sz="900" dirty="0"/>
           </a:p>
@@ -19640,7 +19640,7 @@
                 <a:ea typeface="Calibri" pitchFamily="34" charset="-122"/>
                 <a:cs typeface="Calibri" pitchFamily="34" charset="-120"/>
               </a:rPr>
-              <a:t>Impossible flow — sensor anomaly</a:t>
+              <a:t>Phantom flow — sensor fault or bypass</a:t>
             </a:r>
             <a:endParaRPr lang="en-US" sz="900" dirty="0"/>
           </a:p>

</xml_diff>

<commit_message>
feat: I-2 uses FIT201 (outlet flow from PLC2) instead of FIT101 (inlet flow)
I-2 checks pump running but no flow. P101 drives water OUT through
FIT201, not IN through FIT101. FIT101 is paired with MV101 (I-1).

Correct pairings:
  I-1: MV101=OPEN → FIT101 > 0.4 (inlet valve → inlet flow)
  I-2: P101=ON   → FIT201 > 0.4 (pump → outlet flow)

invariant_checker.py:
- Added READ_TAGS_PLC2 for HMI_FIT201.Pv
- Added --plc2-ip argument (default 192.168.1.20)
- Main loop reads from both PLC1 and PLC2
- PLC2 failure graceful (I-2 skips FIT201 check)

Updated slides, report, and README.
</commit_message>
<xml_diff>
--- a/slides/swat_sutd.pptx
+++ b/slides/swat_sutd.pptx
@@ -18212,7 +18212,7 @@
                 <a:ea typeface="Calibri" pitchFamily="34" charset="-122"/>
                 <a:cs typeface="Calibri" pitchFamily="34" charset="-120"/>
               </a:rPr>
-              <a:t>FIT101 &gt; 0.4 L/s</a:t>
+              <a:t>FIT201 &gt; 0.4 L/s</a:t>
             </a:r>
             <a:endParaRPr lang="en-US" sz="900" dirty="0"/>
           </a:p>
@@ -18280,7 +18280,7 @@
                 <a:ea typeface="Calibri" pitchFamily="34" charset="-122"/>
                 <a:cs typeface="Calibri" pitchFamily="34" charset="-120"/>
               </a:rPr>
-              <a:t>Pump running but no flow</a:t>
+              <a:t>Pump on, no outlet flow</a:t>
             </a:r>
             <a:endParaRPr lang="en-US" sz="900" dirty="0"/>
           </a:p>

</xml_diff>